<commit_message>
Deck: ROC AUC instead of threshold on screenshots, threshold note per card
Screenshot tiles redrawn on exact tile borders (diamond colour), every model
card and the simulator slide explain why the threshold is not informative.
</commit_message>
<xml_diff>
--- a/docs/presentation.pptx
+++ b/docs/presentation.pptx
@@ -8275,7 +8275,7 @@
       </p:sp>
       <p:pic>
         <p:nvPicPr>
-          <p:cNvPr id="5" name="Picture 4" descr="card_sim_impact.png"/>
+          <p:cNvPr id="5" name="Picture 4" descr="card_sim_impact_auc.png"/>
           <p:cNvPicPr>
             <a:picLocks noChangeAspect="1"/>
           </p:cNvPicPr>
@@ -8331,14 +8331,108 @@
                 </a:solidFill>
                 <a:latin typeface="Arial"/>
               </a:rPr>
-              <a:t>Рисунок 8 – Атрибуція механізмів зриву в симуляторі fusion-sim (50 розрядів): 10 з 12</a:t>
-            </a:r>
-          </a:p>
-        </p:txBody>
-      </p:sp>
-      <p:sp>
-        <p:nvSpPr>
-          <p:cNvPr id="7" name="TextBox 6"/>
+              <a:t>Рисунок 8 – Атрибуція механізмів зриву в симуляторі fusion-sim (50 розрядів): 10 з 12 (поле «поріг» замінено на ROC AUC цього прогону)</a:t>
+            </a:r>
+          </a:p>
+        </p:txBody>
+      </p:sp>
+      <p:sp>
+        <p:nvSpPr>
+          <p:cNvPr id="7" name="Rectangle 6"/>
+          <p:cNvSpPr/>
+          <p:nvPr/>
+        </p:nvSpPr>
+        <p:spPr>
+          <a:xfrm>
+            <a:off x="548640" y="5041141"/>
+            <a:ext cx="6035040" cy="914400"/>
+          </a:xfrm>
+          <a:prstGeom prst="rect">
+            <a:avLst/>
+          </a:prstGeom>
+          <a:solidFill>
+            <a:srgbClr val="F8FAFC"/>
+          </a:solidFill>
+          <a:ln w="12700">
+            <a:solidFill>
+              <a:srgbClr val="E2E8F0"/>
+            </a:solidFill>
+          </a:ln>
+          <a:effectLst/>
+        </p:spPr>
+        <p:style>
+          <a:lnRef idx="1">
+            <a:schemeClr val="accent1"/>
+          </a:lnRef>
+          <a:fillRef idx="3">
+            <a:schemeClr val="accent1"/>
+          </a:fillRef>
+          <a:effectRef idx="2">
+            <a:schemeClr val="accent1"/>
+          </a:effectRef>
+          <a:fontRef idx="minor">
+            <a:schemeClr val="lt1"/>
+          </a:fontRef>
+        </p:style>
+        <p:txBody>
+          <a:bodyPr rtlCol="0" anchor="ctr"/>
+          <a:lstStyle/>
+          <a:p>
+            <a:pPr algn="ctr"/>
+          </a:p>
+        </p:txBody>
+      </p:sp>
+      <p:sp>
+        <p:nvSpPr>
+          <p:cNvPr id="8" name="TextBox 7"/>
+          <p:cNvSpPr txBox="1"/>
+          <p:nvPr/>
+        </p:nvSpPr>
+        <p:spPr>
+          <a:xfrm>
+            <a:off x="685800" y="5132581"/>
+            <a:ext cx="5760720" cy="731520"/>
+          </a:xfrm>
+          <a:prstGeom prst="rect">
+            <a:avLst/>
+          </a:prstGeom>
+          <a:noFill/>
+        </p:spPr>
+        <p:txBody>
+          <a:bodyPr wrap="square" anchor="t" lIns="0" rIns="0" tIns="0" bIns="0">
+            <a:spAutoFit/>
+          </a:bodyPr>
+          <a:lstStyle/>
+          <a:p>
+            <a:pPr algn="l">
+              <a:spcAft>
+                <a:spcPts val="0"/>
+              </a:spcAft>
+            </a:pPr>
+            <a:r>
+              <a:rPr sz="1100" b="1" i="0">
+                <a:solidFill>
+                  <a:srgbClr val="0E7490"/>
+                </a:solidFill>
+                <a:latin typeface="Arial"/>
+              </a:rPr>
+              <a:t>Чому ROC AUC замість порогу. </a:t>
+            </a:r>
+            <a:r>
+              <a:rPr sz="1100" b="0" i="0">
+                <a:solidFill>
+                  <a:srgbClr val="475569"/>
+                </a:solidFill>
+                <a:latin typeface="Arial"/>
+              </a:rPr>
+              <a:t>Поріг спрацювання неінформативний: його підбирає засіб оцінки під бюджет хибних тривог, а на 50 розрядах поріг задає один тихий розряд (див. розділ 5); тому наведено ROC AUC.</a:t>
+            </a:r>
+          </a:p>
+        </p:txBody>
+      </p:sp>
+      <p:sp>
+        <p:nvSpPr>
+          <p:cNvPr id="9" name="TextBox 8"/>
           <p:cNvSpPr txBox="1"/>
           <p:nvPr/>
         </p:nvSpPr>
@@ -8393,7 +8487,7 @@
       </p:sp>
       <p:sp>
         <p:nvSpPr>
-          <p:cNvPr id="8" name="TextBox 7"/>
+          <p:cNvPr id="10" name="TextBox 9"/>
           <p:cNvSpPr txBox="1"/>
           <p:nvPr/>
         </p:nvSpPr>
@@ -8947,7 +9041,7 @@
         <p:spPr>
           <a:xfrm>
             <a:off x="521207" y="1252728"/>
-            <a:ext cx="6364224" cy="1099221"/>
+            <a:ext cx="5541264" cy="963000"/>
           </a:xfrm>
           <a:prstGeom prst="rect">
             <a:avLst/>
@@ -8984,7 +9078,7 @@
       </p:sp>
       <p:pic>
         <p:nvPicPr>
-          <p:cNvPr id="5" name="Picture 4" descr="card_xgb_phys.png"/>
+          <p:cNvPr id="5" name="Picture 4" descr="card_xgb_phys_auc.png"/>
           <p:cNvPicPr>
             <a:picLocks noChangeAspect="1"/>
           </p:cNvPicPr>
@@ -8999,7 +9093,7 @@
         <p:spPr>
           <a:xfrm>
             <a:off x="548640" y="1280160"/>
-            <a:ext cx="6309360" cy="1044357"/>
+            <a:ext cx="5486400" cy="908136"/>
           </a:xfrm>
           <a:prstGeom prst="rect">
             <a:avLst/>
@@ -9014,8 +9108,8 @@
         </p:nvSpPr>
         <p:spPr>
           <a:xfrm>
-            <a:off x="548640" y="2379381"/>
-            <a:ext cx="6309360" cy="365760"/>
+            <a:off x="548640" y="2243160"/>
+            <a:ext cx="5486400" cy="365760"/>
           </a:xfrm>
           <a:prstGeom prst="rect">
             <a:avLst/>
@@ -9040,7 +9134,7 @@
                 </a:solidFill>
                 <a:latin typeface="Arial"/>
               </a:rPr>
-              <a:t>Рисунок 9 – Physics: 25,4 % вчасно, пропущено 6</a:t>
+              <a:t>Рисунок 9 – Physics: 25,4 % вчасно, пропущено 6 (поле «поріг» замінено на ROC AUC; ROC AUC валідаційна, по кроках)</a:t>
             </a:r>
           </a:p>
         </p:txBody>
@@ -9053,8 +9147,8 @@
         </p:nvSpPr>
         <p:spPr>
           <a:xfrm>
-            <a:off x="521207" y="2800005"/>
-            <a:ext cx="6364224" cy="1099221"/>
+            <a:off x="521207" y="2727792"/>
+            <a:ext cx="5541264" cy="963000"/>
           </a:xfrm>
           <a:prstGeom prst="rect">
             <a:avLst/>
@@ -9091,7 +9185,7 @@
       </p:sp>
       <p:pic>
         <p:nvPicPr>
-          <p:cNvPr id="8" name="Picture 7" descr="card_xgb_dyn.png"/>
+          <p:cNvPr id="8" name="Picture 7" descr="card_xgb_dyn_auc.png"/>
           <p:cNvPicPr>
             <a:picLocks noChangeAspect="1"/>
           </p:cNvPicPr>
@@ -9105,8 +9199,8 @@
         </p:blipFill>
         <p:spPr>
           <a:xfrm>
-            <a:off x="548640" y="2827437"/>
-            <a:ext cx="6309360" cy="1044357"/>
+            <a:off x="548640" y="2755224"/>
+            <a:ext cx="5486400" cy="908136"/>
           </a:xfrm>
           <a:prstGeom prst="rect">
             <a:avLst/>
@@ -9121,8 +9215,8 @@
         </p:nvSpPr>
         <p:spPr>
           <a:xfrm>
-            <a:off x="548640" y="3926659"/>
-            <a:ext cx="6309360" cy="365760"/>
+            <a:off x="548640" y="3718225"/>
+            <a:ext cx="5486400" cy="365760"/>
           </a:xfrm>
           <a:prstGeom prst="rect">
             <a:avLst/>
@@ -9147,7 +9241,7 @@
                 </a:solidFill>
                 <a:latin typeface="Arial"/>
               </a:rPr>
-              <a:t>Рисунок 10 – Dynamics: 34,9 % вчасно, пропущено 9</a:t>
+              <a:t>Рисунок 10 – Dynamics: 34,9 % вчасно, пропущено 9 (поле «поріг» замінено на ROC AUC; ROC AUC валідаційна, по кроках)</a:t>
             </a:r>
           </a:p>
         </p:txBody>
@@ -9160,8 +9254,8 @@
         </p:nvSpPr>
         <p:spPr>
           <a:xfrm>
-            <a:off x="521207" y="4347283"/>
-            <a:ext cx="6364224" cy="1099221"/>
+            <a:off x="521207" y="4202857"/>
+            <a:ext cx="5541264" cy="963000"/>
           </a:xfrm>
           <a:prstGeom prst="rect">
             <a:avLst/>
@@ -9198,7 +9292,7 @@
       </p:sp>
       <p:pic>
         <p:nvPicPr>
-          <p:cNvPr id="11" name="Picture 10" descr="card_xgb_formula.png"/>
+          <p:cNvPr id="11" name="Picture 10" descr="card_xgb_formula_auc.png"/>
           <p:cNvPicPr>
             <a:picLocks noChangeAspect="1"/>
           </p:cNvPicPr>
@@ -9212,8 +9306,8 @@
         </p:blipFill>
         <p:spPr>
           <a:xfrm>
-            <a:off x="548640" y="4374715"/>
-            <a:ext cx="6309360" cy="1044357"/>
+            <a:off x="548640" y="4230289"/>
+            <a:ext cx="5486400" cy="908136"/>
           </a:xfrm>
           <a:prstGeom prst="rect">
             <a:avLst/>
@@ -9228,8 +9322,8 @@
         </p:nvSpPr>
         <p:spPr>
           <a:xfrm>
-            <a:off x="548640" y="5473936"/>
-            <a:ext cx="6309360" cy="365760"/>
+            <a:off x="548640" y="5193290"/>
+            <a:ext cx="5486400" cy="365760"/>
           </a:xfrm>
           <a:prstGeom prst="rect">
             <a:avLst/>
@@ -9254,14 +9348,108 @@
                 </a:solidFill>
                 <a:latin typeface="Arial"/>
               </a:rPr>
-              <a:t>Рисунок 11 – Formula: 25,4 % вчасно, пропущено 5</a:t>
-            </a:r>
-          </a:p>
-        </p:txBody>
-      </p:sp>
-      <p:sp>
-        <p:nvSpPr>
-          <p:cNvPr id="13" name="TextBox 12"/>
+              <a:t>Рисунок 11 – Formula: 25,4 % вчасно, пропущено 5 (поле «поріг» замінено на ROC AUC; ROC AUC валідаційна, по кроках)</a:t>
+            </a:r>
+          </a:p>
+        </p:txBody>
+      </p:sp>
+      <p:sp>
+        <p:nvSpPr>
+          <p:cNvPr id="13" name="Rectangle 12"/>
+          <p:cNvSpPr/>
+          <p:nvPr/>
+        </p:nvSpPr>
+        <p:spPr>
+          <a:xfrm>
+            <a:off x="548640" y="5687066"/>
+            <a:ext cx="5486400" cy="914400"/>
+          </a:xfrm>
+          <a:prstGeom prst="rect">
+            <a:avLst/>
+          </a:prstGeom>
+          <a:solidFill>
+            <a:srgbClr val="F8FAFC"/>
+          </a:solidFill>
+          <a:ln w="12700">
+            <a:solidFill>
+              <a:srgbClr val="E2E8F0"/>
+            </a:solidFill>
+          </a:ln>
+          <a:effectLst/>
+        </p:spPr>
+        <p:style>
+          <a:lnRef idx="1">
+            <a:schemeClr val="accent1"/>
+          </a:lnRef>
+          <a:fillRef idx="3">
+            <a:schemeClr val="accent1"/>
+          </a:fillRef>
+          <a:effectRef idx="2">
+            <a:schemeClr val="accent1"/>
+          </a:effectRef>
+          <a:fontRef idx="minor">
+            <a:schemeClr val="lt1"/>
+          </a:fontRef>
+        </p:style>
+        <p:txBody>
+          <a:bodyPr rtlCol="0" anchor="ctr"/>
+          <a:lstStyle/>
+          <a:p>
+            <a:pPr algn="ctr"/>
+          </a:p>
+        </p:txBody>
+      </p:sp>
+      <p:sp>
+        <p:nvSpPr>
+          <p:cNvPr id="14" name="TextBox 13"/>
+          <p:cNvSpPr txBox="1"/>
+          <p:nvPr/>
+        </p:nvSpPr>
+        <p:spPr>
+          <a:xfrm>
+            <a:off x="685800" y="5778506"/>
+            <a:ext cx="5212080" cy="731520"/>
+          </a:xfrm>
+          <a:prstGeom prst="rect">
+            <a:avLst/>
+          </a:prstGeom>
+          <a:noFill/>
+        </p:spPr>
+        <p:txBody>
+          <a:bodyPr wrap="square" anchor="t" lIns="0" rIns="0" tIns="0" bIns="0">
+            <a:spAutoFit/>
+          </a:bodyPr>
+          <a:lstStyle/>
+          <a:p>
+            <a:pPr algn="l">
+              <a:spcAft>
+                <a:spcPts val="0"/>
+              </a:spcAft>
+            </a:pPr>
+            <a:r>
+              <a:rPr sz="1100" b="1" i="0">
+                <a:solidFill>
+                  <a:srgbClr val="0E7490"/>
+                </a:solidFill>
+                <a:latin typeface="Arial"/>
+              </a:rPr>
+              <a:t>Чому ROC AUC замість порогу. </a:t>
+            </a:r>
+            <a:r>
+              <a:rPr sz="1100" b="0" i="0">
+                <a:solidFill>
+                  <a:srgbClr val="475569"/>
+                </a:solidFill>
+                <a:latin typeface="Arial"/>
+              </a:rPr>
+              <a:t>Поріг спрацювання неінформативний: його підбирає засіб оцінки під бюджет хибних тривог, шкала ймовірностей у моделей різна, а на малій вибірці поріг задає один тихий розряд. Тому на скриншотах замість порогу наведено ROC AUC, яка від порогу не залежить.</a:t>
+            </a:r>
+          </a:p>
+        </p:txBody>
+      </p:sp>
+      <p:sp>
+        <p:nvSpPr>
+          <p:cNvPr id="15" name="TextBox 14"/>
           <p:cNvSpPr txBox="1"/>
           <p:nvPr/>
         </p:nvSpPr>
@@ -9384,13 +9572,13 @@
       </p:sp>
       <p:sp>
         <p:nvSpPr>
-          <p:cNvPr id="14" name="TextBox 13"/>
+          <p:cNvPr id="16" name="TextBox 15"/>
           <p:cNvSpPr txBox="1"/>
           <p:nvPr/>
         </p:nvSpPr>
         <p:spPr>
           <a:xfrm>
-            <a:off x="7315200" y="4956048"/>
+            <a:off x="7315200" y="3703320"/>
             <a:ext cx="4343400" cy="320040"/>
           </a:xfrm>
           <a:prstGeom prst="rect">
@@ -9423,15 +9611,15 @@
       </p:sp>
       <p:graphicFrame>
         <p:nvGraphicFramePr>
-          <p:cNvPr id="15" name="Table 14"/>
+          <p:cNvPr id="17" name="Table 16"/>
           <p:cNvGraphicFramePr>
             <a:graphicFrameLocks noGrp="1"/>
           </p:cNvGraphicFramePr>
           <p:nvPr/>
         </p:nvGraphicFramePr>
         <p:xfrm>
-          <a:off x="7315200" y="5367528"/>
-          <a:ext cx="4343400" cy="987552"/>
+          <a:off x="7315200" y="4069080"/>
+          <a:ext cx="4343400" cy="694944"/>
         </p:xfrm>
         <a:graphic>
           <a:graphicData uri="http://schemas.openxmlformats.org/drawingml/2006/table">
@@ -9443,7 +9631,7 @@
                 <a:gridCol w="2514600"/>
                 <a:gridCol w="1828800"/>
               </a:tblGrid>
-              <a:tr h="329184">
+              <a:tr h="347472">
                 <a:tc>
                   <a:txBody>
                     <a:bodyPr wrap="square"/>
@@ -9491,7 +9679,7 @@
                   </a:tcPr>
                 </a:tc>
               </a:tr>
-              <a:tr h="329184">
+              <a:tr h="347472">
                 <a:tc>
                   <a:txBody>
                     <a:bodyPr wrap="square"/>
@@ -9539,54 +9727,6 @@
                   </a:tcPr>
                 </a:tc>
               </a:tr>
-              <a:tr h="329184">
-                <a:tc>
-                  <a:txBody>
-                    <a:bodyPr wrap="square"/>
-                    <a:lstStyle/>
-                    <a:p>
-                      <a:pPr algn="l"/>
-                      <a:r>
-                        <a:rPr sz="1100" b="1">
-                          <a:solidFill>
-                            <a:srgbClr val="0F172A"/>
-                          </a:solidFill>
-                          <a:latin typeface="Arial"/>
-                        </a:rPr>
-                        <a:t>поріг для FPR 5 %</a:t>
-                      </a:r>
-                    </a:p>
-                  </a:txBody>
-                  <a:tcPr marL="91440" marR="91440" marT="27432" marB="27432" anchor="ctr">
-                    <a:solidFill>
-                      <a:srgbClr val="FFFFFF"/>
-                    </a:solidFill>
-                  </a:tcPr>
-                </a:tc>
-                <a:tc>
-                  <a:txBody>
-                    <a:bodyPr wrap="square"/>
-                    <a:lstStyle/>
-                    <a:p>
-                      <a:pPr algn="ctr"/>
-                      <a:r>
-                        <a:rPr sz="1200" b="0">
-                          <a:solidFill>
-                            <a:srgbClr val="0F172A"/>
-                          </a:solidFill>
-                          <a:latin typeface="Arial"/>
-                        </a:rPr>
-                        <a:t>0,73–0,76</a:t>
-                      </a:r>
-                    </a:p>
-                  </a:txBody>
-                  <a:tcPr marL="91440" marR="91440" marT="27432" marB="27432" anchor="ctr">
-                    <a:solidFill>
-                      <a:srgbClr val="FFFFFF"/>
-                    </a:solidFill>
-                  </a:tcPr>
-                </a:tc>
-              </a:tr>
             </a:tbl>
           </a:graphicData>
         </a:graphic>
@@ -9741,7 +9881,7 @@
       </p:sp>
       <p:pic>
         <p:nvPicPr>
-          <p:cNvPr id="5" name="Picture 4" descr="card_v6.png"/>
+          <p:cNvPr id="5" name="Picture 4" descr="card_v6_auc.png"/>
           <p:cNvPicPr>
             <a:picLocks noChangeAspect="1"/>
           </p:cNvPicPr>
@@ -9797,7 +9937,7 @@
                 </a:solidFill>
                 <a:latin typeface="Arial"/>
               </a:rPr>
-              <a:t>Рисунок 12 – v6: 63,5 % вчасно на спільній вибірці, пропущено 0</a:t>
+              <a:t>Рисунок 12 – v6: 63,5 % вчасно на спільній вибірці, пропущено 0 (поле «поріг» замінено на ROC AUC; офіційні набори toksym)</a:t>
             </a:r>
           </a:p>
         </p:txBody>
@@ -9810,7 +9950,7 @@
         </p:nvSpPr>
         <p:spPr>
           <a:xfrm>
-            <a:off x="521207" y="2573234"/>
+            <a:off x="521207" y="2637242"/>
             <a:ext cx="6547103" cy="866394"/>
           </a:xfrm>
           <a:prstGeom prst="rect">
@@ -9848,7 +9988,7 @@
       </p:sp>
       <p:pic>
         <p:nvPicPr>
-          <p:cNvPr id="8" name="Picture 7" descr="card_v6b.png"/>
+          <p:cNvPr id="8" name="Picture 7" descr="card_v6b_auc.png"/>
           <p:cNvPicPr>
             <a:picLocks noChangeAspect="1"/>
           </p:cNvPicPr>
@@ -9862,7 +10002,7 @@
         </p:blipFill>
         <p:spPr>
           <a:xfrm>
-            <a:off x="548640" y="2600666"/>
+            <a:off x="548640" y="2664674"/>
             <a:ext cx="6492240" cy="811530"/>
           </a:xfrm>
           <a:prstGeom prst="rect">
@@ -9878,7 +10018,7 @@
         </p:nvSpPr>
         <p:spPr>
           <a:xfrm>
-            <a:off x="548640" y="3467060"/>
+            <a:off x="548640" y="3531068"/>
             <a:ext cx="6492240" cy="365760"/>
           </a:xfrm>
           <a:prstGeom prst="rect">
@@ -9904,14 +10044,108 @@
                 </a:solidFill>
                 <a:latin typeface="Arial"/>
               </a:rPr>
-              <a:t>Рисунок 13 – v6b: 57,1 % вчасно на спільній вибірці, пропущено 1</a:t>
-            </a:r>
-          </a:p>
-        </p:txBody>
-      </p:sp>
-      <p:sp>
-        <p:nvSpPr>
-          <p:cNvPr id="10" name="TextBox 9"/>
+              <a:t>Рисунок 13 – v6b: 57,1 % вчасно на спільній вибірці, пропущено 1 (поле «поріг» замінено на ROC AUC; офіційні набори toksym)</a:t>
+            </a:r>
+          </a:p>
+        </p:txBody>
+      </p:sp>
+      <p:sp>
+        <p:nvSpPr>
+          <p:cNvPr id="10" name="Rectangle 9"/>
+          <p:cNvSpPr/>
+          <p:nvPr/>
+        </p:nvSpPr>
+        <p:spPr>
+          <a:xfrm>
+            <a:off x="548640" y="4024844"/>
+            <a:ext cx="6492240" cy="914400"/>
+          </a:xfrm>
+          <a:prstGeom prst="rect">
+            <a:avLst/>
+          </a:prstGeom>
+          <a:solidFill>
+            <a:srgbClr val="F8FAFC"/>
+          </a:solidFill>
+          <a:ln w="12700">
+            <a:solidFill>
+              <a:srgbClr val="E2E8F0"/>
+            </a:solidFill>
+          </a:ln>
+          <a:effectLst/>
+        </p:spPr>
+        <p:style>
+          <a:lnRef idx="1">
+            <a:schemeClr val="accent1"/>
+          </a:lnRef>
+          <a:fillRef idx="3">
+            <a:schemeClr val="accent1"/>
+          </a:fillRef>
+          <a:effectRef idx="2">
+            <a:schemeClr val="accent1"/>
+          </a:effectRef>
+          <a:fontRef idx="minor">
+            <a:schemeClr val="lt1"/>
+          </a:fontRef>
+        </p:style>
+        <p:txBody>
+          <a:bodyPr rtlCol="0" anchor="ctr"/>
+          <a:lstStyle/>
+          <a:p>
+            <a:pPr algn="ctr"/>
+          </a:p>
+        </p:txBody>
+      </p:sp>
+      <p:sp>
+        <p:nvSpPr>
+          <p:cNvPr id="11" name="TextBox 10"/>
+          <p:cNvSpPr txBox="1"/>
+          <p:nvPr/>
+        </p:nvSpPr>
+        <p:spPr>
+          <a:xfrm>
+            <a:off x="685800" y="4116284"/>
+            <a:ext cx="6217920" cy="731520"/>
+          </a:xfrm>
+          <a:prstGeom prst="rect">
+            <a:avLst/>
+          </a:prstGeom>
+          <a:noFill/>
+        </p:spPr>
+        <p:txBody>
+          <a:bodyPr wrap="square" anchor="t" lIns="0" rIns="0" tIns="0" bIns="0">
+            <a:spAutoFit/>
+          </a:bodyPr>
+          <a:lstStyle/>
+          <a:p>
+            <a:pPr algn="l">
+              <a:spcAft>
+                <a:spcPts val="0"/>
+              </a:spcAft>
+            </a:pPr>
+            <a:r>
+              <a:rPr sz="1100" b="1" i="0">
+                <a:solidFill>
+                  <a:srgbClr val="0E7490"/>
+                </a:solidFill>
+                <a:latin typeface="Arial"/>
+              </a:rPr>
+              <a:t>Чому ROC AUC замість порогу. </a:t>
+            </a:r>
+            <a:r>
+              <a:rPr sz="1100" b="0" i="0">
+                <a:solidFill>
+                  <a:srgbClr val="475569"/>
+                </a:solidFill>
+                <a:latin typeface="Arial"/>
+              </a:rPr>
+              <a:t>Поріг спрацювання неінформативний: його підбирає засіб оцінки під бюджет хибних тривог, шкала ймовірностей у моделей різна, а на малій вибірці поріг задає один тихий розряд. Тому на скриншотах замість порогу наведено ROC AUC, яка від порогу не залежить.</a:t>
+            </a:r>
+          </a:p>
+        </p:txBody>
+      </p:sp>
+      <p:sp>
+        <p:nvSpPr>
+          <p:cNvPr id="12" name="TextBox 11"/>
           <p:cNvSpPr txBox="1"/>
           <p:nvPr/>
         </p:nvSpPr>
@@ -10009,13 +10243,13 @@
       </p:sp>
       <p:sp>
         <p:nvSpPr>
-          <p:cNvPr id="11" name="TextBox 10"/>
+          <p:cNvPr id="13" name="TextBox 12"/>
           <p:cNvSpPr txBox="1"/>
           <p:nvPr/>
         </p:nvSpPr>
         <p:spPr>
           <a:xfrm>
-            <a:off x="7315200" y="4297680"/>
+            <a:off x="7315200" y="3703320"/>
             <a:ext cx="4343400" cy="320040"/>
           </a:xfrm>
           <a:prstGeom prst="rect">
@@ -10048,15 +10282,15 @@
       </p:sp>
       <p:graphicFrame>
         <p:nvGraphicFramePr>
-          <p:cNvPr id="12" name="Table 11"/>
+          <p:cNvPr id="14" name="Table 13"/>
           <p:cNvGraphicFramePr>
             <a:graphicFrameLocks noGrp="1"/>
           </p:cNvGraphicFramePr>
           <p:nvPr/>
         </p:nvGraphicFramePr>
         <p:xfrm>
-          <a:off x="7315200" y="4709160"/>
-          <a:ext cx="4343400" cy="1645920"/>
+          <a:off x="7315200" y="4069080"/>
+          <a:ext cx="4343400" cy="1737360"/>
         </p:xfrm>
         <a:graphic>
           <a:graphicData uri="http://schemas.openxmlformats.org/drawingml/2006/table">
@@ -10068,7 +10302,7 @@
                 <a:gridCol w="2514600"/>
                 <a:gridCol w="1828800"/>
               </a:tblGrid>
-              <a:tr h="329184">
+              <a:tr h="347472">
                 <a:tc>
                   <a:txBody>
                     <a:bodyPr wrap="square"/>
@@ -10116,7 +10350,7 @@
                   </a:tcPr>
                 </a:tc>
               </a:tr>
-              <a:tr h="329184">
+              <a:tr h="347472">
                 <a:tc>
                   <a:txBody>
                     <a:bodyPr wrap="square"/>
@@ -10164,7 +10398,7 @@
                   </a:tcPr>
                 </a:tc>
               </a:tr>
-              <a:tr h="329184">
+              <a:tr h="347472">
                 <a:tc>
                   <a:txBody>
                     <a:bodyPr wrap="square"/>
@@ -10212,7 +10446,7 @@
                   </a:tcPr>
                 </a:tc>
               </a:tr>
-              <a:tr h="329184">
+              <a:tr h="347472">
                 <a:tc>
                   <a:txBody>
                     <a:bodyPr wrap="square"/>
@@ -10260,7 +10494,7 @@
                   </a:tcPr>
                 </a:tc>
               </a:tr>
-              <a:tr h="329184">
+              <a:tr h="347472">
                 <a:tc>
                   <a:txBody>
                     <a:bodyPr wrap="square"/>
@@ -10531,7 +10765,7 @@
         </p:nvSpPr>
         <p:spPr>
           <a:xfrm>
-            <a:off x="521207" y="3156430"/>
+            <a:off x="521207" y="3220438"/>
             <a:ext cx="6089903" cy="1635724"/>
           </a:xfrm>
           <a:prstGeom prst="rect">
@@ -10583,7 +10817,7 @@
         </p:blipFill>
         <p:spPr>
           <a:xfrm>
-            <a:off x="548640" y="3183862"/>
+            <a:off x="548640" y="3247870"/>
             <a:ext cx="6035040" cy="1580860"/>
           </a:xfrm>
           <a:prstGeom prst="rect">
@@ -10599,7 +10833,7 @@
         </p:nvSpPr>
         <p:spPr>
           <a:xfrm>
-            <a:off x="548640" y="4819587"/>
+            <a:off x="548640" y="4883595"/>
             <a:ext cx="6035040" cy="365760"/>
           </a:xfrm>
           <a:prstGeom prst="rect">
@@ -10736,7 +10970,7 @@
         </p:nvSpPr>
         <p:spPr>
           <a:xfrm>
-            <a:off x="7315200" y="4626864"/>
+            <a:off x="7315200" y="3703320"/>
             <a:ext cx="4343400" cy="320040"/>
           </a:xfrm>
           <a:prstGeom prst="rect">
@@ -10776,8 +11010,8 @@
           <p:nvPr/>
         </p:nvGraphicFramePr>
         <p:xfrm>
-          <a:off x="7315200" y="5038344"/>
-          <a:ext cx="4343400" cy="1316736"/>
+          <a:off x="7315200" y="4069080"/>
+          <a:ext cx="4343400" cy="1389888"/>
         </p:xfrm>
         <a:graphic>
           <a:graphicData uri="http://schemas.openxmlformats.org/drawingml/2006/table">
@@ -10789,7 +11023,7 @@
                 <a:gridCol w="2514600"/>
                 <a:gridCol w="1828800"/>
               </a:tblGrid>
-              <a:tr h="329184">
+              <a:tr h="347472">
                 <a:tc>
                   <a:txBody>
                     <a:bodyPr wrap="square"/>
@@ -10837,7 +11071,7 @@
                   </a:tcPr>
                 </a:tc>
               </a:tr>
-              <a:tr h="329184">
+              <a:tr h="347472">
                 <a:tc>
                   <a:txBody>
                     <a:bodyPr wrap="square"/>
@@ -10885,7 +11119,7 @@
                   </a:tcPr>
                 </a:tc>
               </a:tr>
-              <a:tr h="329184">
+              <a:tr h="347472">
                 <a:tc>
                   <a:txBody>
                     <a:bodyPr wrap="square"/>
@@ -10933,7 +11167,7 @@
                   </a:tcPr>
                 </a:tc>
               </a:tr>
-              <a:tr h="329184">
+              <a:tr h="347472">
                 <a:tc>
                   <a:txBody>
                     <a:bodyPr wrap="square"/>
@@ -11302,7 +11536,7 @@
         </p:nvSpPr>
         <p:spPr>
           <a:xfrm>
-            <a:off x="7315200" y="4626864"/>
+            <a:off x="7315200" y="3703320"/>
             <a:ext cx="4343400" cy="320040"/>
           </a:xfrm>
           <a:prstGeom prst="rect">
@@ -11342,8 +11576,8 @@
           <p:nvPr/>
         </p:nvGraphicFramePr>
         <p:xfrm>
-          <a:off x="7315200" y="5038344"/>
-          <a:ext cx="4343400" cy="1316736"/>
+          <a:off x="7315200" y="4069080"/>
+          <a:ext cx="4343400" cy="1389888"/>
         </p:xfrm>
         <a:graphic>
           <a:graphicData uri="http://schemas.openxmlformats.org/drawingml/2006/table">
@@ -11355,7 +11589,7 @@
                 <a:gridCol w="2514600"/>
                 <a:gridCol w="1828800"/>
               </a:tblGrid>
-              <a:tr h="329184">
+              <a:tr h="347472">
                 <a:tc>
                   <a:txBody>
                     <a:bodyPr wrap="square"/>
@@ -11403,7 +11637,7 @@
                   </a:tcPr>
                 </a:tc>
               </a:tr>
-              <a:tr h="329184">
+              <a:tr h="347472">
                 <a:tc>
                   <a:txBody>
                     <a:bodyPr wrap="square"/>
@@ -11451,7 +11685,7 @@
                   </a:tcPr>
                 </a:tc>
               </a:tr>
-              <a:tr h="329184">
+              <a:tr h="347472">
                 <a:tc>
                   <a:txBody>
                     <a:bodyPr wrap="square"/>
@@ -11499,7 +11733,7 @@
                   </a:tcPr>
                 </a:tc>
               </a:tr>
-              <a:tr h="329184">
+              <a:tr h="347472">
                 <a:tc>
                   <a:txBody>
                     <a:bodyPr wrap="square"/>
@@ -11991,7 +12225,7 @@
       </p:sp>
       <p:pic>
         <p:nvPicPr>
-          <p:cNvPr id="5" name="Picture 4" descr="ui_clean_big_01.png"/>
+          <p:cNvPr id="5" name="Picture 4" descr="ui_clean_big_01_auc.png"/>
           <p:cNvPicPr>
             <a:picLocks noChangeAspect="1"/>
           </p:cNvPicPr>
@@ -12047,7 +12281,7 @@
                 </a:solidFill>
                 <a:latin typeface="Arial"/>
               </a:rPr>
-              <a:t>Рисунок 17 – clean_big, запас 0,1 с: 63,5 % вчасно, пропущено 0</a:t>
+              <a:t>Рисунок 17 – clean_big, запас 0,1 с: 63,5 % вчасно, пропущено 0 (поле «поріг» замінено на ROC AUC; офіційні набори toksym)</a:t>
             </a:r>
           </a:p>
         </p:txBody>
@@ -12060,7 +12294,7 @@
         </p:nvSpPr>
         <p:spPr>
           <a:xfrm>
-            <a:off x="521207" y="2599877"/>
+            <a:off x="521207" y="2663885"/>
             <a:ext cx="6547103" cy="899093"/>
           </a:xfrm>
           <a:prstGeom prst="rect">
@@ -12098,7 +12332,7 @@
       </p:sp>
       <p:pic>
         <p:nvPicPr>
-          <p:cNvPr id="8" name="Picture 7" descr="ui_clean_big_003.png"/>
+          <p:cNvPr id="8" name="Picture 7" descr="ui_clean_big_003_auc.png"/>
           <p:cNvPicPr>
             <a:picLocks noChangeAspect="1"/>
           </p:cNvPicPr>
@@ -12112,7 +12346,7 @@
         </p:blipFill>
         <p:spPr>
           <a:xfrm>
-            <a:off x="548640" y="2627309"/>
+            <a:off x="548640" y="2691317"/>
             <a:ext cx="6492240" cy="844229"/>
           </a:xfrm>
           <a:prstGeom prst="rect">
@@ -12128,7 +12362,7 @@
         </p:nvSpPr>
         <p:spPr>
           <a:xfrm>
-            <a:off x="548640" y="3526402"/>
+            <a:off x="548640" y="3590410"/>
             <a:ext cx="6492240" cy="365760"/>
           </a:xfrm>
           <a:prstGeom prst="rect">
@@ -12154,14 +12388,108 @@
                 </a:solidFill>
                 <a:latin typeface="Arial"/>
               </a:rPr>
-              <a:t>Рисунок 18 – clean_big, запас 30 мс: 96,8 % вчасно, пропущено 0</a:t>
-            </a:r>
-          </a:p>
-        </p:txBody>
-      </p:sp>
-      <p:sp>
-        <p:nvSpPr>
-          <p:cNvPr id="10" name="TextBox 9"/>
+              <a:t>Рисунок 18 – clean_big, запас 30 мс: 96,8 % вчасно, пропущено 0 (поле «поріг» замінено на ROC AUC; офіційні набори toksym)</a:t>
+            </a:r>
+          </a:p>
+        </p:txBody>
+      </p:sp>
+      <p:sp>
+        <p:nvSpPr>
+          <p:cNvPr id="10" name="Rectangle 9"/>
+          <p:cNvSpPr/>
+          <p:nvPr/>
+        </p:nvSpPr>
+        <p:spPr>
+          <a:xfrm>
+            <a:off x="548640" y="4084186"/>
+            <a:ext cx="6492240" cy="914400"/>
+          </a:xfrm>
+          <a:prstGeom prst="rect">
+            <a:avLst/>
+          </a:prstGeom>
+          <a:solidFill>
+            <a:srgbClr val="F8FAFC"/>
+          </a:solidFill>
+          <a:ln w="12700">
+            <a:solidFill>
+              <a:srgbClr val="E2E8F0"/>
+            </a:solidFill>
+          </a:ln>
+          <a:effectLst/>
+        </p:spPr>
+        <p:style>
+          <a:lnRef idx="1">
+            <a:schemeClr val="accent1"/>
+          </a:lnRef>
+          <a:fillRef idx="3">
+            <a:schemeClr val="accent1"/>
+          </a:fillRef>
+          <a:effectRef idx="2">
+            <a:schemeClr val="accent1"/>
+          </a:effectRef>
+          <a:fontRef idx="minor">
+            <a:schemeClr val="lt1"/>
+          </a:fontRef>
+        </p:style>
+        <p:txBody>
+          <a:bodyPr rtlCol="0" anchor="ctr"/>
+          <a:lstStyle/>
+          <a:p>
+            <a:pPr algn="ctr"/>
+          </a:p>
+        </p:txBody>
+      </p:sp>
+      <p:sp>
+        <p:nvSpPr>
+          <p:cNvPr id="11" name="TextBox 10"/>
+          <p:cNvSpPr txBox="1"/>
+          <p:nvPr/>
+        </p:nvSpPr>
+        <p:spPr>
+          <a:xfrm>
+            <a:off x="685800" y="4175626"/>
+            <a:ext cx="6217920" cy="731520"/>
+          </a:xfrm>
+          <a:prstGeom prst="rect">
+            <a:avLst/>
+          </a:prstGeom>
+          <a:noFill/>
+        </p:spPr>
+        <p:txBody>
+          <a:bodyPr wrap="square" anchor="t" lIns="0" rIns="0" tIns="0" bIns="0">
+            <a:spAutoFit/>
+          </a:bodyPr>
+          <a:lstStyle/>
+          <a:p>
+            <a:pPr algn="l">
+              <a:spcAft>
+                <a:spcPts val="0"/>
+              </a:spcAft>
+            </a:pPr>
+            <a:r>
+              <a:rPr sz="1100" b="1" i="0">
+                <a:solidFill>
+                  <a:srgbClr val="0E7490"/>
+                </a:solidFill>
+                <a:latin typeface="Arial"/>
+              </a:rPr>
+              <a:t>Чому ROC AUC замість порогу. </a:t>
+            </a:r>
+            <a:r>
+              <a:rPr sz="1100" b="0" i="0">
+                <a:solidFill>
+                  <a:srgbClr val="475569"/>
+                </a:solidFill>
+                <a:latin typeface="Arial"/>
+              </a:rPr>
+              <a:t>Поріг спрацювання неінформативний: його підбирає засіб оцінки під бюджет хибних тривог, шкала ймовірностей у моделей різна, а на малій вибірці поріг задає один тихий розряд. Тому на скриншотах замість порогу наведено ROC AUC, яка від порогу не залежить.</a:t>
+            </a:r>
+          </a:p>
+        </p:txBody>
+      </p:sp>
+      <p:sp>
+        <p:nvSpPr>
+          <p:cNvPr id="12" name="TextBox 11"/>
           <p:cNvSpPr txBox="1"/>
           <p:nvPr/>
         </p:nvSpPr>
@@ -12259,13 +12587,13 @@
       </p:sp>
       <p:sp>
         <p:nvSpPr>
-          <p:cNvPr id="11" name="TextBox 10"/>
+          <p:cNvPr id="13" name="TextBox 12"/>
           <p:cNvSpPr txBox="1"/>
           <p:nvPr/>
         </p:nvSpPr>
         <p:spPr>
           <a:xfrm>
-            <a:off x="7315200" y="4626864"/>
+            <a:off x="7315200" y="3703320"/>
             <a:ext cx="4343400" cy="320040"/>
           </a:xfrm>
           <a:prstGeom prst="rect">
@@ -12298,15 +12626,15 @@
       </p:sp>
       <p:graphicFrame>
         <p:nvGraphicFramePr>
-          <p:cNvPr id="12" name="Table 11"/>
+          <p:cNvPr id="14" name="Table 13"/>
           <p:cNvGraphicFramePr>
             <a:graphicFrameLocks noGrp="1"/>
           </p:cNvGraphicFramePr>
           <p:nvPr/>
         </p:nvGraphicFramePr>
         <p:xfrm>
-          <a:off x="7315200" y="5038344"/>
-          <a:ext cx="4343400" cy="1316736"/>
+          <a:off x="7315200" y="4069080"/>
+          <a:ext cx="4343400" cy="1389888"/>
         </p:xfrm>
         <a:graphic>
           <a:graphicData uri="http://schemas.openxmlformats.org/drawingml/2006/table">
@@ -12318,7 +12646,7 @@
                 <a:gridCol w="2514600"/>
                 <a:gridCol w="1828800"/>
               </a:tblGrid>
-              <a:tr h="329184">
+              <a:tr h="347472">
                 <a:tc>
                   <a:txBody>
                     <a:bodyPr wrap="square"/>
@@ -12366,7 +12694,7 @@
                   </a:tcPr>
                 </a:tc>
               </a:tr>
-              <a:tr h="329184">
+              <a:tr h="347472">
                 <a:tc>
                   <a:txBody>
                     <a:bodyPr wrap="square"/>
@@ -12414,7 +12742,7 @@
                   </a:tcPr>
                 </a:tc>
               </a:tr>
-              <a:tr h="329184">
+              <a:tr h="347472">
                 <a:tc>
                   <a:txBody>
                     <a:bodyPr wrap="square"/>
@@ -12462,7 +12790,7 @@
                   </a:tcPr>
                 </a:tc>
               </a:tr>
-              <a:tr h="329184">
+              <a:tr h="347472">
                 <a:tc>
                   <a:txBody>
                     <a:bodyPr wrap="square"/>
@@ -12574,7 +12902,7 @@
                 </a:solidFill>
                 <a:latin typeface="Arial"/>
               </a:rPr>
-              <a:t>Додаток А.6 Ансамбль ens5: відхилено за вимогою реального часу</a:t>
+              <a:t>Додаток А.6 Ансамбль ens5: відхилено через затримку</a:t>
             </a:r>
           </a:p>
         </p:txBody>
@@ -12664,7 +12992,7 @@
       </p:sp>
       <p:pic>
         <p:nvPicPr>
-          <p:cNvPr id="5" name="Picture 4" descr="card_ens5.png"/>
+          <p:cNvPr id="5" name="Picture 4" descr="card_ens5_auc.png"/>
           <p:cNvPicPr>
             <a:picLocks noChangeAspect="1"/>
           </p:cNvPicPr>
@@ -12720,14 +13048,108 @@
                 </a:solidFill>
                 <a:latin typeface="Arial"/>
               </a:rPr>
-              <a:t>Рисунок 19 – ens5: 60,3 % вчасно на спільній вибірці, пропущено 0</a:t>
-            </a:r>
-          </a:p>
-        </p:txBody>
-      </p:sp>
-      <p:sp>
-        <p:nvSpPr>
-          <p:cNvPr id="7" name="TextBox 6"/>
+              <a:t>Рисунок 19 – ens5: 60,3 % вчасно на спільній вибірці, пропущено 0 (поле «поріг» замінено на ROC AUC; офіційні набори toksym)</a:t>
+            </a:r>
+          </a:p>
+        </p:txBody>
+      </p:sp>
+      <p:sp>
+        <p:nvSpPr>
+          <p:cNvPr id="7" name="Rectangle 6"/>
+          <p:cNvSpPr/>
+          <p:nvPr/>
+        </p:nvSpPr>
+        <p:spPr>
+          <a:xfrm>
+            <a:off x="548640" y="2673029"/>
+            <a:ext cx="6492240" cy="914400"/>
+          </a:xfrm>
+          <a:prstGeom prst="rect">
+            <a:avLst/>
+          </a:prstGeom>
+          <a:solidFill>
+            <a:srgbClr val="F8FAFC"/>
+          </a:solidFill>
+          <a:ln w="12700">
+            <a:solidFill>
+              <a:srgbClr val="E2E8F0"/>
+            </a:solidFill>
+          </a:ln>
+          <a:effectLst/>
+        </p:spPr>
+        <p:style>
+          <a:lnRef idx="1">
+            <a:schemeClr val="accent1"/>
+          </a:lnRef>
+          <a:fillRef idx="3">
+            <a:schemeClr val="accent1"/>
+          </a:fillRef>
+          <a:effectRef idx="2">
+            <a:schemeClr val="accent1"/>
+          </a:effectRef>
+          <a:fontRef idx="minor">
+            <a:schemeClr val="lt1"/>
+          </a:fontRef>
+        </p:style>
+        <p:txBody>
+          <a:bodyPr rtlCol="0" anchor="ctr"/>
+          <a:lstStyle/>
+          <a:p>
+            <a:pPr algn="ctr"/>
+          </a:p>
+        </p:txBody>
+      </p:sp>
+      <p:sp>
+        <p:nvSpPr>
+          <p:cNvPr id="8" name="TextBox 7"/>
+          <p:cNvSpPr txBox="1"/>
+          <p:nvPr/>
+        </p:nvSpPr>
+        <p:spPr>
+          <a:xfrm>
+            <a:off x="685800" y="2764469"/>
+            <a:ext cx="6217920" cy="731520"/>
+          </a:xfrm>
+          <a:prstGeom prst="rect">
+            <a:avLst/>
+          </a:prstGeom>
+          <a:noFill/>
+        </p:spPr>
+        <p:txBody>
+          <a:bodyPr wrap="square" anchor="t" lIns="0" rIns="0" tIns="0" bIns="0">
+            <a:spAutoFit/>
+          </a:bodyPr>
+          <a:lstStyle/>
+          <a:p>
+            <a:pPr algn="l">
+              <a:spcAft>
+                <a:spcPts val="0"/>
+              </a:spcAft>
+            </a:pPr>
+            <a:r>
+              <a:rPr sz="1100" b="1" i="0">
+                <a:solidFill>
+                  <a:srgbClr val="0E7490"/>
+                </a:solidFill>
+                <a:latin typeface="Arial"/>
+              </a:rPr>
+              <a:t>Чому ROC AUC замість порогу. </a:t>
+            </a:r>
+            <a:r>
+              <a:rPr sz="1100" b="0" i="0">
+                <a:solidFill>
+                  <a:srgbClr val="475569"/>
+                </a:solidFill>
+                <a:latin typeface="Arial"/>
+              </a:rPr>
+              <a:t>Поріг спрацювання неінформативний: його підбирає засіб оцінки під бюджет хибних тривог, шкала ймовірностей у моделей різна, а на малій вибірці поріг задає один тихий розряд. Тому на скриншотах замість порогу наведено ROC AUC, яка від порогу не залежить.</a:t>
+            </a:r>
+          </a:p>
+        </p:txBody>
+      </p:sp>
+      <p:sp>
+        <p:nvSpPr>
+          <p:cNvPr id="9" name="TextBox 8"/>
           <p:cNvSpPr txBox="1"/>
           <p:nvPr/>
         </p:nvSpPr>
@@ -12825,13 +13247,13 @@
       </p:sp>
       <p:sp>
         <p:nvSpPr>
-          <p:cNvPr id="8" name="TextBox 7"/>
+          <p:cNvPr id="10" name="TextBox 9"/>
           <p:cNvSpPr txBox="1"/>
           <p:nvPr/>
         </p:nvSpPr>
         <p:spPr>
           <a:xfrm>
-            <a:off x="7315200" y="4626864"/>
+            <a:off x="7315200" y="3703320"/>
             <a:ext cx="4343400" cy="320040"/>
           </a:xfrm>
           <a:prstGeom prst="rect">
@@ -12864,15 +13286,15 @@
       </p:sp>
       <p:graphicFrame>
         <p:nvGraphicFramePr>
-          <p:cNvPr id="9" name="Table 8"/>
+          <p:cNvPr id="11" name="Table 10"/>
           <p:cNvGraphicFramePr>
             <a:graphicFrameLocks noGrp="1"/>
           </p:cNvGraphicFramePr>
           <p:nvPr/>
         </p:nvGraphicFramePr>
         <p:xfrm>
-          <a:off x="7315200" y="5038344"/>
-          <a:ext cx="4343400" cy="1316736"/>
+          <a:off x="7315200" y="4069080"/>
+          <a:ext cx="4343400" cy="1389888"/>
         </p:xfrm>
         <a:graphic>
           <a:graphicData uri="http://schemas.openxmlformats.org/drawingml/2006/table">
@@ -12884,7 +13306,7 @@
                 <a:gridCol w="2514600"/>
                 <a:gridCol w="1828800"/>
               </a:tblGrid>
-              <a:tr h="329184">
+              <a:tr h="347472">
                 <a:tc>
                   <a:txBody>
                     <a:bodyPr wrap="square"/>
@@ -12932,7 +13354,7 @@
                   </a:tcPr>
                 </a:tc>
               </a:tr>
-              <a:tr h="329184">
+              <a:tr h="347472">
                 <a:tc>
                   <a:txBody>
                     <a:bodyPr wrap="square"/>
@@ -12980,7 +13402,7 @@
                   </a:tcPr>
                 </a:tc>
               </a:tr>
-              <a:tr h="329184">
+              <a:tr h="347472">
                 <a:tc>
                   <a:txBody>
                     <a:bodyPr wrap="square"/>
@@ -13028,7 +13450,7 @@
                   </a:tcPr>
                 </a:tc>
               </a:tr>
-              <a:tr h="329184">
+              <a:tr h="347472">
                 <a:tc>
                   <a:txBody>
                     <a:bodyPr wrap="square"/>
@@ -13230,7 +13652,7 @@
       </p:sp>
       <p:pic>
         <p:nvPicPr>
-          <p:cNvPr id="5" name="Picture 4" descr="card_sim_impact.png"/>
+          <p:cNvPr id="5" name="Picture 4" descr="card_sim_impact_auc.png"/>
           <p:cNvPicPr>
             <a:picLocks noChangeAspect="1"/>
           </p:cNvPicPr>
@@ -13286,14 +13708,108 @@
                 </a:solidFill>
                 <a:latin typeface="Arial"/>
               </a:rPr>
-              <a:t>Рисунок 20 – ImpactNet у симуляторі fusion-sim, 50 розрядів</a:t>
-            </a:r>
-          </a:p>
-        </p:txBody>
-      </p:sp>
-      <p:sp>
-        <p:nvSpPr>
-          <p:cNvPr id="7" name="TextBox 6"/>
+              <a:t>Рисунок 20 – ImpactNet у симуляторі fusion-sim, 50 розрядів (поле «поріг» замінено на ROC AUC; ROC AUC цього прогону)</a:t>
+            </a:r>
+          </a:p>
+        </p:txBody>
+      </p:sp>
+      <p:sp>
+        <p:nvSpPr>
+          <p:cNvPr id="7" name="Rectangle 6"/>
+          <p:cNvSpPr/>
+          <p:nvPr/>
+        </p:nvSpPr>
+        <p:spPr>
+          <a:xfrm>
+            <a:off x="548640" y="5038582"/>
+            <a:ext cx="6492240" cy="914400"/>
+          </a:xfrm>
+          <a:prstGeom prst="rect">
+            <a:avLst/>
+          </a:prstGeom>
+          <a:solidFill>
+            <a:srgbClr val="F8FAFC"/>
+          </a:solidFill>
+          <a:ln w="12700">
+            <a:solidFill>
+              <a:srgbClr val="E2E8F0"/>
+            </a:solidFill>
+          </a:ln>
+          <a:effectLst/>
+        </p:spPr>
+        <p:style>
+          <a:lnRef idx="1">
+            <a:schemeClr val="accent1"/>
+          </a:lnRef>
+          <a:fillRef idx="3">
+            <a:schemeClr val="accent1"/>
+          </a:fillRef>
+          <a:effectRef idx="2">
+            <a:schemeClr val="accent1"/>
+          </a:effectRef>
+          <a:fontRef idx="minor">
+            <a:schemeClr val="lt1"/>
+          </a:fontRef>
+        </p:style>
+        <p:txBody>
+          <a:bodyPr rtlCol="0" anchor="ctr"/>
+          <a:lstStyle/>
+          <a:p>
+            <a:pPr algn="ctr"/>
+          </a:p>
+        </p:txBody>
+      </p:sp>
+      <p:sp>
+        <p:nvSpPr>
+          <p:cNvPr id="8" name="TextBox 7"/>
+          <p:cNvSpPr txBox="1"/>
+          <p:nvPr/>
+        </p:nvSpPr>
+        <p:spPr>
+          <a:xfrm>
+            <a:off x="685800" y="5130022"/>
+            <a:ext cx="6217920" cy="731520"/>
+          </a:xfrm>
+          <a:prstGeom prst="rect">
+            <a:avLst/>
+          </a:prstGeom>
+          <a:noFill/>
+        </p:spPr>
+        <p:txBody>
+          <a:bodyPr wrap="square" anchor="t" lIns="0" rIns="0" tIns="0" bIns="0">
+            <a:spAutoFit/>
+          </a:bodyPr>
+          <a:lstStyle/>
+          <a:p>
+            <a:pPr algn="l">
+              <a:spcAft>
+                <a:spcPts val="0"/>
+              </a:spcAft>
+            </a:pPr>
+            <a:r>
+              <a:rPr sz="1100" b="1" i="0">
+                <a:solidFill>
+                  <a:srgbClr val="0E7490"/>
+                </a:solidFill>
+                <a:latin typeface="Arial"/>
+              </a:rPr>
+              <a:t>Чому ROC AUC замість порогу. </a:t>
+            </a:r>
+            <a:r>
+              <a:rPr sz="1100" b="0" i="0">
+                <a:solidFill>
+                  <a:srgbClr val="475569"/>
+                </a:solidFill>
+                <a:latin typeface="Arial"/>
+              </a:rPr>
+              <a:t>Поріг спрацювання неінформативний: його підбирає засіб оцінки під бюджет хибних тривог, шкала ймовірностей у моделей різна, а на малій вибірці поріг задає один тихий розряд. Тому на скриншотах замість порогу наведено ROC AUC, яка від порогу не залежить.</a:t>
+            </a:r>
+          </a:p>
+        </p:txBody>
+      </p:sp>
+      <p:sp>
+        <p:nvSpPr>
+          <p:cNvPr id="9" name="TextBox 8"/>
           <p:cNvSpPr txBox="1"/>
           <p:nvPr/>
         </p:nvSpPr>
@@ -13391,13 +13907,13 @@
       </p:sp>
       <p:sp>
         <p:nvSpPr>
-          <p:cNvPr id="8" name="TextBox 7"/>
+          <p:cNvPr id="10" name="TextBox 9"/>
           <p:cNvSpPr txBox="1"/>
           <p:nvPr/>
         </p:nvSpPr>
         <p:spPr>
           <a:xfrm>
-            <a:off x="7315200" y="4956048"/>
+            <a:off x="7315200" y="3703320"/>
             <a:ext cx="4343400" cy="320040"/>
           </a:xfrm>
           <a:prstGeom prst="rect">
@@ -13430,15 +13946,15 @@
       </p:sp>
       <p:graphicFrame>
         <p:nvGraphicFramePr>
-          <p:cNvPr id="9" name="Table 8"/>
+          <p:cNvPr id="11" name="Table 10"/>
           <p:cNvGraphicFramePr>
             <a:graphicFrameLocks noGrp="1"/>
           </p:cNvGraphicFramePr>
           <p:nvPr/>
         </p:nvGraphicFramePr>
         <p:xfrm>
-          <a:off x="7315200" y="5367528"/>
-          <a:ext cx="4343400" cy="987552"/>
+          <a:off x="7315200" y="4069080"/>
+          <a:ext cx="4343400" cy="1389888"/>
         </p:xfrm>
         <a:graphic>
           <a:graphicData uri="http://schemas.openxmlformats.org/drawingml/2006/table">
@@ -13450,7 +13966,7 @@
                 <a:gridCol w="2514600"/>
                 <a:gridCol w="1828800"/>
               </a:tblGrid>
-              <a:tr h="329184">
+              <a:tr h="347472">
                 <a:tc>
                   <a:txBody>
                     <a:bodyPr wrap="square"/>
@@ -13498,7 +14014,7 @@
                   </a:tcPr>
                 </a:tc>
               </a:tr>
-              <a:tr h="329184">
+              <a:tr h="347472">
                 <a:tc>
                   <a:txBody>
                     <a:bodyPr wrap="square"/>
@@ -13546,7 +14062,55 @@
                   </a:tcPr>
                 </a:tc>
               </a:tr>
-              <a:tr h="329184">
+              <a:tr h="347472">
+                <a:tc>
+                  <a:txBody>
+                    <a:bodyPr wrap="square"/>
+                    <a:lstStyle/>
+                    <a:p>
+                      <a:pPr algn="l"/>
+                      <a:r>
+                        <a:rPr sz="1100" b="1">
+                          <a:solidFill>
+                            <a:srgbClr val="0F172A"/>
+                          </a:solidFill>
+                          <a:latin typeface="Arial"/>
+                        </a:rPr>
+                        <a:t>ROC AUC, 0,1 с (цей прогін)</a:t>
+                      </a:r>
+                    </a:p>
+                  </a:txBody>
+                  <a:tcPr marL="91440" marR="91440" marT="27432" marB="27432" anchor="ctr">
+                    <a:solidFill>
+                      <a:srgbClr val="FFFFFF"/>
+                    </a:solidFill>
+                  </a:tcPr>
+                </a:tc>
+                <a:tc>
+                  <a:txBody>
+                    <a:bodyPr wrap="square"/>
+                    <a:lstStyle/>
+                    <a:p>
+                      <a:pPr algn="ctr"/>
+                      <a:r>
+                        <a:rPr sz="1200" b="0">
+                          <a:solidFill>
+                            <a:srgbClr val="0F172A"/>
+                          </a:solidFill>
+                          <a:latin typeface="Arial"/>
+                        </a:rPr>
+                        <a:t>0,885</a:t>
+                      </a:r>
+                    </a:p>
+                  </a:txBody>
+                  <a:tcPr marL="91440" marR="91440" marT="27432" marB="27432" anchor="ctr">
+                    <a:solidFill>
+                      <a:srgbClr val="FFFFFF"/>
+                    </a:solidFill>
+                  </a:tcPr>
+                </a:tc>
+              </a:tr>
+              <a:tr h="347472">
                 <a:tc>
                   <a:txBody>
                     <a:bodyPr wrap="square"/>

</xml_diff>

<commit_message>
Link the closed-loop simulator fork; 200-discharge attribution results
README and deck: simulator repo (fork of fusionsimulator.io, GPL-3.0) with QR on
the final slide; slide 13 and card A.7 use the 200-discharge run (34 / 49).
</commit_message>
<xml_diff>
--- a/docs/presentation.pptx
+++ b/docs/presentation.pptx
@@ -873,7 +873,7 @@
           <a:lstStyle/>
           <a:p>
             <a:r>
-              <a:t>≈50 с. Симулятор fusion-sim з керуванням у реальному часі: модель тривоги, ImpactNet і порадник. Замкнений контур на 40 розрядах: 11 зривів без керування, 5 з керуванням. Атрибуція на новому рушії: 10 з 12 механізмів, межа Грінвальда і радіація — без помилок; кінк недооцінено. Рушій не моделює шум діагностик, тому калібрування моделей, навчених на шумних даних, переноситься не повністю; наступний крок — додати вимірювальний тракт toksym.</a:t>
+              <a:t>≈50 с. Симулятор fusion-sim з керуванням у реальному часі: модель тривоги, ImpactNet і порадник. Замкнений контур на 40 розрядах: 11 зривів без керування, 5 з керуванням. Атрибуція на новому рушії, 200 розрядів: 34 з 49; Грінвальд 16 з 16, радіація 14 з 17, кінк лише 4 з 16. Рушій не моделює шум діагностик, тому калібрування моделей, навчених на шумних даних, переноситься не повністю; наступний крок — додати вимірювальний тракт toksym.</a:t>
             </a:r>
           </a:p>
         </p:txBody>
@@ -8331,7 +8331,7 @@
                 </a:solidFill>
                 <a:latin typeface="Arial"/>
               </a:rPr>
-              <a:t>Рисунок 8 – Атрибуція механізмів зриву в симуляторі fusion-sim (50 розрядів): 10 з 12 (поле «поріг» замінено на ROC AUC цього прогону)</a:t>
+              <a:t>Рисунок 8 – Атрибуція механізмів зриву в симуляторі fusion-sim, пробний прогін 50 розрядів: 10 з 12 (поле «поріг» замінено на ROC AUC цього прогону)</a:t>
             </a:r>
           </a:p>
         </p:txBody>
@@ -8493,8 +8493,8 @@
         </p:nvSpPr>
         <p:spPr>
           <a:xfrm>
-            <a:off x="6949440" y="2880360"/>
-            <a:ext cx="4709160" cy="2286000"/>
+            <a:off x="6949440" y="2743200"/>
+            <a:ext cx="4709160" cy="2743200"/>
           </a:xfrm>
           <a:prstGeom prst="rect">
             <a:avLst/>
@@ -8509,7 +8509,7 @@
           <a:p>
             <a:pPr algn="l">
               <a:spcAft>
-                <a:spcPts val="1000"/>
+                <a:spcPts val="800"/>
               </a:spcAft>
             </a:pPr>
             <a:r>
@@ -8534,7 +8534,7 @@
           <a:p>
             <a:pPr algn="l">
               <a:spcAft>
-                <a:spcPts val="1000"/>
+                <a:spcPts val="800"/>
               </a:spcAft>
             </a:pPr>
             <a:r>
@@ -8544,7 +8544,7 @@
                 </a:solidFill>
                 <a:latin typeface="Arial"/>
               </a:rPr>
-              <a:t>Обмеження – </a:t>
+              <a:t>Атрибуція, 200 розрядів – </a:t>
             </a:r>
             <a:r>
               <a:rPr sz="1300" b="0" i="0">
@@ -8553,13 +8553,13 @@
                 </a:solidFill>
                 <a:latin typeface="Arial"/>
               </a:rPr>
-              <a:t>40 розрядів; рушій без шуму діагностик; кінк недооцінено (0 з 2)</a:t>
+              <a:t>механізм визначено в 34 з 49 зривів (69 %): Грінвальд 16 з 16, радіація 14 з 17, кінк 4 з 16</a:t>
             </a:r>
           </a:p>
           <a:p>
             <a:pPr algn="l">
               <a:spcAft>
-                <a:spcPts val="1000"/>
+                <a:spcPts val="800"/>
               </a:spcAft>
             </a:pPr>
             <a:r>
@@ -8569,6 +8569,31 @@
                 </a:solidFill>
                 <a:latin typeface="Arial"/>
               </a:rPr>
+              <a:t>Обмеження – </a:t>
+            </a:r>
+            <a:r>
+              <a:rPr sz="1300" b="0" i="0">
+                <a:solidFill>
+                  <a:srgbClr val="0F172A"/>
+                </a:solidFill>
+                <a:latin typeface="Arial"/>
+              </a:rPr>
+              <a:t>рушій без шуму діагностик; частку кінку (q95) недооцінено: 18 % проти 32 %</a:t>
+            </a:r>
+          </a:p>
+          <a:p>
+            <a:pPr algn="l">
+              <a:spcAft>
+                <a:spcPts val="800"/>
+              </a:spcAft>
+            </a:pPr>
+            <a:r>
+              <a:rPr sz="1300" b="1" i="0">
+                <a:solidFill>
+                  <a:srgbClr val="0F172A"/>
+                </a:solidFill>
+                <a:latin typeface="Arial"/>
+              </a:rPr>
               <a:t>Наступні кроки – </a:t>
             </a:r>
             <a:r>
@@ -8578,7 +8603,64 @@
                 </a:solidFill>
                 <a:latin typeface="Arial"/>
               </a:rPr>
-              <a:t>вимірювальний тракт toksym у fusion-sim, 200 розрядів, оцінка ціни керування</a:t>
+              <a:t>вимірювальний тракт toksym у fusion-sim, калібрування q95, оцінка ціни керування</a:t>
+            </a:r>
+          </a:p>
+        </p:txBody>
+      </p:sp>
+      <p:sp>
+        <p:nvSpPr>
+          <p:cNvPr id="11" name="TextBox 10"/>
+          <p:cNvSpPr txBox="1"/>
+          <p:nvPr/>
+        </p:nvSpPr>
+        <p:spPr>
+          <a:xfrm>
+            <a:off x="6949440" y="5623560"/>
+            <a:ext cx="4709160" cy="640080"/>
+          </a:xfrm>
+          <a:prstGeom prst="rect">
+            <a:avLst/>
+          </a:prstGeom>
+          <a:noFill/>
+        </p:spPr>
+        <p:txBody>
+          <a:bodyPr wrap="square" anchor="t" lIns="0" rIns="0" tIns="0" bIns="0">
+            <a:spAutoFit/>
+          </a:bodyPr>
+          <a:lstStyle/>
+          <a:p>
+            <a:pPr algn="l">
+              <a:spcAft>
+                <a:spcPts val="0"/>
+              </a:spcAft>
+            </a:pPr>
+            <a:r>
+              <a:rPr sz="1000" b="1" i="0">
+                <a:solidFill>
+                  <a:srgbClr val="475569"/>
+                </a:solidFill>
+                <a:latin typeface="Arial"/>
+              </a:rPr>
+              <a:t>Симулятор: </a:t>
+            </a:r>
+            <a:r>
+              <a:rPr sz="1000" b="0" i="0">
+                <a:solidFill>
+                  <a:srgbClr val="1D4ED8"/>
+                </a:solidFill>
+                <a:latin typeface="Arial"/>
+              </a:rPr>
+              <a:t>github.com/lurbaby/plasma_simulator</a:t>
+            </a:r>
+            <a:r>
+              <a:rPr sz="1000" b="0" i="0">
+                <a:solidFill>
+                  <a:srgbClr val="475569"/>
+                </a:solidFill>
+                <a:latin typeface="Arial"/>
+              </a:rPr>
+              <a:t> (форк fusionsimulator.io, D. Burgess, GPL-3.0; командою додано залік toksym і керування актуаторами з моделі)</a:t>
             </a:r>
           </a:p>
         </p:txBody>
@@ -8696,7 +8778,7 @@
         <p:spPr>
           <a:xfrm>
             <a:off x="548640" y="1325880"/>
-            <a:ext cx="7863840" cy="4206240"/>
+            <a:ext cx="6035040" cy="4206240"/>
           </a:xfrm>
           <a:prstGeom prst="rect">
             <a:avLst/>
@@ -8812,7 +8894,7 @@
       </p:sp>
       <p:pic>
         <p:nvPicPr>
-          <p:cNvPr id="5" name="Picture 4" descr="repo_qr.png"/>
+          <p:cNvPr id="5" name="Picture 4" descr="qr_plasma-disruption-prediction.png"/>
           <p:cNvPicPr>
             <a:picLocks noChangeAspect="1"/>
           </p:cNvPicPr>
@@ -8826,8 +8908,8 @@
         </p:blipFill>
         <p:spPr>
           <a:xfrm>
-            <a:off x="9052560" y="1371600"/>
-            <a:ext cx="2468880" cy="2468880"/>
+            <a:off x="7086600" y="1371600"/>
+            <a:ext cx="2103120" cy="2103120"/>
           </a:xfrm>
           <a:prstGeom prst="rect">
             <a:avLst/>
@@ -8842,8 +8924,8 @@
         </p:nvSpPr>
         <p:spPr>
           <a:xfrm>
-            <a:off x="8595360" y="3977639"/>
-            <a:ext cx="3383280" cy="822960"/>
+            <a:off x="6812280" y="3611880"/>
+            <a:ext cx="2651760" cy="1097280"/>
           </a:xfrm>
           <a:prstGeom prst="rect">
             <a:avLst/>
@@ -8874,24 +8956,121 @@
           <a:p>
             <a:pPr algn="ctr">
               <a:spcAft>
+                <a:spcPts val="200"/>
+              </a:spcAft>
+            </a:pPr>
+            <a:r>
+              <a:rPr sz="1000" b="0" i="0">
+                <a:solidFill>
+                  <a:srgbClr val="1D4ED8"/>
+                </a:solidFill>
+                <a:latin typeface="Arial"/>
+              </a:rPr>
+              <a:t>github.com/
+llllenah/plasma-disruption-prediction</a:t>
+            </a:r>
+          </a:p>
+        </p:txBody>
+      </p:sp>
+      <p:pic>
+        <p:nvPicPr>
+          <p:cNvPr id="7" name="Picture 6" descr="qr_plasma_simulator.png"/>
+          <p:cNvPicPr>
+            <a:picLocks noChangeAspect="1"/>
+          </p:cNvPicPr>
+          <p:nvPr/>
+        </p:nvPicPr>
+        <p:blipFill>
+          <a:blip r:embed="rId4"/>
+          <a:stretch>
+            <a:fillRect/>
+          </a:stretch>
+        </p:blipFill>
+        <p:spPr>
+          <a:xfrm>
+            <a:off x="9646919" y="1371600"/>
+            <a:ext cx="2103120" cy="2103120"/>
+          </a:xfrm>
+          <a:prstGeom prst="rect">
+            <a:avLst/>
+          </a:prstGeom>
+        </p:spPr>
+      </p:pic>
+      <p:sp>
+        <p:nvSpPr>
+          <p:cNvPr id="8" name="TextBox 7"/>
+          <p:cNvSpPr txBox="1"/>
+          <p:nvPr/>
+        </p:nvSpPr>
+        <p:spPr>
+          <a:xfrm>
+            <a:off x="9372600" y="3611880"/>
+            <a:ext cx="2651760" cy="1097280"/>
+          </a:xfrm>
+          <a:prstGeom prst="rect">
+            <a:avLst/>
+          </a:prstGeom>
+          <a:noFill/>
+        </p:spPr>
+        <p:txBody>
+          <a:bodyPr wrap="square" anchor="t" lIns="0" rIns="0" tIns="0" bIns="0">
+            <a:spAutoFit/>
+          </a:bodyPr>
+          <a:lstStyle/>
+          <a:p>
+            <a:pPr algn="ctr">
+              <a:spcAft>
+                <a:spcPts val="200"/>
+              </a:spcAft>
+            </a:pPr>
+            <a:r>
+              <a:rPr sz="1300" b="1" i="0">
+                <a:solidFill>
+                  <a:srgbClr val="0F172A"/>
+                </a:solidFill>
+                <a:latin typeface="Arial"/>
+              </a:rPr>
+              <a:t>Симулятор з керуванням</a:t>
+            </a:r>
+          </a:p>
+          <a:p>
+            <a:pPr algn="ctr">
+              <a:spcAft>
+                <a:spcPts val="200"/>
+              </a:spcAft>
+            </a:pPr>
+            <a:r>
+              <a:rPr sz="1000" b="0" i="0">
+                <a:solidFill>
+                  <a:srgbClr val="1D4ED8"/>
+                </a:solidFill>
+                <a:latin typeface="Arial"/>
+              </a:rPr>
+              <a:t>github.com/
+lurbaby/plasma_simulator</a:t>
+            </a:r>
+          </a:p>
+          <a:p>
+            <a:pPr algn="ctr">
+              <a:spcAft>
                 <a:spcPts val="0"/>
               </a:spcAft>
             </a:pPr>
             <a:r>
               <a:rPr sz="1000" b="0" i="0">
                 <a:solidFill>
-                  <a:srgbClr val="1D4ED8"/>
-                </a:solidFill>
-                <a:latin typeface="Arial"/>
-              </a:rPr>
-              <a:t>github.com/llllenah/plasma-disruption-prediction</a:t>
-            </a:r>
-          </a:p>
-        </p:txBody>
-      </p:sp>
-      <p:sp>
-        <p:nvSpPr>
-          <p:cNvPr id="7" name="TextBox 6"/>
+                  <a:srgbClr val="475569"/>
+                </a:solidFill>
+                <a:latin typeface="Arial"/>
+              </a:rPr>
+              <a:t>форк fusionsimulator.io, GPL-3.0</a:t>
+            </a:r>
+          </a:p>
+        </p:txBody>
+      </p:sp>
+      <p:sp>
+        <p:nvSpPr>
+          <p:cNvPr id="9" name="TextBox 8"/>
           <p:cNvSpPr txBox="1"/>
           <p:nvPr/>
         </p:nvSpPr>
@@ -13708,7 +13887,7 @@
                 </a:solidFill>
                 <a:latin typeface="Arial"/>
               </a:rPr>
-              <a:t>Рисунок 20 – ImpactNet у симуляторі fusion-sim, 50 розрядів (поле «поріг» замінено на ROC AUC; ROC AUC цього прогону)</a:t>
+              <a:t>Рисунок 20 – ImpactNet у симуляторі fusion-sim, пробний прогін 50 розрядів (поле «поріг» замінено на ROC AUC; ROC AUC цього прогону)</a:t>
             </a:r>
           </a:p>
         </p:txBody>
@@ -13875,7 +14054,7 @@
                 </a:solidFill>
                 <a:latin typeface="Arial"/>
               </a:rPr>
-              <a:t>механізм визначено в 10 з 12 зривів: межа Грінвальда 7 з 7, радіація 3 з 3</a:t>
+              <a:t>200 розрядів: механізм визначено в 34 з 49 зривів; Грінвальд 16 з 16, радіація 14 з 17</a:t>
             </a:r>
           </a:p>
           <a:p>
@@ -13900,7 +14079,7 @@
                 </a:solidFill>
                 <a:latin typeface="Arial"/>
               </a:rPr>
-              <a:t>кінк 0 з 2: частку q95 недооцінено (17 % → 5 %); потрібне калібрування для безшумного рушія</a:t>
+              <a:t>кінк 4 з 16: частку q95 недооцінено (32 % → 18 %); на toksym 49 з 49, тож причина в зсуві рушія, потрібне калібрування</a:t>
             </a:r>
           </a:p>
         </p:txBody>
@@ -13954,7 +14133,7 @@
         </p:nvGraphicFramePr>
         <p:xfrm>
           <a:off x="7315200" y="4069080"/>
-          <a:ext cx="4343400" cy="1389888"/>
+          <a:ext cx="4343400" cy="2084832"/>
         </p:xfrm>
         <a:graphic>
           <a:graphicData uri="http://schemas.openxmlformats.org/drawingml/2006/table">
@@ -14028,7 +14207,55 @@
                           </a:solidFill>
                           <a:latin typeface="Arial"/>
                         </a:rPr>
-                        <a:t>механізм визначено</a:t>
+                        <a:t>механізм, 200 розрядів</a:t>
+                      </a:r>
+                    </a:p>
+                  </a:txBody>
+                  <a:tcPr marL="91440" marR="91440" marT="27432" marB="27432" anchor="ctr">
+                    <a:solidFill>
+                      <a:srgbClr val="FFFFFF"/>
+                    </a:solidFill>
+                  </a:tcPr>
+                </a:tc>
+                <a:tc>
+                  <a:txBody>
+                    <a:bodyPr wrap="square"/>
+                    <a:lstStyle/>
+                    <a:p>
+                      <a:pPr algn="ctr"/>
+                      <a:r>
+                        <a:rPr sz="1200" b="0">
+                          <a:solidFill>
+                            <a:srgbClr val="0F172A"/>
+                          </a:solidFill>
+                          <a:latin typeface="Arial"/>
+                        </a:rPr>
+                        <a:t>34 з 49 (69 %)</a:t>
+                      </a:r>
+                    </a:p>
+                  </a:txBody>
+                  <a:tcPr marL="91440" marR="91440" marT="27432" marB="27432" anchor="ctr">
+                    <a:solidFill>
+                      <a:srgbClr val="FFFFFF"/>
+                    </a:solidFill>
+                  </a:tcPr>
+                </a:tc>
+              </a:tr>
+              <a:tr h="347472">
+                <a:tc>
+                  <a:txBody>
+                    <a:bodyPr wrap="square"/>
+                    <a:lstStyle/>
+                    <a:p>
+                      <a:pPr algn="l"/>
+                      <a:r>
+                        <a:rPr sz="1100" b="1">
+                          <a:solidFill>
+                            <a:srgbClr val="0F172A"/>
+                          </a:solidFill>
+                          <a:latin typeface="Arial"/>
+                        </a:rPr>
+                        <a:t>механізм, 50 розрядів</a:t>
                       </a:r>
                     </a:p>
                   </a:txBody>
@@ -14076,7 +14303,55 @@
                           </a:solidFill>
                           <a:latin typeface="Arial"/>
                         </a:rPr>
-                        <a:t>ROC AUC, 0,1 с (цей прогін)</a:t>
+                        <a:t>вчасно, 0,1 с, 200 розрядів</a:t>
+                      </a:r>
+                    </a:p>
+                  </a:txBody>
+                  <a:tcPr marL="91440" marR="91440" marT="27432" marB="27432" anchor="ctr">
+                    <a:solidFill>
+                      <a:srgbClr val="FFFFFF"/>
+                    </a:solidFill>
+                  </a:tcPr>
+                </a:tc>
+                <a:tc>
+                  <a:txBody>
+                    <a:bodyPr wrap="square"/>
+                    <a:lstStyle/>
+                    <a:p>
+                      <a:pPr algn="ctr"/>
+                      <a:r>
+                        <a:rPr sz="1200" b="0">
+                          <a:solidFill>
+                            <a:srgbClr val="0F172A"/>
+                          </a:solidFill>
+                          <a:latin typeface="Arial"/>
+                        </a:rPr>
+                        <a:t>51,0 %</a:t>
+                      </a:r>
+                    </a:p>
+                  </a:txBody>
+                  <a:tcPr marL="91440" marR="91440" marT="27432" marB="27432" anchor="ctr">
+                    <a:solidFill>
+                      <a:srgbClr val="FFFFFF"/>
+                    </a:solidFill>
+                  </a:tcPr>
+                </a:tc>
+              </a:tr>
+              <a:tr h="347472">
+                <a:tc>
+                  <a:txBody>
+                    <a:bodyPr wrap="square"/>
+                    <a:lstStyle/>
+                    <a:p>
+                      <a:pPr algn="l"/>
+                      <a:r>
+                        <a:rPr sz="1100" b="1">
+                          <a:solidFill>
+                            <a:srgbClr val="0F172A"/>
+                          </a:solidFill>
+                          <a:latin typeface="Arial"/>
+                        </a:rPr>
+                        <a:t>ROC AUC, 0,1 с (50 розрядів)</a:t>
                       </a:r>
                     </a:p>
                   </a:txBody>
@@ -14124,7 +14399,7 @@
                           </a:solidFill>
                           <a:latin typeface="Arial"/>
                         </a:rPr>
-                        <a:t>R² λ (toksym, тест)</a:t>
+                        <a:t>механізм, toksym (тест)</a:t>
                       </a:r>
                     </a:p>
                   </a:txBody>
@@ -14147,7 +14422,7 @@
                           </a:solidFill>
                           <a:latin typeface="Arial"/>
                         </a:rPr>
-                        <a:t>0,996</a:t>
+                        <a:t>49 з 49</a:t>
                       </a:r>
                     </a:p>
                   </a:txBody>

</xml_diff>

<commit_message>
Deck: predictive control plan (13.1) and significance of the closed-loop result
Closed loop 11 vs 5 on 40 discharges: exact test p = 0.105; about 200
discharges per arm needed for p < 0.01 with power 0.84.
</commit_message>
<xml_diff>
--- a/docs/presentation.pptx
+++ b/docs/presentation.pptx
@@ -23,6 +23,7 @@
     <p:sldId id="271" r:id="rId23"/>
     <p:sldId id="272" r:id="rId24"/>
     <p:sldId id="273" r:id="rId25"/>
+    <p:sldId id="274" r:id="rId26"/>
   </p:sldIdLst>
   <p:sldSz cx="12191695" cy="6858000" type="screen4x3"/>
   <p:notesSz cx="6858000" cy="9144000"/>
@@ -1079,7 +1080,7 @@
           <a:lstStyle/>
           <a:p>
             <a:r>
-              <a:t>≈50 с. Моделі навчені на toksym; fusion-sim — інший рушій, без шуму діагностик. 200 розрядів, жодного донавчання. Модель тривоги переноситься: ROC AUC 0,902 проти 0,934 на запасі 0,1 с. ImpactNet: межа Грінвальда 16 з 16, радіація 14 з 17, кінк лише 4 з 16. В 11 з 16 кінкових зривів мережа видає ту саму частку Грінвальда 97,6 % — це насичення входу, а не фізика. Масштабування часток не рятує: 36 з 49 при 5-кратній перевірці. Отже, потрібне донавчання на даних нового рушія.</a:t>
+              <a:t>≈50 с. Порадник зараз реагує на тривогу, але плазма відповідає на зміну уставки із затримкою: густина ≈ 0,3 с, неон ≈ 0,5 с, а на кінкових розрядах тривога приходить лише за 5–75 мс до гасіння. Тому план — прогнозне керування: кожні 0,25 с копія стану програє 5 варіантів дій на 1,5 с уперед з урахуванням запрограмованих хвиль і вибирає дію з найменшою ціною: ймовірність зриву плюс втрата продуктивності. Копія знає прихований стан, тому це верхня межа; на машину переноситься учень — мережа, що вчиться вибирати ту саму дію лише з діагностик.</a:t>
             </a:r>
           </a:p>
         </p:txBody>
@@ -1105,6 +1106,76 @@
 </file>
 
 <file path=ppt/notesSlides/notesSlide18.xml><?xml version="1.0" encoding="utf-8"?>
+<p:notes xmlns:a="http://schemas.openxmlformats.org/drawingml/2006/main" xmlns:p="http://schemas.openxmlformats.org/presentationml/2006/main" xmlns:r="http://schemas.openxmlformats.org/officeDocument/2006/relationships">
+  <p:cSld>
+    <p:spTree>
+      <p:nvGrpSpPr>
+        <p:cNvPr id="1" name=""/>
+        <p:cNvGrpSpPr/>
+        <p:nvPr/>
+      </p:nvGrpSpPr>
+      <p:grpSpPr>
+        <a:xfrm>
+          <a:off x="0" y="0"/>
+          <a:ext cx="0" cy="0"/>
+          <a:chOff x="0" y="0"/>
+          <a:chExt cx="0" cy="0"/>
+        </a:xfrm>
+      </p:grpSpPr>
+      <p:sp>
+        <p:nvSpPr>
+          <p:cNvPr id="2" name="Slide Image Placeholder 1"/>
+          <p:cNvSpPr>
+            <a:spLocks noGrp="1"/>
+          </p:cNvSpPr>
+          <p:nvPr>
+            <p:ph type="sldImg" idx="2"/>
+          </p:nvPr>
+        </p:nvSpPr>
+        <p:spPr/>
+      </p:sp>
+      <p:sp>
+        <p:nvSpPr>
+          <p:cNvPr id="3" name="Notes Placeholder 2"/>
+          <p:cNvSpPr>
+            <a:spLocks noGrp="1"/>
+          </p:cNvSpPr>
+          <p:nvPr>
+            <p:ph type="body" idx="3" sz="quarter"/>
+          </p:nvPr>
+        </p:nvSpPr>
+        <p:spPr/>
+        <p:txBody>
+          <a:bodyPr/>
+          <a:lstStyle/>
+          <a:p>
+            <a:r>
+              <a:t>≈50 с. Моделі навчені на toksym; fusion-sim — інший рушій, без шуму діагностик. 200 розрядів, жодного донавчання. Модель тривоги переноситься: ROC AUC 0,902 проти 0,934 на запасі 0,1 с. ImpactNet: межа Грінвальда 16 з 16, радіація 14 з 17, кінк лише 4 з 16. В 11 з 16 кінкових зривів мережа видає ту саму частку Грінвальда 97,6 % — це насичення входу, а не фізика. Масштабування часток не рятує: 36 з 49 при 5-кратній перевірці. Отже, потрібне донавчання на даних нового рушія.</a:t>
+            </a:r>
+          </a:p>
+        </p:txBody>
+      </p:sp>
+      <p:sp>
+        <p:nvSpPr>
+          <p:cNvPr id="4" name="Slide Number Placeholder 3"/>
+          <p:cNvSpPr>
+            <a:spLocks noGrp="1"/>
+          </p:cNvSpPr>
+          <p:nvPr>
+            <p:ph type="sldNum" idx="5" sz="quarter"/>
+          </p:nvPr>
+        </p:nvSpPr>
+        <p:spPr/>
+      </p:sp>
+    </p:spTree>
+  </p:cSld>
+  <p:clrMapOvr>
+    <a:masterClrMapping/>
+  </p:clrMapOvr>
+</p:notes>
+</file>
+
+<file path=ppt/notesSlides/notesSlide19.xml><?xml version="1.0" encoding="utf-8"?>
 <p:notes xmlns:a="http://schemas.openxmlformats.org/drawingml/2006/main" xmlns:p="http://schemas.openxmlformats.org/presentationml/2006/main" xmlns:r="http://schemas.openxmlformats.org/officeDocument/2006/relationships">
   <p:cSld>
     <p:spTree>
@@ -9748,7 +9819,7 @@
         <p:spPr>
           <a:xfrm>
             <a:off x="6949440" y="2743200"/>
-            <a:ext cx="4709160" cy="2743200"/>
+            <a:ext cx="4709160" cy="2286000"/>
           </a:xfrm>
           <a:prstGeom prst="rect">
             <a:avLst/>
@@ -9832,32 +9903,7 @@
                 </a:solidFill>
                 <a:latin typeface="Arial"/>
               </a:rPr>
-              <a:t>40 розрядів; ціну керування (втрату продуктивності) ще не оцінено</a:t>
-            </a:r>
-          </a:p>
-          <a:p>
-            <a:pPr algn="l">
-              <a:spcAft>
-                <a:spcPts val="800"/>
-              </a:spcAft>
-            </a:pPr>
-            <a:r>
-              <a:rPr sz="1300" b="1" i="0">
-                <a:solidFill>
-                  <a:srgbClr val="0F172A"/>
-                </a:solidFill>
-                <a:latin typeface="Arial"/>
-              </a:rPr>
-              <a:t>Далі: прогнозне керування – </a:t>
-            </a:r>
-            <a:r>
-              <a:rPr sz="1300" b="0" i="0">
-                <a:solidFill>
-                  <a:srgbClr val="0F172A"/>
-                </a:solidFill>
-                <a:latin typeface="Arial"/>
-              </a:rPr>
-              <a:t>копія стану → 3–5 кандидатних дій → прогноз на 1–2 с → дія з найменшим очікуваним ризиком і найменшою втратою продуктивності</a:t>
+              <a:t>40 розрядів: різниця ще не статистично значуща (p ≈ 0,1, точний тест); для p &lt; 0,01 з імовірністю 0,84 потрібно ≈ 200 розрядів на режим; ціну керування ще не оцінено</a:t>
             </a:r>
           </a:p>
         </p:txBody>
@@ -9979,7 +10025,7 @@
                 </a:solidFill>
                 <a:latin typeface="Arial"/>
               </a:rPr>
-              <a:t>14 Перенесення моделей на інший рушій без донавчання</a:t>
+              <a:t>13.1 Наступний крок: прогнозне керування на копії рушія</a:t>
             </a:r>
           </a:p>
         </p:txBody>
@@ -10023,30 +10069,54 @@
           </a:p>
         </p:txBody>
       </p:sp>
-      <p:pic>
-        <p:nvPicPr>
-          <p:cNvPr id="4" name="Picture 3" descr="sim200.png"/>
-          <p:cNvPicPr>
-            <a:picLocks noChangeAspect="1"/>
-          </p:cNvPicPr>
+      <p:sp>
+        <p:nvSpPr>
+          <p:cNvPr id="4" name="Rounded Rectangle 3"/>
+          <p:cNvSpPr/>
           <p:nvPr/>
-        </p:nvPicPr>
-        <p:blipFill>
-          <a:blip r:embed="rId3"/>
-          <a:stretch>
-            <a:fillRect/>
-          </a:stretch>
-        </p:blipFill>
-        <p:spPr>
-          <a:xfrm>
-            <a:off x="548640" y="1234440"/>
-            <a:ext cx="7589520" cy="3529616"/>
-          </a:xfrm>
-          <a:prstGeom prst="rect">
-            <a:avLst/>
+        </p:nvSpPr>
+        <p:spPr>
+          <a:xfrm>
+            <a:off x="548640" y="1325880"/>
+            <a:ext cx="2377440" cy="1325880"/>
+          </a:xfrm>
+          <a:prstGeom prst="roundRect">
+            <a:avLst>
+              <a:gd name="adj" fmla="val 4000"/>
+            </a:avLst>
           </a:prstGeom>
-        </p:spPr>
-      </p:pic>
+          <a:solidFill>
+            <a:srgbClr val="FFFFFF"/>
+          </a:solidFill>
+          <a:ln w="19050">
+            <a:solidFill>
+              <a:srgbClr val="0E7490"/>
+            </a:solidFill>
+          </a:ln>
+          <a:effectLst/>
+        </p:spPr>
+        <p:style>
+          <a:lnRef idx="1">
+            <a:schemeClr val="accent1"/>
+          </a:lnRef>
+          <a:fillRef idx="3">
+            <a:schemeClr val="accent1"/>
+          </a:fillRef>
+          <a:effectRef idx="2">
+            <a:schemeClr val="accent1"/>
+          </a:effectRef>
+          <a:fontRef idx="minor">
+            <a:schemeClr val="lt1"/>
+          </a:fontRef>
+        </p:style>
+        <p:txBody>
+          <a:bodyPr rtlCol="0" anchor="ctr"/>
+          <a:lstStyle/>
+          <a:p>
+            <a:pPr algn="ctr"/>
+          </a:p>
+        </p:txBody>
+      </p:sp>
       <p:sp>
         <p:nvSpPr>
           <p:cNvPr id="5" name="TextBox 4"/>
@@ -10055,8 +10125,8 @@
         </p:nvSpPr>
         <p:spPr>
           <a:xfrm>
-            <a:off x="548640" y="4809776"/>
-            <a:ext cx="7589520" cy="365760"/>
+            <a:off x="640080" y="1417320"/>
+            <a:ext cx="2194560" cy="1188720"/>
           </a:xfrm>
           <a:prstGeom prst="rect">
             <a:avLst/>
@@ -10064,12 +10134,28 @@
           <a:noFill/>
         </p:spPr>
         <p:txBody>
-          <a:bodyPr wrap="square" anchor="t" lIns="0" rIns="0" tIns="0" bIns="0">
+          <a:bodyPr wrap="square" anchor="ctr" lIns="0" rIns="0" tIns="0" bIns="0">
             <a:spAutoFit/>
           </a:bodyPr>
           <a:lstStyle/>
           <a:p>
-            <a:pPr algn="l">
+            <a:pPr algn="ctr">
+              <a:spcAft>
+                <a:spcPts val="400"/>
+              </a:spcAft>
+            </a:pPr>
+            <a:r>
+              <a:rPr sz="1400" b="1" i="0">
+                <a:solidFill>
+                  <a:srgbClr val="0E7490"/>
+                </a:solidFill>
+                <a:latin typeface="Arial"/>
+              </a:rPr>
+              <a:t>Стан розряду</a:t>
+            </a:r>
+          </a:p>
+          <a:p>
+            <a:pPr algn="ctr">
               <a:spcAft>
                 <a:spcPts val="0"/>
               </a:spcAft>
@@ -10081,21 +10167,113 @@
                 </a:solidFill>
                 <a:latin typeface="Arial"/>
               </a:rPr>
-              <a:t>Рисунок 9 – Модель v8 + ImpactNet у симуляторі fusion-sim, 200 розрядів, 49 зарахованих зривів; праворуч — ті самі онлайн-виходи моделі з measured.csv, різниця лише у виборі моменту</a:t>
-            </a:r>
-          </a:p>
-        </p:txBody>
-      </p:sp>
-      <p:sp>
-        <p:nvSpPr>
-          <p:cNvPr id="6" name="TextBox 5"/>
+              <a:t>копія рушія на поточному кроці</a:t>
+            </a:r>
+          </a:p>
+        </p:txBody>
+      </p:sp>
+      <p:sp>
+        <p:nvSpPr>
+          <p:cNvPr id="6" name="Right Arrow 5"/>
+          <p:cNvSpPr/>
+          <p:nvPr/>
+        </p:nvSpPr>
+        <p:spPr>
+          <a:xfrm>
+            <a:off x="2971800" y="1856231"/>
+            <a:ext cx="365760" cy="274320"/>
+          </a:xfrm>
+          <a:prstGeom prst="rightArrow">
+            <a:avLst/>
+          </a:prstGeom>
+          <a:solidFill>
+            <a:srgbClr val="94A3B8"/>
+          </a:solidFill>
+          <a:ln>
+            <a:noFill/>
+          </a:ln>
+          <a:effectLst/>
+        </p:spPr>
+        <p:style>
+          <a:lnRef idx="1">
+            <a:schemeClr val="accent1"/>
+          </a:lnRef>
+          <a:fillRef idx="3">
+            <a:schemeClr val="accent1"/>
+          </a:fillRef>
+          <a:effectRef idx="2">
+            <a:schemeClr val="accent1"/>
+          </a:effectRef>
+          <a:fontRef idx="minor">
+            <a:schemeClr val="lt1"/>
+          </a:fontRef>
+        </p:style>
+        <p:txBody>
+          <a:bodyPr rtlCol="0" anchor="ctr"/>
+          <a:lstStyle/>
+          <a:p>
+            <a:pPr algn="ctr"/>
+          </a:p>
+        </p:txBody>
+      </p:sp>
+      <p:sp>
+        <p:nvSpPr>
+          <p:cNvPr id="7" name="Rounded Rectangle 6"/>
+          <p:cNvSpPr/>
+          <p:nvPr/>
+        </p:nvSpPr>
+        <p:spPr>
+          <a:xfrm>
+            <a:off x="3383280" y="1325880"/>
+            <a:ext cx="2377440" cy="1325880"/>
+          </a:xfrm>
+          <a:prstGeom prst="roundRect">
+            <a:avLst>
+              <a:gd name="adj" fmla="val 4000"/>
+            </a:avLst>
+          </a:prstGeom>
+          <a:solidFill>
+            <a:srgbClr val="FFFFFF"/>
+          </a:solidFill>
+          <a:ln w="19050">
+            <a:solidFill>
+              <a:srgbClr val="6D28D9"/>
+            </a:solidFill>
+          </a:ln>
+          <a:effectLst/>
+        </p:spPr>
+        <p:style>
+          <a:lnRef idx="1">
+            <a:schemeClr val="accent1"/>
+          </a:lnRef>
+          <a:fillRef idx="3">
+            <a:schemeClr val="accent1"/>
+          </a:fillRef>
+          <a:effectRef idx="2">
+            <a:schemeClr val="accent1"/>
+          </a:effectRef>
+          <a:fontRef idx="minor">
+            <a:schemeClr val="lt1"/>
+          </a:fontRef>
+        </p:style>
+        <p:txBody>
+          <a:bodyPr rtlCol="0" anchor="ctr"/>
+          <a:lstStyle/>
+          <a:p>
+            <a:pPr algn="ctr"/>
+          </a:p>
+        </p:txBody>
+      </p:sp>
+      <p:sp>
+        <p:nvSpPr>
+          <p:cNvPr id="8" name="TextBox 7"/>
           <p:cNvSpPr txBox="1"/>
           <p:nvPr/>
         </p:nvSpPr>
         <p:spPr>
           <a:xfrm>
-            <a:off x="8458200" y="1325880"/>
-            <a:ext cx="3200400" cy="2743200"/>
+            <a:off x="3474720" y="1417320"/>
+            <a:ext cx="2194560" cy="1188720"/>
           </a:xfrm>
           <a:prstGeom prst="rect">
             <a:avLst/>
@@ -10103,6 +10281,355 @@
           <a:noFill/>
         </p:spPr>
         <p:txBody>
+          <a:bodyPr wrap="square" anchor="ctr" lIns="0" rIns="0" tIns="0" bIns="0">
+            <a:spAutoFit/>
+          </a:bodyPr>
+          <a:lstStyle/>
+          <a:p>
+            <a:pPr algn="ctr">
+              <a:spcAft>
+                <a:spcPts val="400"/>
+              </a:spcAft>
+            </a:pPr>
+            <a:r>
+              <a:rPr sz="1400" b="1" i="0">
+                <a:solidFill>
+                  <a:srgbClr val="6D28D9"/>
+                </a:solidFill>
+                <a:latin typeface="Arial"/>
+              </a:rPr>
+              <a:t>5 варіантів дій</a:t>
+            </a:r>
+          </a:p>
+          <a:p>
+            <a:pPr algn="ctr">
+              <a:spcAft>
+                <a:spcPts val="0"/>
+              </a:spcAft>
+            </a:pPr>
+            <a:r>
+              <a:rPr sz="1100" b="0" i="0">
+                <a:solidFill>
+                  <a:srgbClr val="475569"/>
+                </a:solidFill>
+                <a:latin typeface="Arial"/>
+              </a:rPr>
+              <a:t>нічого; густина −10 / −20 %; неон; нагрів або струм</a:t>
+            </a:r>
+          </a:p>
+        </p:txBody>
+      </p:sp>
+      <p:sp>
+        <p:nvSpPr>
+          <p:cNvPr id="9" name="Right Arrow 8"/>
+          <p:cNvSpPr/>
+          <p:nvPr/>
+        </p:nvSpPr>
+        <p:spPr>
+          <a:xfrm>
+            <a:off x="5806440" y="1856231"/>
+            <a:ext cx="365760" cy="274320"/>
+          </a:xfrm>
+          <a:prstGeom prst="rightArrow">
+            <a:avLst/>
+          </a:prstGeom>
+          <a:solidFill>
+            <a:srgbClr val="94A3B8"/>
+          </a:solidFill>
+          <a:ln>
+            <a:noFill/>
+          </a:ln>
+          <a:effectLst/>
+        </p:spPr>
+        <p:style>
+          <a:lnRef idx="1">
+            <a:schemeClr val="accent1"/>
+          </a:lnRef>
+          <a:fillRef idx="3">
+            <a:schemeClr val="accent1"/>
+          </a:fillRef>
+          <a:effectRef idx="2">
+            <a:schemeClr val="accent1"/>
+          </a:effectRef>
+          <a:fontRef idx="minor">
+            <a:schemeClr val="lt1"/>
+          </a:fontRef>
+        </p:style>
+        <p:txBody>
+          <a:bodyPr rtlCol="0" anchor="ctr"/>
+          <a:lstStyle/>
+          <a:p>
+            <a:pPr algn="ctr"/>
+          </a:p>
+        </p:txBody>
+      </p:sp>
+      <p:sp>
+        <p:nvSpPr>
+          <p:cNvPr id="10" name="Rounded Rectangle 9"/>
+          <p:cNvSpPr/>
+          <p:nvPr/>
+        </p:nvSpPr>
+        <p:spPr>
+          <a:xfrm>
+            <a:off x="6217920" y="1325880"/>
+            <a:ext cx="2377440" cy="1325880"/>
+          </a:xfrm>
+          <a:prstGeom prst="roundRect">
+            <a:avLst>
+              <a:gd name="adj" fmla="val 4000"/>
+            </a:avLst>
+          </a:prstGeom>
+          <a:solidFill>
+            <a:srgbClr val="FFFFFF"/>
+          </a:solidFill>
+          <a:ln w="19050">
+            <a:solidFill>
+              <a:srgbClr val="1D4ED8"/>
+            </a:solidFill>
+          </a:ln>
+          <a:effectLst/>
+        </p:spPr>
+        <p:style>
+          <a:lnRef idx="1">
+            <a:schemeClr val="accent1"/>
+          </a:lnRef>
+          <a:fillRef idx="3">
+            <a:schemeClr val="accent1"/>
+          </a:fillRef>
+          <a:effectRef idx="2">
+            <a:schemeClr val="accent1"/>
+          </a:effectRef>
+          <a:fontRef idx="minor">
+            <a:schemeClr val="lt1"/>
+          </a:fontRef>
+        </p:style>
+        <p:txBody>
+          <a:bodyPr rtlCol="0" anchor="ctr"/>
+          <a:lstStyle/>
+          <a:p>
+            <a:pPr algn="ctr"/>
+          </a:p>
+        </p:txBody>
+      </p:sp>
+      <p:sp>
+        <p:nvSpPr>
+          <p:cNvPr id="11" name="TextBox 10"/>
+          <p:cNvSpPr txBox="1"/>
+          <p:nvPr/>
+        </p:nvSpPr>
+        <p:spPr>
+          <a:xfrm>
+            <a:off x="6309359" y="1417320"/>
+            <a:ext cx="2194560" cy="1188720"/>
+          </a:xfrm>
+          <a:prstGeom prst="rect">
+            <a:avLst/>
+          </a:prstGeom>
+          <a:noFill/>
+        </p:spPr>
+        <p:txBody>
+          <a:bodyPr wrap="square" anchor="ctr" lIns="0" rIns="0" tIns="0" bIns="0">
+            <a:spAutoFit/>
+          </a:bodyPr>
+          <a:lstStyle/>
+          <a:p>
+            <a:pPr algn="ctr">
+              <a:spcAft>
+                <a:spcPts val="400"/>
+              </a:spcAft>
+            </a:pPr>
+            <a:r>
+              <a:rPr sz="1400" b="1" i="0">
+                <a:solidFill>
+                  <a:srgbClr val="1D4ED8"/>
+                </a:solidFill>
+                <a:latin typeface="Arial"/>
+              </a:rPr>
+              <a:t>Прогноз 1,5 с</a:t>
+            </a:r>
+          </a:p>
+          <a:p>
+            <a:pPr algn="ctr">
+              <a:spcAft>
+                <a:spcPts val="0"/>
+              </a:spcAft>
+            </a:pPr>
+            <a:r>
+              <a:rPr sz="1100" b="0" i="0">
+                <a:solidFill>
+                  <a:srgbClr val="475569"/>
+                </a:solidFill>
+                <a:latin typeface="Arial"/>
+              </a:rPr>
+              <a:t>запрограмовані хвилі + уставки варіанта; сума λ за горизонт</a:t>
+            </a:r>
+          </a:p>
+        </p:txBody>
+      </p:sp>
+      <p:sp>
+        <p:nvSpPr>
+          <p:cNvPr id="12" name="Right Arrow 11"/>
+          <p:cNvSpPr/>
+          <p:nvPr/>
+        </p:nvSpPr>
+        <p:spPr>
+          <a:xfrm>
+            <a:off x="8641080" y="1856231"/>
+            <a:ext cx="365760" cy="274320"/>
+          </a:xfrm>
+          <a:prstGeom prst="rightArrow">
+            <a:avLst/>
+          </a:prstGeom>
+          <a:solidFill>
+            <a:srgbClr val="94A3B8"/>
+          </a:solidFill>
+          <a:ln>
+            <a:noFill/>
+          </a:ln>
+          <a:effectLst/>
+        </p:spPr>
+        <p:style>
+          <a:lnRef idx="1">
+            <a:schemeClr val="accent1"/>
+          </a:lnRef>
+          <a:fillRef idx="3">
+            <a:schemeClr val="accent1"/>
+          </a:fillRef>
+          <a:effectRef idx="2">
+            <a:schemeClr val="accent1"/>
+          </a:effectRef>
+          <a:fontRef idx="minor">
+            <a:schemeClr val="lt1"/>
+          </a:fontRef>
+        </p:style>
+        <p:txBody>
+          <a:bodyPr rtlCol="0" anchor="ctr"/>
+          <a:lstStyle/>
+          <a:p>
+            <a:pPr algn="ctr"/>
+          </a:p>
+        </p:txBody>
+      </p:sp>
+      <p:sp>
+        <p:nvSpPr>
+          <p:cNvPr id="13" name="Rounded Rectangle 12"/>
+          <p:cNvSpPr/>
+          <p:nvPr/>
+        </p:nvSpPr>
+        <p:spPr>
+          <a:xfrm>
+            <a:off x="9052560" y="1325880"/>
+            <a:ext cx="2377440" cy="1325880"/>
+          </a:xfrm>
+          <a:prstGeom prst="roundRect">
+            <a:avLst>
+              <a:gd name="adj" fmla="val 4000"/>
+            </a:avLst>
+          </a:prstGeom>
+          <a:solidFill>
+            <a:srgbClr val="FFFFFF"/>
+          </a:solidFill>
+          <a:ln w="19050">
+            <a:solidFill>
+              <a:srgbClr val="C2410C"/>
+            </a:solidFill>
+          </a:ln>
+          <a:effectLst/>
+        </p:spPr>
+        <p:style>
+          <a:lnRef idx="1">
+            <a:schemeClr val="accent1"/>
+          </a:lnRef>
+          <a:fillRef idx="3">
+            <a:schemeClr val="accent1"/>
+          </a:fillRef>
+          <a:effectRef idx="2">
+            <a:schemeClr val="accent1"/>
+          </a:effectRef>
+          <a:fontRef idx="minor">
+            <a:schemeClr val="lt1"/>
+          </a:fontRef>
+        </p:style>
+        <p:txBody>
+          <a:bodyPr rtlCol="0" anchor="ctr"/>
+          <a:lstStyle/>
+          <a:p>
+            <a:pPr algn="ctr"/>
+          </a:p>
+        </p:txBody>
+      </p:sp>
+      <p:sp>
+        <p:nvSpPr>
+          <p:cNvPr id="14" name="TextBox 13"/>
+          <p:cNvSpPr txBox="1"/>
+          <p:nvPr/>
+        </p:nvSpPr>
+        <p:spPr>
+          <a:xfrm>
+            <a:off x="9144000" y="1417320"/>
+            <a:ext cx="2194560" cy="1188720"/>
+          </a:xfrm>
+          <a:prstGeom prst="rect">
+            <a:avLst/>
+          </a:prstGeom>
+          <a:noFill/>
+        </p:spPr>
+        <p:txBody>
+          <a:bodyPr wrap="square" anchor="ctr" lIns="0" rIns="0" tIns="0" bIns="0">
+            <a:spAutoFit/>
+          </a:bodyPr>
+          <a:lstStyle/>
+          <a:p>
+            <a:pPr algn="ctr">
+              <a:spcAft>
+                <a:spcPts val="400"/>
+              </a:spcAft>
+            </a:pPr>
+            <a:r>
+              <a:rPr sz="1400" b="1" i="0">
+                <a:solidFill>
+                  <a:srgbClr val="C2410C"/>
+                </a:solidFill>
+                <a:latin typeface="Arial"/>
+              </a:rPr>
+              <a:t>Вибір дії</a:t>
+            </a:r>
+          </a:p>
+          <a:p>
+            <a:pPr algn="ctr">
+              <a:spcAft>
+                <a:spcPts val="0"/>
+              </a:spcAft>
+            </a:pPr>
+            <a:r>
+              <a:rPr sz="1100" b="0" i="0">
+                <a:solidFill>
+                  <a:srgbClr val="475569"/>
+                </a:solidFill>
+                <a:latin typeface="Arial"/>
+              </a:rPr>
+              <a:t>мінімум ціни J, кожні 0,25 с</a:t>
+            </a:r>
+          </a:p>
+        </p:txBody>
+      </p:sp>
+      <p:sp>
+        <p:nvSpPr>
+          <p:cNvPr id="15" name="TextBox 14"/>
+          <p:cNvSpPr txBox="1"/>
+          <p:nvPr/>
+        </p:nvSpPr>
+        <p:spPr>
+          <a:xfrm>
+            <a:off x="548640" y="2743200"/>
+            <a:ext cx="10972800" cy="365760"/>
+          </a:xfrm>
+          <a:prstGeom prst="rect">
+            <a:avLst/>
+          </a:prstGeom>
+          <a:noFill/>
+        </p:spPr>
+        <p:txBody>
           <a:bodyPr wrap="square" anchor="t" lIns="0" rIns="0" tIns="0" bIns="0">
             <a:spAutoFit/>
           </a:bodyPr>
@@ -10110,7 +10637,454 @@
           <a:p>
             <a:pPr algn="l">
               <a:spcAft>
-                <a:spcPts val="700"/>
+                <a:spcPts val="0"/>
+              </a:spcAft>
+            </a:pPr>
+            <a:r>
+              <a:rPr sz="1100" b="0" i="0">
+                <a:solidFill>
+                  <a:srgbClr val="475569"/>
+                </a:solidFill>
+                <a:latin typeface="Arial"/>
+              </a:rPr>
+              <a:t>Рисунок 9 – Схема прогнозного керування (план; потребує копіювання стану рушія)</a:t>
+            </a:r>
+          </a:p>
+        </p:txBody>
+      </p:sp>
+      <p:sp>
+        <p:nvSpPr>
+          <p:cNvPr id="16" name="TextBox 15"/>
+          <p:cNvSpPr txBox="1"/>
+          <p:nvPr/>
+        </p:nvSpPr>
+        <p:spPr>
+          <a:xfrm>
+            <a:off x="548640" y="3200400"/>
+            <a:ext cx="5669280" cy="822960"/>
+          </a:xfrm>
+          <a:prstGeom prst="rect">
+            <a:avLst/>
+          </a:prstGeom>
+          <a:noFill/>
+        </p:spPr>
+        <p:txBody>
+          <a:bodyPr wrap="square" anchor="t" lIns="0" rIns="0" tIns="0" bIns="0">
+            <a:spAutoFit/>
+          </a:bodyPr>
+          <a:lstStyle/>
+          <a:p>
+            <a:pPr algn="l">
+              <a:spcAft>
+                <a:spcPts val="400"/>
+              </a:spcAft>
+            </a:pPr>
+            <a:r>
+              <a:rPr sz="1500" b="1" i="0">
+                <a:solidFill>
+                  <a:srgbClr val="0F172A"/>
+                </a:solidFill>
+                <a:latin typeface="Arial"/>
+              </a:rPr>
+              <a:t>J = P(зрив за горизонт) + α · втрата продуктивності</a:t>
+            </a:r>
+          </a:p>
+          <a:p>
+            <a:pPr algn="l">
+              <a:spcAft>
+                <a:spcPts val="0"/>
+              </a:spcAft>
+            </a:pPr>
+            <a:r>
+              <a:rPr sz="1200" b="0" i="0">
+                <a:solidFill>
+                  <a:srgbClr val="475569"/>
+                </a:solidFill>
+                <a:latin typeface="Arial"/>
+              </a:rPr>
+              <a:t>P = 1 − exp(−Σλ·Δt) по прогнозу копії; без другого доданку найкращою дією завжди було б «вимкнути все»</a:t>
+            </a:r>
+          </a:p>
+        </p:txBody>
+      </p:sp>
+      <p:sp>
+        <p:nvSpPr>
+          <p:cNvPr id="17" name="TextBox 16"/>
+          <p:cNvSpPr txBox="1"/>
+          <p:nvPr/>
+        </p:nvSpPr>
+        <p:spPr>
+          <a:xfrm>
+            <a:off x="548640" y="4206240"/>
+            <a:ext cx="5669280" cy="320040"/>
+          </a:xfrm>
+          <a:prstGeom prst="rect">
+            <a:avLst/>
+          </a:prstGeom>
+          <a:noFill/>
+        </p:spPr>
+        <p:txBody>
+          <a:bodyPr wrap="square" anchor="t" lIns="0" rIns="0" tIns="0" bIns="0">
+            <a:spAutoFit/>
+          </a:bodyPr>
+          <a:lstStyle/>
+          <a:p>
+            <a:pPr algn="l">
+              <a:spcAft>
+                <a:spcPts val="0"/>
+              </a:spcAft>
+            </a:pPr>
+            <a:r>
+              <a:rPr sz="1100" b="0" i="0">
+                <a:solidFill>
+                  <a:srgbClr val="475569"/>
+                </a:solidFill>
+                <a:latin typeface="Arial"/>
+              </a:rPr>
+              <a:t>Таблиця 8 – Оцінка часових масштабів</a:t>
+            </a:r>
+          </a:p>
+        </p:txBody>
+      </p:sp>
+      <p:graphicFrame>
+        <p:nvGraphicFramePr>
+          <p:cNvPr id="18" name="Table 17"/>
+          <p:cNvGraphicFramePr>
+            <a:graphicFrameLocks noGrp="1"/>
+          </p:cNvGraphicFramePr>
+          <p:nvPr/>
+        </p:nvGraphicFramePr>
+        <p:xfrm>
+          <a:off x="548640" y="4572000"/>
+          <a:ext cx="5669280" cy="1975104"/>
+        </p:xfrm>
+        <a:graphic>
+          <a:graphicData uri="http://schemas.openxmlformats.org/drawingml/2006/table">
+            <a:tbl>
+              <a:tblPr firstRow="0" bandRow="0">
+                <a:tableStyleId>{5C22544A-7EE6-4342-B048-85BDC9FD1C3A}</a:tableStyleId>
+              </a:tblPr>
+              <a:tblGrid>
+                <a:gridCol w="2834640"/>
+                <a:gridCol w="2834640"/>
+              </a:tblGrid>
+              <a:tr h="329184">
+                <a:tc>
+                  <a:txBody>
+                    <a:bodyPr wrap="square"/>
+                    <a:lstStyle/>
+                    <a:p>
+                      <a:pPr algn="l"/>
+                      <a:r>
+                        <a:rPr sz="1100" b="1">
+                          <a:solidFill>
+                            <a:srgbClr val="475569"/>
+                          </a:solidFill>
+                          <a:latin typeface="Arial"/>
+                        </a:rPr>
+                        <a:t>величина</a:t>
+                      </a:r>
+                    </a:p>
+                  </a:txBody>
+                  <a:tcPr marL="91440" marR="91440" marT="27432" marB="27432" anchor="ctr">
+                    <a:solidFill>
+                      <a:srgbClr val="F1F5F9"/>
+                    </a:solidFill>
+                  </a:tcPr>
+                </a:tc>
+                <a:tc>
+                  <a:txBody>
+                    <a:bodyPr wrap="square"/>
+                    <a:lstStyle/>
+                    <a:p>
+                      <a:pPr algn="ctr"/>
+                      <a:r>
+                        <a:rPr sz="1100" b="1">
+                          <a:solidFill>
+                            <a:srgbClr val="475569"/>
+                          </a:solidFill>
+                          <a:latin typeface="Arial"/>
+                        </a:rPr>
+                        <a:t>значення</a:t>
+                      </a:r>
+                    </a:p>
+                  </a:txBody>
+                  <a:tcPr marL="91440" marR="91440" marT="27432" marB="27432" anchor="ctr">
+                    <a:solidFill>
+                      <a:srgbClr val="F1F5F9"/>
+                    </a:solidFill>
+                  </a:tcPr>
+                </a:tc>
+              </a:tr>
+              <a:tr h="329184">
+                <a:tc>
+                  <a:txBody>
+                    <a:bodyPr wrap="square"/>
+                    <a:lstStyle/>
+                    <a:p>
+                      <a:pPr algn="l"/>
+                      <a:r>
+                        <a:rPr sz="1100" b="1">
+                          <a:solidFill>
+                            <a:srgbClr val="0F172A"/>
+                          </a:solidFill>
+                          <a:latin typeface="Arial"/>
+                        </a:rPr>
+                        <a:t>реакція плазми на уставку</a:t>
+                      </a:r>
+                    </a:p>
+                  </a:txBody>
+                  <a:tcPr marL="91440" marR="91440" marT="27432" marB="27432" anchor="ctr">
+                    <a:solidFill>
+                      <a:srgbClr val="FFFFFF"/>
+                    </a:solidFill>
+                  </a:tcPr>
+                </a:tc>
+                <a:tc>
+                  <a:txBody>
+                    <a:bodyPr wrap="square"/>
+                    <a:lstStyle/>
+                    <a:p>
+                      <a:pPr algn="ctr"/>
+                      <a:r>
+                        <a:rPr sz="1100" b="0">
+                          <a:solidFill>
+                            <a:srgbClr val="0F172A"/>
+                          </a:solidFill>
+                          <a:latin typeface="Arial"/>
+                        </a:rPr>
+                        <a:t>густина ≈ 0,3 с, неон ≈ 0,5 с</a:t>
+                      </a:r>
+                    </a:p>
+                  </a:txBody>
+                  <a:tcPr marL="91440" marR="91440" marT="27432" marB="27432" anchor="ctr">
+                    <a:solidFill>
+                      <a:srgbClr val="FFFFFF"/>
+                    </a:solidFill>
+                  </a:tcPr>
+                </a:tc>
+              </a:tr>
+              <a:tr h="329184">
+                <a:tc>
+                  <a:txBody>
+                    <a:bodyPr wrap="square"/>
+                    <a:lstStyle/>
+                    <a:p>
+                      <a:pPr algn="l"/>
+                      <a:r>
+                        <a:rPr sz="1100" b="1">
+                          <a:solidFill>
+                            <a:srgbClr val="0F172A"/>
+                          </a:solidFill>
+                          <a:latin typeface="Arial"/>
+                        </a:rPr>
+                        <a:t>попередження на кінкових розрядах</a:t>
+                      </a:r>
+                    </a:p>
+                  </a:txBody>
+                  <a:tcPr marL="91440" marR="91440" marT="27432" marB="27432" anchor="ctr">
+                    <a:solidFill>
+                      <a:srgbClr val="FFFFFF"/>
+                    </a:solidFill>
+                  </a:tcPr>
+                </a:tc>
+                <a:tc>
+                  <a:txBody>
+                    <a:bodyPr wrap="square"/>
+                    <a:lstStyle/>
+                    <a:p>
+                      <a:pPr algn="ctr"/>
+                      <a:r>
+                        <a:rPr sz="1100" b="0">
+                          <a:solidFill>
+                            <a:srgbClr val="0F172A"/>
+                          </a:solidFill>
+                          <a:latin typeface="Arial"/>
+                        </a:rPr>
+                        <a:t>5–75 мс (200 розрядів fusion-sim)</a:t>
+                      </a:r>
+                    </a:p>
+                  </a:txBody>
+                  <a:tcPr marL="91440" marR="91440" marT="27432" marB="27432" anchor="ctr">
+                    <a:solidFill>
+                      <a:srgbClr val="FFFFFF"/>
+                    </a:solidFill>
+                  </a:tcPr>
+                </a:tc>
+              </a:tr>
+              <a:tr h="329184">
+                <a:tc>
+                  <a:txBody>
+                    <a:bodyPr wrap="square"/>
+                    <a:lstStyle/>
+                    <a:p>
+                      <a:pPr algn="l"/>
+                      <a:r>
+                        <a:rPr sz="1100" b="1">
+                          <a:solidFill>
+                            <a:srgbClr val="0F172A"/>
+                          </a:solidFill>
+                          <a:latin typeface="Arial"/>
+                        </a:rPr>
+                        <a:t>горизонт прогнозу</a:t>
+                      </a:r>
+                    </a:p>
+                  </a:txBody>
+                  <a:tcPr marL="91440" marR="91440" marT="27432" marB="27432" anchor="ctr">
+                    <a:solidFill>
+                      <a:srgbClr val="FFFFFF"/>
+                    </a:solidFill>
+                  </a:tcPr>
+                </a:tc>
+                <a:tc>
+                  <a:txBody>
+                    <a:bodyPr wrap="square"/>
+                    <a:lstStyle/>
+                    <a:p>
+                      <a:pPr algn="ctr"/>
+                      <a:r>
+                        <a:rPr sz="1100" b="0">
+                          <a:solidFill>
+                            <a:srgbClr val="0F172A"/>
+                          </a:solidFill>
+                          <a:latin typeface="Arial"/>
+                        </a:rPr>
+                        <a:t>1,5 с = 300 кроків ≈ 5 τ густини</a:t>
+                      </a:r>
+                    </a:p>
+                  </a:txBody>
+                  <a:tcPr marL="91440" marR="91440" marT="27432" marB="27432" anchor="ctr">
+                    <a:solidFill>
+                      <a:srgbClr val="FFFFFF"/>
+                    </a:solidFill>
+                  </a:tcPr>
+                </a:tc>
+              </a:tr>
+              <a:tr h="329184">
+                <a:tc>
+                  <a:txBody>
+                    <a:bodyPr wrap="square"/>
+                    <a:lstStyle/>
+                    <a:p>
+                      <a:pPr algn="l"/>
+                      <a:r>
+                        <a:rPr sz="1100" b="1">
+                          <a:solidFill>
+                            <a:srgbClr val="0F172A"/>
+                          </a:solidFill>
+                          <a:latin typeface="Arial"/>
+                        </a:rPr>
+                        <a:t>обчислення на рішення</a:t>
+                      </a:r>
+                    </a:p>
+                  </a:txBody>
+                  <a:tcPr marL="91440" marR="91440" marT="27432" marB="27432" anchor="ctr">
+                    <a:solidFill>
+                      <a:srgbClr val="FFFFFF"/>
+                    </a:solidFill>
+                  </a:tcPr>
+                </a:tc>
+                <a:tc>
+                  <a:txBody>
+                    <a:bodyPr wrap="square"/>
+                    <a:lstStyle/>
+                    <a:p>
+                      <a:pPr algn="ctr"/>
+                      <a:r>
+                        <a:rPr sz="1100" b="0">
+                          <a:solidFill>
+                            <a:srgbClr val="0F172A"/>
+                          </a:solidFill>
+                          <a:latin typeface="Arial"/>
+                        </a:rPr>
+                        <a:t>5 × 300 = 1 500 кроків рушія</a:t>
+                      </a:r>
+                    </a:p>
+                  </a:txBody>
+                  <a:tcPr marL="91440" marR="91440" marT="27432" marB="27432" anchor="ctr">
+                    <a:solidFill>
+                      <a:srgbClr val="FFFFFF"/>
+                    </a:solidFill>
+                  </a:tcPr>
+                </a:tc>
+              </a:tr>
+              <a:tr h="329184">
+                <a:tc>
+                  <a:txBody>
+                    <a:bodyPr wrap="square"/>
+                    <a:lstStyle/>
+                    <a:p>
+                      <a:pPr algn="l"/>
+                      <a:r>
+                        <a:rPr sz="1100" b="1">
+                          <a:solidFill>
+                            <a:srgbClr val="0F172A"/>
+                          </a:solidFill>
+                          <a:latin typeface="Arial"/>
+                        </a:rPr>
+                        <a:t>внесення зміни</a:t>
+                      </a:r>
+                    </a:p>
+                  </a:txBody>
+                  <a:tcPr marL="91440" marR="91440" marT="27432" marB="27432" anchor="ctr">
+                    <a:solidFill>
+                      <a:srgbClr val="FFFFFF"/>
+                    </a:solidFill>
+                  </a:tcPr>
+                </a:tc>
+                <a:tc>
+                  <a:txBody>
+                    <a:bodyPr wrap="square"/>
+                    <a:lstStyle/>
+                    <a:p>
+                      <a:pPr algn="ctr"/>
+                      <a:r>
+                        <a:rPr sz="1100" b="0">
+                          <a:solidFill>
+                            <a:srgbClr val="0F172A"/>
+                          </a:solidFill>
+                          <a:latin typeface="Arial"/>
+                        </a:rPr>
+                        <a:t>1–3 кадри = 5–15 мс</a:t>
+                      </a:r>
+                    </a:p>
+                  </a:txBody>
+                  <a:tcPr marL="91440" marR="91440" marT="27432" marB="27432" anchor="ctr">
+                    <a:solidFill>
+                      <a:srgbClr val="FFFFFF"/>
+                    </a:solidFill>
+                  </a:tcPr>
+                </a:tc>
+              </a:tr>
+            </a:tbl>
+          </a:graphicData>
+        </a:graphic>
+      </p:graphicFrame>
+      <p:sp>
+        <p:nvSpPr>
+          <p:cNvPr id="19" name="TextBox 18"/>
+          <p:cNvSpPr txBox="1"/>
+          <p:nvPr/>
+        </p:nvSpPr>
+        <p:spPr>
+          <a:xfrm>
+            <a:off x="6766560" y="3200400"/>
+            <a:ext cx="4892040" cy="2286000"/>
+          </a:xfrm>
+          <a:prstGeom prst="rect">
+            <a:avLst/>
+          </a:prstGeom>
+          <a:noFill/>
+        </p:spPr>
+        <p:txBody>
+          <a:bodyPr wrap="square" anchor="t" lIns="0" rIns="0" tIns="0" bIns="0">
+            <a:spAutoFit/>
+          </a:bodyPr>
+          <a:lstStyle/>
+          <a:p>
+            <a:pPr algn="l">
+              <a:spcAft>
+                <a:spcPts val="800"/>
               </a:spcAft>
             </a:pPr>
             <a:r>
@@ -10120,7 +11094,7 @@
                 </a:solidFill>
                 <a:latin typeface="Arial"/>
               </a:rPr>
-              <a:t>Тривога – </a:t>
+              <a:t>Чому копія – </a:t>
             </a:r>
             <a:r>
               <a:rPr sz="1200" b="0" i="0">
@@ -10129,13 +11103,13 @@
                 </a:solidFill>
                 <a:latin typeface="Arial"/>
               </a:rPr>
-              <a:t>переноситься: ROC AUC 0,902 проти 0,934 на 0,1 с, 0,970 на 30 мс</a:t>
+              <a:t>реактивний порадник запізнюється: тривога за 5–75 мс, а плазма відповідає за 0,3–0,5 с; копія бачить запрограмоване майбутнє і діє заздалегідь</a:t>
             </a:r>
           </a:p>
           <a:p>
             <a:pPr algn="l">
               <a:spcAft>
-                <a:spcPts val="700"/>
+                <a:spcPts val="800"/>
               </a:spcAft>
             </a:pPr>
             <a:r>
@@ -10145,7 +11119,7 @@
                 </a:solidFill>
                 <a:latin typeface="Arial"/>
               </a:rPr>
-              <a:t>Знахідка – </a:t>
+              <a:t>Вчитель → учень – </a:t>
             </a:r>
             <a:r>
               <a:rPr sz="1200" b="0" i="0">
@@ -10154,13 +11128,13 @@
                 </a:solidFill>
                 <a:latin typeface="Arial"/>
               </a:rPr>
-              <a:t>симулятор брав частки в момент максимуму λ по всьому розряду, а він припадав на прогрів мережі при t = 5 мс, коли плазми ще нема (типова відповідь «Грінвальд 97,6 %»)</a:t>
+              <a:t>копія вибирає дію (верхня межа); мережа вчиться вибирати ту саму дію лише з діагностик — це переноситься на реальну машину</a:t>
             </a:r>
           </a:p>
           <a:p>
             <a:pPr algn="l">
               <a:spcAft>
-                <a:spcPts val="700"/>
+                <a:spcPts val="800"/>
               </a:spcAft>
             </a:pPr>
             <a:r>
@@ -10170,7 +11144,7 @@
                 </a:solidFill>
                 <a:latin typeface="Arial"/>
               </a:rPr>
-              <a:t>Виправлення – </a:t>
+              <a:t>Чесно – </a:t>
             </a:r>
             <a:r>
               <a:rPr sz="1200" b="0" i="0">
@@ -10179,32 +11153,7 @@
                 </a:solidFill>
                 <a:latin typeface="Arial"/>
               </a:rPr>
-              <a:t>максимум λ лише там, де є плазма: 34 → 45 з 49, кінк 4 → 15 з 16, без донавчання</a:t>
-            </a:r>
-          </a:p>
-          <a:p>
-            <a:pPr algn="l">
-              <a:spcAft>
-                <a:spcPts val="700"/>
-              </a:spcAft>
-            </a:pPr>
-            <a:r>
-              <a:rPr sz="1200" b="1" i="0">
-                <a:solidFill>
-                  <a:srgbClr val="0F172A"/>
-                </a:solidFill>
-                <a:latin typeface="Arial"/>
-              </a:rPr>
-              <a:t>Залишок – </a:t>
-            </a:r>
-            <a:r>
-              <a:rPr sz="1200" b="0" i="0">
-                <a:solidFill>
-                  <a:srgbClr val="0F172A"/>
-                </a:solidFill>
-                <a:latin typeface="Arial"/>
-              </a:rPr>
-              <a:t>3 радіаційні зриви названо кінком</a:t>
+              <a:t>копія знає прихований стан плазми, тому її результат — верхня межа, а не досяжний на машині показник</a:t>
             </a:r>
           </a:p>
         </p:txBody>
@@ -10269,7 +11218,7 @@
                 </a:solidFill>
                 <a:latin typeface="Arial"/>
               </a:rPr>
-              <a:t>15 Висновки</a:t>
+              <a:t>14 Перенесення моделей на інший рушій без донавчання</a:t>
             </a:r>
           </a:p>
         </p:txBody>
@@ -10309,6 +11258,296 @@
                 <a:latin typeface="Arial"/>
               </a:rPr>
               <a:t>18</a:t>
+            </a:r>
+          </a:p>
+        </p:txBody>
+      </p:sp>
+      <p:pic>
+        <p:nvPicPr>
+          <p:cNvPr id="4" name="Picture 3" descr="sim200.png"/>
+          <p:cNvPicPr>
+            <a:picLocks noChangeAspect="1"/>
+          </p:cNvPicPr>
+          <p:nvPr/>
+        </p:nvPicPr>
+        <p:blipFill>
+          <a:blip r:embed="rId3"/>
+          <a:stretch>
+            <a:fillRect/>
+          </a:stretch>
+        </p:blipFill>
+        <p:spPr>
+          <a:xfrm>
+            <a:off x="548640" y="1234440"/>
+            <a:ext cx="7589520" cy="3529616"/>
+          </a:xfrm>
+          <a:prstGeom prst="rect">
+            <a:avLst/>
+          </a:prstGeom>
+        </p:spPr>
+      </p:pic>
+      <p:sp>
+        <p:nvSpPr>
+          <p:cNvPr id="5" name="TextBox 4"/>
+          <p:cNvSpPr txBox="1"/>
+          <p:nvPr/>
+        </p:nvSpPr>
+        <p:spPr>
+          <a:xfrm>
+            <a:off x="548640" y="4809776"/>
+            <a:ext cx="7589520" cy="365760"/>
+          </a:xfrm>
+          <a:prstGeom prst="rect">
+            <a:avLst/>
+          </a:prstGeom>
+          <a:noFill/>
+        </p:spPr>
+        <p:txBody>
+          <a:bodyPr wrap="square" anchor="t" lIns="0" rIns="0" tIns="0" bIns="0">
+            <a:spAutoFit/>
+          </a:bodyPr>
+          <a:lstStyle/>
+          <a:p>
+            <a:pPr algn="l">
+              <a:spcAft>
+                <a:spcPts val="0"/>
+              </a:spcAft>
+            </a:pPr>
+            <a:r>
+              <a:rPr sz="1100" b="0" i="0">
+                <a:solidFill>
+                  <a:srgbClr val="475569"/>
+                </a:solidFill>
+                <a:latin typeface="Arial"/>
+              </a:rPr>
+              <a:t>Рисунок 10 – Модель v8 + ImpactNet у симуляторі fusion-sim, 200 розрядів, 49 зарахованих зривів; праворуч — ті самі онлайн-виходи моделі з measured.csv, різниця лише у виборі моменту</a:t>
+            </a:r>
+          </a:p>
+        </p:txBody>
+      </p:sp>
+      <p:sp>
+        <p:nvSpPr>
+          <p:cNvPr id="6" name="TextBox 5"/>
+          <p:cNvSpPr txBox="1"/>
+          <p:nvPr/>
+        </p:nvSpPr>
+        <p:spPr>
+          <a:xfrm>
+            <a:off x="8458200" y="1325880"/>
+            <a:ext cx="3200400" cy="2743200"/>
+          </a:xfrm>
+          <a:prstGeom prst="rect">
+            <a:avLst/>
+          </a:prstGeom>
+          <a:noFill/>
+        </p:spPr>
+        <p:txBody>
+          <a:bodyPr wrap="square" anchor="t" lIns="0" rIns="0" tIns="0" bIns="0">
+            <a:spAutoFit/>
+          </a:bodyPr>
+          <a:lstStyle/>
+          <a:p>
+            <a:pPr algn="l">
+              <a:spcAft>
+                <a:spcPts val="700"/>
+              </a:spcAft>
+            </a:pPr>
+            <a:r>
+              <a:rPr sz="1200" b="1" i="0">
+                <a:solidFill>
+                  <a:srgbClr val="0F172A"/>
+                </a:solidFill>
+                <a:latin typeface="Arial"/>
+              </a:rPr>
+              <a:t>Тривога – </a:t>
+            </a:r>
+            <a:r>
+              <a:rPr sz="1200" b="0" i="0">
+                <a:solidFill>
+                  <a:srgbClr val="0F172A"/>
+                </a:solidFill>
+                <a:latin typeface="Arial"/>
+              </a:rPr>
+              <a:t>переноситься: ROC AUC 0,902 проти 0,934 на 0,1 с, 0,970 на 30 мс</a:t>
+            </a:r>
+          </a:p>
+          <a:p>
+            <a:pPr algn="l">
+              <a:spcAft>
+                <a:spcPts val="700"/>
+              </a:spcAft>
+            </a:pPr>
+            <a:r>
+              <a:rPr sz="1200" b="1" i="0">
+                <a:solidFill>
+                  <a:srgbClr val="0F172A"/>
+                </a:solidFill>
+                <a:latin typeface="Arial"/>
+              </a:rPr>
+              <a:t>Знахідка – </a:t>
+            </a:r>
+            <a:r>
+              <a:rPr sz="1200" b="0" i="0">
+                <a:solidFill>
+                  <a:srgbClr val="0F172A"/>
+                </a:solidFill>
+                <a:latin typeface="Arial"/>
+              </a:rPr>
+              <a:t>симулятор брав частки в момент максимуму λ по всьому розряду, а він припадав на прогрів мережі при t = 5 мс, коли плазми ще нема (типова відповідь «Грінвальд 97,6 %»)</a:t>
+            </a:r>
+          </a:p>
+          <a:p>
+            <a:pPr algn="l">
+              <a:spcAft>
+                <a:spcPts val="700"/>
+              </a:spcAft>
+            </a:pPr>
+            <a:r>
+              <a:rPr sz="1200" b="1" i="0">
+                <a:solidFill>
+                  <a:srgbClr val="0F172A"/>
+                </a:solidFill>
+                <a:latin typeface="Arial"/>
+              </a:rPr>
+              <a:t>Виправлення – </a:t>
+            </a:r>
+            <a:r>
+              <a:rPr sz="1200" b="0" i="0">
+                <a:solidFill>
+                  <a:srgbClr val="0F172A"/>
+                </a:solidFill>
+                <a:latin typeface="Arial"/>
+              </a:rPr>
+              <a:t>максимум λ лише там, де є плазма: 34 → 45 з 49, кінк 4 → 15 з 16, без донавчання</a:t>
+            </a:r>
+          </a:p>
+          <a:p>
+            <a:pPr algn="l">
+              <a:spcAft>
+                <a:spcPts val="700"/>
+              </a:spcAft>
+            </a:pPr>
+            <a:r>
+              <a:rPr sz="1200" b="1" i="0">
+                <a:solidFill>
+                  <a:srgbClr val="0F172A"/>
+                </a:solidFill>
+                <a:latin typeface="Arial"/>
+              </a:rPr>
+              <a:t>Залишок – </a:t>
+            </a:r>
+            <a:r>
+              <a:rPr sz="1200" b="0" i="0">
+                <a:solidFill>
+                  <a:srgbClr val="0F172A"/>
+                </a:solidFill>
+                <a:latin typeface="Arial"/>
+              </a:rPr>
+              <a:t>3 радіаційні зриви названо кінком</a:t>
+            </a:r>
+          </a:p>
+        </p:txBody>
+      </p:sp>
+    </p:spTree>
+  </p:cSld>
+  <p:clrMapOvr>
+    <a:masterClrMapping/>
+  </p:clrMapOvr>
+</p:sld>
+</file>
+
+<file path=ppt/slides/slide19.xml><?xml version="1.0" encoding="utf-8"?>
+<p:sld xmlns:a="http://schemas.openxmlformats.org/drawingml/2006/main" xmlns:p="http://schemas.openxmlformats.org/presentationml/2006/main" xmlns:r="http://schemas.openxmlformats.org/officeDocument/2006/relationships">
+  <p:cSld>
+    <p:bg>
+      <p:bgPr>
+        <a:solidFill>
+          <a:srgbClr val="FFFFFF"/>
+        </a:solidFill>
+        <a:effectLst/>
+      </p:bgPr>
+    </p:bg>
+    <p:spTree>
+      <p:nvGrpSpPr>
+        <p:cNvPr id="1" name=""/>
+        <p:cNvGrpSpPr/>
+        <p:nvPr/>
+      </p:nvGrpSpPr>
+      <p:grpSpPr/>
+      <p:sp>
+        <p:nvSpPr>
+          <p:cNvPr id="2" name="TextBox 1"/>
+          <p:cNvSpPr txBox="1"/>
+          <p:nvPr/>
+        </p:nvSpPr>
+        <p:spPr>
+          <a:xfrm>
+            <a:off x="548640" y="411480"/>
+            <a:ext cx="11064240" cy="640080"/>
+          </a:xfrm>
+          <a:prstGeom prst="rect">
+            <a:avLst/>
+          </a:prstGeom>
+          <a:noFill/>
+        </p:spPr>
+        <p:txBody>
+          <a:bodyPr wrap="square" anchor="t" lIns="0" rIns="0" tIns="0" bIns="0">
+            <a:spAutoFit/>
+          </a:bodyPr>
+          <a:lstStyle/>
+          <a:p>
+            <a:pPr algn="l">
+              <a:spcAft>
+                <a:spcPts val="0"/>
+              </a:spcAft>
+            </a:pPr>
+            <a:r>
+              <a:rPr sz="2600" b="1" i="0">
+                <a:solidFill>
+                  <a:srgbClr val="0F172A"/>
+                </a:solidFill>
+                <a:latin typeface="Arial"/>
+              </a:rPr>
+              <a:t>15 Висновки</a:t>
+            </a:r>
+          </a:p>
+        </p:txBody>
+      </p:sp>
+      <p:sp>
+        <p:nvSpPr>
+          <p:cNvPr id="3" name="TextBox 2"/>
+          <p:cNvSpPr txBox="1"/>
+          <p:nvPr/>
+        </p:nvSpPr>
+        <p:spPr>
+          <a:xfrm>
+            <a:off x="11247120" y="6446520"/>
+            <a:ext cx="457200" cy="274320"/>
+          </a:xfrm>
+          <a:prstGeom prst="rect">
+            <a:avLst/>
+          </a:prstGeom>
+          <a:noFill/>
+        </p:spPr>
+        <p:txBody>
+          <a:bodyPr wrap="square" anchor="t" lIns="0" rIns="0" tIns="0" bIns="0">
+            <a:spAutoFit/>
+          </a:bodyPr>
+          <a:lstStyle/>
+          <a:p>
+            <a:pPr algn="r">
+              <a:spcAft>
+                <a:spcPts val="0"/>
+              </a:spcAft>
+            </a:pPr>
+            <a:r>
+              <a:rPr sz="1000" b="0" i="0">
+                <a:solidFill>
+                  <a:srgbClr val="94A3B8"/>
+                </a:solidFill>
+                <a:latin typeface="Arial"/>
+              </a:rPr>
+              <a:t>19</a:t>
             </a:r>
           </a:p>
         </p:txBody>

</xml_diff>

<commit_message>
Deck 13.1: teacher without planned disturbances, per-variant records, DAgger student
</commit_message>
<xml_diff>
--- a/docs/presentation.pptx
+++ b/docs/presentation.pptx
@@ -1080,7 +1080,7 @@
           <a:lstStyle/>
           <a:p>
             <a:r>
-              <a:t>≈50 с. Порадник зараз реагує на тривогу, але плазма відповідає на зміну уставки із затримкою: густина ≈ 0,3 с, неон ≈ 0,5 с, а на кінкових розрядах тривога приходить лише за 5–75 мс до гасіння. Тому план — прогнозне керування: кожні 0,25 с копія стану програє 5 варіантів дій на 1,5 с уперед з урахуванням запрограмованих хвиль і вибирає дію з найменшою ціною: ймовірність зриву плюс втрата продуктивності. Копія знає прихований стан, тому це верхня межа; на машину переноситься учень — мережа, що вчиться вибирати ту саму дію лише з діагностик.</a:t>
+              <a:t>≈60 с. Порадник зараз реагує на тривогу, але плазма відповідає на зміну уставки із затримкою: густина ≈ 0,3 с, неон ≈ 0,5 с, а на кінкових розрядах тривога приходить лише за 5–75 мс до гасіння. План — прогнозне керування: кожні 0,25 с копія стану програє 5 варіантів дій на 1,5 с уперед і вибирає дію з найменшою ціною: ймовірність зриву плюс втрата продуктивності. Уставки в копії тримаються на поточному рівні, щоб вчитель не бачив запланованих збурень — інакше учень не зможе його навчитися. Копія знає прихований стан, тому вона — вчитель і верхня межа; на машину переноситься учень, що вибирає дію лише з діагностик і запускається від λ, яку оцінює ImpactNet. Після першого учня — раунд DAgger.</a:t>
             </a:r>
           </a:p>
         </p:txBody>
@@ -10025,7 +10025,7 @@
                 </a:solidFill>
                 <a:latin typeface="Arial"/>
               </a:rPr>
-              <a:t>13.1 Наступний крок: прогнозне керування на копії рушія</a:t>
+              <a:t>13.1 Наступний крок: прогнозне керування і навчання учня</a:t>
             </a:r>
           </a:p>
         </p:txBody>
@@ -10167,7 +10167,7 @@
                 </a:solidFill>
                 <a:latin typeface="Arial"/>
               </a:rPr>
-              <a:t>копія рушія на поточному кроці</a:t>
+              <a:t>копія рушія; уставки на поточному рівні, без запланованих збурень</a:t>
             </a:r>
           </a:p>
         </p:txBody>
@@ -10314,7 +10314,7 @@
                 </a:solidFill>
                 <a:latin typeface="Arial"/>
               </a:rPr>
-              <a:t>нічого; густина −10 / −20 %; неон; нагрів або струм</a:t>
+              <a:t>нічого; густина −10 / −20 %; неон; нагрів або струм; «послабити»</a:t>
             </a:r>
           </a:p>
         </p:txBody>
@@ -10461,7 +10461,7 @@
                 </a:solidFill>
                 <a:latin typeface="Arial"/>
               </a:rPr>
-              <a:t>запрограмовані хвилі + уставки варіанта; сума λ за горизонт</a:t>
+              <a:t>сума λ і втрата продуктивності для кожного варіанта</a:t>
             </a:r>
           </a:p>
         </p:txBody>
@@ -10608,7 +10608,7 @@
                 </a:solidFill>
                 <a:latin typeface="Arial"/>
               </a:rPr>
-              <a:t>мінімум ціни J, кожні 0,25 с</a:t>
+              <a:t>мінімум ціни J, кожні 0,25 с; запуск від λ, а не від тривоги</a:t>
             </a:r>
           </a:p>
         </p:txBody>
@@ -10647,7 +10647,7 @@
                 </a:solidFill>
                 <a:latin typeface="Arial"/>
               </a:rPr>
-              <a:t>Рисунок 9 – Схема прогнозного керування (план; потребує копіювання стану рушія)</a:t>
+              <a:t>Рисунок 9 – Схема вчителя: прогнозне керування на копії рушія (план; потребує копіювання стану рушія)</a:t>
             </a:r>
           </a:p>
         </p:txBody>
@@ -11068,8 +11068,8 @@
         </p:nvSpPr>
         <p:spPr>
           <a:xfrm>
-            <a:off x="6766560" y="3200400"/>
-            <a:ext cx="4892040" cy="2286000"/>
+            <a:off x="6766560" y="3154680"/>
+            <a:ext cx="4892040" cy="2743200"/>
           </a:xfrm>
           <a:prstGeom prst="rect">
             <a:avLst/>
@@ -11084,7 +11084,7 @@
           <a:p>
             <a:pPr algn="l">
               <a:spcAft>
-                <a:spcPts val="800"/>
+                <a:spcPts val="700"/>
               </a:spcAft>
             </a:pPr>
             <a:r>
@@ -11103,13 +11103,13 @@
                 </a:solidFill>
                 <a:latin typeface="Arial"/>
               </a:rPr>
-              <a:t>реактивний порадник запізнюється: тривога за 5–75 мс, а плазма відповідає за 0,3–0,5 с; копія бачить запрограмоване майбутнє і діє заздалегідь</a:t>
+              <a:t>реактивний порадник запізнюється: тривога за 5–75 мс, а плазма відповідає за 0,3–0,5 с</a:t>
             </a:r>
           </a:p>
           <a:p>
             <a:pPr algn="l">
               <a:spcAft>
-                <a:spcPts val="800"/>
+                <a:spcPts val="700"/>
               </a:spcAft>
             </a:pPr>
             <a:r>
@@ -11119,7 +11119,7 @@
                 </a:solidFill>
                 <a:latin typeface="Arial"/>
               </a:rPr>
-              <a:t>Вчитель → учень – </a:t>
+              <a:t>Дані для учня – </a:t>
             </a:r>
             <a:r>
               <a:rPr sz="1200" b="0" i="0">
@@ -11128,13 +11128,13 @@
                 </a:solidFill>
                 <a:latin typeface="Arial"/>
               </a:rPr>
-              <a:t>копія вибирає дію (верхня межа); мережа вчиться вибирати ту саму дію лише з діагностик — це переноситься на реальну машину</a:t>
+              <a:t>ризик і втрата продуктивності кожного варіанта окремо (α підбирається потім, м'які мітки) та поточні множники уставок (щоб не повторювати дію)</a:t>
             </a:r>
           </a:p>
           <a:p>
             <a:pPr algn="l">
               <a:spcAft>
-                <a:spcPts val="800"/>
+                <a:spcPts val="700"/>
               </a:spcAft>
             </a:pPr>
             <a:r>
@@ -11144,6 +11144,31 @@
                 </a:solidFill>
                 <a:latin typeface="Arial"/>
               </a:rPr>
+              <a:t>Учень – </a:t>
+            </a:r>
+            <a:r>
+              <a:rPr sz="1200" b="0" i="0">
+                <a:solidFill>
+                  <a:srgbClr val="0F172A"/>
+                </a:solidFill>
+                <a:latin typeface="Arial"/>
+              </a:rPr>
+              <a:t>вибирає дію лише з діагностик; запускається від λ, яку оцінює ImpactNet; далі раунд DAgger: учень керує, вчитель розмічає</a:t>
+            </a:r>
+          </a:p>
+          <a:p>
+            <a:pPr algn="l">
+              <a:spcAft>
+                <a:spcPts val="700"/>
+              </a:spcAft>
+            </a:pPr>
+            <a:r>
+              <a:rPr sz="1200" b="1" i="0">
+                <a:solidFill>
+                  <a:srgbClr val="0F172A"/>
+                </a:solidFill>
+                <a:latin typeface="Arial"/>
+              </a:rPr>
               <a:t>Чесно – </a:t>
             </a:r>
             <a:r>
@@ -11153,7 +11178,7 @@
                 </a:solidFill>
                 <a:latin typeface="Arial"/>
               </a:rPr>
-              <a:t>копія знає прихований стан плазми, тому її результат — верхня межа, а не досяжний на машині показник</a:t>
+              <a:t>копія знає прихований стан плазми, тому її результат — верхня межа; на машину переноситься учень</a:t>
             </a:r>
           </a:p>
         </p:txBody>

</xml_diff>

<commit_message>
Closed loop: fixer student 31 -> 5 preventable disruptions on 100 new discharges
Slides 13 and 13.1 now show the teacher (engine-copy rollouts) and the student
(instruments only) results; conclusions and README updated.
</commit_message>
<xml_diff>
--- a/docs/presentation.pptx
+++ b/docs/presentation.pptx
@@ -1010,7 +1010,7 @@
           <a:lstStyle/>
           <a:p>
             <a:r>
-              <a:t>≈50 с. Симулятор fusion-sim з керуванням у реальному часі: модель тривоги, ImpactNet і порадник. Замкнений контур на 40 розрядах: 11 зривів без керування, 5 з керуванням. Атрибуція на новому рушії, 200 розрядів: 34 з 49; Грінвальд 16 з 16, радіація 14 з 17, кінк лише 4 з 16. Рушій не моделює шум діагностик, тому калібрування моделей, навчених на шумних даних, переноситься не повністю; наступний крок — додати вимірювальний тракт toksym.</a:t>
+              <a:t>≈60 с. Ланцюг «побачити → пояснити → виправити»: v8 дає тривогу, ImpactNet — ризик і причину, учень fixer вибирає одну з 8 дій. 100 нових розрядів, однакових у всіх режимах. Без керування 31 зрив, якому можна запобігти; порадник на правилах — 21; вчитель на копії рушія — 5; учень, який бачить лише прилади, — теж 5. Учень зрівнявся з ідеальним двійником. Жодного розряду не зіпсовано: 26 врятовано, 0 зіпсовано, p = 3·10⁻⁸. Енергія плазми не впала. Спонтанні зриви, 8–9 зі 100, не відверне ніхто; без них 95 % розрядів без зриву проти 69 %.</a:t>
             </a:r>
           </a:p>
         </p:txBody>
@@ -1080,7 +1080,7 @@
           <a:lstStyle/>
           <a:p>
             <a:r>
-              <a:t>≈60 с. Порадник зараз реагує на тривогу, але плазма відповідає на зміну уставки із затримкою: густина ≈ 0,3 с, неон ≈ 0,5 с, а на кінкових розрядах тривога приходить лише за 5–75 мс до гасіння. План — прогнозне керування: кожні 0,25 с копія стану програє 5 варіантів дій на 1,5 с уперед і вибирає дію з найменшою ціною: ймовірність зриву плюс втрата продуктивності. Уставки в копії тримаються на поточному рівні, щоб вчитель не бачив запланованих збурень — інакше учень не зможе його навчитися. Копія знає прихований стан, тому вона — вчитель і верхня межа; на машину переноситься учень, що вибирає дію лише з діагностик і запускається від λ, яку оцінює ImpactNet. Після першого учня — раунд DAgger.</a:t>
+              <a:t>≈60 с. Вчитель кожні 0,25 с копіює стан рушія разом з генератором випадкових чисел і програє 8 дій на 1 с уперед, рахуючи ймовірність зриву і втрату продуктивності; вибирає найдешевшу. Копія знає розклад машини, як його знає система керування, але не бачить незапланованих збурень газу. Копія знає прихований стан, тому вчитель — лише верхня межа. Учень — 16 регресорів градієнтного бустингу — вчиться передбачати оцінки вчителя для кожної дії лише з приладів, виходів ImpactNet і поточних множників уставок; плюс один раунд DAgger. На нових розрядах учень дорівнює вчителю.</a:t>
             </a:r>
           </a:p>
         </p:txBody>
@@ -1220,7 +1220,7 @@
           <a:lstStyle/>
           <a:p>
             <a:r>
-              <a:t>≈40 с. Модель раннього попередження без формул і без підказок симулятора: об'єм 0,924 проти 0,765, ROC AUC 0,998 на 30 мс. ImpactNet визначає механізм зриву: 49 з 49. Замкнений контур удвічі зменшує кількість зривів; на іншому рушії тривога переноситься без донавчання. Поріг спрацювання неінформативний, моделі порівнюються за ROC AUC. Код і звіти — у репозиторії.</a:t>
+              <a:t>≈40 с. Модель раннього попередження без формул і без підказок симулятора: об'єм 0,924 проти 0,765, ROC AUC 0,998 на 30 мс. ImpactNet визначає механізм зриву: 49 з 49. У замкненому контурі учень, що бачить лише прилади, зменшує кількість зривів, яким можна запобігти, з 31 до 5 без втрати продуктивності; на іншому рушії тривога переноситься без донавчання. Поріг спрацювання неінформативний, моделі порівнюються за ROC AUC. Код і звіти — у репозиторії.</a:t>
             </a:r>
           </a:p>
         </p:txBody>
@@ -9510,7 +9510,7 @@
                 </a:solidFill>
                 <a:latin typeface="Arial"/>
               </a:rPr>
-              <a:t>13 Замкнений контур керування в симуляторі</a:t>
+              <a:t>13 Замкнений контур: модель запобігає зриву в реальному часі</a:t>
             </a:r>
           </a:p>
         </p:txBody>
@@ -9554,53 +9554,9 @@
           </a:p>
         </p:txBody>
       </p:sp>
-      <p:sp>
-        <p:nvSpPr>
-          <p:cNvPr id="4" name="Rectangle 3"/>
-          <p:cNvSpPr/>
-          <p:nvPr/>
-        </p:nvSpPr>
-        <p:spPr>
-          <a:xfrm>
-            <a:off x="521207" y="1252728"/>
-            <a:ext cx="6089903" cy="3038605"/>
-          </a:xfrm>
-          <a:prstGeom prst="rect">
-            <a:avLst/>
-          </a:prstGeom>
-          <a:noFill/>
-          <a:ln w="12700">
-            <a:solidFill>
-              <a:srgbClr val="E2E8F0"/>
-            </a:solidFill>
-          </a:ln>
-          <a:effectLst/>
-        </p:spPr>
-        <p:style>
-          <a:lnRef idx="1">
-            <a:schemeClr val="accent1"/>
-          </a:lnRef>
-          <a:fillRef idx="3">
-            <a:schemeClr val="accent1"/>
-          </a:fillRef>
-          <a:effectRef idx="2">
-            <a:schemeClr val="accent1"/>
-          </a:effectRef>
-          <a:fontRef idx="minor">
-            <a:schemeClr val="lt1"/>
-          </a:fontRef>
-        </p:style>
-        <p:txBody>
-          <a:bodyPr rtlCol="0" anchor="ctr"/>
-          <a:lstStyle/>
-          <a:p>
-            <a:pPr algn="ctr"/>
-          </a:p>
-        </p:txBody>
-      </p:sp>
       <p:pic>
         <p:nvPicPr>
-          <p:cNvPr id="5" name="Picture 4" descr="card_sim_impact_auc.png"/>
+          <p:cNvPr id="4" name="Picture 3" descr="fixer.png"/>
           <p:cNvPicPr>
             <a:picLocks noChangeAspect="1"/>
           </p:cNvPicPr>
@@ -9614,8 +9570,8 @@
         </p:blipFill>
         <p:spPr>
           <a:xfrm>
-            <a:off x="548640" y="1280160"/>
-            <a:ext cx="6035040" cy="2983741"/>
+            <a:off x="548640" y="1234440"/>
+            <a:ext cx="7406640" cy="3044010"/>
           </a:xfrm>
           <a:prstGeom prst="rect">
             <a:avLst/>
@@ -9624,14 +9580,14 @@
       </p:pic>
       <p:sp>
         <p:nvSpPr>
-          <p:cNvPr id="6" name="TextBox 5"/>
+          <p:cNvPr id="5" name="TextBox 4"/>
           <p:cNvSpPr txBox="1"/>
           <p:nvPr/>
         </p:nvSpPr>
         <p:spPr>
           <a:xfrm>
-            <a:off x="548640" y="4309621"/>
-            <a:ext cx="6035040" cy="365760"/>
+            <a:off x="548640" y="4324170"/>
+            <a:ext cx="7406640" cy="365760"/>
           </a:xfrm>
           <a:prstGeom prst="rect">
             <a:avLst/>
@@ -9656,67 +9612,21 @@
                 </a:solidFill>
                 <a:latin typeface="Arial"/>
               </a:rPr>
-              <a:t>Рисунок 8 – Атрибуція механізмів зриву в симуляторі fusion-sim, пробний прогін 50 розрядів: 10 з 12 (поле «поріг» замінено на ROC AUC цього прогону)</a:t>
-            </a:r>
-          </a:p>
-        </p:txBody>
-      </p:sp>
-      <p:sp>
-        <p:nvSpPr>
-          <p:cNvPr id="7" name="Rectangle 6"/>
-          <p:cNvSpPr/>
-          <p:nvPr/>
-        </p:nvSpPr>
-        <p:spPr>
-          <a:xfrm>
-            <a:off x="548640" y="5041141"/>
-            <a:ext cx="6035040" cy="914400"/>
-          </a:xfrm>
-          <a:prstGeom prst="rect">
-            <a:avLst/>
-          </a:prstGeom>
-          <a:solidFill>
-            <a:srgbClr val="F8FAFC"/>
-          </a:solidFill>
-          <a:ln w="12700">
-            <a:solidFill>
-              <a:srgbClr val="E2E8F0"/>
-            </a:solidFill>
-          </a:ln>
-          <a:effectLst/>
-        </p:spPr>
-        <p:style>
-          <a:lnRef idx="1">
-            <a:schemeClr val="accent1"/>
-          </a:lnRef>
-          <a:fillRef idx="3">
-            <a:schemeClr val="accent1"/>
-          </a:fillRef>
-          <a:effectRef idx="2">
-            <a:schemeClr val="accent1"/>
-          </a:effectRef>
-          <a:fontRef idx="minor">
-            <a:schemeClr val="lt1"/>
-          </a:fontRef>
-        </p:style>
-        <p:txBody>
-          <a:bodyPr rtlCol="0" anchor="ctr"/>
-          <a:lstStyle/>
-          <a:p>
-            <a:pPr algn="ctr"/>
-          </a:p>
-        </p:txBody>
-      </p:sp>
-      <p:sp>
-        <p:nvSpPr>
-          <p:cNvPr id="8" name="TextBox 7"/>
+              <a:t>Рисунок 8 – Керування в симуляторі fusion-sim: 100 нових розрядів (seed 2000), однакові в усіх режимах; за звітом fusionsim teach</a:t>
+            </a:r>
+          </a:p>
+        </p:txBody>
+      </p:sp>
+      <p:sp>
+        <p:nvSpPr>
+          <p:cNvPr id="6" name="TextBox 5"/>
           <p:cNvSpPr txBox="1"/>
           <p:nvPr/>
         </p:nvSpPr>
         <p:spPr>
           <a:xfrm>
-            <a:off x="685800" y="5132581"/>
-            <a:ext cx="5760720" cy="731520"/>
+            <a:off x="8275320" y="1280160"/>
+            <a:ext cx="3383280" cy="1188720"/>
           </a:xfrm>
           <a:prstGeom prst="rect">
             <a:avLst/>
@@ -9731,40 +9641,47 @@
           <a:p>
             <a:pPr algn="l">
               <a:spcAft>
+                <a:spcPts val="200"/>
+              </a:spcAft>
+            </a:pPr>
+            <a:r>
+              <a:rPr sz="4000" b="1" i="0">
+                <a:solidFill>
+                  <a:srgbClr val="047857"/>
+                </a:solidFill>
+                <a:latin typeface="Arial"/>
+              </a:rPr>
+              <a:t>31 → 5</a:t>
+            </a:r>
+          </a:p>
+          <a:p>
+            <a:pPr algn="l">
+              <a:spcAft>
                 <a:spcPts val="0"/>
               </a:spcAft>
             </a:pPr>
             <a:r>
-              <a:rPr sz="1100" b="1" i="0">
-                <a:solidFill>
-                  <a:srgbClr val="0E7490"/>
-                </a:solidFill>
-                <a:latin typeface="Arial"/>
-              </a:rPr>
-              <a:t>Чому ROC AUC замість порогу. </a:t>
-            </a:r>
-            <a:r>
-              <a:rPr sz="1100" b="0" i="0">
+              <a:rPr sz="1200" b="0" i="0">
                 <a:solidFill>
                   <a:srgbClr val="475569"/>
                 </a:solidFill>
                 <a:latin typeface="Arial"/>
               </a:rPr>
-              <a:t>Поріг спрацювання неінформативний: його підбирає засіб оцінки під бюджет хибних тривог, а на 50 розрядах поріг задає один тихий розряд (див. розділ 5); тому наведено ROC AUC.</a:t>
-            </a:r>
-          </a:p>
-        </p:txBody>
-      </p:sp>
-      <p:sp>
-        <p:nvSpPr>
-          <p:cNvPr id="9" name="TextBox 8"/>
+              <a:t>зривів, яким можна запобігти: без керування → учень</a:t>
+            </a:r>
+          </a:p>
+        </p:txBody>
+      </p:sp>
+      <p:sp>
+        <p:nvSpPr>
+          <p:cNvPr id="7" name="TextBox 6"/>
           <p:cNvSpPr txBox="1"/>
           <p:nvPr/>
         </p:nvSpPr>
         <p:spPr>
           <a:xfrm>
-            <a:off x="6949440" y="1371600"/>
-            <a:ext cx="4663440" cy="1188720"/>
+            <a:off x="8275320" y="2514600"/>
+            <a:ext cx="3383280" cy="2286000"/>
           </a:xfrm>
           <a:prstGeom prst="rect">
             <a:avLst/>
@@ -9779,47 +9696,90 @@
           <a:p>
             <a:pPr algn="l">
               <a:spcAft>
-                <a:spcPts val="200"/>
-              </a:spcAft>
-            </a:pPr>
-            <a:r>
-              <a:rPr sz="4600" b="1" i="0">
-                <a:solidFill>
-                  <a:srgbClr val="C2410C"/>
-                </a:solidFill>
-                <a:latin typeface="Arial"/>
-              </a:rPr>
-              <a:t>11 → 5</a:t>
+                <a:spcPts val="700"/>
+              </a:spcAft>
+            </a:pPr>
+            <a:r>
+              <a:rPr sz="1200" b="1" i="0">
+                <a:solidFill>
+                  <a:srgbClr val="0F172A"/>
+                </a:solidFill>
+                <a:latin typeface="Arial"/>
+              </a:rPr>
+              <a:t>Ланцюг – </a:t>
+            </a:r>
+            <a:r>
+              <a:rPr sz="1200" b="0" i="0">
+                <a:solidFill>
+                  <a:srgbClr val="0F172A"/>
+                </a:solidFill>
+                <a:latin typeface="Arial"/>
+              </a:rPr>
+              <a:t>v8 (коли) → ImpactNet (чому) → учень (що змінити): 8 дій, кожні 0,25 с</a:t>
             </a:r>
           </a:p>
           <a:p>
             <a:pPr algn="l">
               <a:spcAft>
-                <a:spcPts val="0"/>
-              </a:spcAft>
-            </a:pPr>
+                <a:spcPts val="700"/>
+              </a:spcAft>
+            </a:pPr>
+            <a:r>
+              <a:rPr sz="1200" b="1" i="0">
+                <a:solidFill>
+                  <a:srgbClr val="0F172A"/>
+                </a:solidFill>
+                <a:latin typeface="Arial"/>
+              </a:rPr>
+              <a:t>Без шкоди – </a:t>
+            </a:r>
             <a:r>
               <a:rPr sz="1200" b="0" i="0">
                 <a:solidFill>
-                  <a:srgbClr val="475569"/>
-                </a:solidFill>
-                <a:latin typeface="Arial"/>
-              </a:rPr>
-              <a:t>зривів на 40 розрядах з автокеруванням і без нього (−55 %)</a:t>
-            </a:r>
-          </a:p>
-        </p:txBody>
-      </p:sp>
-      <p:sp>
-        <p:nvSpPr>
-          <p:cNvPr id="10" name="TextBox 9"/>
+                  <a:srgbClr val="0F172A"/>
+                </a:solidFill>
+                <a:latin typeface="Arial"/>
+              </a:rPr>
+              <a:t>врятовано 26, зіпсовано 0 (тест Мак-Немара, p = 3·10⁻⁸); енергія W 2,371 → 2,374 МДж</a:t>
+            </a:r>
+          </a:p>
+          <a:p>
+            <a:pPr algn="l">
+              <a:spcAft>
+                <a:spcPts val="700"/>
+              </a:spcAft>
+            </a:pPr>
+            <a:r>
+              <a:rPr sz="1200" b="1" i="0">
+                <a:solidFill>
+                  <a:srgbClr val="0F172A"/>
+                </a:solidFill>
+                <a:latin typeface="Arial"/>
+              </a:rPr>
+              <a:t>Межа – </a:t>
+            </a:r>
+            <a:r>
+              <a:rPr sz="1200" b="0" i="0">
+                <a:solidFill>
+                  <a:srgbClr val="0F172A"/>
+                </a:solidFill>
+                <a:latin typeface="Arial"/>
+              </a:rPr>
+              <a:t>спонтанні зриви (8–9 зі 100) не відверне ніхто; без них 95 % розрядів без зриву проти 69 %</a:t>
+            </a:r>
+          </a:p>
+        </p:txBody>
+      </p:sp>
+      <p:sp>
+        <p:nvSpPr>
+          <p:cNvPr id="8" name="TextBox 7"/>
           <p:cNvSpPr txBox="1"/>
           <p:nvPr/>
         </p:nvSpPr>
         <p:spPr>
           <a:xfrm>
-            <a:off x="6949440" y="2743200"/>
-            <a:ext cx="4709160" cy="2286000"/>
+            <a:off x="548640" y="5989320"/>
+            <a:ext cx="11064240" cy="457200"/>
           </a:xfrm>
           <a:prstGeom prst="rect">
             <a:avLst/>
@@ -9834,104 +9794,6 @@
           <a:p>
             <a:pPr algn="l">
               <a:spcAft>
-                <a:spcPts val="800"/>
-              </a:spcAft>
-            </a:pPr>
-            <a:r>
-              <a:rPr sz="1300" b="1" i="0">
-                <a:solidFill>
-                  <a:srgbClr val="0F172A"/>
-                </a:solidFill>
-                <a:latin typeface="Arial"/>
-              </a:rPr>
-              <a:t>Контур – </a:t>
-            </a:r>
-            <a:r>
-              <a:rPr sz="1300" b="0" i="0">
-                <a:solidFill>
-                  <a:srgbClr val="0F172A"/>
-                </a:solidFill>
-                <a:latin typeface="Arial"/>
-              </a:rPr>
-              <a:t>діагностики → модель тривоги (коли) → ImpactNet (чому) → порадник → зміна уставок; цикл 5 мс</a:t>
-            </a:r>
-          </a:p>
-          <a:p>
-            <a:pPr algn="l">
-              <a:spcAft>
-                <a:spcPts val="800"/>
-              </a:spcAft>
-            </a:pPr>
-            <a:r>
-              <a:rPr sz="1300" b="1" i="0">
-                <a:solidFill>
-                  <a:srgbClr val="0F172A"/>
-                </a:solidFill>
-                <a:latin typeface="Arial"/>
-              </a:rPr>
-              <a:t>Порадник – </a:t>
-            </a:r>
-            <a:r>
-              <a:rPr sz="1300" b="0" i="0">
-                <a:solidFill>
-                  <a:srgbClr val="0F172A"/>
-                </a:solidFill>
-                <a:latin typeface="Arial"/>
-              </a:rPr>
-              <a:t>головна загроза з часток ImpactNet → конкретна дія (наприклад, знизити уставку густини); автокерування виконує її, коли p моделі вище порогу</a:t>
-            </a:r>
-          </a:p>
-          <a:p>
-            <a:pPr algn="l">
-              <a:spcAft>
-                <a:spcPts val="800"/>
-              </a:spcAft>
-            </a:pPr>
-            <a:r>
-              <a:rPr sz="1300" b="1" i="0">
-                <a:solidFill>
-                  <a:srgbClr val="0F172A"/>
-                </a:solidFill>
-                <a:latin typeface="Arial"/>
-              </a:rPr>
-              <a:t>Обмеження – </a:t>
-            </a:r>
-            <a:r>
-              <a:rPr sz="1300" b="0" i="0">
-                <a:solidFill>
-                  <a:srgbClr val="0F172A"/>
-                </a:solidFill>
-                <a:latin typeface="Arial"/>
-              </a:rPr>
-              <a:t>40 розрядів: різниця ще не статистично значуща (p ≈ 0,1, точний тест); для p &lt; 0,01 з імовірністю 0,84 потрібно ≈ 200 розрядів на режим; ціну керування ще не оцінено</a:t>
-            </a:r>
-          </a:p>
-        </p:txBody>
-      </p:sp>
-      <p:sp>
-        <p:nvSpPr>
-          <p:cNvPr id="11" name="TextBox 10"/>
-          <p:cNvSpPr txBox="1"/>
-          <p:nvPr/>
-        </p:nvSpPr>
-        <p:spPr>
-          <a:xfrm>
-            <a:off x="6949440" y="5623560"/>
-            <a:ext cx="4709160" cy="640080"/>
-          </a:xfrm>
-          <a:prstGeom prst="rect">
-            <a:avLst/>
-          </a:prstGeom>
-          <a:noFill/>
-        </p:spPr>
-        <p:txBody>
-          <a:bodyPr wrap="square" anchor="t" lIns="0" rIns="0" tIns="0" bIns="0">
-            <a:spAutoFit/>
-          </a:bodyPr>
-          <a:lstStyle/>
-          <a:p>
-            <a:pPr algn="l">
-              <a:spcAft>
                 <a:spcPts val="0"/>
               </a:spcAft>
             </a:pPr>
@@ -9960,7 +9822,7 @@
                 </a:solidFill>
                 <a:latin typeface="Arial"/>
               </a:rPr>
-              <a:t> (форк fusionsimulator.io, D. Burgess, GPL-3.0; командою додано залік toksym і керування актуаторами з моделі)</a:t>
+              <a:t> (форк fusionsimulator.io, D. Burgess, GPL-3.0; командою додано залік toksym, fixer, вчителя й учня). Довірчий інтервал на 100 розрядах ±9 п. п.</a:t>
             </a:r>
           </a:p>
         </p:txBody>
@@ -10025,7 +9887,7 @@
                 </a:solidFill>
                 <a:latin typeface="Arial"/>
               </a:rPr>
-              <a:t>13.1 Наступний крок: прогнозне керування і навчання учня</a:t>
+              <a:t>13.1 Як навчено керування: вчитель на копії рушія і учень</a:t>
             </a:r>
           </a:p>
         </p:txBody>
@@ -10151,7 +10013,7 @@
                 </a:solidFill>
                 <a:latin typeface="Arial"/>
               </a:rPr>
-              <a:t>Стан розряду</a:t>
+              <a:t>Копія стану</a:t>
             </a:r>
           </a:p>
           <a:p>
@@ -10167,7 +10029,7 @@
                 </a:solidFill>
                 <a:latin typeface="Arial"/>
               </a:rPr>
-              <a:t>копія рушія; уставки на поточному рівні, без запланованих збурень</a:t>
+              <a:t>рушій + генератор випадковості; розклад машини за планом, газ на поточному рівні</a:t>
             </a:r>
           </a:p>
         </p:txBody>
@@ -10298,7 +10160,7 @@
                 </a:solidFill>
                 <a:latin typeface="Arial"/>
               </a:rPr>
-              <a:t>5 варіантів дій</a:t>
+              <a:t>8 дій</a:t>
             </a:r>
           </a:p>
           <a:p>
@@ -10314,7 +10176,7 @@
                 </a:solidFill>
                 <a:latin typeface="Arial"/>
               </a:rPr>
-              <a:t>нічого; густина −10 / −20 %; неон; нагрів або струм; «послабити»</a:t>
+              <a:t>нічого; густина −10 / −20 %; неон; Iₚ −10 %; нагрів ±20 %; повернути</a:t>
             </a:r>
           </a:p>
         </p:txBody>
@@ -10445,7 +10307,7 @@
                 </a:solidFill>
                 <a:latin typeface="Arial"/>
               </a:rPr>
-              <a:t>Прогноз 1,5 с</a:t>
+              <a:t>Прогноз 1 с</a:t>
             </a:r>
           </a:p>
           <a:p>
@@ -10461,7 +10323,7 @@
                 </a:solidFill>
                 <a:latin typeface="Arial"/>
               </a:rPr>
-              <a:t>сума λ і втрата продуктивності для кожного варіанта</a:t>
+              <a:t>крок 20 мс; P = 1 − e^(−∫λdt) і втрата продуктивності</a:t>
             </a:r>
           </a:p>
         </p:txBody>
@@ -10592,7 +10454,7 @@
                 </a:solidFill>
                 <a:latin typeface="Arial"/>
               </a:rPr>
-              <a:t>Вибір дії</a:t>
+              <a:t>Найдешевша дія</a:t>
             </a:r>
           </a:p>
           <a:p>
@@ -10608,7 +10470,7 @@
                 </a:solidFill>
                 <a:latin typeface="Arial"/>
               </a:rPr>
-              <a:t>мінімум ціни J, кожні 0,25 с; запуск від λ, а не від тривоги</a:t>
+              <a:t>J = P + α · втрата; множники на програму, розряд іде далі</a:t>
             </a:r>
           </a:p>
         </p:txBody>
@@ -10647,7 +10509,7 @@
                 </a:solidFill>
                 <a:latin typeface="Arial"/>
               </a:rPr>
-              <a:t>Рисунок 9 – Схема вчителя: прогнозне керування на копії рушія (план; потребує копіювання стану рушія)</a:t>
+              <a:t>Рисунок 9 – Вчитель: прогнозне керування на копії рушія (бачить прихований стан, тому це верхня межа)</a:t>
             </a:r>
           </a:p>
         </p:txBody>
@@ -10661,7 +10523,7 @@
         <p:spPr>
           <a:xfrm>
             <a:off x="548640" y="3200400"/>
-            <a:ext cx="5669280" cy="822960"/>
+            <a:ext cx="5669280" cy="320040"/>
           </a:xfrm>
           <a:prstGeom prst="rect">
             <a:avLst/>
@@ -10676,87 +10538,32 @@
           <a:p>
             <a:pPr algn="l">
               <a:spcAft>
-                <a:spcPts val="400"/>
-              </a:spcAft>
-            </a:pPr>
-            <a:r>
-              <a:rPr sz="1500" b="1" i="0">
-                <a:solidFill>
-                  <a:srgbClr val="0F172A"/>
-                </a:solidFill>
-                <a:latin typeface="Arial"/>
-              </a:rPr>
-              <a:t>J = P(зрив за горизонт) + α · втрата продуктивності</a:t>
-            </a:r>
-          </a:p>
-          <a:p>
-            <a:pPr algn="l">
-              <a:spcAft>
                 <a:spcPts val="0"/>
               </a:spcAft>
             </a:pPr>
             <a:r>
-              <a:rPr sz="1200" b="0" i="0">
+              <a:rPr sz="1100" b="0" i="0">
                 <a:solidFill>
                   <a:srgbClr val="475569"/>
                 </a:solidFill>
                 <a:latin typeface="Arial"/>
               </a:rPr>
-              <a:t>P = 1 − exp(−Σλ·Δt) по прогнозу копії; без другого доданку найкращою дією завжди було б «вимкнути все»</a:t>
-            </a:r>
-          </a:p>
-        </p:txBody>
-      </p:sp>
-      <p:sp>
-        <p:nvSpPr>
-          <p:cNvPr id="17" name="TextBox 16"/>
-          <p:cNvSpPr txBox="1"/>
-          <p:nvPr/>
-        </p:nvSpPr>
-        <p:spPr>
-          <a:xfrm>
-            <a:off x="548640" y="4206240"/>
-            <a:ext cx="5669280" cy="320040"/>
-          </a:xfrm>
-          <a:prstGeom prst="rect">
-            <a:avLst/>
-          </a:prstGeom>
-          <a:noFill/>
-        </p:spPr>
-        <p:txBody>
-          <a:bodyPr wrap="square" anchor="t" lIns="0" rIns="0" tIns="0" bIns="0">
-            <a:spAutoFit/>
-          </a:bodyPr>
-          <a:lstStyle/>
-          <a:p>
-            <a:pPr algn="l">
-              <a:spcAft>
-                <a:spcPts val="0"/>
-              </a:spcAft>
-            </a:pPr>
-            <a:r>
-              <a:rPr sz="1100" b="0" i="0">
-                <a:solidFill>
-                  <a:srgbClr val="475569"/>
-                </a:solidFill>
-                <a:latin typeface="Arial"/>
-              </a:rPr>
-              <a:t>Таблиця 8 – Оцінка часових масштабів</a:t>
+              <a:t>Таблиця 8 – Учень і його навчання</a:t>
             </a:r>
           </a:p>
         </p:txBody>
       </p:sp>
       <p:graphicFrame>
         <p:nvGraphicFramePr>
-          <p:cNvPr id="18" name="Table 17"/>
+          <p:cNvPr id="17" name="Table 16"/>
           <p:cNvGraphicFramePr>
             <a:graphicFrameLocks noGrp="1"/>
           </p:cNvGraphicFramePr>
           <p:nvPr/>
         </p:nvGraphicFramePr>
         <p:xfrm>
-          <a:off x="548640" y="4572000"/>
-          <a:ext cx="5669280" cy="1975104"/>
+          <a:off x="548640" y="3566160"/>
+          <a:ext cx="5669280" cy="2743200"/>
         </p:xfrm>
         <a:graphic>
           <a:graphicData uri="http://schemas.openxmlformats.org/drawingml/2006/table">
@@ -10765,10 +10572,10 @@
                 <a:tableStyleId>{5C22544A-7EE6-4342-B048-85BDC9FD1C3A}</a:tableStyleId>
               </a:tblPr>
               <a:tblGrid>
-                <a:gridCol w="2834640"/>
-                <a:gridCol w="2834640"/>
+                <a:gridCol w="1234440"/>
+                <a:gridCol w="4434840"/>
               </a:tblGrid>
-              <a:tr h="329184">
+              <a:tr h="457200">
                 <a:tc>
                   <a:txBody>
                     <a:bodyPr wrap="square"/>
@@ -10782,7 +10589,7 @@
                           </a:solidFill>
                           <a:latin typeface="Arial"/>
                         </a:rPr>
-                        <a:t>величина</a:t>
+                        <a:t>складова</a:t>
                       </a:r>
                     </a:p>
                   </a:txBody>
@@ -10805,7 +10612,7 @@
                           </a:solidFill>
                           <a:latin typeface="Arial"/>
                         </a:rPr>
-                        <a:t>значення</a:t>
+                        <a:t>що закладено</a:t>
                       </a:r>
                     </a:p>
                   </a:txBody>
@@ -10816,7 +10623,7 @@
                   </a:tcPr>
                 </a:tc>
               </a:tr>
-              <a:tr h="329184">
+              <a:tr h="457200">
                 <a:tc>
                   <a:txBody>
                     <a:bodyPr wrap="square"/>
@@ -10830,7 +10637,7 @@
                           </a:solidFill>
                           <a:latin typeface="Arial"/>
                         </a:rPr>
-                        <a:t>реакція плазми на уставку</a:t>
+                        <a:t>модель</a:t>
                       </a:r>
                     </a:p>
                   </a:txBody>
@@ -10853,7 +10660,7 @@
                           </a:solidFill>
                           <a:latin typeface="Arial"/>
                         </a:rPr>
-                        <a:t>густина ≈ 0,3 с, неон ≈ 0,5 с</a:t>
+                        <a:t>16 регресорів HGB: P(зрив за 1 с) і втрата для кожної з 8 дій</a:t>
                       </a:r>
                     </a:p>
                   </a:txBody>
@@ -10864,7 +10671,7 @@
                   </a:tcPr>
                 </a:tc>
               </a:tr>
-              <a:tr h="329184">
+              <a:tr h="457200">
                 <a:tc>
                   <a:txBody>
                     <a:bodyPr wrap="square"/>
@@ -10878,7 +10685,7 @@
                           </a:solidFill>
                           <a:latin typeface="Arial"/>
                         </a:rPr>
-                        <a:t>попередження на кінкових розрядах</a:t>
+                        <a:t>ознаки (56)</a:t>
                       </a:r>
                     </a:p>
                   </a:txBody>
@@ -10901,7 +10708,7 @@
                           </a:solidFill>
                           <a:latin typeface="Arial"/>
                         </a:rPr>
-                        <a:t>5–75 мс (200 розрядів fusion-sim)</a:t>
+                        <a:t>λ, ризики й частки ImpactNet; f_GW, q95, P_rad/P_in, βN з приладів; 16 каналів; множники; тренди</a:t>
                       </a:r>
                     </a:p>
                   </a:txBody>
@@ -10912,7 +10719,7 @@
                   </a:tcPr>
                 </a:tc>
               </a:tr>
-              <a:tr h="329184">
+              <a:tr h="457200">
                 <a:tc>
                   <a:txBody>
                     <a:bodyPr wrap="square"/>
@@ -10926,7 +10733,7 @@
                           </a:solidFill>
                           <a:latin typeface="Arial"/>
                         </a:rPr>
-                        <a:t>горизонт прогнозу</a:t>
+                        <a:t>заборонено</a:t>
                       </a:r>
                     </a:p>
                   </a:txBody>
@@ -10949,7 +10756,7 @@
                           </a:solidFill>
                           <a:latin typeface="Arial"/>
                         </a:rPr>
-                        <a:t>1,5 с = 300 кроків ≈ 5 τ густини</a:t>
+                        <a:t>справжня λ рушія, внутрішні змінні, майбутнє програми</a:t>
                       </a:r>
                     </a:p>
                   </a:txBody>
@@ -10960,7 +10767,7 @@
                   </a:tcPr>
                 </a:tc>
               </a:tr>
-              <a:tr h="329184">
+              <a:tr h="457200">
                 <a:tc>
                   <a:txBody>
                     <a:bodyPr wrap="square"/>
@@ -10974,7 +10781,7 @@
                           </a:solidFill>
                           <a:latin typeface="Arial"/>
                         </a:rPr>
-                        <a:t>обчислення на рішення</a:t>
+                        <a:t>дані</a:t>
                       </a:r>
                     </a:p>
                   </a:txBody>
@@ -10997,7 +10804,7 @@
                           </a:solidFill>
                           <a:latin typeface="Arial"/>
                         </a:rPr>
-                        <a:t>5 × 300 = 1 500 кроків рушія</a:t>
+                        <a:t>300 розрядів вчителя (seed 1000) + розряди без керування + 1 раунд DAgger</a:t>
                       </a:r>
                     </a:p>
                   </a:txBody>
@@ -11008,7 +10815,7 @@
                   </a:tcPr>
                 </a:tc>
               </a:tr>
-              <a:tr h="329184">
+              <a:tr h="457200">
                 <a:tc>
                   <a:txBody>
                     <a:bodyPr wrap="square"/>
@@ -11022,7 +10829,7 @@
                           </a:solidFill>
                           <a:latin typeface="Arial"/>
                         </a:rPr>
-                        <a:t>внесення зміни</a:t>
+                        <a:t>перевірка</a:t>
                       </a:r>
                     </a:p>
                   </a:txBody>
@@ -11045,7 +10852,7 @@
                           </a:solidFill>
                           <a:latin typeface="Arial"/>
                         </a:rPr>
-                        <a:t>1–3 кадри = 5–15 мс</a:t>
+                        <a:t>100 нових розрядів (seed 2000), ті самі в усіх режимах</a:t>
                       </a:r>
                     </a:p>
                   </a:txBody>
@@ -11062,13 +10869,13 @@
       </p:graphicFrame>
       <p:sp>
         <p:nvSpPr>
-          <p:cNvPr id="19" name="TextBox 18"/>
+          <p:cNvPr id="18" name="TextBox 17"/>
           <p:cNvSpPr txBox="1"/>
           <p:nvPr/>
         </p:nvSpPr>
         <p:spPr>
           <a:xfrm>
-            <a:off x="6766560" y="3154680"/>
+            <a:off x="6766560" y="3200400"/>
             <a:ext cx="4892040" cy="2743200"/>
           </a:xfrm>
           <a:prstGeom prst="rect">
@@ -11103,7 +10910,7 @@
                 </a:solidFill>
                 <a:latin typeface="Arial"/>
               </a:rPr>
-              <a:t>реактивний порадник запізнюється: тривога за 5–75 мс, а плазма відповідає за 0,3–0,5 с</a:t>
+              <a:t>плазма відповідає на уставку за 0,3–0,5 с, а тривога на кінкових розрядах — за 5–75 мс; копія бачить наслідки дії на 1 с уперед</a:t>
             </a:r>
           </a:p>
           <a:p>
@@ -11119,7 +10926,7 @@
                 </a:solidFill>
                 <a:latin typeface="Arial"/>
               </a:rPr>
-              <a:t>Дані для учня – </a:t>
+              <a:t>Чесний вчитель – </a:t>
             </a:r>
             <a:r>
               <a:rPr sz="1200" b="0" i="0">
@@ -11128,7 +10935,7 @@
                 </a:solidFill>
                 <a:latin typeface="Arial"/>
               </a:rPr>
-              <a:t>ризик і втрата продуктивності кожного варіанта окремо (α підбирається потім, м'які мітки) та поточні множники уставок (щоб не повторювати дію)</a:t>
+              <a:t>газ у копії на поточному рівні: незаплановані збурення не видно, інакше учень не зміг би навчитися</a:t>
             </a:r>
           </a:p>
           <a:p>
@@ -11144,7 +10951,7 @@
                 </a:solidFill>
                 <a:latin typeface="Arial"/>
               </a:rPr>
-              <a:t>Учень – </a:t>
+              <a:t>Швидкість – </a:t>
             </a:r>
             <a:r>
               <a:rPr sz="1200" b="0" i="0">
@@ -11153,7 +10960,7 @@
                 </a:solidFill>
                 <a:latin typeface="Arial"/>
               </a:rPr>
-              <a:t>вибирає дію лише з діагностик; запускається від λ, яку оцінює ImpactNet; далі раунд DAgger: учень керує, вчитель розмічає</a:t>
+              <a:t>рішення ≈ 17 мс (9 копій × 50 кроків); у браузері — по одній дії на кадр</a:t>
             </a:r>
           </a:p>
           <a:p>
@@ -11169,7 +10976,7 @@
                 </a:solidFill>
                 <a:latin typeface="Arial"/>
               </a:rPr>
-              <a:t>Чесно – </a:t>
+              <a:t>Результат – </a:t>
             </a:r>
             <a:r>
               <a:rPr sz="1200" b="0" i="0">
@@ -11178,7 +10985,7 @@
                 </a:solidFill>
                 <a:latin typeface="Arial"/>
               </a:rPr>
-              <a:t>копія знає прихований стан плазми, тому її результат — верхня межа; на машину переноситься учень</a:t>
+              <a:t>учень = вчитель: 5 зривів зі 31; з копії на машину переноситься саме учень</a:t>
             </a:r>
           </a:p>
         </p:txBody>
@@ -11695,7 +11502,7 @@
                 </a:solidFill>
                 <a:latin typeface="Arial"/>
               </a:rPr>
-              <a:t>Замкнений контур керування в симуляторі зменшує кількість зривів з 11 до 5 на 40 розрядах; на іншому рушії тривога працює без донавчання (ROC AUC 0,902), кінк потребує донавчання.</a:t>
+              <a:t>У замкненому контурі учень, що бачить лише прилади, зменшує кількість зривів, яким можна запобігти, з 31 до 5 на 100 нових розрядах без втрати продуктивності — як ідеальний двійник.</a:t>
             </a:r>
           </a:p>
         </p:txBody>

</xml_diff>

<commit_message>
Deck: physics appendix A.1-A.5 (operating limits sweep, vessel shielding, dIp/dt and Mirnov trigger tests)
</commit_message>
<xml_diff>
--- a/docs/presentation.pptx
+++ b/docs/presentation.pptx
@@ -24,6 +24,11 @@
     <p:sldId id="272" r:id="rId24"/>
     <p:sldId id="273" r:id="rId25"/>
     <p:sldId id="274" r:id="rId26"/>
+    <p:sldId id="275" r:id="rId27"/>
+    <p:sldId id="276" r:id="rId28"/>
+    <p:sldId id="277" r:id="rId29"/>
+    <p:sldId id="278" r:id="rId30"/>
+    <p:sldId id="279" r:id="rId31"/>
   </p:sldIdLst>
   <p:sldSz cx="12191695" cy="6858000" type="screen4x3"/>
   <p:notesSz cx="6858000" cy="9144000"/>
@@ -1291,6 +1296,356 @@
           <a:p>
             <a:r>
               <a:t>≈45 с. Зрив — швидка втрата утримання плазми: після запуску 50–100 мс розвивається передвісник, далі термічне гасіння за 1–2 мс. Модель отримує 100 діагностичних сигналів кожні 5 мс і повертає ймовірність зриву лише з минулих даних. Тривога зараховується, якщо випереджає термічне гасіння щонайменше на заданий запас; поріг підбирається під бюджет хибних тривог. Інтегральна метрика — об'єм, середня площа під кривою TPR(FPR) за запасами 10 мс–1 с. На рисунку — реальні сигнали розряду: густина повільно зростає до межі, модель б'є тривогу за 1,24 с до гасіння.</a:t>
+            </a:r>
+          </a:p>
+        </p:txBody>
+      </p:sp>
+      <p:sp>
+        <p:nvSpPr>
+          <p:cNvPr id="4" name="Slide Number Placeholder 3"/>
+          <p:cNvSpPr>
+            <a:spLocks noGrp="1"/>
+          </p:cNvSpPr>
+          <p:nvPr>
+            <p:ph type="sldNum" idx="5" sz="quarter"/>
+          </p:nvPr>
+        </p:nvSpPr>
+        <p:spPr/>
+      </p:sp>
+    </p:spTree>
+  </p:cSld>
+  <p:clrMapOvr>
+    <a:masterClrMapping/>
+  </p:clrMapOvr>
+</p:notes>
+</file>
+
+<file path=ppt/notesSlides/notesSlide20.xml><?xml version="1.0" encoding="utf-8"?>
+<p:notes xmlns:a="http://schemas.openxmlformats.org/drawingml/2006/main" xmlns:p="http://schemas.openxmlformats.org/presentationml/2006/main" xmlns:r="http://schemas.openxmlformats.org/officeDocument/2006/relationships">
+  <p:cSld>
+    <p:spTree>
+      <p:nvGrpSpPr>
+        <p:cNvPr id="1" name=""/>
+        <p:cNvGrpSpPr/>
+        <p:nvPr/>
+      </p:nvGrpSpPr>
+      <p:grpSpPr>
+        <a:xfrm>
+          <a:off x="0" y="0"/>
+          <a:ext cx="0" cy="0"/>
+          <a:chOff x="0" y="0"/>
+          <a:chExt cx="0" cy="0"/>
+        </a:xfrm>
+      </p:grpSpPr>
+      <p:sp>
+        <p:nvSpPr>
+          <p:cNvPr id="2" name="Slide Image Placeholder 1"/>
+          <p:cNvSpPr>
+            <a:spLocks noGrp="1"/>
+          </p:cNvSpPr>
+          <p:nvPr>
+            <p:ph type="sldImg" idx="2"/>
+          </p:nvPr>
+        </p:nvSpPr>
+        <p:spPr/>
+      </p:sp>
+      <p:sp>
+        <p:nvSpPr>
+          <p:cNvPr id="3" name="Notes Placeholder 2"/>
+          <p:cNvSpPr>
+            <a:spLocks noGrp="1"/>
+          </p:cNvSpPr>
+          <p:nvPr>
+            <p:ph type="body" idx="3" sz="quarter"/>
+          </p:nvPr>
+        </p:nvSpPr>
+        <p:spPr/>
+        <p:txBody>
+          <a:bodyPr/>
+          <a:lstStyle/>
+          <a:p>
+            <a:r>
+              <a:t>Сканування струму і уставки густини (91 розряд). При малому струмі домінує межа Грінвальда, при великому — низький q95 (кінк); між ними вікно низького ризику. За густиною λ зростає на два порядки, коли f_GW підходить до 1.</a:t>
+            </a:r>
+          </a:p>
+        </p:txBody>
+      </p:sp>
+      <p:sp>
+        <p:nvSpPr>
+          <p:cNvPr id="4" name="Slide Number Placeholder 3"/>
+          <p:cNvSpPr>
+            <a:spLocks noGrp="1"/>
+          </p:cNvSpPr>
+          <p:nvPr>
+            <p:ph type="sldNum" idx="5" sz="quarter"/>
+          </p:nvPr>
+        </p:nvSpPr>
+        <p:spPr/>
+      </p:sp>
+    </p:spTree>
+  </p:cSld>
+  <p:clrMapOvr>
+    <a:masterClrMapping/>
+  </p:clrMapOvr>
+</p:notes>
+</file>
+
+<file path=ppt/notesSlides/notesSlide21.xml><?xml version="1.0" encoding="utf-8"?>
+<p:notes xmlns:a="http://schemas.openxmlformats.org/drawingml/2006/main" xmlns:p="http://schemas.openxmlformats.org/presentationml/2006/main" xmlns:r="http://schemas.openxmlformats.org/officeDocument/2006/relationships">
+  <p:cSld>
+    <p:spTree>
+      <p:nvGrpSpPr>
+        <p:cNvPr id="1" name=""/>
+        <p:cNvGrpSpPr/>
+        <p:nvPr/>
+      </p:nvGrpSpPr>
+      <p:grpSpPr>
+        <a:xfrm>
+          <a:off x="0" y="0"/>
+          <a:ext cx="0" cy="0"/>
+          <a:chOff x="0" y="0"/>
+          <a:chExt cx="0" cy="0"/>
+        </a:xfrm>
+      </p:grpSpPr>
+      <p:sp>
+        <p:nvSpPr>
+          <p:cNvPr id="2" name="Slide Image Placeholder 1"/>
+          <p:cNvSpPr>
+            <a:spLocks noGrp="1"/>
+          </p:cNvSpPr>
+          <p:nvPr>
+            <p:ph type="sldImg" idx="2"/>
+          </p:nvPr>
+        </p:nvSpPr>
+        <p:spPr/>
+      </p:sp>
+      <p:sp>
+        <p:nvSpPr>
+          <p:cNvPr id="3" name="Notes Placeholder 2"/>
+          <p:cNvSpPr>
+            <a:spLocks noGrp="1"/>
+          </p:cNvSpPr>
+          <p:nvPr>
+            <p:ph type="body" idx="3" sz="quarter"/>
+          </p:nvPr>
+        </p:nvSpPr>
+        <p:spPr/>
+        <p:txBody>
+          <a:bodyPr/>
+          <a:lstStyle/>
+          <a:p>
+            <a:r>
+              <a:t>Перевірка, чи можна ловити зрив швидкими магнітними сигналами dB/dt, dIₚ/dt і зондами Мірнова. Камера JET діє як фільтр із постійною часу 4–5,5 мс і послаблює магнітні імпульси в 1,3–2,5 раза.</a:t>
+            </a:r>
+          </a:p>
+        </p:txBody>
+      </p:sp>
+      <p:sp>
+        <p:nvSpPr>
+          <p:cNvPr id="4" name="Slide Number Placeholder 3"/>
+          <p:cNvSpPr>
+            <a:spLocks noGrp="1"/>
+          </p:cNvSpPr>
+          <p:nvPr>
+            <p:ph type="sldNum" idx="5" sz="quarter"/>
+          </p:nvPr>
+        </p:nvSpPr>
+        <p:spPr/>
+      </p:sp>
+    </p:spTree>
+  </p:cSld>
+  <p:clrMapOvr>
+    <a:masterClrMapping/>
+  </p:clrMapOvr>
+</p:notes>
+</file>
+
+<file path=ppt/notesSlides/notesSlide22.xml><?xml version="1.0" encoding="utf-8"?>
+<p:notes xmlns:a="http://schemas.openxmlformats.org/drawingml/2006/main" xmlns:p="http://schemas.openxmlformats.org/presentationml/2006/main" xmlns:r="http://schemas.openxmlformats.org/officeDocument/2006/relationships">
+  <p:cSld>
+    <p:spTree>
+      <p:nvGrpSpPr>
+        <p:cNvPr id="1" name=""/>
+        <p:cNvGrpSpPr/>
+        <p:nvPr/>
+      </p:nvGrpSpPr>
+      <p:grpSpPr>
+        <a:xfrm>
+          <a:off x="0" y="0"/>
+          <a:ext cx="0" cy="0"/>
+          <a:chOff x="0" y="0"/>
+          <a:chExt cx="0" cy="0"/>
+        </a:xfrm>
+      </p:grpSpPr>
+      <p:sp>
+        <p:nvSpPr>
+          <p:cNvPr id="2" name="Slide Image Placeholder 1"/>
+          <p:cNvSpPr>
+            <a:spLocks noGrp="1"/>
+          </p:cNvSpPr>
+          <p:nvPr>
+            <p:ph type="sldImg" idx="2"/>
+          </p:nvPr>
+        </p:nvSpPr>
+        <p:spPr/>
+      </p:sp>
+      <p:sp>
+        <p:nvSpPr>
+          <p:cNvPr id="3" name="Notes Placeholder 2"/>
+          <p:cNvSpPr>
+            <a:spLocks noGrp="1"/>
+          </p:cNvSpPr>
+          <p:nvPr>
+            <p:ph type="body" idx="3" sz="quarter"/>
+          </p:nvPr>
+        </p:nvSpPr>
+        <p:spPr/>
+        <p:txBody>
+          <a:bodyPr/>
+          <a:lstStyle/>
+          <a:p>
+            <a:r>
+              <a:t>Гіпотеза: числова похідна струму як ранній маркер. Перевірка на розряді 5: за 300 мс до гасіння похідна не перетинає поріг; термічне гасіння передує гасінню струму, струм утримує індуктивність плазми. Тригер запізнюється або пропускає зрив.</a:t>
+            </a:r>
+          </a:p>
+        </p:txBody>
+      </p:sp>
+      <p:sp>
+        <p:nvSpPr>
+          <p:cNvPr id="4" name="Slide Number Placeholder 3"/>
+          <p:cNvSpPr>
+            <a:spLocks noGrp="1"/>
+          </p:cNvSpPr>
+          <p:nvPr>
+            <p:ph type="sldNum" idx="5" sz="quarter"/>
+          </p:nvPr>
+        </p:nvSpPr>
+        <p:spPr/>
+      </p:sp>
+    </p:spTree>
+  </p:cSld>
+  <p:clrMapOvr>
+    <a:masterClrMapping/>
+  </p:clrMapOvr>
+</p:notes>
+</file>
+
+<file path=ppt/notesSlides/notesSlide23.xml><?xml version="1.0" encoding="utf-8"?>
+<p:notes xmlns:a="http://schemas.openxmlformats.org/drawingml/2006/main" xmlns:p="http://schemas.openxmlformats.org/presentationml/2006/main" xmlns:r="http://schemas.openxmlformats.org/officeDocument/2006/relationships">
+  <p:cSld>
+    <p:spTree>
+      <p:nvGrpSpPr>
+        <p:cNvPr id="1" name=""/>
+        <p:cNvGrpSpPr/>
+        <p:nvPr/>
+      </p:nvGrpSpPr>
+      <p:grpSpPr>
+        <a:xfrm>
+          <a:off x="0" y="0"/>
+          <a:ext cx="0" cy="0"/>
+          <a:chOff x="0" y="0"/>
+          <a:chExt cx="0" cy="0"/>
+        </a:xfrm>
+      </p:grpSpPr>
+      <p:sp>
+        <p:nvSpPr>
+          <p:cNvPr id="2" name="Slide Image Placeholder 1"/>
+          <p:cNvSpPr>
+            <a:spLocks noGrp="1"/>
+          </p:cNvSpPr>
+          <p:nvPr>
+            <p:ph type="sldImg" idx="2"/>
+          </p:nvPr>
+        </p:nvSpPr>
+        <p:spPr/>
+      </p:sp>
+      <p:sp>
+        <p:nvSpPr>
+          <p:cNvPr id="3" name="Notes Placeholder 2"/>
+          <p:cNvSpPr>
+            <a:spLocks noGrp="1"/>
+          </p:cNvSpPr>
+          <p:nvPr>
+            <p:ph type="body" idx="3" sz="quarter"/>
+          </p:nvPr>
+        </p:nvSpPr>
+        <p:spPr/>
+        <p:txBody>
+          <a:bodyPr/>
+          <a:lstStyle/>
+          <a:p>
+            <a:r>
+              <a:t>Розряд 27: проста сума котушок Мірнова гаситься взаємно, просторовий RMS показує наростання лише за 50–90 мс до гасіння, а одиночні сплески — це ELM, які дають хибні тривоги. Звідси наш дизайн: МГД-сигнали — лише для передвісника, раннє попередження — за межами f_GW, q95, βN, P_rad/P_in.</a:t>
+            </a:r>
+          </a:p>
+        </p:txBody>
+      </p:sp>
+      <p:sp>
+        <p:nvSpPr>
+          <p:cNvPr id="4" name="Slide Number Placeholder 3"/>
+          <p:cNvSpPr>
+            <a:spLocks noGrp="1"/>
+          </p:cNvSpPr>
+          <p:nvPr>
+            <p:ph type="sldNum" idx="5" sz="quarter"/>
+          </p:nvPr>
+        </p:nvSpPr>
+        <p:spPr/>
+      </p:sp>
+    </p:spTree>
+  </p:cSld>
+  <p:clrMapOvr>
+    <a:masterClrMapping/>
+  </p:clrMapOvr>
+</p:notes>
+</file>
+
+<file path=ppt/notesSlides/notesSlide24.xml><?xml version="1.0" encoding="utf-8"?>
+<p:notes xmlns:a="http://schemas.openxmlformats.org/drawingml/2006/main" xmlns:p="http://schemas.openxmlformats.org/presentationml/2006/main" xmlns:r="http://schemas.openxmlformats.org/officeDocument/2006/relationships">
+  <p:cSld>
+    <p:spTree>
+      <p:nvGrpSpPr>
+        <p:cNvPr id="1" name=""/>
+        <p:cNvGrpSpPr/>
+        <p:nvPr/>
+      </p:nvGrpSpPr>
+      <p:grpSpPr>
+        <a:xfrm>
+          <a:off x="0" y="0"/>
+          <a:ext cx="0" cy="0"/>
+          <a:chOff x="0" y="0"/>
+          <a:chExt cx="0" cy="0"/>
+        </a:xfrm>
+      </p:grpSpPr>
+      <p:sp>
+        <p:nvSpPr>
+          <p:cNvPr id="2" name="Slide Image Placeholder 1"/>
+          <p:cNvSpPr>
+            <a:spLocks noGrp="1"/>
+          </p:cNvSpPr>
+          <p:nvPr>
+            <p:ph type="sldImg" idx="2"/>
+          </p:nvPr>
+        </p:nvSpPr>
+        <p:spPr/>
+      </p:sp>
+      <p:sp>
+        <p:nvSpPr>
+          <p:cNvPr id="3" name="Notes Placeholder 2"/>
+          <p:cNvSpPr>
+            <a:spLocks noGrp="1"/>
+          </p:cNvSpPr>
+          <p:nvPr>
+            <p:ph type="body" idx="3" sz="quarter"/>
+          </p:nvPr>
+        </p:nvSpPr>
+        <p:spPr/>
+        <p:txBody>
+          <a:bodyPr/>
+          <a:lstStyle/>
+          <a:p>
+            <a:r>
+              <a:t>Підсумок фізичного аналізу: які евристики не спрацювали і які рішення лягли в основу моделей.</a:t>
             </a:r>
           </a:p>
         </p:txBody>
@@ -12012,6 +12367,2107 @@
           </a:p>
         </p:txBody>
       </p:sp>
+    </p:spTree>
+  </p:cSld>
+  <p:clrMapOvr>
+    <a:masterClrMapping/>
+  </p:clrMapOvr>
+</p:sld>
+</file>
+
+<file path=ppt/slides/slide20.xml><?xml version="1.0" encoding="utf-8"?>
+<p:sld xmlns:a="http://schemas.openxmlformats.org/drawingml/2006/main" xmlns:p="http://schemas.openxmlformats.org/presentationml/2006/main" xmlns:r="http://schemas.openxmlformats.org/officeDocument/2006/relationships">
+  <p:cSld>
+    <p:bg>
+      <p:bgPr>
+        <a:solidFill>
+          <a:srgbClr val="FFFFFF"/>
+        </a:solidFill>
+        <a:effectLst/>
+      </p:bgPr>
+    </p:bg>
+    <p:spTree>
+      <p:nvGrpSpPr>
+        <p:cNvPr id="1" name=""/>
+        <p:cNvGrpSpPr/>
+        <p:nvPr/>
+      </p:nvGrpSpPr>
+      <p:grpSpPr/>
+      <p:sp>
+        <p:nvSpPr>
+          <p:cNvPr id="2" name="TextBox 1"/>
+          <p:cNvSpPr txBox="1"/>
+          <p:nvPr/>
+        </p:nvSpPr>
+        <p:spPr>
+          <a:xfrm>
+            <a:off x="548640" y="411480"/>
+            <a:ext cx="11064240" cy="640080"/>
+          </a:xfrm>
+          <a:prstGeom prst="rect">
+            <a:avLst/>
+          </a:prstGeom>
+          <a:noFill/>
+        </p:spPr>
+        <p:txBody>
+          <a:bodyPr wrap="square" anchor="t" lIns="0" rIns="0" tIns="0" bIns="0">
+            <a:spAutoFit/>
+          </a:bodyPr>
+          <a:lstStyle/>
+          <a:p>
+            <a:pPr algn="l">
+              <a:spcAft>
+                <a:spcPts val="0"/>
+              </a:spcAft>
+            </a:pPr>
+            <a:r>
+              <a:rPr sz="2600" b="1" i="0">
+                <a:solidFill>
+                  <a:srgbClr val="0F172A"/>
+                </a:solidFill>
+                <a:latin typeface="Arial"/>
+              </a:rPr>
+              <a:t>Додаток А.1 Фізичні драйвери: конкуренція меж Грінвальда і low-q</a:t>
+            </a:r>
+          </a:p>
+        </p:txBody>
+      </p:sp>
+      <p:sp>
+        <p:nvSpPr>
+          <p:cNvPr id="3" name="TextBox 2"/>
+          <p:cNvSpPr txBox="1"/>
+          <p:nvPr/>
+        </p:nvSpPr>
+        <p:spPr>
+          <a:xfrm>
+            <a:off x="11247120" y="6446520"/>
+            <a:ext cx="457200" cy="274320"/>
+          </a:xfrm>
+          <a:prstGeom prst="rect">
+            <a:avLst/>
+          </a:prstGeom>
+          <a:noFill/>
+        </p:spPr>
+        <p:txBody>
+          <a:bodyPr wrap="square" anchor="t" lIns="0" rIns="0" tIns="0" bIns="0">
+            <a:spAutoFit/>
+          </a:bodyPr>
+          <a:lstStyle/>
+          <a:p>
+            <a:pPr algn="r">
+              <a:spcAft>
+                <a:spcPts val="0"/>
+              </a:spcAft>
+            </a:pPr>
+            <a:r>
+              <a:rPr sz="1000" b="0" i="0">
+                <a:solidFill>
+                  <a:srgbClr val="94A3B8"/>
+                </a:solidFill>
+                <a:latin typeface="Arial"/>
+              </a:rPr>
+              <a:t>20</a:t>
+            </a:r>
+          </a:p>
+        </p:txBody>
+      </p:sp>
+      <p:sp>
+        <p:nvSpPr>
+          <p:cNvPr id="4" name="Rectangle 3"/>
+          <p:cNvSpPr/>
+          <p:nvPr/>
+        </p:nvSpPr>
+        <p:spPr>
+          <a:xfrm>
+            <a:off x="521207" y="1252728"/>
+            <a:ext cx="7735824" cy="3966794"/>
+          </a:xfrm>
+          <a:prstGeom prst="rect">
+            <a:avLst/>
+          </a:prstGeom>
+          <a:noFill/>
+          <a:ln w="12700">
+            <a:solidFill>
+              <a:srgbClr val="E2E8F0"/>
+            </a:solidFill>
+          </a:ln>
+          <a:effectLst/>
+        </p:spPr>
+        <p:style>
+          <a:lnRef idx="1">
+            <a:schemeClr val="accent1"/>
+          </a:lnRef>
+          <a:fillRef idx="3">
+            <a:schemeClr val="accent1"/>
+          </a:fillRef>
+          <a:effectRef idx="2">
+            <a:schemeClr val="accent1"/>
+          </a:effectRef>
+          <a:fontRef idx="minor">
+            <a:schemeClr val="lt1"/>
+          </a:fontRef>
+        </p:style>
+        <p:txBody>
+          <a:bodyPr rtlCol="0" anchor="ctr"/>
+          <a:lstStyle/>
+          <a:p>
+            <a:pPr algn="ctr"/>
+          </a:p>
+        </p:txBody>
+      </p:sp>
+      <p:pic>
+        <p:nvPicPr>
+          <p:cNvPr id="5" name="Picture 4" descr="phys_sweep.png"/>
+          <p:cNvPicPr>
+            <a:picLocks noChangeAspect="1"/>
+          </p:cNvPicPr>
+          <p:nvPr/>
+        </p:nvPicPr>
+        <p:blipFill>
+          <a:blip r:embed="rId3"/>
+          <a:stretch>
+            <a:fillRect/>
+          </a:stretch>
+        </p:blipFill>
+        <p:spPr>
+          <a:xfrm>
+            <a:off x="548640" y="1280160"/>
+            <a:ext cx="7680960" cy="3911930"/>
+          </a:xfrm>
+          <a:prstGeom prst="rect">
+            <a:avLst/>
+          </a:prstGeom>
+        </p:spPr>
+      </p:pic>
+      <p:sp>
+        <p:nvSpPr>
+          <p:cNvPr id="6" name="TextBox 5"/>
+          <p:cNvSpPr txBox="1"/>
+          <p:nvPr/>
+        </p:nvSpPr>
+        <p:spPr>
+          <a:xfrm>
+            <a:off x="548640" y="5237810"/>
+            <a:ext cx="7680960" cy="365760"/>
+          </a:xfrm>
+          <a:prstGeom prst="rect">
+            <a:avLst/>
+          </a:prstGeom>
+          <a:noFill/>
+        </p:spPr>
+        <p:txBody>
+          <a:bodyPr wrap="square" anchor="t" lIns="0" rIns="0" tIns="0" bIns="0">
+            <a:spAutoFit/>
+          </a:bodyPr>
+          <a:lstStyle/>
+          <a:p>
+            <a:pPr algn="l">
+              <a:spcAft>
+                <a:spcPts val="0"/>
+              </a:spcAft>
+            </a:pPr>
+            <a:r>
+              <a:rPr sz="1100" b="0" i="0">
+                <a:solidFill>
+                  <a:srgbClr val="475569"/>
+                </a:solidFill>
+                <a:latin typeface="Arial"/>
+              </a:rPr>
+              <a:t>Рисунок 11 – Сканування струму Iₚ і уставки густини (91 розряд): A — ризики r_GW і r_q від Iₚ; B — λ від Iₚ; C — f_GW і r_GW від густини; D — λ від густини</a:t>
+            </a:r>
+          </a:p>
+        </p:txBody>
+      </p:sp>
+      <p:sp>
+        <p:nvSpPr>
+          <p:cNvPr id="7" name="Rectangle 6"/>
+          <p:cNvSpPr/>
+          <p:nvPr/>
+        </p:nvSpPr>
+        <p:spPr>
+          <a:xfrm>
+            <a:off x="8595360" y="1280160"/>
+            <a:ext cx="3063240" cy="1600200"/>
+          </a:xfrm>
+          <a:prstGeom prst="rect">
+            <a:avLst/>
+          </a:prstGeom>
+          <a:solidFill>
+            <a:srgbClr val="F8FAFC"/>
+          </a:solidFill>
+          <a:ln w="12700">
+            <a:solidFill>
+              <a:srgbClr val="E2E8F0"/>
+            </a:solidFill>
+          </a:ln>
+          <a:effectLst/>
+        </p:spPr>
+        <p:style>
+          <a:lnRef idx="1">
+            <a:schemeClr val="accent1"/>
+          </a:lnRef>
+          <a:fillRef idx="3">
+            <a:schemeClr val="accent1"/>
+          </a:fillRef>
+          <a:effectRef idx="2">
+            <a:schemeClr val="accent1"/>
+          </a:effectRef>
+          <a:fontRef idx="minor">
+            <a:schemeClr val="lt1"/>
+          </a:fontRef>
+        </p:style>
+        <p:txBody>
+          <a:bodyPr rtlCol="0" anchor="ctr"/>
+          <a:lstStyle/>
+          <a:p>
+            <a:pPr algn="ctr"/>
+          </a:p>
+        </p:txBody>
+      </p:sp>
+      <p:sp>
+        <p:nvSpPr>
+          <p:cNvPr id="8" name="TextBox 7"/>
+          <p:cNvSpPr txBox="1"/>
+          <p:nvPr/>
+        </p:nvSpPr>
+        <p:spPr>
+          <a:xfrm>
+            <a:off x="8732520" y="1371600"/>
+            <a:ext cx="2834640" cy="1463040"/>
+          </a:xfrm>
+          <a:prstGeom prst="rect">
+            <a:avLst/>
+          </a:prstGeom>
+          <a:noFill/>
+        </p:spPr>
+        <p:txBody>
+          <a:bodyPr wrap="square" anchor="t" lIns="0" rIns="0" tIns="0" bIns="0">
+            <a:spAutoFit/>
+          </a:bodyPr>
+          <a:lstStyle/>
+          <a:p>
+            <a:pPr algn="l">
+              <a:spcAft>
+                <a:spcPts val="800"/>
+              </a:spcAft>
+            </a:pPr>
+            <a:r>
+              <a:rPr sz="1300" b="1" i="0">
+                <a:solidFill>
+                  <a:srgbClr val="0F172A"/>
+                </a:solidFill>
+                <a:latin typeface="Arial"/>
+              </a:rPr>
+              <a:t>λ = 1 − Πᵢ (1 − rᵢ³)(1 − r_lm)</a:t>
+            </a:r>
+          </a:p>
+          <a:p>
+            <a:pPr algn="l">
+              <a:spcAft>
+                <a:spcPts val="800"/>
+              </a:spcAft>
+            </a:pPr>
+            <a:r>
+              <a:rPr sz="1300" b="1" i="0">
+                <a:solidFill>
+                  <a:srgbClr val="0F172A"/>
+                </a:solidFill>
+                <a:latin typeface="Arial"/>
+              </a:rPr>
+              <a:t>f_GW = n̄ₑ / n_GW</a:t>
+            </a:r>
+          </a:p>
+          <a:p>
+            <a:pPr algn="l">
+              <a:spcAft>
+                <a:spcPts val="0"/>
+              </a:spcAft>
+            </a:pPr>
+            <a:r>
+              <a:rPr sz="1300" b="1" i="0">
+                <a:solidFill>
+                  <a:srgbClr val="0F172A"/>
+                </a:solidFill>
+                <a:latin typeface="Arial"/>
+              </a:rPr>
+              <a:t>f_GW ∝ n̄ₑ / Iₚ</a:t>
+            </a:r>
+          </a:p>
+        </p:txBody>
+      </p:sp>
+      <p:sp>
+        <p:nvSpPr>
+          <p:cNvPr id="9" name="TextBox 8"/>
+          <p:cNvSpPr txBox="1"/>
+          <p:nvPr/>
+        </p:nvSpPr>
+        <p:spPr>
+          <a:xfrm>
+            <a:off x="8595360" y="3108960"/>
+            <a:ext cx="3063240" cy="2286000"/>
+          </a:xfrm>
+          <a:prstGeom prst="rect">
+            <a:avLst/>
+          </a:prstGeom>
+          <a:noFill/>
+        </p:spPr>
+        <p:txBody>
+          <a:bodyPr wrap="square" anchor="t" lIns="0" rIns="0" tIns="0" bIns="0">
+            <a:spAutoFit/>
+          </a:bodyPr>
+          <a:lstStyle/>
+          <a:p>
+            <a:pPr algn="l">
+              <a:spcAft>
+                <a:spcPts val="700"/>
+              </a:spcAft>
+            </a:pPr>
+            <a:r>
+              <a:rPr sz="1200" b="1" i="0">
+                <a:solidFill>
+                  <a:srgbClr val="0F172A"/>
+                </a:solidFill>
+                <a:latin typeface="Arial"/>
+              </a:rPr>
+              <a:t>Струм – </a:t>
+            </a:r>
+            <a:r>
+              <a:rPr sz="1200" b="0" i="0">
+                <a:solidFill>
+                  <a:srgbClr val="0F172A"/>
+                </a:solidFill>
+                <a:latin typeface="Arial"/>
+              </a:rPr>
+              <a:t>малий Iₚ — межа Грінвальда, великий — low-q (кінк); між ними вікно низького ризику ≈ 2,6–3,6 МА</a:t>
+            </a:r>
+          </a:p>
+          <a:p>
+            <a:pPr algn="l">
+              <a:spcAft>
+                <a:spcPts val="700"/>
+              </a:spcAft>
+            </a:pPr>
+            <a:r>
+              <a:rPr sz="1200" b="1" i="0">
+                <a:solidFill>
+                  <a:srgbClr val="0F172A"/>
+                </a:solidFill>
+                <a:latin typeface="Arial"/>
+              </a:rPr>
+              <a:t>Густина – </a:t>
+            </a:r>
+            <a:r>
+              <a:rPr sz="1200" b="0" i="0">
+                <a:solidFill>
+                  <a:srgbClr val="0F172A"/>
+                </a:solidFill>
+                <a:latin typeface="Arial"/>
+              </a:rPr>
+              <a:t>коли f_GW підходить до 1, λ зростає на два порядки</a:t>
+            </a:r>
+          </a:p>
+          <a:p>
+            <a:pPr algn="l">
+              <a:spcAft>
+                <a:spcPts val="700"/>
+              </a:spcAft>
+            </a:pPr>
+            <a:r>
+              <a:rPr sz="1200" b="1" i="0">
+                <a:solidFill>
+                  <a:srgbClr val="0F172A"/>
+                </a:solidFill>
+                <a:latin typeface="Arial"/>
+              </a:rPr>
+              <a:t>Висновок – </a:t>
+            </a:r>
+            <a:r>
+              <a:rPr sz="1200" b="0" i="0">
+                <a:solidFill>
+                  <a:srgbClr val="0F172A"/>
+                </a:solidFill>
+                <a:latin typeface="Arial"/>
+              </a:rPr>
+              <a:t>межі конкурують: зниження одного ризику підвищує інший, тому керування має знати механізм</a:t>
+            </a:r>
+          </a:p>
+        </p:txBody>
+      </p:sp>
+    </p:spTree>
+  </p:cSld>
+  <p:clrMapOvr>
+    <a:masterClrMapping/>
+  </p:clrMapOvr>
+</p:sld>
+</file>
+
+<file path=ppt/slides/slide21.xml><?xml version="1.0" encoding="utf-8"?>
+<p:sld xmlns:a="http://schemas.openxmlformats.org/drawingml/2006/main" xmlns:p="http://schemas.openxmlformats.org/presentationml/2006/main" xmlns:r="http://schemas.openxmlformats.org/officeDocument/2006/relationships">
+  <p:cSld>
+    <p:bg>
+      <p:bgPr>
+        <a:solidFill>
+          <a:srgbClr val="FFFFFF"/>
+        </a:solidFill>
+        <a:effectLst/>
+      </p:bgPr>
+    </p:bg>
+    <p:spTree>
+      <p:nvGrpSpPr>
+        <p:cNvPr id="1" name=""/>
+        <p:cNvGrpSpPr/>
+        <p:nvPr/>
+      </p:nvGrpSpPr>
+      <p:grpSpPr/>
+      <p:sp>
+        <p:nvSpPr>
+          <p:cNvPr id="2" name="TextBox 1"/>
+          <p:cNvSpPr txBox="1"/>
+          <p:nvPr/>
+        </p:nvSpPr>
+        <p:spPr>
+          <a:xfrm>
+            <a:off x="548640" y="411480"/>
+            <a:ext cx="11064240" cy="640080"/>
+          </a:xfrm>
+          <a:prstGeom prst="rect">
+            <a:avLst/>
+          </a:prstGeom>
+          <a:noFill/>
+        </p:spPr>
+        <p:txBody>
+          <a:bodyPr wrap="square" anchor="t" lIns="0" rIns="0" tIns="0" bIns="0">
+            <a:spAutoFit/>
+          </a:bodyPr>
+          <a:lstStyle/>
+          <a:p>
+            <a:pPr algn="l">
+              <a:spcAft>
+                <a:spcPts val="0"/>
+              </a:spcAft>
+            </a:pPr>
+            <a:r>
+              <a:rPr sz="2600" b="1" i="0">
+                <a:solidFill>
+                  <a:srgbClr val="0F172A"/>
+                </a:solidFill>
+                <a:latin typeface="Arial"/>
+              </a:rPr>
+              <a:t>Додаток А.2 Екранування камери і швидкі магнітні тригери</a:t>
+            </a:r>
+          </a:p>
+        </p:txBody>
+      </p:sp>
+      <p:sp>
+        <p:nvSpPr>
+          <p:cNvPr id="3" name="TextBox 2"/>
+          <p:cNvSpPr txBox="1"/>
+          <p:nvPr/>
+        </p:nvSpPr>
+        <p:spPr>
+          <a:xfrm>
+            <a:off x="11247120" y="6446520"/>
+            <a:ext cx="457200" cy="274320"/>
+          </a:xfrm>
+          <a:prstGeom prst="rect">
+            <a:avLst/>
+          </a:prstGeom>
+          <a:noFill/>
+        </p:spPr>
+        <p:txBody>
+          <a:bodyPr wrap="square" anchor="t" lIns="0" rIns="0" tIns="0" bIns="0">
+            <a:spAutoFit/>
+          </a:bodyPr>
+          <a:lstStyle/>
+          <a:p>
+            <a:pPr algn="r">
+              <a:spcAft>
+                <a:spcPts val="0"/>
+              </a:spcAft>
+            </a:pPr>
+            <a:r>
+              <a:rPr sz="1000" b="0" i="0">
+                <a:solidFill>
+                  <a:srgbClr val="94A3B8"/>
+                </a:solidFill>
+                <a:latin typeface="Arial"/>
+              </a:rPr>
+              <a:t>21</a:t>
+            </a:r>
+          </a:p>
+        </p:txBody>
+      </p:sp>
+      <p:sp>
+        <p:nvSpPr>
+          <p:cNvPr id="4" name="Rectangle 3"/>
+          <p:cNvSpPr/>
+          <p:nvPr/>
+        </p:nvSpPr>
+        <p:spPr>
+          <a:xfrm>
+            <a:off x="548640" y="1325880"/>
+            <a:ext cx="5394960" cy="1508760"/>
+          </a:xfrm>
+          <a:prstGeom prst="rect">
+            <a:avLst/>
+          </a:prstGeom>
+          <a:solidFill>
+            <a:srgbClr val="F8FAFC"/>
+          </a:solidFill>
+          <a:ln w="12700">
+            <a:solidFill>
+              <a:srgbClr val="E2E8F0"/>
+            </a:solidFill>
+          </a:ln>
+          <a:effectLst/>
+        </p:spPr>
+        <p:style>
+          <a:lnRef idx="1">
+            <a:schemeClr val="accent1"/>
+          </a:lnRef>
+          <a:fillRef idx="3">
+            <a:schemeClr val="accent1"/>
+          </a:fillRef>
+          <a:effectRef idx="2">
+            <a:schemeClr val="accent1"/>
+          </a:effectRef>
+          <a:fontRef idx="minor">
+            <a:schemeClr val="lt1"/>
+          </a:fontRef>
+        </p:style>
+        <p:txBody>
+          <a:bodyPr rtlCol="0" anchor="ctr"/>
+          <a:lstStyle/>
+          <a:p>
+            <a:pPr algn="ctr"/>
+          </a:p>
+        </p:txBody>
+      </p:sp>
+      <p:sp>
+        <p:nvSpPr>
+          <p:cNvPr id="5" name="TextBox 4"/>
+          <p:cNvSpPr txBox="1"/>
+          <p:nvPr/>
+        </p:nvSpPr>
+        <p:spPr>
+          <a:xfrm>
+            <a:off x="731520" y="1463040"/>
+            <a:ext cx="5029200" cy="1920240"/>
+          </a:xfrm>
+          <a:prstGeom prst="rect">
+            <a:avLst/>
+          </a:prstGeom>
+          <a:noFill/>
+        </p:spPr>
+        <p:txBody>
+          <a:bodyPr wrap="square" anchor="t" lIns="0" rIns="0" tIns="0" bIns="0">
+            <a:spAutoFit/>
+          </a:bodyPr>
+          <a:lstStyle/>
+          <a:p>
+            <a:pPr algn="l">
+              <a:spcAft>
+                <a:spcPts val="400"/>
+              </a:spcAft>
+            </a:pPr>
+            <a:r>
+              <a:rPr sz="1200" b="1" i="0">
+                <a:solidFill>
+                  <a:srgbClr val="475569"/>
+                </a:solidFill>
+                <a:latin typeface="Arial"/>
+              </a:rPr>
+              <a:t>Постійна часу камери</a:t>
+            </a:r>
+          </a:p>
+          <a:p>
+            <a:pPr algn="l">
+              <a:spcAft>
+                <a:spcPts val="1000"/>
+              </a:spcAft>
+            </a:pPr>
+            <a:r>
+              <a:rPr sz="2000" b="1" i="0">
+                <a:solidFill>
+                  <a:srgbClr val="0F172A"/>
+                </a:solidFill>
+                <a:latin typeface="Arial"/>
+              </a:rPr>
+              <a:t>τ_w = L_v / R_v ≈ 4–5,5 мс</a:t>
+            </a:r>
+          </a:p>
+          <a:p>
+            <a:pPr algn="l">
+              <a:spcAft>
+                <a:spcPts val="0"/>
+              </a:spcAft>
+            </a:pPr>
+            <a:r>
+              <a:rPr sz="1200" b="0" i="0">
+                <a:solidFill>
+                  <a:srgbClr val="475569"/>
+                </a:solidFill>
+                <a:latin typeface="Arial"/>
+              </a:rPr>
+              <a:t>Оцінка для JET, камера якого має високоомні сильфони</a:t>
+            </a:r>
+          </a:p>
+        </p:txBody>
+      </p:sp>
+      <p:sp>
+        <p:nvSpPr>
+          <p:cNvPr id="6" name="Rectangle 5"/>
+          <p:cNvSpPr/>
+          <p:nvPr/>
+        </p:nvSpPr>
+        <p:spPr>
+          <a:xfrm>
+            <a:off x="6263640" y="1325880"/>
+            <a:ext cx="5394960" cy="1508760"/>
+          </a:xfrm>
+          <a:prstGeom prst="rect">
+            <a:avLst/>
+          </a:prstGeom>
+          <a:solidFill>
+            <a:srgbClr val="F8FAFC"/>
+          </a:solidFill>
+          <a:ln w="12700">
+            <a:solidFill>
+              <a:srgbClr val="E2E8F0"/>
+            </a:solidFill>
+          </a:ln>
+          <a:effectLst/>
+        </p:spPr>
+        <p:style>
+          <a:lnRef idx="1">
+            <a:schemeClr val="accent1"/>
+          </a:lnRef>
+          <a:fillRef idx="3">
+            <a:schemeClr val="accent1"/>
+          </a:fillRef>
+          <a:effectRef idx="2">
+            <a:schemeClr val="accent1"/>
+          </a:effectRef>
+          <a:fontRef idx="minor">
+            <a:schemeClr val="lt1"/>
+          </a:fontRef>
+        </p:style>
+        <p:txBody>
+          <a:bodyPr rtlCol="0" anchor="ctr"/>
+          <a:lstStyle/>
+          <a:p>
+            <a:pPr algn="ctr"/>
+          </a:p>
+        </p:txBody>
+      </p:sp>
+      <p:sp>
+        <p:nvSpPr>
+          <p:cNvPr id="7" name="TextBox 6"/>
+          <p:cNvSpPr txBox="1"/>
+          <p:nvPr/>
+        </p:nvSpPr>
+        <p:spPr>
+          <a:xfrm>
+            <a:off x="6446520" y="1463040"/>
+            <a:ext cx="5029200" cy="1920240"/>
+          </a:xfrm>
+          <a:prstGeom prst="rect">
+            <a:avLst/>
+          </a:prstGeom>
+          <a:noFill/>
+        </p:spPr>
+        <p:txBody>
+          <a:bodyPr wrap="square" anchor="t" lIns="0" rIns="0" tIns="0" bIns="0">
+            <a:spAutoFit/>
+          </a:bodyPr>
+          <a:lstStyle/>
+          <a:p>
+            <a:pPr algn="l">
+              <a:spcAft>
+                <a:spcPts val="400"/>
+              </a:spcAft>
+            </a:pPr>
+            <a:r>
+              <a:rPr sz="1200" b="1" i="0">
+                <a:solidFill>
+                  <a:srgbClr val="475569"/>
+                </a:solidFill>
+                <a:latin typeface="Arial"/>
+              </a:rPr>
+              <a:t>Коефіцієнт екранування</a:t>
+            </a:r>
+          </a:p>
+          <a:p>
+            <a:pPr algn="l">
+              <a:spcAft>
+                <a:spcPts val="600"/>
+              </a:spcAft>
+            </a:pPr>
+            <a:r>
+              <a:rPr sz="1500" b="1" i="0">
+                <a:solidFill>
+                  <a:srgbClr val="0F172A"/>
+                </a:solidFill>
+                <a:latin typeface="Arial"/>
+              </a:rPr>
+              <a:t>S = (dB/dt)max без камери / (dB/dt)max з камерою</a:t>
+            </a:r>
+          </a:p>
+          <a:p>
+            <a:pPr algn="l">
+              <a:spcAft>
+                <a:spcPts val="0"/>
+              </a:spcAft>
+            </a:pPr>
+            <a:r>
+              <a:rPr sz="2000" b="1" i="0">
+                <a:solidFill>
+                  <a:srgbClr val="0F172A"/>
+                </a:solidFill>
+                <a:latin typeface="Arial"/>
+              </a:rPr>
+              <a:t>S ≈ 1,3–2,5</a:t>
+            </a:r>
+          </a:p>
+        </p:txBody>
+      </p:sp>
+      <p:sp>
+        <p:nvSpPr>
+          <p:cNvPr id="8" name="TextBox 7"/>
+          <p:cNvSpPr txBox="1"/>
+          <p:nvPr/>
+        </p:nvSpPr>
+        <p:spPr>
+          <a:xfrm>
+            <a:off x="548640" y="3154680"/>
+            <a:ext cx="11064240" cy="1828800"/>
+          </a:xfrm>
+          <a:prstGeom prst="rect">
+            <a:avLst/>
+          </a:prstGeom>
+          <a:noFill/>
+        </p:spPr>
+        <p:txBody>
+          <a:bodyPr wrap="square" anchor="t" lIns="0" rIns="0" tIns="0" bIns="0">
+            <a:spAutoFit/>
+          </a:bodyPr>
+          <a:lstStyle/>
+          <a:p>
+            <a:pPr algn="l">
+              <a:spcAft>
+                <a:spcPts val="1000"/>
+              </a:spcAft>
+            </a:pPr>
+            <a:r>
+              <a:rPr sz="1400" b="1" i="0">
+                <a:solidFill>
+                  <a:srgbClr val="0F172A"/>
+                </a:solidFill>
+                <a:latin typeface="Arial"/>
+              </a:rPr>
+              <a:t>Фільтр – </a:t>
+            </a:r>
+            <a:r>
+              <a:rPr sz="1400" b="0" i="0">
+                <a:solidFill>
+                  <a:srgbClr val="0F172A"/>
+                </a:solidFill>
+                <a:latin typeface="Arial"/>
+              </a:rPr>
+              <a:t>камера діє як згладжувальний фільтр із затримкою близько 5 мс і розтягує магнітні імпульси в часі</a:t>
+            </a:r>
+          </a:p>
+          <a:p>
+            <a:pPr algn="l">
+              <a:spcAft>
+                <a:spcPts val="1000"/>
+              </a:spcAft>
+            </a:pPr>
+            <a:r>
+              <a:rPr sz="1400" b="1" i="0">
+                <a:solidFill>
+                  <a:srgbClr val="0F172A"/>
+                </a:solidFill>
+                <a:latin typeface="Arial"/>
+              </a:rPr>
+              <a:t>Наслідок – </a:t>
+            </a:r>
+            <a:r>
+              <a:rPr sz="1400" b="0" i="0">
+                <a:solidFill>
+                  <a:srgbClr val="0F172A"/>
+                </a:solidFill>
+                <a:latin typeface="Arial"/>
+              </a:rPr>
+              <a:t>швидкі магнітні похідні приходять до приладів ослабленими і запізнілими — це перевіряють наступні два слайди</a:t>
+            </a:r>
+          </a:p>
+        </p:txBody>
+      </p:sp>
+    </p:spTree>
+  </p:cSld>
+  <p:clrMapOvr>
+    <a:masterClrMapping/>
+  </p:clrMapOvr>
+</p:sld>
+</file>
+
+<file path=ppt/slides/slide22.xml><?xml version="1.0" encoding="utf-8"?>
+<p:sld xmlns:a="http://schemas.openxmlformats.org/drawingml/2006/main" xmlns:p="http://schemas.openxmlformats.org/presentationml/2006/main" xmlns:r="http://schemas.openxmlformats.org/officeDocument/2006/relationships">
+  <p:cSld>
+    <p:bg>
+      <p:bgPr>
+        <a:solidFill>
+          <a:srgbClr val="FFFFFF"/>
+        </a:solidFill>
+        <a:effectLst/>
+      </p:bgPr>
+    </p:bg>
+    <p:spTree>
+      <p:nvGrpSpPr>
+        <p:cNvPr id="1" name=""/>
+        <p:cNvGrpSpPr/>
+        <p:nvPr/>
+      </p:nvGrpSpPr>
+      <p:grpSpPr/>
+      <p:sp>
+        <p:nvSpPr>
+          <p:cNvPr id="2" name="TextBox 1"/>
+          <p:cNvSpPr txBox="1"/>
+          <p:nvPr/>
+        </p:nvSpPr>
+        <p:spPr>
+          <a:xfrm>
+            <a:off x="548640" y="411480"/>
+            <a:ext cx="11064240" cy="640080"/>
+          </a:xfrm>
+          <a:prstGeom prst="rect">
+            <a:avLst/>
+          </a:prstGeom>
+          <a:noFill/>
+        </p:spPr>
+        <p:txBody>
+          <a:bodyPr wrap="square" anchor="t" lIns="0" rIns="0" tIns="0" bIns="0">
+            <a:spAutoFit/>
+          </a:bodyPr>
+          <a:lstStyle/>
+          <a:p>
+            <a:pPr algn="l">
+              <a:spcAft>
+                <a:spcPts val="0"/>
+              </a:spcAft>
+            </a:pPr>
+            <a:r>
+              <a:rPr sz="2600" b="1" i="0">
+                <a:solidFill>
+                  <a:srgbClr val="0F172A"/>
+                </a:solidFill>
+                <a:latin typeface="Arial"/>
+              </a:rPr>
+              <a:t>Додаток А.3 Гіпотеза швидкого тригера dIₚ/dt та її перевірка</a:t>
+            </a:r>
+          </a:p>
+        </p:txBody>
+      </p:sp>
+      <p:sp>
+        <p:nvSpPr>
+          <p:cNvPr id="3" name="TextBox 2"/>
+          <p:cNvSpPr txBox="1"/>
+          <p:nvPr/>
+        </p:nvSpPr>
+        <p:spPr>
+          <a:xfrm>
+            <a:off x="11247120" y="6446520"/>
+            <a:ext cx="457200" cy="274320"/>
+          </a:xfrm>
+          <a:prstGeom prst="rect">
+            <a:avLst/>
+          </a:prstGeom>
+          <a:noFill/>
+        </p:spPr>
+        <p:txBody>
+          <a:bodyPr wrap="square" anchor="t" lIns="0" rIns="0" tIns="0" bIns="0">
+            <a:spAutoFit/>
+          </a:bodyPr>
+          <a:lstStyle/>
+          <a:p>
+            <a:pPr algn="r">
+              <a:spcAft>
+                <a:spcPts val="0"/>
+              </a:spcAft>
+            </a:pPr>
+            <a:r>
+              <a:rPr sz="1000" b="0" i="0">
+                <a:solidFill>
+                  <a:srgbClr val="94A3B8"/>
+                </a:solidFill>
+                <a:latin typeface="Arial"/>
+              </a:rPr>
+              <a:t>22</a:t>
+            </a:r>
+          </a:p>
+        </p:txBody>
+      </p:sp>
+      <p:sp>
+        <p:nvSpPr>
+          <p:cNvPr id="4" name="Rectangle 3"/>
+          <p:cNvSpPr/>
+          <p:nvPr/>
+        </p:nvSpPr>
+        <p:spPr>
+          <a:xfrm>
+            <a:off x="521207" y="1252728"/>
+            <a:ext cx="5910975" cy="4626864"/>
+          </a:xfrm>
+          <a:prstGeom prst="rect">
+            <a:avLst/>
+          </a:prstGeom>
+          <a:noFill/>
+          <a:ln w="12700">
+            <a:solidFill>
+              <a:srgbClr val="E2E8F0"/>
+            </a:solidFill>
+          </a:ln>
+          <a:effectLst/>
+        </p:spPr>
+        <p:style>
+          <a:lnRef idx="1">
+            <a:schemeClr val="accent1"/>
+          </a:lnRef>
+          <a:fillRef idx="3">
+            <a:schemeClr val="accent1"/>
+          </a:fillRef>
+          <a:effectRef idx="2">
+            <a:schemeClr val="accent1"/>
+          </a:effectRef>
+          <a:fontRef idx="minor">
+            <a:schemeClr val="lt1"/>
+          </a:fontRef>
+        </p:style>
+        <p:txBody>
+          <a:bodyPr rtlCol="0" anchor="ctr"/>
+          <a:lstStyle/>
+          <a:p>
+            <a:pPr algn="ctr"/>
+          </a:p>
+        </p:txBody>
+      </p:sp>
+      <p:pic>
+        <p:nvPicPr>
+          <p:cNvPr id="5" name="Picture 4" descr="phys_dipdt.png"/>
+          <p:cNvPicPr>
+            <a:picLocks noChangeAspect="1"/>
+          </p:cNvPicPr>
+          <p:nvPr/>
+        </p:nvPicPr>
+        <p:blipFill>
+          <a:blip r:embed="rId3"/>
+          <a:stretch>
+            <a:fillRect/>
+          </a:stretch>
+        </p:blipFill>
+        <p:spPr>
+          <a:xfrm>
+            <a:off x="548640" y="1280160"/>
+            <a:ext cx="5856111" cy="4572000"/>
+          </a:xfrm>
+          <a:prstGeom prst="rect">
+            <a:avLst/>
+          </a:prstGeom>
+        </p:spPr>
+      </p:pic>
+      <p:sp>
+        <p:nvSpPr>
+          <p:cNvPr id="6" name="TextBox 5"/>
+          <p:cNvSpPr txBox="1"/>
+          <p:nvPr/>
+        </p:nvSpPr>
+        <p:spPr>
+          <a:xfrm>
+            <a:off x="548640" y="5897880"/>
+            <a:ext cx="5856111" cy="365760"/>
+          </a:xfrm>
+          <a:prstGeom prst="rect">
+            <a:avLst/>
+          </a:prstGeom>
+          <a:noFill/>
+        </p:spPr>
+        <p:txBody>
+          <a:bodyPr wrap="square" anchor="t" lIns="0" rIns="0" tIns="0" bIns="0">
+            <a:spAutoFit/>
+          </a:bodyPr>
+          <a:lstStyle/>
+          <a:p>
+            <a:pPr algn="l">
+              <a:spcAft>
+                <a:spcPts val="0"/>
+              </a:spcAft>
+            </a:pPr>
+            <a:r>
+              <a:rPr sz="1100" b="0" i="0">
+                <a:solidFill>
+                  <a:srgbClr val="475569"/>
+                </a:solidFill>
+                <a:latin typeface="Arial"/>
+              </a:rPr>
+              <a:t>Рисунок 12 – Перевірка магнітного тригера на розряді 5: Iₚ, dIₚ/dt з порогом −10 МА/с і сигнал тривоги</a:t>
+            </a:r>
+          </a:p>
+        </p:txBody>
+      </p:sp>
+      <p:sp>
+        <p:nvSpPr>
+          <p:cNvPr id="7" name="TextBox 6"/>
+          <p:cNvSpPr txBox="1"/>
+          <p:nvPr/>
+        </p:nvSpPr>
+        <p:spPr>
+          <a:xfrm>
+            <a:off x="6861951" y="1371600"/>
+            <a:ext cx="4750928" cy="2743200"/>
+          </a:xfrm>
+          <a:prstGeom prst="rect">
+            <a:avLst/>
+          </a:prstGeom>
+          <a:noFill/>
+        </p:spPr>
+        <p:txBody>
+          <a:bodyPr wrap="square" anchor="t" lIns="0" rIns="0" tIns="0" bIns="0">
+            <a:spAutoFit/>
+          </a:bodyPr>
+          <a:lstStyle/>
+          <a:p>
+            <a:pPr algn="l">
+              <a:spcAft>
+                <a:spcPts val="900"/>
+              </a:spcAft>
+            </a:pPr>
+            <a:r>
+              <a:rPr sz="1300" b="1" i="0">
+                <a:solidFill>
+                  <a:srgbClr val="0F172A"/>
+                </a:solidFill>
+                <a:latin typeface="Arial"/>
+              </a:rPr>
+              <a:t>Гіпотеза – </a:t>
+            </a:r>
+            <a:r>
+              <a:rPr sz="1300" b="0" i="0">
+                <a:solidFill>
+                  <a:srgbClr val="0F172A"/>
+                </a:solidFill>
+                <a:latin typeface="Arial"/>
+              </a:rPr>
+              <a:t>D_I(t) = (Iₚ(t) − Iₚ(t − Δt)) / Δt на кожному кроці (Δt = 5 мс); тривога при D_I &lt; −10 МА/с</a:t>
+            </a:r>
+          </a:p>
+          <a:p>
+            <a:pPr algn="l">
+              <a:spcAft>
+                <a:spcPts val="900"/>
+              </a:spcAft>
+            </a:pPr>
+            <a:r>
+              <a:rPr sz="1300" b="1" i="0">
+                <a:solidFill>
+                  <a:srgbClr val="0F172A"/>
+                </a:solidFill>
+                <a:latin typeface="Arial"/>
+              </a:rPr>
+              <a:t>Фізика – </a:t>
+            </a:r>
+            <a:r>
+              <a:rPr sz="1300" b="0" i="0">
+                <a:solidFill>
+                  <a:srgbClr val="0F172A"/>
+                </a:solidFill>
+                <a:latin typeface="Arial"/>
+              </a:rPr>
+              <a:t>термічне гасіння t_Q передує гасінню струму: у момент t_Q струм ще утримує індуктивність плазми</a:t>
+            </a:r>
+          </a:p>
+          <a:p>
+            <a:pPr algn="l">
+              <a:spcAft>
+                <a:spcPts val="900"/>
+              </a:spcAft>
+            </a:pPr>
+            <a:r>
+              <a:rPr sz="1300" b="1" i="0">
+                <a:solidFill>
+                  <a:srgbClr val="0F172A"/>
+                </a:solidFill>
+                <a:latin typeface="Arial"/>
+              </a:rPr>
+              <a:t>Результат – </a:t>
+            </a:r>
+            <a:r>
+              <a:rPr sz="1300" b="0" i="0">
+                <a:solidFill>
+                  <a:srgbClr val="0F172A"/>
+                </a:solidFill>
+                <a:latin typeface="Arial"/>
+              </a:rPr>
+              <a:t>у заліковому вікні 300 мс поріг не перетнуто: тригер запізнюється або пропускає зрив</a:t>
+            </a:r>
+          </a:p>
+          <a:p>
+            <a:pPr algn="l">
+              <a:spcAft>
+                <a:spcPts val="900"/>
+              </a:spcAft>
+            </a:pPr>
+            <a:r>
+              <a:rPr sz="1300" b="1" i="0">
+                <a:solidFill>
+                  <a:srgbClr val="0F172A"/>
+                </a:solidFill>
+                <a:latin typeface="Arial"/>
+              </a:rPr>
+              <a:t>Висновок – </a:t>
+            </a:r>
+            <a:r>
+              <a:rPr sz="1300" b="0" i="0">
+                <a:solidFill>
+                  <a:srgbClr val="0F172A"/>
+                </a:solidFill>
+                <a:latin typeface="Arial"/>
+              </a:rPr>
+              <a:t>dIₚ/dt як тригер раннього попередження відкинуто</a:t>
+            </a:r>
+          </a:p>
+        </p:txBody>
+      </p:sp>
+    </p:spTree>
+  </p:cSld>
+  <p:clrMapOvr>
+    <a:masterClrMapping/>
+  </p:clrMapOvr>
+</p:sld>
+</file>
+
+<file path=ppt/slides/slide23.xml><?xml version="1.0" encoding="utf-8"?>
+<p:sld xmlns:a="http://schemas.openxmlformats.org/drawingml/2006/main" xmlns:p="http://schemas.openxmlformats.org/presentationml/2006/main" xmlns:r="http://schemas.openxmlformats.org/officeDocument/2006/relationships">
+  <p:cSld>
+    <p:bg>
+      <p:bgPr>
+        <a:solidFill>
+          <a:srgbClr val="FFFFFF"/>
+        </a:solidFill>
+        <a:effectLst/>
+      </p:bgPr>
+    </p:bg>
+    <p:spTree>
+      <p:nvGrpSpPr>
+        <p:cNvPr id="1" name=""/>
+        <p:cNvGrpSpPr/>
+        <p:nvPr/>
+      </p:nvGrpSpPr>
+      <p:grpSpPr/>
+      <p:sp>
+        <p:nvSpPr>
+          <p:cNvPr id="2" name="TextBox 1"/>
+          <p:cNvSpPr txBox="1"/>
+          <p:nvPr/>
+        </p:nvSpPr>
+        <p:spPr>
+          <a:xfrm>
+            <a:off x="548640" y="411480"/>
+            <a:ext cx="11064240" cy="640080"/>
+          </a:xfrm>
+          <a:prstGeom prst="rect">
+            <a:avLst/>
+          </a:prstGeom>
+          <a:noFill/>
+        </p:spPr>
+        <p:txBody>
+          <a:bodyPr wrap="square" anchor="t" lIns="0" rIns="0" tIns="0" bIns="0">
+            <a:spAutoFit/>
+          </a:bodyPr>
+          <a:lstStyle/>
+          <a:p>
+            <a:pPr algn="l">
+              <a:spcAft>
+                <a:spcPts val="0"/>
+              </a:spcAft>
+            </a:pPr>
+            <a:r>
+              <a:rPr sz="2600" b="1" i="0">
+                <a:solidFill>
+                  <a:srgbClr val="0F172A"/>
+                </a:solidFill>
+                <a:latin typeface="Arial"/>
+              </a:rPr>
+              <a:t>Додаток А.4 Спростування гіпотези: зонди Мірнова і пастка ELM</a:t>
+            </a:r>
+          </a:p>
+        </p:txBody>
+      </p:sp>
+      <p:sp>
+        <p:nvSpPr>
+          <p:cNvPr id="3" name="TextBox 2"/>
+          <p:cNvSpPr txBox="1"/>
+          <p:nvPr/>
+        </p:nvSpPr>
+        <p:spPr>
+          <a:xfrm>
+            <a:off x="11247120" y="6446520"/>
+            <a:ext cx="457200" cy="274320"/>
+          </a:xfrm>
+          <a:prstGeom prst="rect">
+            <a:avLst/>
+          </a:prstGeom>
+          <a:noFill/>
+        </p:spPr>
+        <p:txBody>
+          <a:bodyPr wrap="square" anchor="t" lIns="0" rIns="0" tIns="0" bIns="0">
+            <a:spAutoFit/>
+          </a:bodyPr>
+          <a:lstStyle/>
+          <a:p>
+            <a:pPr algn="r">
+              <a:spcAft>
+                <a:spcPts val="0"/>
+              </a:spcAft>
+            </a:pPr>
+            <a:r>
+              <a:rPr sz="1000" b="0" i="0">
+                <a:solidFill>
+                  <a:srgbClr val="94A3B8"/>
+                </a:solidFill>
+                <a:latin typeface="Arial"/>
+              </a:rPr>
+              <a:t>23</a:t>
+            </a:r>
+          </a:p>
+        </p:txBody>
+      </p:sp>
+      <p:sp>
+        <p:nvSpPr>
+          <p:cNvPr id="4" name="Rectangle 3"/>
+          <p:cNvSpPr/>
+          <p:nvPr/>
+        </p:nvSpPr>
+        <p:spPr>
+          <a:xfrm>
+            <a:off x="521207" y="1252728"/>
+            <a:ext cx="7644384" cy="3774047"/>
+          </a:xfrm>
+          <a:prstGeom prst="rect">
+            <a:avLst/>
+          </a:prstGeom>
+          <a:noFill/>
+          <a:ln w="12700">
+            <a:solidFill>
+              <a:srgbClr val="E2E8F0"/>
+            </a:solidFill>
+          </a:ln>
+          <a:effectLst/>
+        </p:spPr>
+        <p:style>
+          <a:lnRef idx="1">
+            <a:schemeClr val="accent1"/>
+          </a:lnRef>
+          <a:fillRef idx="3">
+            <a:schemeClr val="accent1"/>
+          </a:fillRef>
+          <a:effectRef idx="2">
+            <a:schemeClr val="accent1"/>
+          </a:effectRef>
+          <a:fontRef idx="minor">
+            <a:schemeClr val="lt1"/>
+          </a:fontRef>
+        </p:style>
+        <p:txBody>
+          <a:bodyPr rtlCol="0" anchor="ctr"/>
+          <a:lstStyle/>
+          <a:p>
+            <a:pPr algn="ctr"/>
+          </a:p>
+        </p:txBody>
+      </p:sp>
+      <p:pic>
+        <p:nvPicPr>
+          <p:cNvPr id="5" name="Picture 4" descr="phys_mirnov.png"/>
+          <p:cNvPicPr>
+            <a:picLocks noChangeAspect="1"/>
+          </p:cNvPicPr>
+          <p:nvPr/>
+        </p:nvPicPr>
+        <p:blipFill>
+          <a:blip r:embed="rId3"/>
+          <a:stretch>
+            <a:fillRect/>
+          </a:stretch>
+        </p:blipFill>
+        <p:spPr>
+          <a:xfrm>
+            <a:off x="548640" y="1280160"/>
+            <a:ext cx="7589520" cy="3719183"/>
+          </a:xfrm>
+          <a:prstGeom prst="rect">
+            <a:avLst/>
+          </a:prstGeom>
+        </p:spPr>
+      </p:pic>
+      <p:sp>
+        <p:nvSpPr>
+          <p:cNvPr id="6" name="TextBox 5"/>
+          <p:cNvSpPr txBox="1"/>
+          <p:nvPr/>
+        </p:nvSpPr>
+        <p:spPr>
+          <a:xfrm>
+            <a:off x="548640" y="5045063"/>
+            <a:ext cx="7589520" cy="365760"/>
+          </a:xfrm>
+          <a:prstGeom prst="rect">
+            <a:avLst/>
+          </a:prstGeom>
+          <a:noFill/>
+        </p:spPr>
+        <p:txBody>
+          <a:bodyPr wrap="square" anchor="t" lIns="0" rIns="0" tIns="0" bIns="0">
+            <a:spAutoFit/>
+          </a:bodyPr>
+          <a:lstStyle/>
+          <a:p>
+            <a:pPr algn="l">
+              <a:spcAft>
+                <a:spcPts val="0"/>
+              </a:spcAft>
+            </a:pPr>
+            <a:r>
+              <a:rPr sz="1100" b="0" i="0">
+                <a:solidFill>
+                  <a:srgbClr val="475569"/>
+                </a:solidFill>
+                <a:latin typeface="Arial"/>
+              </a:rPr>
+              <a:t>Рисунок 13 – Розряд 27: Iₚ, сигнал котушок Мірнова (проста сума і просторовий RMS), детектор замкненої моди</a:t>
+            </a:r>
+          </a:p>
+        </p:txBody>
+      </p:sp>
+      <p:sp>
+        <p:nvSpPr>
+          <p:cNvPr id="7" name="TextBox 6"/>
+          <p:cNvSpPr txBox="1"/>
+          <p:nvPr/>
+        </p:nvSpPr>
+        <p:spPr>
+          <a:xfrm>
+            <a:off x="8503920" y="1371600"/>
+            <a:ext cx="3154680" cy="2743200"/>
+          </a:xfrm>
+          <a:prstGeom prst="rect">
+            <a:avLst/>
+          </a:prstGeom>
+          <a:noFill/>
+        </p:spPr>
+        <p:txBody>
+          <a:bodyPr wrap="square" anchor="t" lIns="0" rIns="0" tIns="0" bIns="0">
+            <a:spAutoFit/>
+          </a:bodyPr>
+          <a:lstStyle/>
+          <a:p>
+            <a:pPr algn="l">
+              <a:spcAft>
+                <a:spcPts val="800"/>
+              </a:spcAft>
+            </a:pPr>
+            <a:r>
+              <a:rPr sz="1200" b="1" i="0">
+                <a:solidFill>
+                  <a:srgbClr val="0F172A"/>
+                </a:solidFill>
+                <a:latin typeface="Arial"/>
+              </a:rPr>
+              <a:t>Сума каналів – </a:t>
+            </a:r>
+            <a:r>
+              <a:rPr sz="1200" b="0" i="0">
+                <a:solidFill>
+                  <a:srgbClr val="0F172A"/>
+                </a:solidFill>
+                <a:latin typeface="Arial"/>
+              </a:rPr>
+              <a:t>ΣBᵢ гаситься взаємно: моди компенсують одна одну</a:t>
+            </a:r>
+          </a:p>
+          <a:p>
+            <a:pPr algn="l">
+              <a:spcAft>
+                <a:spcPts val="800"/>
+              </a:spcAft>
+            </a:pPr>
+            <a:r>
+              <a:rPr sz="1200" b="1" i="0">
+                <a:solidFill>
+                  <a:srgbClr val="0F172A"/>
+                </a:solidFill>
+                <a:latin typeface="Arial"/>
+              </a:rPr>
+              <a:t>Просторовий RMS – </a:t>
+            </a:r>
+            <a:r>
+              <a:rPr sz="1200" b="0" i="0">
+                <a:solidFill>
+                  <a:srgbClr val="0F172A"/>
+                </a:solidFill>
+                <a:latin typeface="Arial"/>
+              </a:rPr>
+              <a:t>R(t) = √(⅛ ΣBᵢ²) показує наростання лише за 50–90 мс до t_Q</a:t>
+            </a:r>
+          </a:p>
+          <a:p>
+            <a:pPr algn="l">
+              <a:spcAft>
+                <a:spcPts val="800"/>
+              </a:spcAft>
+            </a:pPr>
+            <a:r>
+              <a:rPr sz="1200" b="1" i="0">
+                <a:solidFill>
+                  <a:srgbClr val="0F172A"/>
+                </a:solidFill>
+                <a:latin typeface="Arial"/>
+              </a:rPr>
+              <a:t>Пастка ELM – </a:t>
+            </a:r>
+            <a:r>
+              <a:rPr sz="1200" b="0" i="0">
+                <a:solidFill>
+                  <a:srgbClr val="0F172A"/>
+                </a:solidFill>
+                <a:latin typeface="Arial"/>
+              </a:rPr>
+              <a:t>одиночні сплески — ELM; стаціонарний поріг дає хибні тривоги</a:t>
+            </a:r>
+          </a:p>
+          <a:p>
+            <a:pPr algn="l">
+              <a:spcAft>
+                <a:spcPts val="800"/>
+              </a:spcAft>
+            </a:pPr>
+            <a:r>
+              <a:rPr sz="1200" b="1" i="0">
+                <a:solidFill>
+                  <a:srgbClr val="0F172A"/>
+                </a:solidFill>
+                <a:latin typeface="Arial"/>
+              </a:rPr>
+              <a:t>У моделі – </a:t>
+            </a:r>
+            <a:r>
+              <a:rPr sz="1200" b="0" i="0">
+                <a:solidFill>
+                  <a:srgbClr val="0F172A"/>
+                </a:solidFill>
+                <a:latin typeface="Arial"/>
+              </a:rPr>
+              <a:t>МГД — лише для передвісника (голова A); раннє попередження (голова B) — за межами f_GW, q95, βN, P_rad/P_in</a:t>
+            </a:r>
+          </a:p>
+        </p:txBody>
+      </p:sp>
+    </p:spTree>
+  </p:cSld>
+  <p:clrMapOvr>
+    <a:masterClrMapping/>
+  </p:clrMapOvr>
+</p:sld>
+</file>
+
+<file path=ppt/slides/slide24.xml><?xml version="1.0" encoding="utf-8"?>
+<p:sld xmlns:a="http://schemas.openxmlformats.org/drawingml/2006/main" xmlns:p="http://schemas.openxmlformats.org/presentationml/2006/main" xmlns:r="http://schemas.openxmlformats.org/officeDocument/2006/relationships">
+  <p:cSld>
+    <p:bg>
+      <p:bgPr>
+        <a:solidFill>
+          <a:srgbClr val="FFFFFF"/>
+        </a:solidFill>
+        <a:effectLst/>
+      </p:bgPr>
+    </p:bg>
+    <p:spTree>
+      <p:nvGrpSpPr>
+        <p:cNvPr id="1" name=""/>
+        <p:cNvGrpSpPr/>
+        <p:nvPr/>
+      </p:nvGrpSpPr>
+      <p:grpSpPr/>
+      <p:sp>
+        <p:nvSpPr>
+          <p:cNvPr id="2" name="TextBox 1"/>
+          <p:cNvSpPr txBox="1"/>
+          <p:nvPr/>
+        </p:nvSpPr>
+        <p:spPr>
+          <a:xfrm>
+            <a:off x="548640" y="411480"/>
+            <a:ext cx="11064240" cy="640080"/>
+          </a:xfrm>
+          <a:prstGeom prst="rect">
+            <a:avLst/>
+          </a:prstGeom>
+          <a:noFill/>
+        </p:spPr>
+        <p:txBody>
+          <a:bodyPr wrap="square" anchor="t" lIns="0" rIns="0" tIns="0" bIns="0">
+            <a:spAutoFit/>
+          </a:bodyPr>
+          <a:lstStyle/>
+          <a:p>
+            <a:pPr algn="l">
+              <a:spcAft>
+                <a:spcPts val="0"/>
+              </a:spcAft>
+            </a:pPr>
+            <a:r>
+              <a:rPr sz="2600" b="1" i="0">
+                <a:solidFill>
+                  <a:srgbClr val="0F172A"/>
+                </a:solidFill>
+                <a:latin typeface="Arial"/>
+              </a:rPr>
+              <a:t>Додаток А.5 Фізичний аналіз: що відкинуто і що впроваджено</a:t>
+            </a:r>
+          </a:p>
+        </p:txBody>
+      </p:sp>
+      <p:sp>
+        <p:nvSpPr>
+          <p:cNvPr id="3" name="TextBox 2"/>
+          <p:cNvSpPr txBox="1"/>
+          <p:nvPr/>
+        </p:nvSpPr>
+        <p:spPr>
+          <a:xfrm>
+            <a:off x="11247120" y="6446520"/>
+            <a:ext cx="457200" cy="274320"/>
+          </a:xfrm>
+          <a:prstGeom prst="rect">
+            <a:avLst/>
+          </a:prstGeom>
+          <a:noFill/>
+        </p:spPr>
+        <p:txBody>
+          <a:bodyPr wrap="square" anchor="t" lIns="0" rIns="0" tIns="0" bIns="0">
+            <a:spAutoFit/>
+          </a:bodyPr>
+          <a:lstStyle/>
+          <a:p>
+            <a:pPr algn="r">
+              <a:spcAft>
+                <a:spcPts val="0"/>
+              </a:spcAft>
+            </a:pPr>
+            <a:r>
+              <a:rPr sz="1000" b="0" i="0">
+                <a:solidFill>
+                  <a:srgbClr val="94A3B8"/>
+                </a:solidFill>
+                <a:latin typeface="Arial"/>
+              </a:rPr>
+              <a:t>24</a:t>
+            </a:r>
+          </a:p>
+        </p:txBody>
+      </p:sp>
+      <p:sp>
+        <p:nvSpPr>
+          <p:cNvPr id="4" name="TextBox 3"/>
+          <p:cNvSpPr txBox="1"/>
+          <p:nvPr/>
+        </p:nvSpPr>
+        <p:spPr>
+          <a:xfrm>
+            <a:off x="548640" y="1234440"/>
+            <a:ext cx="11064240" cy="320040"/>
+          </a:xfrm>
+          <a:prstGeom prst="rect">
+            <a:avLst/>
+          </a:prstGeom>
+          <a:noFill/>
+        </p:spPr>
+        <p:txBody>
+          <a:bodyPr wrap="square" anchor="t" lIns="0" rIns="0" tIns="0" bIns="0">
+            <a:spAutoFit/>
+          </a:bodyPr>
+          <a:lstStyle/>
+          <a:p>
+            <a:pPr algn="l">
+              <a:spcAft>
+                <a:spcPts val="0"/>
+              </a:spcAft>
+            </a:pPr>
+            <a:r>
+              <a:rPr sz="1100" b="0" i="0">
+                <a:solidFill>
+                  <a:srgbClr val="475569"/>
+                </a:solidFill>
+                <a:latin typeface="Arial"/>
+              </a:rPr>
+              <a:t>Таблиця 9 – Невдалі евристики і впроваджені рішення</a:t>
+            </a:r>
+          </a:p>
+        </p:txBody>
+      </p:sp>
+      <p:graphicFrame>
+        <p:nvGraphicFramePr>
+          <p:cNvPr id="5" name="Table 4"/>
+          <p:cNvGraphicFramePr>
+            <a:graphicFrameLocks noGrp="1"/>
+          </p:cNvGraphicFramePr>
+          <p:nvPr/>
+        </p:nvGraphicFramePr>
+        <p:xfrm>
+          <a:off x="548640" y="1600200"/>
+          <a:ext cx="11064240" cy="4389120"/>
+        </p:xfrm>
+        <a:graphic>
+          <a:graphicData uri="http://schemas.openxmlformats.org/drawingml/2006/table">
+            <a:tbl>
+              <a:tblPr firstRow="0" bandRow="0">
+                <a:tableStyleId>{5C22544A-7EE6-4342-B048-85BDC9FD1C3A}</a:tableStyleId>
+              </a:tblPr>
+              <a:tblGrid>
+                <a:gridCol w="2103120"/>
+                <a:gridCol w="4480560"/>
+                <a:gridCol w="4480560"/>
+              </a:tblGrid>
+              <a:tr h="731520">
+                <a:tc>
+                  <a:txBody>
+                    <a:bodyPr wrap="square"/>
+                    <a:lstStyle/>
+                    <a:p>
+                      <a:pPr algn="l"/>
+                      <a:r>
+                        <a:rPr sz="1200" b="1">
+                          <a:solidFill>
+                            <a:srgbClr val="475569"/>
+                          </a:solidFill>
+                          <a:latin typeface="Arial"/>
+                        </a:rPr>
+                        <a:t>категорія</a:t>
+                      </a:r>
+                    </a:p>
+                  </a:txBody>
+                  <a:tcPr marL="91440" marR="91440" marT="27432" marB="27432" anchor="ctr">
+                    <a:solidFill>
+                      <a:srgbClr val="F1F5F9"/>
+                    </a:solidFill>
+                  </a:tcPr>
+                </a:tc>
+                <a:tc>
+                  <a:txBody>
+                    <a:bodyPr wrap="square"/>
+                    <a:lstStyle/>
+                    <a:p>
+                      <a:pPr algn="ctr"/>
+                      <a:r>
+                        <a:rPr sz="1200" b="1">
+                          <a:solidFill>
+                            <a:srgbClr val="475569"/>
+                          </a:solidFill>
+                          <a:latin typeface="Arial"/>
+                        </a:rPr>
+                        <a:t>що відкинуто</a:t>
+                      </a:r>
+                    </a:p>
+                  </a:txBody>
+                  <a:tcPr marL="91440" marR="91440" marT="27432" marB="27432" anchor="ctr">
+                    <a:solidFill>
+                      <a:srgbClr val="F1F5F9"/>
+                    </a:solidFill>
+                  </a:tcPr>
+                </a:tc>
+                <a:tc>
+                  <a:txBody>
+                    <a:bodyPr wrap="square"/>
+                    <a:lstStyle/>
+                    <a:p>
+                      <a:pPr algn="ctr"/>
+                      <a:r>
+                        <a:rPr sz="1200" b="1">
+                          <a:solidFill>
+                            <a:srgbClr val="475569"/>
+                          </a:solidFill>
+                          <a:latin typeface="Arial"/>
+                        </a:rPr>
+                        <a:t>що впроваджено</a:t>
+                      </a:r>
+                    </a:p>
+                  </a:txBody>
+                  <a:tcPr marL="91440" marR="91440" marT="27432" marB="27432" anchor="ctr">
+                    <a:solidFill>
+                      <a:srgbClr val="F1F5F9"/>
+                    </a:solidFill>
+                  </a:tcPr>
+                </a:tc>
+              </a:tr>
+              <a:tr h="731520">
+                <a:tc>
+                  <a:txBody>
+                    <a:bodyPr wrap="square"/>
+                    <a:lstStyle/>
+                    <a:p>
+                      <a:pPr algn="l"/>
+                      <a:r>
+                        <a:rPr sz="1200" b="1">
+                          <a:solidFill>
+                            <a:srgbClr val="0F172A"/>
+                          </a:solidFill>
+                          <a:latin typeface="Arial"/>
+                        </a:rPr>
+                        <a:t>магнітні похідні</a:t>
+                      </a:r>
+                    </a:p>
+                  </a:txBody>
+                  <a:tcPr marL="91440" marR="91440" marT="27432" marB="27432" anchor="ctr">
+                    <a:solidFill>
+                      <a:srgbClr val="FFFFFF"/>
+                    </a:solidFill>
+                  </a:tcPr>
+                </a:tc>
+                <a:tc>
+                  <a:txBody>
+                    <a:bodyPr wrap="square"/>
+                    <a:lstStyle/>
+                    <a:p>
+                      <a:pPr algn="ctr"/>
+                      <a:r>
+                        <a:rPr sz="1200" b="0">
+                          <a:solidFill>
+                            <a:srgbClr val="0F172A"/>
+                          </a:solidFill>
+                          <a:latin typeface="Arial"/>
+                        </a:rPr>
+                        <a:t>поріг за dIₚ/dt або dB_p/dt: запізнюється, виникає лише на гасінні струму</a:t>
+                      </a:r>
+                    </a:p>
+                  </a:txBody>
+                  <a:tcPr marL="91440" marR="91440" marT="27432" marB="27432" anchor="ctr">
+                    <a:solidFill>
+                      <a:srgbClr val="FFFFFF"/>
+                    </a:solidFill>
+                  </a:tcPr>
+                </a:tc>
+                <a:tc>
+                  <a:txBody>
+                    <a:bodyPr wrap="square"/>
+                    <a:lstStyle/>
+                    <a:p>
+                      <a:pPr algn="ctr"/>
+                      <a:r>
+                        <a:rPr sz="1200" b="0">
+                          <a:solidFill>
+                            <a:srgbClr val="0F172A"/>
+                          </a:solidFill>
+                          <a:latin typeface="Arial"/>
+                        </a:rPr>
+                        <a:t>контроль запізнення; відмова від dIₚ/dt як тригера попередження</a:t>
+                      </a:r>
+                    </a:p>
+                  </a:txBody>
+                  <a:tcPr marL="91440" marR="91440" marT="27432" marB="27432" anchor="ctr">
+                    <a:solidFill>
+                      <a:srgbClr val="FFFFFF"/>
+                    </a:solidFill>
+                  </a:tcPr>
+                </a:tc>
+              </a:tr>
+              <a:tr h="731520">
+                <a:tc>
+                  <a:txBody>
+                    <a:bodyPr wrap="square"/>
+                    <a:lstStyle/>
+                    <a:p>
+                      <a:pPr algn="l"/>
+                      <a:r>
+                        <a:rPr sz="1200" b="1">
+                          <a:solidFill>
+                            <a:srgbClr val="0F172A"/>
+                          </a:solidFill>
+                          <a:latin typeface="Arial"/>
+                        </a:rPr>
+                        <a:t>котушки Мірнова</a:t>
+                      </a:r>
+                    </a:p>
+                  </a:txBody>
+                  <a:tcPr marL="91440" marR="91440" marT="27432" marB="27432" anchor="ctr">
+                    <a:solidFill>
+                      <a:srgbClr val="FFFFFF"/>
+                    </a:solidFill>
+                  </a:tcPr>
+                </a:tc>
+                <a:tc>
+                  <a:txBody>
+                    <a:bodyPr wrap="square"/>
+                    <a:lstStyle/>
+                    <a:p>
+                      <a:pPr algn="ctr"/>
+                      <a:r>
+                        <a:rPr sz="1200" b="0">
+                          <a:solidFill>
+                            <a:srgbClr val="0F172A"/>
+                          </a:solidFill>
+                          <a:latin typeface="Arial"/>
+                        </a:rPr>
+                        <a:t>скалярна сума каналів ΣBᵢ: взаємне гасіння мод</a:t>
+                      </a:r>
+                    </a:p>
+                  </a:txBody>
+                  <a:tcPr marL="91440" marR="91440" marT="27432" marB="27432" anchor="ctr">
+                    <a:solidFill>
+                      <a:srgbClr val="FFFFFF"/>
+                    </a:solidFill>
+                  </a:tcPr>
+                </a:tc>
+                <a:tc>
+                  <a:txBody>
+                    <a:bodyPr wrap="square"/>
+                    <a:lstStyle/>
+                    <a:p>
+                      <a:pPr algn="ctr"/>
+                      <a:r>
+                        <a:rPr sz="1200" b="0">
+                          <a:solidFill>
+                            <a:srgbClr val="0F172A"/>
+                          </a:solidFill>
+                          <a:latin typeface="Arial"/>
+                        </a:rPr>
+                        <a:t>просторовий RMS √(⅛ ΣBᵢ²), фур'є-моди, крос-кореляція</a:t>
+                      </a:r>
+                    </a:p>
+                  </a:txBody>
+                  <a:tcPr marL="91440" marR="91440" marT="27432" marB="27432" anchor="ctr">
+                    <a:solidFill>
+                      <a:srgbClr val="FFFFFF"/>
+                    </a:solidFill>
+                  </a:tcPr>
+                </a:tc>
+              </a:tr>
+              <a:tr h="731520">
+                <a:tc>
+                  <a:txBody>
+                    <a:bodyPr wrap="square"/>
+                    <a:lstStyle/>
+                    <a:p>
+                      <a:pPr algn="l"/>
+                      <a:r>
+                        <a:rPr sz="1200" b="1">
+                          <a:solidFill>
+                            <a:srgbClr val="0F172A"/>
+                          </a:solidFill>
+                          <a:latin typeface="Arial"/>
+                        </a:rPr>
+                        <a:t>горизонт прогнозу</a:t>
+                      </a:r>
+                    </a:p>
+                  </a:txBody>
+                  <a:tcPr marL="91440" marR="91440" marT="27432" marB="27432" anchor="ctr">
+                    <a:solidFill>
+                      <a:srgbClr val="FFFFFF"/>
+                    </a:solidFill>
+                  </a:tcPr>
+                </a:tc>
+                <a:tc>
+                  <a:txBody>
+                    <a:bodyPr wrap="square"/>
+                    <a:lstStyle/>
+                    <a:p>
+                      <a:pPr algn="ctr"/>
+                      <a:r>
+                        <a:rPr sz="1200" b="0">
+                          <a:solidFill>
+                            <a:srgbClr val="0F172A"/>
+                          </a:solidFill>
+                          <a:latin typeface="Arial"/>
+                        </a:rPr>
+                        <a:t>300 мс лише з МГД-каналів: вони ростуть лише за 50–90 мс</a:t>
+                      </a:r>
+                    </a:p>
+                  </a:txBody>
+                  <a:tcPr marL="91440" marR="91440" marT="27432" marB="27432" anchor="ctr">
+                    <a:solidFill>
+                      <a:srgbClr val="FFFFFF"/>
+                    </a:solidFill>
+                  </a:tcPr>
+                </a:tc>
+                <a:tc>
+                  <a:txBody>
+                    <a:bodyPr wrap="square"/>
+                    <a:lstStyle/>
+                    <a:p>
+                      <a:pPr algn="ctr"/>
+                      <a:r>
+                        <a:rPr sz="1200" b="0">
+                          <a:solidFill>
+                            <a:srgbClr val="0F172A"/>
+                          </a:solidFill>
+                          <a:latin typeface="Arial"/>
+                        </a:rPr>
+                        <a:t>балансні параметри для раннього вікна 300–1000 мс: f_GW, q95, βN, болометрія P_rad/P_in</a:t>
+                      </a:r>
+                    </a:p>
+                  </a:txBody>
+                  <a:tcPr marL="91440" marR="91440" marT="27432" marB="27432" anchor="ctr">
+                    <a:solidFill>
+                      <a:srgbClr val="FFFFFF"/>
+                    </a:solidFill>
+                  </a:tcPr>
+                </a:tc>
+              </a:tr>
+              <a:tr h="731520">
+                <a:tc>
+                  <a:txBody>
+                    <a:bodyPr wrap="square"/>
+                    <a:lstStyle/>
+                    <a:p>
+                      <a:pPr algn="l"/>
+                      <a:r>
+                        <a:rPr sz="1200" b="1">
+                          <a:solidFill>
+                            <a:srgbClr val="0F172A"/>
+                          </a:solidFill>
+                          <a:latin typeface="Arial"/>
+                        </a:rPr>
+                        <a:t>обробка сигналів</a:t>
+                      </a:r>
+                    </a:p>
+                  </a:txBody>
+                  <a:tcPr marL="91440" marR="91440" marT="27432" marB="27432" anchor="ctr">
+                    <a:solidFill>
+                      <a:srgbClr val="FFFFFF"/>
+                    </a:solidFill>
+                  </a:tcPr>
+                </a:tc>
+                <a:tc>
+                  <a:txBody>
+                    <a:bodyPr wrap="square"/>
+                    <a:lstStyle/>
+                    <a:p>
+                      <a:pPr algn="ctr"/>
+                      <a:r>
+                        <a:rPr sz="1200" b="0">
+                          <a:solidFill>
+                            <a:srgbClr val="0F172A"/>
+                          </a:solidFill>
+                          <a:latin typeface="Arial"/>
+                        </a:rPr>
+                        <a:t>непричинні фільтри і стаціонарні амплітудні пороги: хибні тривоги через ELM</a:t>
+                      </a:r>
+                    </a:p>
+                  </a:txBody>
+                  <a:tcPr marL="91440" marR="91440" marT="27432" marB="27432" anchor="ctr">
+                    <a:solidFill>
+                      <a:srgbClr val="FFFFFF"/>
+                    </a:solidFill>
+                  </a:tcPr>
+                </a:tc>
+                <a:tc>
+                  <a:txBody>
+                    <a:bodyPr wrap="square"/>
+                    <a:lstStyle/>
+                    <a:p>
+                      <a:pPr algn="ctr"/>
+                      <a:r>
+                        <a:rPr sz="1200" b="0">
+                          <a:solidFill>
+                            <a:srgbClr val="0F172A"/>
+                          </a:solidFill>
+                          <a:latin typeface="Arial"/>
+                        </a:rPr>
+                        <a:t>суворо причинні ковзні вікна, тренди похідних, аналіз стійких сплесків</a:t>
+                      </a:r>
+                    </a:p>
+                  </a:txBody>
+                  <a:tcPr marL="91440" marR="91440" marT="27432" marB="27432" anchor="ctr">
+                    <a:solidFill>
+                      <a:srgbClr val="FFFFFF"/>
+                    </a:solidFill>
+                  </a:tcPr>
+                </a:tc>
+              </a:tr>
+              <a:tr h="731520">
+                <a:tc>
+                  <a:txBody>
+                    <a:bodyPr wrap="square"/>
+                    <a:lstStyle/>
+                    <a:p>
+                      <a:pPr algn="l"/>
+                      <a:r>
+                        <a:rPr sz="1200" b="1">
+                          <a:solidFill>
+                            <a:srgbClr val="0F172A"/>
+                          </a:solidFill>
+                          <a:latin typeface="Arial"/>
+                        </a:rPr>
+                        <a:t>валідація</a:t>
+                      </a:r>
+                    </a:p>
+                  </a:txBody>
+                  <a:tcPr marL="91440" marR="91440" marT="27432" marB="27432" anchor="ctr">
+                    <a:solidFill>
+                      <a:srgbClr val="FFFFFF"/>
+                    </a:solidFill>
+                  </a:tcPr>
+                </a:tc>
+                <a:tc>
+                  <a:txBody>
+                    <a:bodyPr wrap="square"/>
+                    <a:lstStyle/>
+                    <a:p>
+                      <a:pPr algn="ctr"/>
+                      <a:r>
+                        <a:rPr sz="1200" b="0">
+                          <a:solidFill>
+                            <a:srgbClr val="0F172A"/>
+                          </a:solidFill>
+                          <a:latin typeface="Arial"/>
+                        </a:rPr>
+                        <a:t>випадкове розбиття рядків: витік даних між сусідніми кадрами</a:t>
+                      </a:r>
+                    </a:p>
+                  </a:txBody>
+                  <a:tcPr marL="91440" marR="91440" marT="27432" marB="27432" anchor="ctr">
+                    <a:solidFill>
+                      <a:srgbClr val="FFFFFF"/>
+                    </a:solidFill>
+                  </a:tcPr>
+                </a:tc>
+                <a:tc>
+                  <a:txBody>
+                    <a:bodyPr wrap="square"/>
+                    <a:lstStyle/>
+                    <a:p>
+                      <a:pPr algn="ctr"/>
+                      <a:r>
+                        <a:rPr sz="1200" b="0">
+                          <a:solidFill>
+                            <a:srgbClr val="0F172A"/>
+                          </a:solidFill>
+                          <a:latin typeface="Arial"/>
+                        </a:rPr>
+                        <a:t>розбиття строго за розрядами (GroupKFold за shot_id), контроль lead time і хибних тривог</a:t>
+                      </a:r>
+                    </a:p>
+                  </a:txBody>
+                  <a:tcPr marL="91440" marR="91440" marT="27432" marB="27432" anchor="ctr">
+                    <a:solidFill>
+                      <a:srgbClr val="FFFFFF"/>
+                    </a:solidFill>
+                  </a:tcPr>
+                </a:tc>
+              </a:tr>
+            </a:tbl>
+          </a:graphicData>
+        </a:graphic>
+      </p:graphicFrame>
     </p:spTree>
   </p:cSld>
   <p:clrMapOvr>

</xml_diff>

<commit_message>
Deck: emphasise disruption prevention (title, slide 13 banner, first conclusion)
</commit_message>
<xml_diff>
--- a/docs/presentation.pptx
+++ b/docs/presentation.pptx
@@ -5687,7 +5687,7 @@
                 </a:solidFill>
                 <a:latin typeface="Arial"/>
               </a:rPr>
-              <a:t>Прогнозування та атрибуція зривів плазми в токамаці в реальному часі</a:t>
+              <a:t>Прогнозування і запобігання зривам плазми в токамаці в реальному часі</a:t>
             </a:r>
           </a:p>
         </p:txBody>
@@ -5726,7 +5726,7 @@
                 </a:solidFill>
                 <a:latin typeface="Arial"/>
               </a:rPr>
-              <a:t>Модель раннього попередження за 100 діагностиками, нейромережа ImpactNet з фізичним апріорі та замкнений контур керування в симуляторі</a:t>
+              <a:t>Система передбачає зрив, визначає його причину і сама підбирає уставки плазми так, щоб зриву не сталося: відвернуто 26 з 31 зриву</a:t>
             </a:r>
           </a:p>
         </p:txBody>
@@ -17006,7 +17006,7 @@
                 </a:solidFill>
                 <a:latin typeface="Arial"/>
               </a:rPr>
-              <a:t>13 Замкнений контур: модель запобігає зриву в реальному часі</a:t>
+              <a:t>13 Запобігання зриву: система сама підбирає уставки</a:t>
             </a:r>
           </a:p>
         </p:txBody>
@@ -17050,9 +17050,103 @@
           </a:p>
         </p:txBody>
       </p:sp>
+      <p:sp>
+        <p:nvSpPr>
+          <p:cNvPr id="4" name="Rectangle 3"/>
+          <p:cNvSpPr/>
+          <p:nvPr/>
+        </p:nvSpPr>
+        <p:spPr>
+          <a:xfrm>
+            <a:off x="548640" y="1188720"/>
+            <a:ext cx="11109960" cy="731520"/>
+          </a:xfrm>
+          <a:prstGeom prst="rect">
+            <a:avLst/>
+          </a:prstGeom>
+          <a:solidFill>
+            <a:srgbClr val="ECFDF5"/>
+          </a:solidFill>
+          <a:ln w="15875">
+            <a:solidFill>
+              <a:srgbClr val="047857"/>
+            </a:solidFill>
+          </a:ln>
+          <a:effectLst/>
+        </p:spPr>
+        <p:style>
+          <a:lnRef idx="1">
+            <a:schemeClr val="accent1"/>
+          </a:lnRef>
+          <a:fillRef idx="3">
+            <a:schemeClr val="accent1"/>
+          </a:fillRef>
+          <a:effectRef idx="2">
+            <a:schemeClr val="accent1"/>
+          </a:effectRef>
+          <a:fontRef idx="minor">
+            <a:schemeClr val="lt1"/>
+          </a:fontRef>
+        </p:style>
+        <p:txBody>
+          <a:bodyPr rtlCol="0" anchor="ctr"/>
+          <a:lstStyle/>
+          <a:p>
+            <a:pPr algn="ctr"/>
+          </a:p>
+        </p:txBody>
+      </p:sp>
+      <p:sp>
+        <p:nvSpPr>
+          <p:cNvPr id="5" name="TextBox 4"/>
+          <p:cNvSpPr txBox="1"/>
+          <p:nvPr/>
+        </p:nvSpPr>
+        <p:spPr>
+          <a:xfrm>
+            <a:off x="731520" y="1261872"/>
+            <a:ext cx="10789920" cy="594360"/>
+          </a:xfrm>
+          <a:prstGeom prst="rect">
+            <a:avLst/>
+          </a:prstGeom>
+          <a:noFill/>
+        </p:spPr>
+        <p:txBody>
+          <a:bodyPr wrap="square" anchor="ctr" lIns="0" rIns="0" tIns="0" bIns="0">
+            <a:spAutoFit/>
+          </a:bodyPr>
+          <a:lstStyle/>
+          <a:p>
+            <a:pPr algn="l">
+              <a:spcAft>
+                <a:spcPts val="0"/>
+              </a:spcAft>
+            </a:pPr>
+            <a:r>
+              <a:rPr sz="1500" b="1" i="0">
+                <a:solidFill>
+                  <a:srgbClr val="047857"/>
+                </a:solidFill>
+                <a:latin typeface="Arial"/>
+              </a:rPr>
+              <a:t>Не лише прогноз. </a:t>
+            </a:r>
+            <a:r>
+              <a:rPr sz="1500" b="0" i="0">
+                <a:solidFill>
+                  <a:srgbClr val="0F172A"/>
+                </a:solidFill>
+                <a:latin typeface="Arial"/>
+              </a:rPr>
+              <a:t>Кожні 0,25 с модель сама вирішує, що змінити — густину, неон, струм чи нагрів, — і зрив не стається: 26 з 31 відвернуто, енергія плазми без втрат.</a:t>
+            </a:r>
+          </a:p>
+        </p:txBody>
+      </p:sp>
       <p:pic>
         <p:nvPicPr>
-          <p:cNvPr id="4" name="Picture 3" descr="fixer.png"/>
+          <p:cNvPr id="6" name="Picture 5" descr="fixer.png"/>
           <p:cNvPicPr>
             <a:picLocks noChangeAspect="1"/>
           </p:cNvPicPr>
@@ -17066,7 +17160,7 @@
         </p:blipFill>
         <p:spPr>
           <a:xfrm>
-            <a:off x="548640" y="1234440"/>
+            <a:off x="548640" y="2103120"/>
             <a:ext cx="7406640" cy="3044010"/>
           </a:xfrm>
           <a:prstGeom prst="rect">
@@ -17076,13 +17170,13 @@
       </p:pic>
       <p:sp>
         <p:nvSpPr>
-          <p:cNvPr id="5" name="TextBox 4"/>
+          <p:cNvPr id="7" name="TextBox 6"/>
           <p:cNvSpPr txBox="1"/>
           <p:nvPr/>
         </p:nvSpPr>
         <p:spPr>
           <a:xfrm>
-            <a:off x="548640" y="4324170"/>
+            <a:off x="548640" y="5192850"/>
             <a:ext cx="7406640" cy="365760"/>
           </a:xfrm>
           <a:prstGeom prst="rect">
@@ -17115,13 +17209,13 @@
       </p:sp>
       <p:sp>
         <p:nvSpPr>
-          <p:cNvPr id="6" name="TextBox 5"/>
+          <p:cNvPr id="8" name="TextBox 7"/>
           <p:cNvSpPr txBox="1"/>
           <p:nvPr/>
         </p:nvSpPr>
         <p:spPr>
           <a:xfrm>
-            <a:off x="8275320" y="1280160"/>
+            <a:off x="8275320" y="2103120"/>
             <a:ext cx="3383280" cy="1188720"/>
           </a:xfrm>
           <a:prstGeom prst="rect">
@@ -17163,20 +17257,20 @@
                 </a:solidFill>
                 <a:latin typeface="Arial"/>
               </a:rPr>
-              <a:t>зривів, яким можна запобігти: без керування → учень</a:t>
-            </a:r>
-          </a:p>
-        </p:txBody>
-      </p:sp>
-      <p:sp>
-        <p:nvSpPr>
-          <p:cNvPr id="7" name="TextBox 6"/>
+              <a:t>зривів, яким можна запобігти: без керування → з моделлю</a:t>
+            </a:r>
+          </a:p>
+        </p:txBody>
+      </p:sp>
+      <p:sp>
+        <p:nvSpPr>
+          <p:cNvPr id="9" name="TextBox 8"/>
           <p:cNvSpPr txBox="1"/>
           <p:nvPr/>
         </p:nvSpPr>
         <p:spPr>
           <a:xfrm>
-            <a:off x="8275320" y="2514600"/>
+            <a:off x="8275320" y="3291840"/>
             <a:ext cx="3383280" cy="2286000"/>
           </a:xfrm>
           <a:prstGeom prst="rect">
@@ -17268,7 +17362,7 @@
       </p:sp>
       <p:sp>
         <p:nvSpPr>
-          <p:cNvPr id="8" name="TextBox 7"/>
+          <p:cNvPr id="10" name="TextBox 9"/>
           <p:cNvSpPr txBox="1"/>
           <p:nvPr/>
         </p:nvSpPr>
@@ -19373,6 +19467,31 @@
               <a:t>1. </a:t>
             </a:r>
             <a:r>
+              <a:rPr sz="1500" b="1" i="0">
+                <a:solidFill>
+                  <a:srgbClr val="0F172A"/>
+                </a:solidFill>
+                <a:latin typeface="Arial"/>
+              </a:rPr>
+              <a:t>Система в реальному часі передбачає зрив, визначає причину і сама підбирає уставки: 26 з 31 зриву відвернуто на 100 нових розрядах без втрати енергії плазми.</a:t>
+            </a:r>
+          </a:p>
+          <a:p>
+            <a:pPr algn="l">
+              <a:spcAft>
+                <a:spcPts val="1200"/>
+              </a:spcAft>
+            </a:pPr>
+            <a:r>
+              <a:rPr sz="1500" b="1" i="0">
+                <a:solidFill>
+                  <a:srgbClr val="0F172A"/>
+                </a:solidFill>
+                <a:latin typeface="Arial"/>
+              </a:rPr>
+              <a:t>2. </a:t>
+            </a:r>
+            <a:r>
               <a:rPr sz="1500" b="0" i="0">
                 <a:solidFill>
                   <a:srgbClr val="0F172A"/>
@@ -19395,7 +19514,7 @@
                 </a:solidFill>
                 <a:latin typeface="Arial"/>
               </a:rPr>
-              <a:t>2. </a:t>
+              <a:t>3. </a:t>
             </a:r>
             <a:r>
               <a:rPr sz="1500" b="0" i="0">
@@ -19410,7 +19529,7 @@
           <a:p>
             <a:pPr algn="l">
               <a:spcAft>
-                <a:spcPts val="1200"/>
+                <a:spcPts val="0"/>
               </a:spcAft>
             </a:pPr>
             <a:r>
@@ -19420,7 +19539,7 @@
                 </a:solidFill>
                 <a:latin typeface="Arial"/>
               </a:rPr>
-              <a:t>3. </a:t>
+              <a:t>4. </a:t>
             </a:r>
             <a:r>
               <a:rPr sz="1500" b="0" i="0">
@@ -19430,31 +19549,6 @@
                 <a:latin typeface="Arial"/>
               </a:rPr>
               <a:t>Поріг спрацювання не характеризує модель; коректне порівняння — за ROC AUC.</a:t>
-            </a:r>
-          </a:p>
-          <a:p>
-            <a:pPr algn="l">
-              <a:spcAft>
-                <a:spcPts val="0"/>
-              </a:spcAft>
-            </a:pPr>
-            <a:r>
-              <a:rPr sz="1500" b="1" i="0">
-                <a:solidFill>
-                  <a:srgbClr val="0F172A"/>
-                </a:solidFill>
-                <a:latin typeface="Arial"/>
-              </a:rPr>
-              <a:t>4. </a:t>
-            </a:r>
-            <a:r>
-              <a:rPr sz="1500" b="0" i="0">
-                <a:solidFill>
-                  <a:srgbClr val="0F172A"/>
-                </a:solidFill>
-                <a:latin typeface="Arial"/>
-              </a:rPr>
-              <a:t>У замкненому контурі учень, що бачить лише прилади, зменшує кількість зривів, яким можна запобігти, з 31 до 5 на 100 нових розрядах без втрати продуктивності — як ідеальний двійник.</a:t>
             </a:r>
           </a:p>
         </p:txBody>

</xml_diff>

<commit_message>
Deck: hypotheses H6-H8 (operating limits, fast magnetic triggers, prevention) and hypothesis tags on the slides that test them
</commit_message>
<xml_diff>
--- a/docs/presentation.pptx
+++ b/docs/presentation.pptx
@@ -2211,7 +2211,7 @@
           <a:lstStyle/>
           <a:p>
             <a:r>
-              <a:t>≈45 с. Перевірено п'ять гіпотез. Чотири підтверджено. Четверта спростована і дала головний висновок: навіть точна інтенсивність зриву λ — слабкий сигнал тривоги, бо зрив — пуассонівський процес; тому потрібні дві моделі: момент і механізм.</a:t>
+              <a:t>≈60 с. Перевірено вісім гіпотез, шість підтверджено. H4 спростована і дала головний висновок: навіть точна інтенсивність зриву λ — слабкий сигнал тривоги, бо зрив — пуассонівський процес; тому потрібні дві моделі: момент і механізм. H7 спростована фізичним аналізом: швидкі магнітні сигнали запізнюються, тому раннє попередження спирається на межі. H8 — головний результат: знаючи причину, система сама змінює уставки і відвертає зрив.</a:t>
             </a:r>
           </a:p>
         </p:txBody>
@@ -9522,26 +9522,24 @@
       </p:sp>
       <p:sp>
         <p:nvSpPr>
-          <p:cNvPr id="4" name="Rounded Rectangle 3"/>
+          <p:cNvPr id="4" name="Rectangle 3"/>
           <p:cNvSpPr/>
           <p:nvPr/>
         </p:nvSpPr>
         <p:spPr>
           <a:xfrm>
-            <a:off x="548640" y="1828800"/>
-            <a:ext cx="1965960" cy="2011680"/>
-          </a:xfrm>
-          <a:prstGeom prst="roundRect">
-            <a:avLst>
-              <a:gd name="adj" fmla="val 4000"/>
-            </a:avLst>
+            <a:off x="548640" y="914400"/>
+            <a:ext cx="4206240" cy="274320"/>
+          </a:xfrm>
+          <a:prstGeom prst="rect">
+            <a:avLst/>
           </a:prstGeom>
           <a:solidFill>
-            <a:srgbClr val="FFFFFF"/>
+            <a:srgbClr val="ECFDF5"/>
           </a:solidFill>
-          <a:ln w="19050">
+          <a:ln w="9525">
             <a:solidFill>
-              <a:srgbClr val="0E7490"/>
+              <a:srgbClr val="047857"/>
             </a:solidFill>
           </a:ln>
           <a:effectLst/>
@@ -9576,8 +9574,8 @@
         </p:nvSpPr>
         <p:spPr>
           <a:xfrm>
-            <a:off x="658368" y="1920240"/>
-            <a:ext cx="1746504" cy="1828800"/>
+            <a:off x="640080" y="914400"/>
+            <a:ext cx="4023360" cy="274320"/>
           </a:xfrm>
           <a:prstGeom prst="rect">
             <a:avLst/>
@@ -9590,35 +9588,19 @@
           </a:bodyPr>
           <a:lstStyle/>
           <a:p>
-            <a:pPr algn="ctr">
-              <a:spcAft>
-                <a:spcPts val="600"/>
-              </a:spcAft>
-            </a:pPr>
-            <a:r>
-              <a:rPr sz="1500" b="1" i="0">
-                <a:solidFill>
-                  <a:srgbClr val="0E7490"/>
-                </a:solidFill>
-                <a:latin typeface="Arial"/>
-              </a:rPr>
-              <a:t>100 діагностик</a:t>
-            </a:r>
-          </a:p>
-          <a:p>
-            <a:pPr algn="ctr">
+            <a:pPr algn="l">
               <a:spcAft>
                 <a:spcPts val="0"/>
               </a:spcAft>
             </a:pPr>
             <a:r>
-              <a:rPr sz="1200" b="0" i="0">
-                <a:solidFill>
-                  <a:srgbClr val="475569"/>
-                </a:solidFill>
-                <a:latin typeface="Arial"/>
-              </a:rPr>
-              <a:t>крок 5 мс</a:t>
+              <a:rPr sz="1100" b="1" i="0">
+                <a:solidFill>
+                  <a:srgbClr val="047857"/>
+                </a:solidFill>
+                <a:latin typeface="Arial"/>
+              </a:rPr>
+              <a:t>Гіпотеза H1 — підтверджено</a:t>
             </a:r>
           </a:p>
         </p:txBody>
@@ -9631,7 +9613,7 @@
         </p:nvSpPr>
         <p:spPr>
           <a:xfrm>
-            <a:off x="3035808" y="1828800"/>
+            <a:off x="548640" y="1828800"/>
             <a:ext cx="1965960" cy="2011680"/>
           </a:xfrm>
           <a:prstGeom prst="roundRect">
@@ -9644,7 +9626,7 @@
           </a:solidFill>
           <a:ln w="19050">
             <a:solidFill>
-              <a:srgbClr val="6D28D9"/>
+              <a:srgbClr val="0E7490"/>
             </a:solidFill>
           </a:ln>
           <a:effectLst/>
@@ -9679,7 +9661,7 @@
         </p:nvSpPr>
         <p:spPr>
           <a:xfrm>
-            <a:off x="3145536" y="1920240"/>
+            <a:off x="658368" y="1920240"/>
             <a:ext cx="1746504" cy="1828800"/>
           </a:xfrm>
           <a:prstGeom prst="rect">
@@ -9701,11 +9683,11 @@
             <a:r>
               <a:rPr sz="1500" b="1" i="0">
                 <a:solidFill>
-                  <a:srgbClr val="6D28D9"/>
-                </a:solidFill>
-                <a:latin typeface="Arial"/>
-              </a:rPr>
-              <a:t>Причинні ознаки</a:t>
+                  <a:srgbClr val="0E7490"/>
+                </a:solidFill>
+                <a:latin typeface="Arial"/>
+              </a:rPr>
+              <a:t>100 діагностик</a:t>
             </a:r>
           </a:p>
           <a:p>
@@ -9721,32 +9703,34 @@
                 </a:solidFill>
                 <a:latin typeface="Arial"/>
               </a:rPr>
-              <a:t>EMA 50 мс, 250 мс, 1 с;
-тренди; передвісник;
-актуатори</a:t>
-            </a:r>
-          </a:p>
-        </p:txBody>
-      </p:sp>
-      <p:sp>
-        <p:nvSpPr>
-          <p:cNvPr id="8" name="Right Arrow 7"/>
+              <a:t>крок 5 мс</a:t>
+            </a:r>
+          </a:p>
+        </p:txBody>
+      </p:sp>
+      <p:sp>
+        <p:nvSpPr>
+          <p:cNvPr id="8" name="Rounded Rectangle 7"/>
           <p:cNvSpPr/>
           <p:nvPr/>
         </p:nvSpPr>
         <p:spPr>
           <a:xfrm>
-            <a:off x="2560320" y="2697480"/>
-            <a:ext cx="365760" cy="274320"/>
-          </a:xfrm>
-          <a:prstGeom prst="rightArrow">
-            <a:avLst/>
+            <a:off x="3035808" y="1828800"/>
+            <a:ext cx="1965960" cy="2011680"/>
+          </a:xfrm>
+          <a:prstGeom prst="roundRect">
+            <a:avLst>
+              <a:gd name="adj" fmla="val 4000"/>
+            </a:avLst>
           </a:prstGeom>
           <a:solidFill>
-            <a:srgbClr val="94A3B8"/>
+            <a:srgbClr val="FFFFFF"/>
           </a:solidFill>
-          <a:ln>
-            <a:noFill/>
+          <a:ln w="19050">
+            <a:solidFill>
+              <a:srgbClr val="6D28D9"/>
+            </a:solidFill>
           </a:ln>
           <a:effectLst/>
         </p:spPr>
@@ -9774,13 +9758,70 @@
       </p:sp>
       <p:sp>
         <p:nvSpPr>
-          <p:cNvPr id="9" name="Right Arrow 8"/>
+          <p:cNvPr id="9" name="TextBox 8"/>
+          <p:cNvSpPr txBox="1"/>
+          <p:nvPr/>
+        </p:nvSpPr>
+        <p:spPr>
+          <a:xfrm>
+            <a:off x="3145536" y="1920240"/>
+            <a:ext cx="1746504" cy="1828800"/>
+          </a:xfrm>
+          <a:prstGeom prst="rect">
+            <a:avLst/>
+          </a:prstGeom>
+          <a:noFill/>
+        </p:spPr>
+        <p:txBody>
+          <a:bodyPr wrap="square" anchor="ctr" lIns="0" rIns="0" tIns="0" bIns="0">
+            <a:spAutoFit/>
+          </a:bodyPr>
+          <a:lstStyle/>
+          <a:p>
+            <a:pPr algn="ctr">
+              <a:spcAft>
+                <a:spcPts val="600"/>
+              </a:spcAft>
+            </a:pPr>
+            <a:r>
+              <a:rPr sz="1500" b="1" i="0">
+                <a:solidFill>
+                  <a:srgbClr val="6D28D9"/>
+                </a:solidFill>
+                <a:latin typeface="Arial"/>
+              </a:rPr>
+              <a:t>Причинні ознаки</a:t>
+            </a:r>
+          </a:p>
+          <a:p>
+            <a:pPr algn="ctr">
+              <a:spcAft>
+                <a:spcPts val="0"/>
+              </a:spcAft>
+            </a:pPr>
+            <a:r>
+              <a:rPr sz="1200" b="0" i="0">
+                <a:solidFill>
+                  <a:srgbClr val="475569"/>
+                </a:solidFill>
+                <a:latin typeface="Arial"/>
+              </a:rPr>
+              <a:t>EMA 50 мс, 250 мс, 1 с;
+тренди; передвісник;
+актуатори</a:t>
+            </a:r>
+          </a:p>
+        </p:txBody>
+      </p:sp>
+      <p:sp>
+        <p:nvSpPr>
+          <p:cNvPr id="10" name="Right Arrow 9"/>
           <p:cNvSpPr/>
           <p:nvPr/>
         </p:nvSpPr>
         <p:spPr>
           <a:xfrm>
-            <a:off x="5047488" y="2697480"/>
+            <a:off x="2560320" y="2697480"/>
             <a:ext cx="365760" cy="274320"/>
           </a:xfrm>
           <a:prstGeom prst="rightArrow">
@@ -9818,27 +9859,23 @@
       </p:sp>
       <p:sp>
         <p:nvSpPr>
-          <p:cNvPr id="10" name="Rounded Rectangle 9"/>
+          <p:cNvPr id="11" name="Right Arrow 10"/>
           <p:cNvSpPr/>
           <p:nvPr/>
         </p:nvSpPr>
         <p:spPr>
           <a:xfrm>
-            <a:off x="5486400" y="1325880"/>
-            <a:ext cx="2286000" cy="1417320"/>
-          </a:xfrm>
-          <a:prstGeom prst="roundRect">
-            <a:avLst>
-              <a:gd name="adj" fmla="val 4000"/>
-            </a:avLst>
+            <a:off x="5047488" y="2697480"/>
+            <a:ext cx="365760" cy="274320"/>
+          </a:xfrm>
+          <a:prstGeom prst="rightArrow">
+            <a:avLst/>
           </a:prstGeom>
           <a:solidFill>
-            <a:srgbClr val="FFFFFF"/>
+            <a:srgbClr val="94A3B8"/>
           </a:solidFill>
-          <a:ln w="19050">
-            <a:solidFill>
-              <a:srgbClr val="047857"/>
-            </a:solidFill>
+          <a:ln>
+            <a:noFill/>
           </a:ln>
           <a:effectLst/>
         </p:spPr>
@@ -9866,69 +9903,13 @@
       </p:sp>
       <p:sp>
         <p:nvSpPr>
-          <p:cNvPr id="11" name="TextBox 10"/>
-          <p:cNvSpPr txBox="1"/>
-          <p:nvPr/>
-        </p:nvSpPr>
-        <p:spPr>
-          <a:xfrm>
-            <a:off x="5577840" y="1399032"/>
-            <a:ext cx="2103120" cy="1280160"/>
-          </a:xfrm>
-          <a:prstGeom prst="rect">
-            <a:avLst/>
-          </a:prstGeom>
-          <a:noFill/>
-        </p:spPr>
-        <p:txBody>
-          <a:bodyPr wrap="square" anchor="ctr" lIns="0" rIns="0" tIns="0" bIns="0">
-            <a:spAutoFit/>
-          </a:bodyPr>
-          <a:lstStyle/>
-          <a:p>
-            <a:pPr algn="ctr">
-              <a:spcAft>
-                <a:spcPts val="400"/>
-              </a:spcAft>
-            </a:pPr>
-            <a:r>
-              <a:rPr sz="1500" b="1" i="0">
-                <a:solidFill>
-                  <a:srgbClr val="047857"/>
-                </a:solidFill>
-                <a:latin typeface="Arial"/>
-              </a:rPr>
-              <a:t>Голова A (HGB)</a:t>
-            </a:r>
-          </a:p>
-          <a:p>
-            <a:pPr algn="ctr">
-              <a:spcAft>
-                <a:spcPts val="0"/>
-              </a:spcAft>
-            </a:pPr>
-            <a:r>
-              <a:rPr sz="1200" b="0" i="0">
-                <a:solidFill>
-                  <a:srgbClr val="475569"/>
-                </a:solidFill>
-                <a:latin typeface="Arial"/>
-              </a:rPr>
-              <a:t>P(гасіння ≤ 0,1 с)
-передвісник</a:t>
-            </a:r>
-          </a:p>
-        </p:txBody>
-      </p:sp>
-      <p:sp>
-        <p:nvSpPr>
           <p:cNvPr id="12" name="Rounded Rectangle 11"/>
           <p:cNvSpPr/>
           <p:nvPr/>
         </p:nvSpPr>
         <p:spPr>
           <a:xfrm>
-            <a:off x="5486400" y="3154680"/>
+            <a:off x="5486400" y="1325880"/>
             <a:ext cx="2286000" cy="1417320"/>
           </a:xfrm>
           <a:prstGeom prst="roundRect">
@@ -9976,7 +9957,7 @@
         </p:nvSpPr>
         <p:spPr>
           <a:xfrm>
-            <a:off x="5577840" y="3227832"/>
+            <a:off x="5577840" y="1399032"/>
             <a:ext cx="2103120" cy="1280160"/>
           </a:xfrm>
           <a:prstGeom prst="rect">
@@ -10002,7 +9983,7 @@
                 </a:solidFill>
                 <a:latin typeface="Arial"/>
               </a:rPr>
-              <a:t>Голова B (HGB)</a:t>
+              <a:t>Голова A (HGB)</a:t>
             </a:r>
           </a:p>
           <a:p>
@@ -10018,31 +9999,35 @@
                 </a:solidFill>
                 <a:latin typeface="Arial"/>
               </a:rPr>
-              <a:t>P(гасіння ≤ 4,5 с)
-раннє попередження</a:t>
-            </a:r>
-          </a:p>
-        </p:txBody>
-      </p:sp>
-      <p:sp>
-        <p:nvSpPr>
-          <p:cNvPr id="14" name="Right Arrow 13"/>
+              <a:t>P(гасіння ≤ 0,1 с)
+передвісник</a:t>
+            </a:r>
+          </a:p>
+        </p:txBody>
+      </p:sp>
+      <p:sp>
+        <p:nvSpPr>
+          <p:cNvPr id="14" name="Rounded Rectangle 13"/>
           <p:cNvSpPr/>
           <p:nvPr/>
         </p:nvSpPr>
         <p:spPr>
           <a:xfrm>
-            <a:off x="7909560" y="2697480"/>
-            <a:ext cx="365760" cy="274320"/>
-          </a:xfrm>
-          <a:prstGeom prst="rightArrow">
-            <a:avLst/>
+            <a:off x="5486400" y="3154680"/>
+            <a:ext cx="2286000" cy="1417320"/>
+          </a:xfrm>
+          <a:prstGeom prst="roundRect">
+            <a:avLst>
+              <a:gd name="adj" fmla="val 4000"/>
+            </a:avLst>
           </a:prstGeom>
           <a:solidFill>
-            <a:srgbClr val="94A3B8"/>
+            <a:srgbClr val="FFFFFF"/>
           </a:solidFill>
-          <a:ln>
-            <a:noFill/>
+          <a:ln w="19050">
+            <a:solidFill>
+              <a:srgbClr val="047857"/>
+            </a:solidFill>
           </a:ln>
           <a:effectLst/>
         </p:spPr>
@@ -10070,27 +10055,79 @@
       </p:sp>
       <p:sp>
         <p:nvSpPr>
-          <p:cNvPr id="15" name="Rounded Rectangle 14"/>
+          <p:cNvPr id="15" name="TextBox 14"/>
+          <p:cNvSpPr txBox="1"/>
+          <p:nvPr/>
+        </p:nvSpPr>
+        <p:spPr>
+          <a:xfrm>
+            <a:off x="5577840" y="3227832"/>
+            <a:ext cx="2103120" cy="1280160"/>
+          </a:xfrm>
+          <a:prstGeom prst="rect">
+            <a:avLst/>
+          </a:prstGeom>
+          <a:noFill/>
+        </p:spPr>
+        <p:txBody>
+          <a:bodyPr wrap="square" anchor="ctr" lIns="0" rIns="0" tIns="0" bIns="0">
+            <a:spAutoFit/>
+          </a:bodyPr>
+          <a:lstStyle/>
+          <a:p>
+            <a:pPr algn="ctr">
+              <a:spcAft>
+                <a:spcPts val="400"/>
+              </a:spcAft>
+            </a:pPr>
+            <a:r>
+              <a:rPr sz="1500" b="1" i="0">
+                <a:solidFill>
+                  <a:srgbClr val="047857"/>
+                </a:solidFill>
+                <a:latin typeface="Arial"/>
+              </a:rPr>
+              <a:t>Голова B (HGB)</a:t>
+            </a:r>
+          </a:p>
+          <a:p>
+            <a:pPr algn="ctr">
+              <a:spcAft>
+                <a:spcPts val="0"/>
+              </a:spcAft>
+            </a:pPr>
+            <a:r>
+              <a:rPr sz="1200" b="0" i="0">
+                <a:solidFill>
+                  <a:srgbClr val="475569"/>
+                </a:solidFill>
+                <a:latin typeface="Arial"/>
+              </a:rPr>
+              <a:t>P(гасіння ≤ 4,5 с)
+раннє попередження</a:t>
+            </a:r>
+          </a:p>
+        </p:txBody>
+      </p:sp>
+      <p:sp>
+        <p:nvSpPr>
+          <p:cNvPr id="16" name="Right Arrow 15"/>
           <p:cNvSpPr/>
           <p:nvPr/>
         </p:nvSpPr>
         <p:spPr>
           <a:xfrm>
-            <a:off x="8412480" y="1828800"/>
-            <a:ext cx="3246120" cy="2011680"/>
-          </a:xfrm>
-          <a:prstGeom prst="roundRect">
-            <a:avLst>
-              <a:gd name="adj" fmla="val 4000"/>
-            </a:avLst>
+            <a:off x="7909560" y="2697480"/>
+            <a:ext cx="365760" cy="274320"/>
+          </a:xfrm>
+          <a:prstGeom prst="rightArrow">
+            <a:avLst/>
           </a:prstGeom>
           <a:solidFill>
-            <a:srgbClr val="FFFFFF"/>
+            <a:srgbClr val="94A3B8"/>
           </a:solidFill>
-          <a:ln w="19050">
-            <a:solidFill>
-              <a:srgbClr val="C2410C"/>
-            </a:solidFill>
+          <a:ln>
+            <a:noFill/>
           </a:ln>
           <a:effectLst/>
         </p:spPr>
@@ -10118,7 +10155,55 @@
       </p:sp>
       <p:sp>
         <p:nvSpPr>
-          <p:cNvPr id="16" name="TextBox 15"/>
+          <p:cNvPr id="17" name="Rounded Rectangle 16"/>
+          <p:cNvSpPr/>
+          <p:nvPr/>
+        </p:nvSpPr>
+        <p:spPr>
+          <a:xfrm>
+            <a:off x="8412480" y="1828800"/>
+            <a:ext cx="3246120" cy="2011680"/>
+          </a:xfrm>
+          <a:prstGeom prst="roundRect">
+            <a:avLst>
+              <a:gd name="adj" fmla="val 4000"/>
+            </a:avLst>
+          </a:prstGeom>
+          <a:solidFill>
+            <a:srgbClr val="FFFFFF"/>
+          </a:solidFill>
+          <a:ln w="19050">
+            <a:solidFill>
+              <a:srgbClr val="C2410C"/>
+            </a:solidFill>
+          </a:ln>
+          <a:effectLst/>
+        </p:spPr>
+        <p:style>
+          <a:lnRef idx="1">
+            <a:schemeClr val="accent1"/>
+          </a:lnRef>
+          <a:fillRef idx="3">
+            <a:schemeClr val="accent1"/>
+          </a:fillRef>
+          <a:effectRef idx="2">
+            <a:schemeClr val="accent1"/>
+          </a:effectRef>
+          <a:fontRef idx="minor">
+            <a:schemeClr val="lt1"/>
+          </a:fontRef>
+        </p:style>
+        <p:txBody>
+          <a:bodyPr rtlCol="0" anchor="ctr"/>
+          <a:lstStyle/>
+          <a:p>
+            <a:pPr algn="ctr"/>
+          </a:p>
+        </p:txBody>
+      </p:sp>
+      <p:sp>
+        <p:nvSpPr>
+          <p:cNvPr id="18" name="TextBox 17"/>
           <p:cNvSpPr txBox="1"/>
           <p:nvPr/>
         </p:nvSpPr>
@@ -10174,7 +10259,7 @@
       </p:sp>
       <p:sp>
         <p:nvSpPr>
-          <p:cNvPr id="17" name="TextBox 16"/>
+          <p:cNvPr id="19" name="TextBox 18"/>
           <p:cNvSpPr txBox="1"/>
           <p:nvPr/>
         </p:nvSpPr>
@@ -10213,7 +10298,7 @@
       </p:sp>
       <p:sp>
         <p:nvSpPr>
-          <p:cNvPr id="18" name="TextBox 17"/>
+          <p:cNvPr id="20" name="TextBox 19"/>
           <p:cNvSpPr txBox="1"/>
           <p:nvPr/>
         </p:nvSpPr>
@@ -10365,7 +10450,92 @@
       </p:sp>
       <p:sp>
         <p:nvSpPr>
-          <p:cNvPr id="4" name="TextBox 3"/>
+          <p:cNvPr id="4" name="Rectangle 3"/>
+          <p:cNvSpPr/>
+          <p:nvPr/>
+        </p:nvSpPr>
+        <p:spPr>
+          <a:xfrm>
+            <a:off x="548640" y="914400"/>
+            <a:ext cx="4206240" cy="274320"/>
+          </a:xfrm>
+          <a:prstGeom prst="rect">
+            <a:avLst/>
+          </a:prstGeom>
+          <a:solidFill>
+            <a:srgbClr val="ECFDF5"/>
+          </a:solidFill>
+          <a:ln w="9525">
+            <a:solidFill>
+              <a:srgbClr val="047857"/>
+            </a:solidFill>
+          </a:ln>
+          <a:effectLst/>
+        </p:spPr>
+        <p:style>
+          <a:lnRef idx="1">
+            <a:schemeClr val="accent1"/>
+          </a:lnRef>
+          <a:fillRef idx="3">
+            <a:schemeClr val="accent1"/>
+          </a:fillRef>
+          <a:effectRef idx="2">
+            <a:schemeClr val="accent1"/>
+          </a:effectRef>
+          <a:fontRef idx="minor">
+            <a:schemeClr val="lt1"/>
+          </a:fontRef>
+        </p:style>
+        <p:txBody>
+          <a:bodyPr rtlCol="0" anchor="ctr"/>
+          <a:lstStyle/>
+          <a:p>
+            <a:pPr algn="ctr"/>
+          </a:p>
+        </p:txBody>
+      </p:sp>
+      <p:sp>
+        <p:nvSpPr>
+          <p:cNvPr id="5" name="TextBox 4"/>
+          <p:cNvSpPr txBox="1"/>
+          <p:nvPr/>
+        </p:nvSpPr>
+        <p:spPr>
+          <a:xfrm>
+            <a:off x="640080" y="914400"/>
+            <a:ext cx="4023360" cy="274320"/>
+          </a:xfrm>
+          <a:prstGeom prst="rect">
+            <a:avLst/>
+          </a:prstGeom>
+          <a:noFill/>
+        </p:spPr>
+        <p:txBody>
+          <a:bodyPr wrap="square" anchor="ctr" lIns="0" rIns="0" tIns="0" bIns="0">
+            <a:spAutoFit/>
+          </a:bodyPr>
+          <a:lstStyle/>
+          <a:p>
+            <a:pPr algn="l">
+              <a:spcAft>
+                <a:spcPts val="0"/>
+              </a:spcAft>
+            </a:pPr>
+            <a:r>
+              <a:rPr sz="1100" b="1" i="0">
+                <a:solidFill>
+                  <a:srgbClr val="047857"/>
+                </a:solidFill>
+                <a:latin typeface="Arial"/>
+              </a:rPr>
+              <a:t>Гіпотези H2 і H3 — підтверджено</a:t>
+            </a:r>
+          </a:p>
+        </p:txBody>
+      </p:sp>
+      <p:sp>
+        <p:nvSpPr>
+          <p:cNvPr id="6" name="TextBox 5"/>
           <p:cNvSpPr txBox="1"/>
           <p:nvPr/>
         </p:nvSpPr>
@@ -10404,7 +10574,7 @@
       </p:sp>
       <p:graphicFrame>
         <p:nvGraphicFramePr>
-          <p:cNvPr id="5" name="Table 4"/>
+          <p:cNvPr id="7" name="Table 6"/>
           <p:cNvGraphicFramePr>
             <a:graphicFrameLocks noGrp="1"/>
           </p:cNvGraphicFramePr>
@@ -10928,7 +11098,7 @@
       </p:graphicFrame>
       <p:sp>
         <p:nvSpPr>
-          <p:cNvPr id="6" name="TextBox 5"/>
+          <p:cNvPr id="8" name="TextBox 7"/>
           <p:cNvSpPr txBox="1"/>
           <p:nvPr/>
         </p:nvSpPr>
@@ -12346,16 +12516,18 @@
         </p:nvSpPr>
         <p:spPr>
           <a:xfrm>
-            <a:off x="521207" y="1252728"/>
-            <a:ext cx="7735824" cy="3966794"/>
+            <a:off x="548640" y="914400"/>
+            <a:ext cx="4206240" cy="274320"/>
           </a:xfrm>
           <a:prstGeom prst="rect">
             <a:avLst/>
           </a:prstGeom>
-          <a:noFill/>
-          <a:ln w="12700">
+          <a:solidFill>
+            <a:srgbClr val="ECFDF5"/>
+          </a:solidFill>
+          <a:ln w="9525">
             <a:solidFill>
-              <a:srgbClr val="E2E8F0"/>
+              <a:srgbClr val="047857"/>
             </a:solidFill>
           </a:ln>
           <a:effectLst/>
@@ -12382,48 +12554,24 @@
           </a:p>
         </p:txBody>
       </p:sp>
-      <p:pic>
-        <p:nvPicPr>
-          <p:cNvPr id="5" name="Picture 4" descr="phys_sweep.png"/>
-          <p:cNvPicPr>
-            <a:picLocks noChangeAspect="1"/>
-          </p:cNvPicPr>
-          <p:nvPr/>
-        </p:nvPicPr>
-        <p:blipFill>
-          <a:blip r:embed="rId3"/>
-          <a:stretch>
-            <a:fillRect/>
-          </a:stretch>
-        </p:blipFill>
-        <p:spPr>
-          <a:xfrm>
-            <a:off x="548640" y="1280160"/>
-            <a:ext cx="7680960" cy="3911930"/>
+      <p:sp>
+        <p:nvSpPr>
+          <p:cNvPr id="5" name="TextBox 4"/>
+          <p:cNvSpPr txBox="1"/>
+          <p:nvPr/>
+        </p:nvSpPr>
+        <p:spPr>
+          <a:xfrm>
+            <a:off x="640080" y="914400"/>
+            <a:ext cx="4023360" cy="274320"/>
           </a:xfrm>
           <a:prstGeom prst="rect">
             <a:avLst/>
           </a:prstGeom>
-        </p:spPr>
-      </p:pic>
-      <p:sp>
-        <p:nvSpPr>
-          <p:cNvPr id="6" name="TextBox 5"/>
-          <p:cNvSpPr txBox="1"/>
-          <p:nvPr/>
-        </p:nvSpPr>
-        <p:spPr>
-          <a:xfrm>
-            <a:off x="548640" y="5237810"/>
-            <a:ext cx="7680960" cy="365760"/>
-          </a:xfrm>
-          <a:prstGeom prst="rect">
-            <a:avLst/>
-          </a:prstGeom>
           <a:noFill/>
         </p:spPr>
         <p:txBody>
-          <a:bodyPr wrap="square" anchor="t" lIns="0" rIns="0" tIns="0" bIns="0">
+          <a:bodyPr wrap="square" anchor="ctr" lIns="0" rIns="0" tIns="0" bIns="0">
             <a:spAutoFit/>
           </a:bodyPr>
           <a:lstStyle/>
@@ -12434,34 +12582,32 @@
               </a:spcAft>
             </a:pPr>
             <a:r>
-              <a:rPr sz="1100" b="0" i="0">
-                <a:solidFill>
-                  <a:srgbClr val="475569"/>
-                </a:solidFill>
-                <a:latin typeface="Arial"/>
-              </a:rPr>
-              <a:t>Рисунок 17 – Сканування струму Iₚ і уставки густини (91 розряд): A — ризики r_GW і r_q від Iₚ; B — λ від Iₚ; C — f_GW і r_GW від густини; D — λ від густини</a:t>
-            </a:r>
-          </a:p>
-        </p:txBody>
-      </p:sp>
-      <p:sp>
-        <p:nvSpPr>
-          <p:cNvPr id="7" name="Rectangle 6"/>
+              <a:rPr sz="1100" b="1" i="0">
+                <a:solidFill>
+                  <a:srgbClr val="047857"/>
+                </a:solidFill>
+                <a:latin typeface="Arial"/>
+              </a:rPr>
+              <a:t>Гіпотеза H6 — підтверджено</a:t>
+            </a:r>
+          </a:p>
+        </p:txBody>
+      </p:sp>
+      <p:sp>
+        <p:nvSpPr>
+          <p:cNvPr id="6" name="Rectangle 5"/>
           <p:cNvSpPr/>
           <p:nvPr/>
         </p:nvSpPr>
         <p:spPr>
           <a:xfrm>
-            <a:off x="8595360" y="1280160"/>
-            <a:ext cx="3063240" cy="1600200"/>
+            <a:off x="521207" y="1252728"/>
+            <a:ext cx="7735824" cy="3966794"/>
           </a:xfrm>
           <a:prstGeom prst="rect">
             <a:avLst/>
           </a:prstGeom>
-          <a:solidFill>
-            <a:srgbClr val="F8FAFC"/>
-          </a:solidFill>
+          <a:noFill/>
           <a:ln w="12700">
             <a:solidFill>
               <a:srgbClr val="E2E8F0"/>
@@ -12491,6 +12637,30 @@
           </a:p>
         </p:txBody>
       </p:sp>
+      <p:pic>
+        <p:nvPicPr>
+          <p:cNvPr id="7" name="Picture 6" descr="phys_sweep.png"/>
+          <p:cNvPicPr>
+            <a:picLocks noChangeAspect="1"/>
+          </p:cNvPicPr>
+          <p:nvPr/>
+        </p:nvPicPr>
+        <p:blipFill>
+          <a:blip r:embed="rId3"/>
+          <a:stretch>
+            <a:fillRect/>
+          </a:stretch>
+        </p:blipFill>
+        <p:spPr>
+          <a:xfrm>
+            <a:off x="548640" y="1280160"/>
+            <a:ext cx="7680960" cy="3911930"/>
+          </a:xfrm>
+          <a:prstGeom prst="rect">
+            <a:avLst/>
+          </a:prstGeom>
+        </p:spPr>
+      </p:pic>
       <p:sp>
         <p:nvSpPr>
           <p:cNvPr id="8" name="TextBox 7"/>
@@ -12499,8 +12669,8 @@
         </p:nvSpPr>
         <p:spPr>
           <a:xfrm>
-            <a:off x="8732520" y="1371600"/>
-            <a:ext cx="2834640" cy="1463040"/>
+            <a:off x="548640" y="5237810"/>
+            <a:ext cx="7680960" cy="365760"/>
           </a:xfrm>
           <a:prstGeom prst="rect">
             <a:avLst/>
@@ -12515,63 +12685,77 @@
           <a:p>
             <a:pPr algn="l">
               <a:spcAft>
-                <a:spcPts val="800"/>
-              </a:spcAft>
-            </a:pPr>
-            <a:r>
-              <a:rPr sz="1300" b="1" i="0">
-                <a:solidFill>
-                  <a:srgbClr val="0F172A"/>
-                </a:solidFill>
-                <a:latin typeface="Arial"/>
-              </a:rPr>
-              <a:t>λ = 1 − Πᵢ (1 − rᵢ³)(1 − r_lm)</a:t>
-            </a:r>
-          </a:p>
-          <a:p>
-            <a:pPr algn="l">
-              <a:spcAft>
-                <a:spcPts val="800"/>
-              </a:spcAft>
-            </a:pPr>
-            <a:r>
-              <a:rPr sz="1300" b="1" i="0">
-                <a:solidFill>
-                  <a:srgbClr val="0F172A"/>
-                </a:solidFill>
-                <a:latin typeface="Arial"/>
-              </a:rPr>
-              <a:t>f_GW = n̄ₑ / n_GW</a:t>
-            </a:r>
-          </a:p>
-          <a:p>
-            <a:pPr algn="l">
-              <a:spcAft>
                 <a:spcPts val="0"/>
               </a:spcAft>
             </a:pPr>
             <a:r>
-              <a:rPr sz="1300" b="1" i="0">
-                <a:solidFill>
-                  <a:srgbClr val="0F172A"/>
-                </a:solidFill>
-                <a:latin typeface="Arial"/>
-              </a:rPr>
-              <a:t>f_GW ∝ n̄ₑ / Iₚ</a:t>
-            </a:r>
-          </a:p>
-        </p:txBody>
-      </p:sp>
-      <p:sp>
-        <p:nvSpPr>
-          <p:cNvPr id="9" name="TextBox 8"/>
+              <a:rPr sz="1100" b="0" i="0">
+                <a:solidFill>
+                  <a:srgbClr val="475569"/>
+                </a:solidFill>
+                <a:latin typeface="Arial"/>
+              </a:rPr>
+              <a:t>Рисунок 17 – Сканування струму Iₚ і уставки густини (91 розряд): A — ризики r_GW і r_q від Iₚ; B — λ від Iₚ; C — f_GW і r_GW від густини; D — λ від густини</a:t>
+            </a:r>
+          </a:p>
+        </p:txBody>
+      </p:sp>
+      <p:sp>
+        <p:nvSpPr>
+          <p:cNvPr id="9" name="Rectangle 8"/>
+          <p:cNvSpPr/>
+          <p:nvPr/>
+        </p:nvSpPr>
+        <p:spPr>
+          <a:xfrm>
+            <a:off x="8595360" y="1280160"/>
+            <a:ext cx="3063240" cy="1600200"/>
+          </a:xfrm>
+          <a:prstGeom prst="rect">
+            <a:avLst/>
+          </a:prstGeom>
+          <a:solidFill>
+            <a:srgbClr val="F8FAFC"/>
+          </a:solidFill>
+          <a:ln w="12700">
+            <a:solidFill>
+              <a:srgbClr val="E2E8F0"/>
+            </a:solidFill>
+          </a:ln>
+          <a:effectLst/>
+        </p:spPr>
+        <p:style>
+          <a:lnRef idx="1">
+            <a:schemeClr val="accent1"/>
+          </a:lnRef>
+          <a:fillRef idx="3">
+            <a:schemeClr val="accent1"/>
+          </a:fillRef>
+          <a:effectRef idx="2">
+            <a:schemeClr val="accent1"/>
+          </a:effectRef>
+          <a:fontRef idx="minor">
+            <a:schemeClr val="lt1"/>
+          </a:fontRef>
+        </p:style>
+        <p:txBody>
+          <a:bodyPr rtlCol="0" anchor="ctr"/>
+          <a:lstStyle/>
+          <a:p>
+            <a:pPr algn="ctr"/>
+          </a:p>
+        </p:txBody>
+      </p:sp>
+      <p:sp>
+        <p:nvSpPr>
+          <p:cNvPr id="10" name="TextBox 9"/>
           <p:cNvSpPr txBox="1"/>
           <p:nvPr/>
         </p:nvSpPr>
         <p:spPr>
           <a:xfrm>
-            <a:off x="8595360" y="3108960"/>
-            <a:ext cx="3063240" cy="2286000"/>
+            <a:off x="8732520" y="1371600"/>
+            <a:ext cx="2834640" cy="1463040"/>
           </a:xfrm>
           <a:prstGeom prst="rect">
             <a:avLst/>
@@ -12586,6 +12770,77 @@
           <a:p>
             <a:pPr algn="l">
               <a:spcAft>
+                <a:spcPts val="800"/>
+              </a:spcAft>
+            </a:pPr>
+            <a:r>
+              <a:rPr sz="1300" b="1" i="0">
+                <a:solidFill>
+                  <a:srgbClr val="0F172A"/>
+                </a:solidFill>
+                <a:latin typeface="Arial"/>
+              </a:rPr>
+              <a:t>λ = 1 − Πᵢ (1 − rᵢ³)(1 − r_lm)</a:t>
+            </a:r>
+          </a:p>
+          <a:p>
+            <a:pPr algn="l">
+              <a:spcAft>
+                <a:spcPts val="800"/>
+              </a:spcAft>
+            </a:pPr>
+            <a:r>
+              <a:rPr sz="1300" b="1" i="0">
+                <a:solidFill>
+                  <a:srgbClr val="0F172A"/>
+                </a:solidFill>
+                <a:latin typeface="Arial"/>
+              </a:rPr>
+              <a:t>f_GW = n̄ₑ / n_GW</a:t>
+            </a:r>
+          </a:p>
+          <a:p>
+            <a:pPr algn="l">
+              <a:spcAft>
+                <a:spcPts val="0"/>
+              </a:spcAft>
+            </a:pPr>
+            <a:r>
+              <a:rPr sz="1300" b="1" i="0">
+                <a:solidFill>
+                  <a:srgbClr val="0F172A"/>
+                </a:solidFill>
+                <a:latin typeface="Arial"/>
+              </a:rPr>
+              <a:t>f_GW ∝ n̄ₑ / Iₚ</a:t>
+            </a:r>
+          </a:p>
+        </p:txBody>
+      </p:sp>
+      <p:sp>
+        <p:nvSpPr>
+          <p:cNvPr id="11" name="TextBox 10"/>
+          <p:cNvSpPr txBox="1"/>
+          <p:nvPr/>
+        </p:nvSpPr>
+        <p:spPr>
+          <a:xfrm>
+            <a:off x="8595360" y="3108960"/>
+            <a:ext cx="3063240" cy="2286000"/>
+          </a:xfrm>
+          <a:prstGeom prst="rect">
+            <a:avLst/>
+          </a:prstGeom>
+          <a:noFill/>
+        </p:spPr>
+        <p:txBody>
+          <a:bodyPr wrap="square" anchor="t" lIns="0" rIns="0" tIns="0" bIns="0">
+            <a:spAutoFit/>
+          </a:bodyPr>
+          <a:lstStyle/>
+          <a:p>
+            <a:pPr algn="l">
+              <a:spcAft>
                 <a:spcPts val="700"/>
               </a:spcAft>
             </a:pPr>
@@ -12655,7 +12910,7 @@
                 </a:solidFill>
                 <a:latin typeface="Arial"/>
               </a:rPr>
-              <a:t>межі конкурують: зниження одного ризику підвищує інший, тому керування має знати механізм</a:t>
+              <a:t>межі конкурують: зниження одного ризику підвищує інший, тому керування має знати механізм — звідси гіпотеза H8 (розд. 13)</a:t>
             </a:r>
           </a:p>
         </p:txBody>
@@ -13473,16 +13728,18 @@
         </p:nvSpPr>
         <p:spPr>
           <a:xfrm>
-            <a:off x="521207" y="1252728"/>
-            <a:ext cx="5910975" cy="4626864"/>
+            <a:off x="548640" y="914400"/>
+            <a:ext cx="4206240" cy="274320"/>
           </a:xfrm>
           <a:prstGeom prst="rect">
             <a:avLst/>
           </a:prstGeom>
-          <a:noFill/>
-          <a:ln w="12700">
+          <a:solidFill>
+            <a:srgbClr val="FFF7ED"/>
+          </a:solidFill>
+          <a:ln w="9525">
             <a:solidFill>
-              <a:srgbClr val="E2E8F0"/>
+              <a:srgbClr val="C2410C"/>
             </a:solidFill>
           </a:ln>
           <a:effectLst/>
@@ -13509,9 +13766,92 @@
           </a:p>
         </p:txBody>
       </p:sp>
+      <p:sp>
+        <p:nvSpPr>
+          <p:cNvPr id="5" name="TextBox 4"/>
+          <p:cNvSpPr txBox="1"/>
+          <p:nvPr/>
+        </p:nvSpPr>
+        <p:spPr>
+          <a:xfrm>
+            <a:off x="640080" y="914400"/>
+            <a:ext cx="4023360" cy="274320"/>
+          </a:xfrm>
+          <a:prstGeom prst="rect">
+            <a:avLst/>
+          </a:prstGeom>
+          <a:noFill/>
+        </p:spPr>
+        <p:txBody>
+          <a:bodyPr wrap="square" anchor="ctr" lIns="0" rIns="0" tIns="0" bIns="0">
+            <a:spAutoFit/>
+          </a:bodyPr>
+          <a:lstStyle/>
+          <a:p>
+            <a:pPr algn="l">
+              <a:spcAft>
+                <a:spcPts val="0"/>
+              </a:spcAft>
+            </a:pPr>
+            <a:r>
+              <a:rPr sz="1100" b="1" i="0">
+                <a:solidFill>
+                  <a:srgbClr val="C2410C"/>
+                </a:solidFill>
+                <a:latin typeface="Arial"/>
+              </a:rPr>
+              <a:t>Гіпотеза H7 — спростовано</a:t>
+            </a:r>
+          </a:p>
+        </p:txBody>
+      </p:sp>
+      <p:sp>
+        <p:nvSpPr>
+          <p:cNvPr id="6" name="Rectangle 5"/>
+          <p:cNvSpPr/>
+          <p:nvPr/>
+        </p:nvSpPr>
+        <p:spPr>
+          <a:xfrm>
+            <a:off x="521207" y="1252728"/>
+            <a:ext cx="5910975" cy="4626864"/>
+          </a:xfrm>
+          <a:prstGeom prst="rect">
+            <a:avLst/>
+          </a:prstGeom>
+          <a:noFill/>
+          <a:ln w="12700">
+            <a:solidFill>
+              <a:srgbClr val="E2E8F0"/>
+            </a:solidFill>
+          </a:ln>
+          <a:effectLst/>
+        </p:spPr>
+        <p:style>
+          <a:lnRef idx="1">
+            <a:schemeClr val="accent1"/>
+          </a:lnRef>
+          <a:fillRef idx="3">
+            <a:schemeClr val="accent1"/>
+          </a:fillRef>
+          <a:effectRef idx="2">
+            <a:schemeClr val="accent1"/>
+          </a:effectRef>
+          <a:fontRef idx="minor">
+            <a:schemeClr val="lt1"/>
+          </a:fontRef>
+        </p:style>
+        <p:txBody>
+          <a:bodyPr rtlCol="0" anchor="ctr"/>
+          <a:lstStyle/>
+          <a:p>
+            <a:pPr algn="ctr"/>
+          </a:p>
+        </p:txBody>
+      </p:sp>
       <p:pic>
         <p:nvPicPr>
-          <p:cNvPr id="5" name="Picture 4" descr="phys_dipdt.png"/>
+          <p:cNvPr id="7" name="Picture 6" descr="phys_dipdt.png"/>
           <p:cNvPicPr>
             <a:picLocks noChangeAspect="1"/>
           </p:cNvPicPr>
@@ -13535,7 +13875,7 @@
       </p:pic>
       <p:sp>
         <p:nvSpPr>
-          <p:cNvPr id="6" name="TextBox 5"/>
+          <p:cNvPr id="8" name="TextBox 7"/>
           <p:cNvSpPr txBox="1"/>
           <p:nvPr/>
         </p:nvSpPr>
@@ -13574,7 +13914,7 @@
       </p:sp>
       <p:sp>
         <p:nvSpPr>
-          <p:cNvPr id="7" name="TextBox 6"/>
+          <p:cNvPr id="9" name="TextBox 8"/>
           <p:cNvSpPr txBox="1"/>
           <p:nvPr/>
         </p:nvSpPr>
@@ -13807,16 +14147,18 @@
         </p:nvSpPr>
         <p:spPr>
           <a:xfrm>
-            <a:off x="521207" y="1252728"/>
-            <a:ext cx="7644384" cy="3774047"/>
+            <a:off x="548640" y="914400"/>
+            <a:ext cx="4206240" cy="274320"/>
           </a:xfrm>
           <a:prstGeom prst="rect">
             <a:avLst/>
           </a:prstGeom>
-          <a:noFill/>
-          <a:ln w="12700">
+          <a:solidFill>
+            <a:srgbClr val="FFF7ED"/>
+          </a:solidFill>
+          <a:ln w="9525">
             <a:solidFill>
-              <a:srgbClr val="E2E8F0"/>
+              <a:srgbClr val="C2410C"/>
             </a:solidFill>
           </a:ln>
           <a:effectLst/>
@@ -13843,9 +14185,92 @@
           </a:p>
         </p:txBody>
       </p:sp>
+      <p:sp>
+        <p:nvSpPr>
+          <p:cNvPr id="5" name="TextBox 4"/>
+          <p:cNvSpPr txBox="1"/>
+          <p:nvPr/>
+        </p:nvSpPr>
+        <p:spPr>
+          <a:xfrm>
+            <a:off x="640080" y="914400"/>
+            <a:ext cx="4023360" cy="274320"/>
+          </a:xfrm>
+          <a:prstGeom prst="rect">
+            <a:avLst/>
+          </a:prstGeom>
+          <a:noFill/>
+        </p:spPr>
+        <p:txBody>
+          <a:bodyPr wrap="square" anchor="ctr" lIns="0" rIns="0" tIns="0" bIns="0">
+            <a:spAutoFit/>
+          </a:bodyPr>
+          <a:lstStyle/>
+          <a:p>
+            <a:pPr algn="l">
+              <a:spcAft>
+                <a:spcPts val="0"/>
+              </a:spcAft>
+            </a:pPr>
+            <a:r>
+              <a:rPr sz="1100" b="1" i="0">
+                <a:solidFill>
+                  <a:srgbClr val="C2410C"/>
+                </a:solidFill>
+                <a:latin typeface="Arial"/>
+              </a:rPr>
+              <a:t>Гіпотеза H7 — спростовано</a:t>
+            </a:r>
+          </a:p>
+        </p:txBody>
+      </p:sp>
+      <p:sp>
+        <p:nvSpPr>
+          <p:cNvPr id="6" name="Rectangle 5"/>
+          <p:cNvSpPr/>
+          <p:nvPr/>
+        </p:nvSpPr>
+        <p:spPr>
+          <a:xfrm>
+            <a:off x="521207" y="1252728"/>
+            <a:ext cx="7644384" cy="3774047"/>
+          </a:xfrm>
+          <a:prstGeom prst="rect">
+            <a:avLst/>
+          </a:prstGeom>
+          <a:noFill/>
+          <a:ln w="12700">
+            <a:solidFill>
+              <a:srgbClr val="E2E8F0"/>
+            </a:solidFill>
+          </a:ln>
+          <a:effectLst/>
+        </p:spPr>
+        <p:style>
+          <a:lnRef idx="1">
+            <a:schemeClr val="accent1"/>
+          </a:lnRef>
+          <a:fillRef idx="3">
+            <a:schemeClr val="accent1"/>
+          </a:fillRef>
+          <a:effectRef idx="2">
+            <a:schemeClr val="accent1"/>
+          </a:effectRef>
+          <a:fontRef idx="minor">
+            <a:schemeClr val="lt1"/>
+          </a:fontRef>
+        </p:style>
+        <p:txBody>
+          <a:bodyPr rtlCol="0" anchor="ctr"/>
+          <a:lstStyle/>
+          <a:p>
+            <a:pPr algn="ctr"/>
+          </a:p>
+        </p:txBody>
+      </p:sp>
       <p:pic>
         <p:nvPicPr>
-          <p:cNvPr id="5" name="Picture 4" descr="phys_mirnov.png"/>
+          <p:cNvPr id="7" name="Picture 6" descr="phys_mirnov.png"/>
           <p:cNvPicPr>
             <a:picLocks noChangeAspect="1"/>
           </p:cNvPicPr>
@@ -13869,7 +14294,7 @@
       </p:pic>
       <p:sp>
         <p:nvSpPr>
-          <p:cNvPr id="6" name="TextBox 5"/>
+          <p:cNvPr id="8" name="TextBox 7"/>
           <p:cNvSpPr txBox="1"/>
           <p:nvPr/>
         </p:nvSpPr>
@@ -13908,7 +14333,7 @@
       </p:sp>
       <p:sp>
         <p:nvSpPr>
-          <p:cNvPr id="7" name="TextBox 6"/>
+          <p:cNvPr id="9" name="TextBox 8"/>
           <p:cNvSpPr txBox="1"/>
           <p:nvPr/>
         </p:nvSpPr>
@@ -16460,9 +16885,94 @@
           </a:p>
         </p:txBody>
       </p:sp>
+      <p:sp>
+        <p:nvSpPr>
+          <p:cNvPr id="4" name="Rectangle 3"/>
+          <p:cNvSpPr/>
+          <p:nvPr/>
+        </p:nvSpPr>
+        <p:spPr>
+          <a:xfrm>
+            <a:off x="548640" y="914400"/>
+            <a:ext cx="4206240" cy="274320"/>
+          </a:xfrm>
+          <a:prstGeom prst="rect">
+            <a:avLst/>
+          </a:prstGeom>
+          <a:solidFill>
+            <a:srgbClr val="FFF7ED"/>
+          </a:solidFill>
+          <a:ln w="9525">
+            <a:solidFill>
+              <a:srgbClr val="C2410C"/>
+            </a:solidFill>
+          </a:ln>
+          <a:effectLst/>
+        </p:spPr>
+        <p:style>
+          <a:lnRef idx="1">
+            <a:schemeClr val="accent1"/>
+          </a:lnRef>
+          <a:fillRef idx="3">
+            <a:schemeClr val="accent1"/>
+          </a:fillRef>
+          <a:effectRef idx="2">
+            <a:schemeClr val="accent1"/>
+          </a:effectRef>
+          <a:fontRef idx="minor">
+            <a:schemeClr val="lt1"/>
+          </a:fontRef>
+        </p:style>
+        <p:txBody>
+          <a:bodyPr rtlCol="0" anchor="ctr"/>
+          <a:lstStyle/>
+          <a:p>
+            <a:pPr algn="ctr"/>
+          </a:p>
+        </p:txBody>
+      </p:sp>
+      <p:sp>
+        <p:nvSpPr>
+          <p:cNvPr id="5" name="TextBox 4"/>
+          <p:cNvSpPr txBox="1"/>
+          <p:nvPr/>
+        </p:nvSpPr>
+        <p:spPr>
+          <a:xfrm>
+            <a:off x="640080" y="914400"/>
+            <a:ext cx="4023360" cy="274320"/>
+          </a:xfrm>
+          <a:prstGeom prst="rect">
+            <a:avLst/>
+          </a:prstGeom>
+          <a:noFill/>
+        </p:spPr>
+        <p:txBody>
+          <a:bodyPr wrap="square" anchor="ctr" lIns="0" rIns="0" tIns="0" bIns="0">
+            <a:spAutoFit/>
+          </a:bodyPr>
+          <a:lstStyle/>
+          <a:p>
+            <a:pPr algn="l">
+              <a:spcAft>
+                <a:spcPts val="0"/>
+              </a:spcAft>
+            </a:pPr>
+            <a:r>
+              <a:rPr sz="1100" b="1" i="0">
+                <a:solidFill>
+                  <a:srgbClr val="C2410C"/>
+                </a:solidFill>
+                <a:latin typeface="Arial"/>
+              </a:rPr>
+              <a:t>Гіпотеза H4 — спростовано, H5 — підтверджено</a:t>
+            </a:r>
+          </a:p>
+        </p:txBody>
+      </p:sp>
       <p:pic>
         <p:nvPicPr>
-          <p:cNvPr id="4" name="Picture 3" descr="oracle.png"/>
+          <p:cNvPr id="6" name="Picture 5" descr="oracle.png"/>
           <p:cNvPicPr>
             <a:picLocks noChangeAspect="1"/>
           </p:cNvPicPr>
@@ -16486,7 +16996,7 @@
       </p:pic>
       <p:sp>
         <p:nvSpPr>
-          <p:cNvPr id="5" name="TextBox 4"/>
+          <p:cNvPr id="7" name="TextBox 6"/>
           <p:cNvSpPr txBox="1"/>
           <p:nvPr/>
         </p:nvSpPr>
@@ -16525,7 +17035,7 @@
       </p:sp>
       <p:sp>
         <p:nvSpPr>
-          <p:cNvPr id="6" name="TextBox 5"/>
+          <p:cNvPr id="8" name="TextBox 7"/>
           <p:cNvSpPr txBox="1"/>
           <p:nvPr/>
         </p:nvSpPr>
@@ -16598,7 +17108,7 @@
       </p:sp>
       <p:sp>
         <p:nvSpPr>
-          <p:cNvPr id="7" name="TextBox 6"/>
+          <p:cNvPr id="9" name="TextBox 8"/>
           <p:cNvSpPr txBox="1"/>
           <p:nvPr/>
         </p:nvSpPr>
@@ -16637,7 +17147,7 @@
       </p:sp>
       <p:graphicFrame>
         <p:nvGraphicFramePr>
-          <p:cNvPr id="8" name="Table 7"/>
+          <p:cNvPr id="10" name="Table 9"/>
           <p:cNvGraphicFramePr>
             <a:graphicFrameLocks noGrp="1"/>
           </p:cNvGraphicFramePr>
@@ -17058,8 +17568,8 @@
         </p:nvSpPr>
         <p:spPr>
           <a:xfrm>
-            <a:off x="548640" y="1188720"/>
-            <a:ext cx="11109960" cy="731520"/>
+            <a:off x="548640" y="914400"/>
+            <a:ext cx="4206240" cy="274320"/>
           </a:xfrm>
           <a:prstGeom prst="rect">
             <a:avLst/>
@@ -17067,7 +17577,7 @@
           <a:solidFill>
             <a:srgbClr val="ECFDF5"/>
           </a:solidFill>
-          <a:ln w="15875">
+          <a:ln w="9525">
             <a:solidFill>
               <a:srgbClr val="047857"/>
             </a:solidFill>
@@ -17104,8 +17614,8 @@
         </p:nvSpPr>
         <p:spPr>
           <a:xfrm>
-            <a:off x="731520" y="1261872"/>
-            <a:ext cx="10789920" cy="594360"/>
+            <a:off x="640080" y="914400"/>
+            <a:ext cx="4023360" cy="274320"/>
           </a:xfrm>
           <a:prstGeom prst="rect">
             <a:avLst/>
@@ -17124,6 +17634,91 @@
               </a:spcAft>
             </a:pPr>
             <a:r>
+              <a:rPr sz="1100" b="1" i="0">
+                <a:solidFill>
+                  <a:srgbClr val="047857"/>
+                </a:solidFill>
+                <a:latin typeface="Arial"/>
+              </a:rPr>
+              <a:t>Гіпотеза H8 — підтверджено</a:t>
+            </a:r>
+          </a:p>
+        </p:txBody>
+      </p:sp>
+      <p:sp>
+        <p:nvSpPr>
+          <p:cNvPr id="6" name="Rectangle 5"/>
+          <p:cNvSpPr/>
+          <p:nvPr/>
+        </p:nvSpPr>
+        <p:spPr>
+          <a:xfrm>
+            <a:off x="548640" y="1298448"/>
+            <a:ext cx="11109960" cy="731520"/>
+          </a:xfrm>
+          <a:prstGeom prst="rect">
+            <a:avLst/>
+          </a:prstGeom>
+          <a:solidFill>
+            <a:srgbClr val="ECFDF5"/>
+          </a:solidFill>
+          <a:ln w="15875">
+            <a:solidFill>
+              <a:srgbClr val="047857"/>
+            </a:solidFill>
+          </a:ln>
+          <a:effectLst/>
+        </p:spPr>
+        <p:style>
+          <a:lnRef idx="1">
+            <a:schemeClr val="accent1"/>
+          </a:lnRef>
+          <a:fillRef idx="3">
+            <a:schemeClr val="accent1"/>
+          </a:fillRef>
+          <a:effectRef idx="2">
+            <a:schemeClr val="accent1"/>
+          </a:effectRef>
+          <a:fontRef idx="minor">
+            <a:schemeClr val="lt1"/>
+          </a:fontRef>
+        </p:style>
+        <p:txBody>
+          <a:bodyPr rtlCol="0" anchor="ctr"/>
+          <a:lstStyle/>
+          <a:p>
+            <a:pPr algn="ctr"/>
+          </a:p>
+        </p:txBody>
+      </p:sp>
+      <p:sp>
+        <p:nvSpPr>
+          <p:cNvPr id="7" name="TextBox 6"/>
+          <p:cNvSpPr txBox="1"/>
+          <p:nvPr/>
+        </p:nvSpPr>
+        <p:spPr>
+          <a:xfrm>
+            <a:off x="731520" y="1371600"/>
+            <a:ext cx="10789920" cy="594360"/>
+          </a:xfrm>
+          <a:prstGeom prst="rect">
+            <a:avLst/>
+          </a:prstGeom>
+          <a:noFill/>
+        </p:spPr>
+        <p:txBody>
+          <a:bodyPr wrap="square" anchor="ctr" lIns="0" rIns="0" tIns="0" bIns="0">
+            <a:spAutoFit/>
+          </a:bodyPr>
+          <a:lstStyle/>
+          <a:p>
+            <a:pPr algn="l">
+              <a:spcAft>
+                <a:spcPts val="0"/>
+              </a:spcAft>
+            </a:pPr>
+            <a:r>
               <a:rPr sz="1500" b="1" i="0">
                 <a:solidFill>
                   <a:srgbClr val="047857"/>
@@ -17146,7 +17741,7 @@
       </p:sp>
       <p:pic>
         <p:nvPicPr>
-          <p:cNvPr id="6" name="Picture 5" descr="fixer.png"/>
+          <p:cNvPr id="8" name="Picture 7" descr="fixer.png"/>
           <p:cNvPicPr>
             <a:picLocks noChangeAspect="1"/>
           </p:cNvPicPr>
@@ -17160,7 +17755,7 @@
         </p:blipFill>
         <p:spPr>
           <a:xfrm>
-            <a:off x="548640" y="2103120"/>
+            <a:off x="548640" y="2194560"/>
             <a:ext cx="7406640" cy="3044010"/>
           </a:xfrm>
           <a:prstGeom prst="rect">
@@ -17170,13 +17765,13 @@
       </p:pic>
       <p:sp>
         <p:nvSpPr>
-          <p:cNvPr id="7" name="TextBox 6"/>
+          <p:cNvPr id="9" name="TextBox 8"/>
           <p:cNvSpPr txBox="1"/>
           <p:nvPr/>
         </p:nvSpPr>
         <p:spPr>
           <a:xfrm>
-            <a:off x="548640" y="5192850"/>
+            <a:off x="548640" y="5284290"/>
             <a:ext cx="7406640" cy="365760"/>
           </a:xfrm>
           <a:prstGeom prst="rect">
@@ -17209,7 +17804,7 @@
       </p:sp>
       <p:sp>
         <p:nvSpPr>
-          <p:cNvPr id="8" name="TextBox 7"/>
+          <p:cNvPr id="10" name="TextBox 9"/>
           <p:cNvSpPr txBox="1"/>
           <p:nvPr/>
         </p:nvSpPr>
@@ -17264,7 +17859,7 @@
       </p:sp>
       <p:sp>
         <p:nvSpPr>
-          <p:cNvPr id="9" name="TextBox 8"/>
+          <p:cNvPr id="11" name="TextBox 10"/>
           <p:cNvSpPr txBox="1"/>
           <p:nvPr/>
         </p:nvSpPr>
@@ -17362,7 +17957,7 @@
       </p:sp>
       <p:sp>
         <p:nvSpPr>
-          <p:cNvPr id="10" name="TextBox 9"/>
+          <p:cNvPr id="12" name="TextBox 11"/>
           <p:cNvSpPr txBox="1"/>
           <p:nvPr/>
         </p:nvSpPr>
@@ -19921,7 +20516,7 @@
         </p:nvGraphicFramePr>
         <p:xfrm>
           <a:off x="548640" y="1645920"/>
-          <a:ext cx="11109960" cy="3950208"/>
+          <a:ext cx="11109960" cy="4690863"/>
         </p:xfrm>
         <a:graphic>
           <a:graphicData uri="http://schemas.openxmlformats.org/drawingml/2006/table">
@@ -19935,7 +20530,7 @@
                 <a:gridCol w="3794760"/>
                 <a:gridCol w="1828800"/>
               </a:tblGrid>
-              <a:tr h="658368">
+              <a:tr h="521207">
                 <a:tc>
                   <a:txBody>
                     <a:bodyPr wrap="square"/>
@@ -20029,7 +20624,7 @@
                   </a:tcPr>
                 </a:tc>
               </a:tr>
-              <a:tr h="658368">
+              <a:tr h="521207">
                 <a:tc>
                   <a:txBody>
                     <a:bodyPr wrap="square"/>
@@ -20037,7 +20632,7 @@
                     <a:p>
                       <a:pPr algn="l"/>
                       <a:r>
-                        <a:rPr sz="1300" b="1">
+                        <a:rPr sz="1200" b="1">
                           <a:solidFill>
                             <a:srgbClr val="0F172A"/>
                           </a:solidFill>
@@ -20060,7 +20655,7 @@
                     <a:p>
                       <a:pPr algn="ctr"/>
                       <a:r>
-                        <a:rPr sz="1300" b="0">
+                        <a:rPr sz="1200" b="0">
                           <a:solidFill>
                             <a:srgbClr val="0F172A"/>
                           </a:solidFill>
@@ -20083,7 +20678,7 @@
                     <a:p>
                       <a:pPr algn="ctr"/>
                       <a:r>
-                        <a:rPr sz="1300" b="0">
+                        <a:rPr sz="1200" b="0">
                           <a:solidFill>
                             <a:srgbClr val="0F172A"/>
                           </a:solidFill>
@@ -20106,7 +20701,7 @@
                     <a:p>
                       <a:pPr algn="ctr"/>
                       <a:r>
-                        <a:rPr sz="1300" b="0">
+                        <a:rPr sz="1200" b="0">
                           <a:solidFill>
                             <a:srgbClr val="0F172A"/>
                           </a:solidFill>
@@ -20123,7 +20718,7 @@
                   </a:tcPr>
                 </a:tc>
               </a:tr>
-              <a:tr h="658368">
+              <a:tr h="521207">
                 <a:tc>
                   <a:txBody>
                     <a:bodyPr wrap="square"/>
@@ -20131,7 +20726,7 @@
                     <a:p>
                       <a:pPr algn="l"/>
                       <a:r>
-                        <a:rPr sz="1300" b="1">
+                        <a:rPr sz="1200" b="1">
                           <a:solidFill>
                             <a:srgbClr val="0F172A"/>
                           </a:solidFill>
@@ -20154,7 +20749,7 @@
                     <a:p>
                       <a:pPr algn="ctr"/>
                       <a:r>
-                        <a:rPr sz="1300" b="0">
+                        <a:rPr sz="1200" b="0">
                           <a:solidFill>
                             <a:srgbClr val="0F172A"/>
                           </a:solidFill>
@@ -20177,7 +20772,7 @@
                     <a:p>
                       <a:pPr algn="ctr"/>
                       <a:r>
-                        <a:rPr sz="1300" b="0">
+                        <a:rPr sz="1200" b="0">
                           <a:solidFill>
                             <a:srgbClr val="0F172A"/>
                           </a:solidFill>
@@ -20200,7 +20795,7 @@
                     <a:p>
                       <a:pPr algn="ctr"/>
                       <a:r>
-                        <a:rPr sz="1300" b="0">
+                        <a:rPr sz="1200" b="0">
                           <a:solidFill>
                             <a:srgbClr val="0F172A"/>
                           </a:solidFill>
@@ -20217,7 +20812,7 @@
                   </a:tcPr>
                 </a:tc>
               </a:tr>
-              <a:tr h="658368">
+              <a:tr h="521207">
                 <a:tc>
                   <a:txBody>
                     <a:bodyPr wrap="square"/>
@@ -20225,7 +20820,7 @@
                     <a:p>
                       <a:pPr algn="l"/>
                       <a:r>
-                        <a:rPr sz="1300" b="1">
+                        <a:rPr sz="1200" b="1">
                           <a:solidFill>
                             <a:srgbClr val="0F172A"/>
                           </a:solidFill>
@@ -20248,7 +20843,7 @@
                     <a:p>
                       <a:pPr algn="ctr"/>
                       <a:r>
-                        <a:rPr sz="1300" b="0">
+                        <a:rPr sz="1200" b="0">
                           <a:solidFill>
                             <a:srgbClr val="0F172A"/>
                           </a:solidFill>
@@ -20271,7 +20866,7 @@
                     <a:p>
                       <a:pPr algn="ctr"/>
                       <a:r>
-                        <a:rPr sz="1300" b="0">
+                        <a:rPr sz="1200" b="0">
                           <a:solidFill>
                             <a:srgbClr val="0F172A"/>
                           </a:solidFill>
@@ -20294,7 +20889,7 @@
                     <a:p>
                       <a:pPr algn="ctr"/>
                       <a:r>
-                        <a:rPr sz="1300" b="0">
+                        <a:rPr sz="1200" b="0">
                           <a:solidFill>
                             <a:srgbClr val="0F172A"/>
                           </a:solidFill>
@@ -20311,7 +20906,7 @@
                   </a:tcPr>
                 </a:tc>
               </a:tr>
-              <a:tr h="658368">
+              <a:tr h="521207">
                 <a:tc>
                   <a:txBody>
                     <a:bodyPr wrap="square"/>
@@ -20319,7 +20914,7 @@
                     <a:p>
                       <a:pPr algn="l"/>
                       <a:r>
-                        <a:rPr sz="1300" b="1">
+                        <a:rPr sz="1200" b="1">
                           <a:solidFill>
                             <a:srgbClr val="0F172A"/>
                           </a:solidFill>
@@ -20342,7 +20937,7 @@
                     <a:p>
                       <a:pPr algn="ctr"/>
                       <a:r>
-                        <a:rPr sz="1300" b="0">
+                        <a:rPr sz="1200" b="0">
                           <a:solidFill>
                             <a:srgbClr val="0F172A"/>
                           </a:solidFill>
@@ -20365,7 +20960,7 @@
                     <a:p>
                       <a:pPr algn="ctr"/>
                       <a:r>
-                        <a:rPr sz="1300" b="0">
+                        <a:rPr sz="1200" b="0">
                           <a:solidFill>
                             <a:srgbClr val="0F172A"/>
                           </a:solidFill>
@@ -20388,7 +20983,7 @@
                     <a:p>
                       <a:pPr algn="ctr"/>
                       <a:r>
-                        <a:rPr sz="1300" b="0">
+                        <a:rPr sz="1200" b="0">
                           <a:solidFill>
                             <a:srgbClr val="0F172A"/>
                           </a:solidFill>
@@ -20405,7 +21000,7 @@
                   </a:tcPr>
                 </a:tc>
               </a:tr>
-              <a:tr h="658368">
+              <a:tr h="521207">
                 <a:tc>
                   <a:txBody>
                     <a:bodyPr wrap="square"/>
@@ -20413,7 +21008,7 @@
                     <a:p>
                       <a:pPr algn="l"/>
                       <a:r>
-                        <a:rPr sz="1300" b="1">
+                        <a:rPr sz="1200" b="1">
                           <a:solidFill>
                             <a:srgbClr val="0F172A"/>
                           </a:solidFill>
@@ -20436,7 +21031,7 @@
                     <a:p>
                       <a:pPr algn="ctr"/>
                       <a:r>
-                        <a:rPr sz="1300" b="0">
+                        <a:rPr sz="1200" b="0">
                           <a:solidFill>
                             <a:srgbClr val="0F172A"/>
                           </a:solidFill>
@@ -20459,7 +21054,7 @@
                     <a:p>
                       <a:pPr algn="ctr"/>
                       <a:r>
-                        <a:rPr sz="1300" b="0">
+                        <a:rPr sz="1200" b="0">
                           <a:solidFill>
                             <a:srgbClr val="0F172A"/>
                           </a:solidFill>
@@ -20482,7 +21077,289 @@
                     <a:p>
                       <a:pPr algn="ctr"/>
                       <a:r>
-                        <a:rPr sz="1300" b="0">
+                        <a:rPr sz="1200" b="0">
+                          <a:solidFill>
+                            <a:srgbClr val="0F172A"/>
+                          </a:solidFill>
+                          <a:latin typeface="Arial"/>
+                        </a:rPr>
+                        <a:t>підтверджено</a:t>
+                      </a:r>
+                    </a:p>
+                  </a:txBody>
+                  <a:tcPr marL="91440" marR="91440" marT="27432" marB="27432" anchor="ctr">
+                    <a:solidFill>
+                      <a:srgbClr val="ECFDF5"/>
+                    </a:solidFill>
+                  </a:tcPr>
+                </a:tc>
+              </a:tr>
+              <a:tr h="521207">
+                <a:tc>
+                  <a:txBody>
+                    <a:bodyPr wrap="square"/>
+                    <a:lstStyle/>
+                    <a:p>
+                      <a:pPr algn="l"/>
+                      <a:r>
+                        <a:rPr sz="1200" b="1">
+                          <a:solidFill>
+                            <a:srgbClr val="0F172A"/>
+                          </a:solidFill>
+                          <a:latin typeface="Arial"/>
+                        </a:rPr>
+                        <a:t>H6</a:t>
+                      </a:r>
+                    </a:p>
+                  </a:txBody>
+                  <a:tcPr marL="91440" marR="91440" marT="27432" marB="27432" anchor="ctr">
+                    <a:solidFill>
+                      <a:srgbClr val="FFFFFF"/>
+                    </a:solidFill>
+                  </a:tcPr>
+                </a:tc>
+                <a:tc>
+                  <a:txBody>
+                    <a:bodyPr wrap="square"/>
+                    <a:lstStyle/>
+                    <a:p>
+                      <a:pPr algn="ctr"/>
+                      <a:r>
+                        <a:rPr sz="1200" b="0">
+                          <a:solidFill>
+                            <a:srgbClr val="0F172A"/>
+                          </a:solidFill>
+                          <a:latin typeface="Arial"/>
+                        </a:rPr>
+                        <a:t>Межі Грінвальда і low-q конкурують: існує вікно струму з мінімальним ризиком</a:t>
+                      </a:r>
+                    </a:p>
+                  </a:txBody>
+                  <a:tcPr marL="91440" marR="91440" marT="27432" marB="27432" anchor="ctr">
+                    <a:solidFill>
+                      <a:srgbClr val="FFFFFF"/>
+                    </a:solidFill>
+                  </a:tcPr>
+                </a:tc>
+                <a:tc>
+                  <a:txBody>
+                    <a:bodyPr wrap="square"/>
+                    <a:lstStyle/>
+                    <a:p>
+                      <a:pPr algn="ctr"/>
+                      <a:r>
+                        <a:rPr sz="1200" b="0">
+                          <a:solidFill>
+                            <a:srgbClr val="0F172A"/>
+                          </a:solidFill>
+                          <a:latin typeface="Arial"/>
+                        </a:rPr>
+                        <a:t>мінімум λ при Iₚ ≈ 2,6–3,6 МА (сканування 91 розряду, розд. 10.1)</a:t>
+                      </a:r>
+                    </a:p>
+                  </a:txBody>
+                  <a:tcPr marL="91440" marR="91440" marT="27432" marB="27432" anchor="ctr">
+                    <a:solidFill>
+                      <a:srgbClr val="FFFFFF"/>
+                    </a:solidFill>
+                  </a:tcPr>
+                </a:tc>
+                <a:tc>
+                  <a:txBody>
+                    <a:bodyPr wrap="square"/>
+                    <a:lstStyle/>
+                    <a:p>
+                      <a:pPr algn="ctr"/>
+                      <a:r>
+                        <a:rPr sz="1200" b="0">
+                          <a:solidFill>
+                            <a:srgbClr val="0F172A"/>
+                          </a:solidFill>
+                          <a:latin typeface="Arial"/>
+                        </a:rPr>
+                        <a:t>підтверджено</a:t>
+                      </a:r>
+                    </a:p>
+                  </a:txBody>
+                  <a:tcPr marL="91440" marR="91440" marT="27432" marB="27432" anchor="ctr">
+                    <a:solidFill>
+                      <a:srgbClr val="ECFDF5"/>
+                    </a:solidFill>
+                  </a:tcPr>
+                </a:tc>
+              </a:tr>
+              <a:tr h="521207">
+                <a:tc>
+                  <a:txBody>
+                    <a:bodyPr wrap="square"/>
+                    <a:lstStyle/>
+                    <a:p>
+                      <a:pPr algn="l"/>
+                      <a:r>
+                        <a:rPr sz="1200" b="1">
+                          <a:solidFill>
+                            <a:srgbClr val="0F172A"/>
+                          </a:solidFill>
+                          <a:latin typeface="Arial"/>
+                        </a:rPr>
+                        <a:t>H7</a:t>
+                      </a:r>
+                    </a:p>
+                  </a:txBody>
+                  <a:tcPr marL="91440" marR="91440" marT="27432" marB="27432" anchor="ctr">
+                    <a:solidFill>
+                      <a:srgbClr val="FFFFFF"/>
+                    </a:solidFill>
+                  </a:tcPr>
+                </a:tc>
+                <a:tc>
+                  <a:txBody>
+                    <a:bodyPr wrap="square"/>
+                    <a:lstStyle/>
+                    <a:p>
+                      <a:pPr algn="ctr"/>
+                      <a:r>
+                        <a:rPr sz="1200" b="0">
+                          <a:solidFill>
+                            <a:srgbClr val="0F172A"/>
+                          </a:solidFill>
+                          <a:latin typeface="Arial"/>
+                        </a:rPr>
+                        <a:t>Швидкі магнітні сигнали (dIₚ/dt, котушки Мірнова) дають раннє попередження</a:t>
+                      </a:r>
+                    </a:p>
+                  </a:txBody>
+                  <a:tcPr marL="91440" marR="91440" marT="27432" marB="27432" anchor="ctr">
+                    <a:solidFill>
+                      <a:srgbClr val="FFFFFF"/>
+                    </a:solidFill>
+                  </a:tcPr>
+                </a:tc>
+                <a:tc>
+                  <a:txBody>
+                    <a:bodyPr wrap="square"/>
+                    <a:lstStyle/>
+                    <a:p>
+                      <a:pPr algn="ctr"/>
+                      <a:r>
+                        <a:rPr sz="1200" b="0">
+                          <a:solidFill>
+                            <a:srgbClr val="0F172A"/>
+                          </a:solidFill>
+                          <a:latin typeface="Arial"/>
+                        </a:rPr>
+                        <a:t>МГД-сигнали ростуть лише за 50–90 мс до гасіння (розд. 10.3–10.4)</a:t>
+                      </a:r>
+                    </a:p>
+                  </a:txBody>
+                  <a:tcPr marL="91440" marR="91440" marT="27432" marB="27432" anchor="ctr">
+                    <a:solidFill>
+                      <a:srgbClr val="FFFFFF"/>
+                    </a:solidFill>
+                  </a:tcPr>
+                </a:tc>
+                <a:tc>
+                  <a:txBody>
+                    <a:bodyPr wrap="square"/>
+                    <a:lstStyle/>
+                    <a:p>
+                      <a:pPr algn="ctr"/>
+                      <a:r>
+                        <a:rPr sz="1200" b="0">
+                          <a:solidFill>
+                            <a:srgbClr val="0F172A"/>
+                          </a:solidFill>
+                          <a:latin typeface="Arial"/>
+                        </a:rPr>
+                        <a:t>спростовано</a:t>
+                      </a:r>
+                    </a:p>
+                  </a:txBody>
+                  <a:tcPr marL="91440" marR="91440" marT="27432" marB="27432" anchor="ctr">
+                    <a:solidFill>
+                      <a:srgbClr val="FFF7ED"/>
+                    </a:solidFill>
+                  </a:tcPr>
+                </a:tc>
+              </a:tr>
+              <a:tr h="521207">
+                <a:tc>
+                  <a:txBody>
+                    <a:bodyPr wrap="square"/>
+                    <a:lstStyle/>
+                    <a:p>
+                      <a:pPr algn="l"/>
+                      <a:r>
+                        <a:rPr sz="1200" b="1">
+                          <a:solidFill>
+                            <a:srgbClr val="0F172A"/>
+                          </a:solidFill>
+                          <a:latin typeface="Arial"/>
+                        </a:rPr>
+                        <a:t>H8</a:t>
+                      </a:r>
+                    </a:p>
+                  </a:txBody>
+                  <a:tcPr marL="91440" marR="91440" marT="27432" marB="27432" anchor="ctr">
+                    <a:solidFill>
+                      <a:srgbClr val="FFFFFF"/>
+                    </a:solidFill>
+                  </a:tcPr>
+                </a:tc>
+                <a:tc>
+                  <a:txBody>
+                    <a:bodyPr wrap="square"/>
+                    <a:lstStyle/>
+                    <a:p>
+                      <a:pPr algn="ctr"/>
+                      <a:r>
+                        <a:rPr sz="1200" b="0">
+                          <a:solidFill>
+                            <a:srgbClr val="0F172A"/>
+                          </a:solidFill>
+                          <a:latin typeface="Arial"/>
+                        </a:rPr>
+                        <a:t>Знаючи причину зриву, можна вчасно змінити уставки і запобігти зриву без втрати продуктивності</a:t>
+                      </a:r>
+                    </a:p>
+                  </a:txBody>
+                  <a:tcPr marL="91440" marR="91440" marT="27432" marB="27432" anchor="ctr">
+                    <a:solidFill>
+                      <a:srgbClr val="FFFFFF"/>
+                    </a:solidFill>
+                  </a:tcPr>
+                </a:tc>
+                <a:tc>
+                  <a:txBody>
+                    <a:bodyPr wrap="square"/>
+                    <a:lstStyle/>
+                    <a:p>
+                      <a:pPr algn="ctr"/>
+                      <a:r>
+                        <a:rPr sz="1200" b="0">
+                          <a:solidFill>
+                            <a:srgbClr val="0F172A"/>
+                          </a:solidFill>
+                          <a:latin typeface="Arial"/>
+                        </a:rPr>
+                        <a:t>31 → 5 зривів на 100 нових розрядах, енергія без змін (розд. 13)</a:t>
+                      </a:r>
+                    </a:p>
+                  </a:txBody>
+                  <a:tcPr marL="91440" marR="91440" marT="27432" marB="27432" anchor="ctr">
+                    <a:solidFill>
+                      <a:srgbClr val="FFFFFF"/>
+                    </a:solidFill>
+                  </a:tcPr>
+                </a:tc>
+                <a:tc>
+                  <a:txBody>
+                    <a:bodyPr wrap="square"/>
+                    <a:lstStyle/>
+                    <a:p>
+                      <a:pPr algn="ctr"/>
+                      <a:r>
+                        <a:rPr sz="1200" b="0">
                           <a:solidFill>
                             <a:srgbClr val="0F172A"/>
                           </a:solidFill>

</xml_diff>

<commit_message>
Deck: hypothesis tags state the hypothesis itself instead of its number
</commit_message>
<xml_diff>
--- a/docs/presentation.pptx
+++ b/docs/presentation.pptx
@@ -9529,7 +9529,7 @@
         <p:spPr>
           <a:xfrm>
             <a:off x="548640" y="914400"/>
-            <a:ext cx="4206240" cy="274320"/>
+            <a:ext cx="7681874" cy="274320"/>
           </a:xfrm>
           <a:prstGeom prst="rect">
             <a:avLst/>
@@ -9575,7 +9575,7 @@
         <p:spPr>
           <a:xfrm>
             <a:off x="640080" y="914400"/>
-            <a:ext cx="4023360" cy="274320"/>
+            <a:ext cx="7498994" cy="274320"/>
           </a:xfrm>
           <a:prstGeom prst="rect">
             <a:avLst/>
@@ -9600,7 +9600,7 @@
                 </a:solidFill>
                 <a:latin typeface="Arial"/>
               </a:rPr>
-              <a:t>Гіпотеза H1 — підтверджено</a:t>
+              <a:t>Гіпотеза: детектор передвісника разом з раннім попередженням кращий за одну модель — підтверджено</a:t>
             </a:r>
           </a:p>
         </p:txBody>
@@ -10457,7 +10457,7 @@
         <p:spPr>
           <a:xfrm>
             <a:off x="548640" y="914400"/>
-            <a:ext cx="4206240" cy="274320"/>
+            <a:ext cx="7074712" cy="274320"/>
           </a:xfrm>
           <a:prstGeom prst="rect">
             <a:avLst/>
@@ -10503,7 +10503,7 @@
         <p:spPr>
           <a:xfrm>
             <a:off x="640080" y="914400"/>
-            <a:ext cx="4023360" cy="274320"/>
+            <a:ext cx="6891832" cy="274320"/>
           </a:xfrm>
           <a:prstGeom prst="rect">
             <a:avLst/>
@@ -10528,7 +10528,7 @@
                 </a:solidFill>
                 <a:latin typeface="Arial"/>
               </a:rPr>
-              <a:t>Гіпотези H2 і H3 — підтверджено</a:t>
+              <a:t>Гіпотеза: для прогнозу не потрібні ні формули шпаргалки, ні мітка сценарію — підтверджено</a:t>
             </a:r>
           </a:p>
         </p:txBody>
@@ -12517,7 +12517,7 @@
         <p:spPr>
           <a:xfrm>
             <a:off x="548640" y="914400"/>
-            <a:ext cx="4206240" cy="274320"/>
+            <a:ext cx="7985455" cy="274320"/>
           </a:xfrm>
           <a:prstGeom prst="rect">
             <a:avLst/>
@@ -12563,7 +12563,7 @@
         <p:spPr>
           <a:xfrm>
             <a:off x="640080" y="914400"/>
-            <a:ext cx="4023360" cy="274320"/>
+            <a:ext cx="7802575" cy="274320"/>
           </a:xfrm>
           <a:prstGeom prst="rect">
             <a:avLst/>
@@ -12588,7 +12588,7 @@
                 </a:solidFill>
                 <a:latin typeface="Arial"/>
               </a:rPr>
-              <a:t>Гіпотеза H6 — підтверджено</a:t>
+              <a:t>Гіпотеза: межі Грінвальда і low-q конкурують, існує вікно струму з мінімальним ризиком — підтверджено</a:t>
             </a:r>
           </a:p>
         </p:txBody>
@@ -12910,7 +12910,7 @@
                 </a:solidFill>
                 <a:latin typeface="Arial"/>
               </a:rPr>
-              <a:t>межі конкурують: зниження одного ризику підвищує інший, тому керування має знати механізм — звідси гіпотеза H8 (розд. 13)</a:t>
+              <a:t>межі конкурують: зниження одного ризику підвищує інший, тому керування має знати механізм — це перевіряємо в розділі 13</a:t>
             </a:r>
           </a:p>
         </p:txBody>
@@ -13729,7 +13729,7 @@
         <p:spPr>
           <a:xfrm>
             <a:off x="548640" y="914400"/>
-            <a:ext cx="4206240" cy="274320"/>
+            <a:ext cx="6012180" cy="274320"/>
           </a:xfrm>
           <a:prstGeom prst="rect">
             <a:avLst/>
@@ -13775,7 +13775,7 @@
         <p:spPr>
           <a:xfrm>
             <a:off x="640080" y="914400"/>
-            <a:ext cx="4023360" cy="274320"/>
+            <a:ext cx="5829300" cy="274320"/>
           </a:xfrm>
           <a:prstGeom prst="rect">
             <a:avLst/>
@@ -13800,7 +13800,7 @@
                 </a:solidFill>
                 <a:latin typeface="Arial"/>
               </a:rPr>
-              <a:t>Гіпотеза H7 — спростовано</a:t>
+              <a:t>Гіпотеза: швидка похідна струму dIₚ/dt дає раннє попередження — спростовано</a:t>
             </a:r>
           </a:p>
         </p:txBody>
@@ -14148,7 +14148,7 @@
         <p:spPr>
           <a:xfrm>
             <a:off x="548640" y="914400"/>
-            <a:ext cx="4206240" cy="274320"/>
+            <a:ext cx="5177332" cy="274320"/>
           </a:xfrm>
           <a:prstGeom prst="rect">
             <a:avLst/>
@@ -14194,7 +14194,7 @@
         <p:spPr>
           <a:xfrm>
             <a:off x="640080" y="914400"/>
-            <a:ext cx="4023360" cy="274320"/>
+            <a:ext cx="4994452" cy="274320"/>
           </a:xfrm>
           <a:prstGeom prst="rect">
             <a:avLst/>
@@ -14219,7 +14219,7 @@
                 </a:solidFill>
                 <a:latin typeface="Arial"/>
               </a:rPr>
-              <a:t>Гіпотеза H7 — спростовано</a:t>
+              <a:t>Гіпотеза: котушки Мірнова дають раннє попередження — спростовано</a:t>
             </a:r>
           </a:p>
         </p:txBody>
@@ -16894,7 +16894,7 @@
         <p:spPr>
           <a:xfrm>
             <a:off x="548640" y="914400"/>
-            <a:ext cx="4206240" cy="274320"/>
+            <a:ext cx="8744407" cy="274320"/>
           </a:xfrm>
           <a:prstGeom prst="rect">
             <a:avLst/>
@@ -16940,7 +16940,7 @@
         <p:spPr>
           <a:xfrm>
             <a:off x="640080" y="914400"/>
-            <a:ext cx="4023360" cy="274320"/>
+            <a:ext cx="8561527" cy="274320"/>
           </a:xfrm>
           <a:prstGeom prst="rect">
             <a:avLst/>
@@ -16965,7 +16965,7 @@
                 </a:solidFill>
                 <a:latin typeface="Arial"/>
               </a:rPr>
-              <a:t>Гіпотеза H4 — спростовано, H5 — підтверджено</a:t>
+              <a:t>Гіпотези: точної λ достатньо для тривоги — спростовано; фізичне апріорі дає причину без розмітки — підтверджено</a:t>
             </a:r>
           </a:p>
         </p:txBody>
@@ -17569,7 +17569,7 @@
         <p:spPr>
           <a:xfrm>
             <a:off x="548640" y="914400"/>
-            <a:ext cx="4206240" cy="274320"/>
+            <a:ext cx="7302398" cy="274320"/>
           </a:xfrm>
           <a:prstGeom prst="rect">
             <a:avLst/>
@@ -17615,7 +17615,7 @@
         <p:spPr>
           <a:xfrm>
             <a:off x="640080" y="914400"/>
-            <a:ext cx="4023360" cy="274320"/>
+            <a:ext cx="7119518" cy="274320"/>
           </a:xfrm>
           <a:prstGeom prst="rect">
             <a:avLst/>
@@ -17640,7 +17640,7 @@
                 </a:solidFill>
                 <a:latin typeface="Arial"/>
               </a:rPr>
-              <a:t>Гіпотеза H8 — підтверджено</a:t>
+              <a:t>Гіпотеза: знаючи причину зриву, можна вчасно змінити уставки і запобігти йому — підтверджено</a:t>
             </a:r>
           </a:p>
         </p:txBody>

</xml_diff>

<commit_message>
Deck: leakage definition, drop causality point, plain-language line on slide 10, volume-only conclusion
</commit_message>
<xml_diff>
--- a/docs/presentation.pptx
+++ b/docs/presentation.pptx
@@ -2141,7 +2141,7 @@
           <a:lstStyle/>
           <a:p>
             <a:r>
-              <a:t>≈40 с. Модель раннього попередження без формул і без підказок симулятора: об'єм 0,924 проти 0,765, ROC AUC 0,998 на 30 мс. ImpactNet визначає механізм зриву: 49 з 49. У замкненому контурі учень, що бачить лише прилади, зменшує кількість зривів, яким можна запобігти, з 31 до 5 без втрати продуктивності; на іншому рушії тривога переноситься без донавчання. Поріг спрацювання неінформативний, моделі порівнюються за ROC AUC. Код і звіти — у репозиторії.</a:t>
+              <a:t>≈40 с. Модель раннього попередження без формул і без підказок симулятора: об'єм заліку 0,924 проти 0,765 у базового рішення. ImpactNet визначає механізм зриву: 49 з 49. У замкненому контурі учень, що бачить лише прилади, зменшує кількість зривів, яким можна запобігти, з 31 до 5 без втрати продуктивності; на іншому рушії тривога переноситься без донавчання. Поріг спрацювання неінформативний, моделі порівнюються за ROC AUC. Код і звіти — у репозиторії.</a:t>
             </a:r>
           </a:p>
         </p:txBody>
@@ -2281,7 +2281,7 @@
           <a:lstStyle/>
           <a:p>
             <a:r>
-              <a:t>≈40 с. Дані генеруються симулятором за незалежними сидами, навчальна і тестова вибірки не перетинаються. Оцінка — офіційний засіб toksym score на чотирьох наборах, 747 розрядів, 228 зривів. Моделі порівнюються парним бутстрепом на тих самих розрядах, критерій прийняття P &gt; 0,9 зафіксовано до експерименту. Ознаки причинні, той самий код працює у навчанні та в заліку; мітку сценарію і формули шпаргалки вилучено, щоб уникнути витоку інформації.</a:t>
+              <a:t>≈40 с. Дані генеруються симулятором за незалежними сидами, навчальна і тестова вибірки не перетинаються. Оцінка — офіційний засіб toksym score на чотирьох наборах, 747 розрядів, 228 зривів. Моделі порівнюються парним бутстрепом на тих самих розрядах, критерій прийняття P &gt; 0,9 зафіксовано до експерименту. Ознаки не залежать від цільової змінної: модель не бачить ні заздалегідь відомих результатів, ні майбутнього розряду.</a:t>
             </a:r>
           </a:p>
         </p:txBody>
@@ -11711,8 +11711,8 @@
         </p:nvSpPr>
         <p:spPr>
           <a:xfrm>
-            <a:off x="548640" y="2011680"/>
-            <a:ext cx="10972800" cy="320040"/>
+            <a:off x="548640" y="1783080"/>
+            <a:ext cx="11064240" cy="320040"/>
           </a:xfrm>
           <a:prstGeom prst="rect">
             <a:avLst/>
@@ -11731,6 +11731,45 @@
               </a:spcAft>
             </a:pPr>
             <a:r>
+              <a:rPr sz="1200" b="0" i="0">
+                <a:solidFill>
+                  <a:srgbClr val="475569"/>
+                </a:solidFill>
+                <a:latin typeface="Arial"/>
+              </a:rPr>
+              <a:t>Простими словами: що ближче параметр до своєї межі, то більший ризик rᵢ; λ — сумарна інтенсивність зриву, 1/с</a:t>
+            </a:r>
+          </a:p>
+        </p:txBody>
+      </p:sp>
+      <p:sp>
+        <p:nvSpPr>
+          <p:cNvPr id="6" name="TextBox 5"/>
+          <p:cNvSpPr txBox="1"/>
+          <p:nvPr/>
+        </p:nvSpPr>
+        <p:spPr>
+          <a:xfrm>
+            <a:off x="548640" y="2240280"/>
+            <a:ext cx="10972800" cy="320040"/>
+          </a:xfrm>
+          <a:prstGeom prst="rect">
+            <a:avLst/>
+          </a:prstGeom>
+          <a:noFill/>
+        </p:spPr>
+        <p:txBody>
+          <a:bodyPr wrap="square" anchor="t" lIns="0" rIns="0" tIns="0" bIns="0">
+            <a:spAutoFit/>
+          </a:bodyPr>
+          <a:lstStyle/>
+          <a:p>
+            <a:pPr algn="l">
+              <a:spcAft>
+                <a:spcPts val="0"/>
+              </a:spcAft>
+            </a:pPr>
+            <a:r>
               <a:rPr sz="1100" b="0" i="0">
                 <a:solidFill>
                   <a:srgbClr val="475569"/>
@@ -11744,15 +11783,15 @@
       </p:sp>
       <p:graphicFrame>
         <p:nvGraphicFramePr>
-          <p:cNvPr id="6" name="Table 5"/>
+          <p:cNvPr id="7" name="Table 6"/>
           <p:cNvGraphicFramePr>
             <a:graphicFrameLocks noGrp="1"/>
           </p:cNvGraphicFramePr>
           <p:nvPr/>
         </p:nvGraphicFramePr>
         <p:xfrm>
-          <a:off x="548640" y="2377440"/>
-          <a:ext cx="11109960" cy="2651760"/>
+          <a:off x="548640" y="2606040"/>
+          <a:ext cx="11109960" cy="2560320"/>
         </p:xfrm>
         <a:graphic>
           <a:graphicData uri="http://schemas.openxmlformats.org/drawingml/2006/table">
@@ -11767,7 +11806,7 @@
                 <a:gridCol w="3246120"/>
                 <a:gridCol w="2651760"/>
               </a:tblGrid>
-              <a:tr h="530352">
+              <a:tr h="512064">
                 <a:tc>
                   <a:txBody>
                     <a:bodyPr wrap="square"/>
@@ -11884,7 +11923,7 @@
                   </a:tcPr>
                 </a:tc>
               </a:tr>
-              <a:tr h="530352">
+              <a:tr h="512064">
                 <a:tc>
                   <a:txBody>
                     <a:bodyPr wrap="square"/>
@@ -12001,7 +12040,7 @@
                   </a:tcPr>
                 </a:tc>
               </a:tr>
-              <a:tr h="530352">
+              <a:tr h="512064">
                 <a:tc>
                   <a:txBody>
                     <a:bodyPr wrap="square"/>
@@ -12118,7 +12157,7 @@
                   </a:tcPr>
                 </a:tc>
               </a:tr>
-              <a:tr h="530352">
+              <a:tr h="512064">
                 <a:tc>
                   <a:txBody>
                     <a:bodyPr wrap="square"/>
@@ -12235,7 +12274,7 @@
                   </a:tcPr>
                 </a:tc>
               </a:tr>
-              <a:tr h="530352">
+              <a:tr h="512064">
                 <a:tc>
                   <a:txBody>
                     <a:bodyPr wrap="square"/>
@@ -12358,13 +12397,13 @@
       </p:graphicFrame>
       <p:sp>
         <p:nvSpPr>
-          <p:cNvPr id="7" name="TextBox 6"/>
+          <p:cNvPr id="8" name="TextBox 7"/>
           <p:cNvSpPr txBox="1"/>
           <p:nvPr/>
         </p:nvSpPr>
         <p:spPr>
           <a:xfrm>
-            <a:off x="548640" y="5257800"/>
+            <a:off x="548640" y="5349240"/>
             <a:ext cx="11064240" cy="1371600"/>
           </a:xfrm>
           <a:prstGeom prst="rect">
@@ -20093,7 +20132,7 @@
                 </a:solidFill>
                 <a:latin typeface="Arial"/>
               </a:rPr>
-              <a:t>Модель раннього попередження без формул шпаргалки і мітки сценарію досягає об'єму 0,924 (базове рішення 0,765) і ROC AUC 0,998 на запасі 30 мс.</a:t>
+              <a:t>Модель раннього попередження без формул шпаргалки і мітки сценарію: об'єм заліку 0,924 (базове рішення 0,765).</a:t>
             </a:r>
           </a:p>
           <a:p>
@@ -21591,7 +21630,7 @@
         <p:spPr>
           <a:xfrm>
             <a:off x="6309360" y="1371600"/>
-            <a:ext cx="5349240" cy="2286000"/>
+            <a:ext cx="5349240" cy="1828800"/>
           </a:xfrm>
           <a:prstGeom prst="rect">
             <a:avLst/>
@@ -21616,7 +21655,7 @@
                 </a:solidFill>
                 <a:latin typeface="Arial"/>
               </a:rPr>
-              <a:t>Причинність ознак – </a:t>
+              <a:t>Відтворюваність – </a:t>
             </a:r>
             <a:r>
               <a:rPr sz="1500" b="0" i="0">
@@ -21625,7 +21664,7 @@
                 </a:solidFill>
                 <a:latin typeface="Arial"/>
               </a:rPr>
-              <a:t>використовуються лише минулі значення; один і той самий клас ознак у навчанні і на заліку</a:t>
+              <a:t>результати на ноутбуці і на сервері збігаються, оскільки симулятор детермінований</a:t>
             </a:r>
           </a:p>
           <a:p>
@@ -21641,7 +21680,7 @@
                 </a:solidFill>
                 <a:latin typeface="Arial"/>
               </a:rPr>
-              <a:t>Відтворюваність – </a:t>
+              <a:t>Відсутність витоку – </a:t>
             </a:r>
             <a:r>
               <a:rPr sz="1500" b="0" i="0">
@@ -21650,32 +21689,7 @@
                 </a:solidFill>
                 <a:latin typeface="Arial"/>
               </a:rPr>
-              <a:t>результати на ноутбуці і на сервері збігаються, оскільки симулятор детермінований</a:t>
-            </a:r>
-          </a:p>
-          <a:p>
-            <a:pPr algn="l">
-              <a:spcAft>
-                <a:spcPts val="1600"/>
-              </a:spcAft>
-            </a:pPr>
-            <a:r>
-              <a:rPr sz="1500" b="1" i="0">
-                <a:solidFill>
-                  <a:srgbClr val="0F172A"/>
-                </a:solidFill>
-                <a:latin typeface="Arial"/>
-              </a:rPr>
-              <a:t>Відсутність витоку – </a:t>
-            </a:r>
-            <a:r>
-              <a:rPr sz="1500" b="0" i="0">
-                <a:solidFill>
-                  <a:srgbClr val="0F172A"/>
-                </a:solidFill>
-                <a:latin typeface="Arial"/>
-              </a:rPr>
-              <a:t>вилучено мітку сценарію та формули шпаргалки; мітки використовуються лише як ціль навчання</a:t>
+              <a:t>гарантія повної незалежності ознак від цільової змінної під час навчання, що виключає використання заздалегідь відомих результатів або майбутніх контекстів</a:t>
             </a:r>
           </a:p>
         </p:txBody>

</xml_diff>

<commit_message>
Deck: live demo slide after conclusions (why our own simulator, toksym vs fusion-sim, clickable link)
</commit_message>
<xml_diff>
--- a/docs/presentation.pptx
+++ b/docs/presentation.pptx
@@ -36,6 +36,7 @@
     <p:sldId id="284" r:id="rId36"/>
     <p:sldId id="285" r:id="rId37"/>
     <p:sldId id="286" r:id="rId38"/>
+    <p:sldId id="287" r:id="rId39"/>
   </p:sldIdLst>
   <p:sldSz cx="12191695" cy="6858000" type="screen4x3"/>
   <p:notesSz cx="6858000" cy="9144000"/>
@@ -2213,6 +2214,76 @@
           <a:p>
             <a:r>
               <a:t>≈40 с. Модель раннього попередження без формул і без підказок симулятора: об'єм заліку 0,924 проти 0,765 у базового рішення. ImpactNet визначає механізм зриву: 49 з 49. У замкненому контурі учень, що бачить лише прилади, зменшує кількість зривів, яким можна запобігти, з 31 до 5 без втрати продуктивності; на іншому рушії тривога переноситься без донавчання. Поріг спрацювання неінформативний, моделі порівнюються за ROC AUC. Код і звіти — у репозиторії.</a:t>
+            </a:r>
+          </a:p>
+        </p:txBody>
+      </p:sp>
+      <p:sp>
+        <p:nvSpPr>
+          <p:cNvPr id="4" name="Slide Number Placeholder 3"/>
+          <p:cNvSpPr>
+            <a:spLocks noGrp="1"/>
+          </p:cNvSpPr>
+          <p:nvPr>
+            <p:ph type="sldNum" idx="5" sz="quarter"/>
+          </p:nvPr>
+        </p:nvSpPr>
+        <p:spPr/>
+      </p:sp>
+    </p:spTree>
+  </p:cSld>
+  <p:clrMapOvr>
+    <a:masterClrMapping/>
+  </p:clrMapOvr>
+</p:notes>
+</file>
+
+<file path=ppt/notesSlides/notesSlide32.xml><?xml version="1.0" encoding="utf-8"?>
+<p:notes xmlns:a="http://schemas.openxmlformats.org/drawingml/2006/main" xmlns:p="http://schemas.openxmlformats.org/presentationml/2006/main" xmlns:r="http://schemas.openxmlformats.org/officeDocument/2006/relationships">
+  <p:cSld>
+    <p:spTree>
+      <p:nvGrpSpPr>
+        <p:cNvPr id="1" name=""/>
+        <p:cNvGrpSpPr/>
+        <p:nvPr/>
+      </p:nvGrpSpPr>
+      <p:grpSpPr>
+        <a:xfrm>
+          <a:off x="0" y="0"/>
+          <a:ext cx="0" cy="0"/>
+          <a:chOff x="0" y="0"/>
+          <a:chExt cx="0" cy="0"/>
+        </a:xfrm>
+      </p:grpSpPr>
+      <p:sp>
+        <p:nvSpPr>
+          <p:cNvPr id="2" name="Slide Image Placeholder 1"/>
+          <p:cNvSpPr>
+            <a:spLocks noGrp="1"/>
+          </p:cNvSpPr>
+          <p:nvPr>
+            <p:ph type="sldImg" idx="2"/>
+          </p:nvPr>
+        </p:nvSpPr>
+        <p:spPr/>
+      </p:sp>
+      <p:sp>
+        <p:nvSpPr>
+          <p:cNvPr id="3" name="Notes Placeholder 2"/>
+          <p:cNvSpPr>
+            <a:spLocks noGrp="1"/>
+          </p:cNvSpPr>
+          <p:nvPr>
+            <p:ph type="body" idx="3" sz="quarter"/>
+          </p:nvPr>
+        </p:nvSpPr>
+        <p:spPr/>
+        <p:txBody>
+          <a:bodyPr/>
+          <a:lstStyle/>
+          <a:p>
+            <a:r>
+              <a:t>≈30 с і перехід до демо. Симулятор організаторів toksym генерує розряди й оцінює тривогу, але не дає змінювати параметри плазми під час розряду, тож замкнений контур на ньому неможливий. Тому на основі відкритого рушія fusionsimulator.io, на якому побудовано і toksym, ми зробили fusion-sim: усе, що вміє toksym, плюс керування уставками в реальному часі моделлю і «тінь» — ту саму плазму без втручань для порівняння. Показуємо: JET, сценарій Density limit, модель v8_fixer. Без fixer розряд зривається на 4–5 с, з fixer — ні.</a:t>
             </a:r>
           </a:p>
         </p:txBody>
@@ -21523,6 +21594,983 @@
           <a:xfrm>
             <a:off x="548640" y="5715000"/>
             <a:ext cx="7315200" cy="457200"/>
+          </a:xfrm>
+          <a:prstGeom prst="rect">
+            <a:avLst/>
+          </a:prstGeom>
+          <a:noFill/>
+        </p:spPr>
+        <p:txBody>
+          <a:bodyPr wrap="square" anchor="t" lIns="0" rIns="0" tIns="0" bIns="0">
+            <a:spAutoFit/>
+          </a:bodyPr>
+          <a:lstStyle/>
+          <a:p>
+            <a:pPr algn="l">
+              <a:spcAft>
+                <a:spcPts val="0"/>
+              </a:spcAft>
+            </a:pPr>
+            <a:r>
+              <a:rPr sz="1800" b="1" i="0">
+                <a:solidFill>
+                  <a:srgbClr val="047857"/>
+                </a:solidFill>
+                <a:latin typeface="Arial"/>
+              </a:rPr>
+              <a:t>Далі — демонстрація в реальному часі →</a:t>
+            </a:r>
+          </a:p>
+        </p:txBody>
+      </p:sp>
+    </p:spTree>
+  </p:cSld>
+  <p:clrMapOvr>
+    <a:masterClrMapping/>
+  </p:clrMapOvr>
+</p:sld>
+</file>
+
+<file path=ppt/slides/slide32.xml><?xml version="1.0" encoding="utf-8"?>
+<p:sld xmlns:a="http://schemas.openxmlformats.org/drawingml/2006/main" xmlns:p="http://schemas.openxmlformats.org/presentationml/2006/main" xmlns:r="http://schemas.openxmlformats.org/officeDocument/2006/relationships">
+  <p:cSld>
+    <p:bg>
+      <p:bgPr>
+        <a:solidFill>
+          <a:srgbClr val="FFFFFF"/>
+        </a:solidFill>
+        <a:effectLst/>
+      </p:bgPr>
+    </p:bg>
+    <p:spTree>
+      <p:nvGrpSpPr>
+        <p:cNvPr id="1" name=""/>
+        <p:cNvGrpSpPr/>
+        <p:nvPr/>
+      </p:nvGrpSpPr>
+      <p:grpSpPr/>
+      <p:sp>
+        <p:nvSpPr>
+          <p:cNvPr id="2" name="TextBox 1"/>
+          <p:cNvSpPr txBox="1"/>
+          <p:nvPr/>
+        </p:nvSpPr>
+        <p:spPr>
+          <a:xfrm>
+            <a:off x="548640" y="411480"/>
+            <a:ext cx="11064240" cy="640080"/>
+          </a:xfrm>
+          <a:prstGeom prst="rect">
+            <a:avLst/>
+          </a:prstGeom>
+          <a:noFill/>
+        </p:spPr>
+        <p:txBody>
+          <a:bodyPr wrap="square" anchor="t" lIns="0" rIns="0" tIns="0" bIns="0">
+            <a:spAutoFit/>
+          </a:bodyPr>
+          <a:lstStyle/>
+          <a:p>
+            <a:pPr algn="l">
+              <a:spcAft>
+                <a:spcPts val="0"/>
+              </a:spcAft>
+            </a:pPr>
+            <a:r>
+              <a:rPr sz="2600" b="1" i="0">
+                <a:solidFill>
+                  <a:srgbClr val="0F172A"/>
+                </a:solidFill>
+                <a:latin typeface="Arial"/>
+              </a:rPr>
+              <a:t>16 Демонстрація: запобігання зриву в реальному часі</a:t>
+            </a:r>
+          </a:p>
+        </p:txBody>
+      </p:sp>
+      <p:sp>
+        <p:nvSpPr>
+          <p:cNvPr id="3" name="TextBox 2"/>
+          <p:cNvSpPr txBox="1"/>
+          <p:nvPr/>
+        </p:nvSpPr>
+        <p:spPr>
+          <a:xfrm>
+            <a:off x="11247120" y="6446520"/>
+            <a:ext cx="457200" cy="274320"/>
+          </a:xfrm>
+          <a:prstGeom prst="rect">
+            <a:avLst/>
+          </a:prstGeom>
+          <a:noFill/>
+        </p:spPr>
+        <p:txBody>
+          <a:bodyPr wrap="square" anchor="t" lIns="0" rIns="0" tIns="0" bIns="0">
+            <a:spAutoFit/>
+          </a:bodyPr>
+          <a:lstStyle/>
+          <a:p>
+            <a:pPr algn="r">
+              <a:spcAft>
+                <a:spcPts val="0"/>
+              </a:spcAft>
+            </a:pPr>
+            <a:r>
+              <a:rPr sz="1000" b="0" i="0">
+                <a:solidFill>
+                  <a:srgbClr val="94A3B8"/>
+                </a:solidFill>
+                <a:latin typeface="Arial"/>
+              </a:rPr>
+              <a:t>32</a:t>
+            </a:r>
+          </a:p>
+        </p:txBody>
+      </p:sp>
+      <p:sp>
+        <p:nvSpPr>
+          <p:cNvPr id="4" name="TextBox 3"/>
+          <p:cNvSpPr txBox="1"/>
+          <p:nvPr/>
+        </p:nvSpPr>
+        <p:spPr>
+          <a:xfrm>
+            <a:off x="548640" y="1280160"/>
+            <a:ext cx="6035040" cy="1188720"/>
+          </a:xfrm>
+          <a:prstGeom prst="rect">
+            <a:avLst/>
+          </a:prstGeom>
+          <a:noFill/>
+        </p:spPr>
+        <p:txBody>
+          <a:bodyPr wrap="square" anchor="t" lIns="0" rIns="0" tIns="0" bIns="0">
+            <a:spAutoFit/>
+          </a:bodyPr>
+          <a:lstStyle/>
+          <a:p>
+            <a:pPr algn="l">
+              <a:spcAft>
+                <a:spcPts val="0"/>
+              </a:spcAft>
+            </a:pPr>
+            <a:r>
+              <a:rPr sz="1400" b="1" i="0">
+                <a:solidFill>
+                  <a:srgbClr val="0F172A"/>
+                </a:solidFill>
+                <a:latin typeface="Arial"/>
+              </a:rPr>
+              <a:t>Чому власний симулятор. </a:t>
+            </a:r>
+            <a:r>
+              <a:rPr sz="1400" b="0" i="0">
+                <a:solidFill>
+                  <a:srgbClr val="0F172A"/>
+                </a:solidFill>
+                <a:latin typeface="Arial"/>
+              </a:rPr>
+              <a:t>Симулятор організаторів toksym генерує розряди й оцінює тривогу, але не дає змінювати параметри плазми під час розряду, тож замкнений контур на ньому неможливий. Тому на основі відкритого рушія fusionsimulator.io, на якому побудовано і toksym, ми зробили власний — fusion-sim.</a:t>
+            </a:r>
+          </a:p>
+        </p:txBody>
+      </p:sp>
+      <p:sp>
+        <p:nvSpPr>
+          <p:cNvPr id="5" name="TextBox 4"/>
+          <p:cNvSpPr txBox="1"/>
+          <p:nvPr/>
+        </p:nvSpPr>
+        <p:spPr>
+          <a:xfrm>
+            <a:off x="548640" y="2697480"/>
+            <a:ext cx="6035040" cy="320040"/>
+          </a:xfrm>
+          <a:prstGeom prst="rect">
+            <a:avLst/>
+          </a:prstGeom>
+          <a:noFill/>
+        </p:spPr>
+        <p:txBody>
+          <a:bodyPr wrap="square" anchor="t" lIns="0" rIns="0" tIns="0" bIns="0">
+            <a:spAutoFit/>
+          </a:bodyPr>
+          <a:lstStyle/>
+          <a:p>
+            <a:pPr algn="l">
+              <a:spcAft>
+                <a:spcPts val="0"/>
+              </a:spcAft>
+            </a:pPr>
+            <a:r>
+              <a:rPr sz="1100" b="0" i="0">
+                <a:solidFill>
+                  <a:srgbClr val="475569"/>
+                </a:solidFill>
+                <a:latin typeface="Arial"/>
+              </a:rPr>
+              <a:t>Таблиця 16 – Можливості симуляторів</a:t>
+            </a:r>
+          </a:p>
+        </p:txBody>
+      </p:sp>
+      <p:graphicFrame>
+        <p:nvGraphicFramePr>
+          <p:cNvPr id="6" name="Table 5"/>
+          <p:cNvGraphicFramePr>
+            <a:graphicFrameLocks noGrp="1"/>
+          </p:cNvGraphicFramePr>
+          <p:nvPr/>
+        </p:nvGraphicFramePr>
+        <p:xfrm>
+          <a:off x="548640" y="3063240"/>
+          <a:ext cx="6035040" cy="2816352"/>
+        </p:xfrm>
+        <a:graphic>
+          <a:graphicData uri="http://schemas.openxmlformats.org/drawingml/2006/table">
+            <a:tbl>
+              <a:tblPr firstRow="0" bandRow="0">
+                <a:tableStyleId>{5C22544A-7EE6-4342-B048-85BDC9FD1C3A}</a:tableStyleId>
+              </a:tblPr>
+              <a:tblGrid>
+                <a:gridCol w="3017520"/>
+                <a:gridCol w="1097280"/>
+                <a:gridCol w="1920240"/>
+              </a:tblGrid>
+              <a:tr h="402336">
+                <a:tc>
+                  <a:txBody>
+                    <a:bodyPr wrap="square"/>
+                    <a:lstStyle/>
+                    <a:p>
+                      <a:pPr algn="l"/>
+                      <a:r>
+                        <a:rPr sz="1100" b="1">
+                          <a:solidFill>
+                            <a:srgbClr val="475569"/>
+                          </a:solidFill>
+                          <a:latin typeface="Arial"/>
+                        </a:rPr>
+                        <a:t>можливість</a:t>
+                      </a:r>
+                    </a:p>
+                  </a:txBody>
+                  <a:tcPr marL="91440" marR="91440" marT="27432" marB="27432" anchor="ctr">
+                    <a:solidFill>
+                      <a:srgbClr val="F1F5F9"/>
+                    </a:solidFill>
+                  </a:tcPr>
+                </a:tc>
+                <a:tc>
+                  <a:txBody>
+                    <a:bodyPr wrap="square"/>
+                    <a:lstStyle/>
+                    <a:p>
+                      <a:pPr algn="ctr"/>
+                      <a:r>
+                        <a:rPr sz="1100" b="1">
+                          <a:solidFill>
+                            <a:srgbClr val="475569"/>
+                          </a:solidFill>
+                          <a:latin typeface="Arial"/>
+                        </a:rPr>
+                        <a:t>toksym</a:t>
+                      </a:r>
+                    </a:p>
+                  </a:txBody>
+                  <a:tcPr marL="91440" marR="91440" marT="27432" marB="27432" anchor="ctr">
+                    <a:solidFill>
+                      <a:srgbClr val="F1F5F9"/>
+                    </a:solidFill>
+                  </a:tcPr>
+                </a:tc>
+                <a:tc>
+                  <a:txBody>
+                    <a:bodyPr wrap="square"/>
+                    <a:lstStyle/>
+                    <a:p>
+                      <a:pPr algn="ctr"/>
+                      <a:r>
+                        <a:rPr sz="1100" b="1">
+                          <a:solidFill>
+                            <a:srgbClr val="475569"/>
+                          </a:solidFill>
+                          <a:latin typeface="Arial"/>
+                        </a:rPr>
+                        <a:t>fusion-sim</a:t>
+                      </a:r>
+                    </a:p>
+                  </a:txBody>
+                  <a:tcPr marL="91440" marR="91440" marT="27432" marB="27432" anchor="ctr">
+                    <a:solidFill>
+                      <a:srgbClr val="F1F5F9"/>
+                    </a:solidFill>
+                  </a:tcPr>
+                </a:tc>
+              </a:tr>
+              <a:tr h="402336">
+                <a:tc>
+                  <a:txBody>
+                    <a:bodyPr wrap="square"/>
+                    <a:lstStyle/>
+                    <a:p>
+                      <a:pPr algn="l"/>
+                      <a:r>
+                        <a:rPr sz="1100" b="1">
+                          <a:solidFill>
+                            <a:srgbClr val="0F172A"/>
+                          </a:solidFill>
+                          <a:latin typeface="Arial"/>
+                        </a:rPr>
+                        <a:t>генерація розрядів, залік моделі, звіт</a:t>
+                      </a:r>
+                    </a:p>
+                  </a:txBody>
+                  <a:tcPr marL="91440" marR="91440" marT="27432" marB="27432" anchor="ctr">
+                    <a:solidFill>
+                      <a:srgbClr val="FFFFFF"/>
+                    </a:solidFill>
+                  </a:tcPr>
+                </a:tc>
+                <a:tc>
+                  <a:txBody>
+                    <a:bodyPr wrap="square"/>
+                    <a:lstStyle/>
+                    <a:p>
+                      <a:pPr algn="ctr"/>
+                      <a:r>
+                        <a:rPr sz="1200" b="0">
+                          <a:solidFill>
+                            <a:srgbClr val="0F172A"/>
+                          </a:solidFill>
+                          <a:latin typeface="Arial"/>
+                        </a:rPr>
+                        <a:t>так</a:t>
+                      </a:r>
+                    </a:p>
+                  </a:txBody>
+                  <a:tcPr marL="91440" marR="91440" marT="27432" marB="27432" anchor="ctr">
+                    <a:solidFill>
+                      <a:srgbClr val="FFFFFF"/>
+                    </a:solidFill>
+                  </a:tcPr>
+                </a:tc>
+                <a:tc>
+                  <a:txBody>
+                    <a:bodyPr wrap="square"/>
+                    <a:lstStyle/>
+                    <a:p>
+                      <a:pPr algn="ctr"/>
+                      <a:r>
+                        <a:rPr sz="1100" b="0">
+                          <a:solidFill>
+                            <a:srgbClr val="0F172A"/>
+                          </a:solidFill>
+                          <a:latin typeface="Arial"/>
+                        </a:rPr>
+                        <a:t>так</a:t>
+                      </a:r>
+                    </a:p>
+                  </a:txBody>
+                  <a:tcPr marL="91440" marR="91440" marT="27432" marB="27432" anchor="ctr">
+                    <a:solidFill>
+                      <a:srgbClr val="FFFFFF"/>
+                    </a:solidFill>
+                  </a:tcPr>
+                </a:tc>
+              </a:tr>
+              <a:tr h="402336">
+                <a:tc>
+                  <a:txBody>
+                    <a:bodyPr wrap="square"/>
+                    <a:lstStyle/>
+                    <a:p>
+                      <a:pPr algn="l"/>
+                      <a:r>
+                        <a:rPr sz="1100" b="1">
+                          <a:solidFill>
+                            <a:srgbClr val="0F172A"/>
+                          </a:solidFill>
+                          <a:latin typeface="Arial"/>
+                        </a:rPr>
+                        <a:t>зміна уставок під час розряду</a:t>
+                      </a:r>
+                    </a:p>
+                  </a:txBody>
+                  <a:tcPr marL="91440" marR="91440" marT="27432" marB="27432" anchor="ctr">
+                    <a:solidFill>
+                      <a:srgbClr val="FFFFFF"/>
+                    </a:solidFill>
+                  </a:tcPr>
+                </a:tc>
+                <a:tc>
+                  <a:txBody>
+                    <a:bodyPr wrap="square"/>
+                    <a:lstStyle/>
+                    <a:p>
+                      <a:pPr algn="ctr"/>
+                      <a:r>
+                        <a:rPr sz="1200" b="0">
+                          <a:solidFill>
+                            <a:srgbClr val="0F172A"/>
+                          </a:solidFill>
+                          <a:latin typeface="Arial"/>
+                        </a:rPr>
+                        <a:t>ні</a:t>
+                      </a:r>
+                    </a:p>
+                  </a:txBody>
+                  <a:tcPr marL="91440" marR="91440" marT="27432" marB="27432" anchor="ctr">
+                    <a:solidFill>
+                      <a:srgbClr val="FFFFFF"/>
+                    </a:solidFill>
+                  </a:tcPr>
+                </a:tc>
+                <a:tc>
+                  <a:txBody>
+                    <a:bodyPr wrap="square"/>
+                    <a:lstStyle/>
+                    <a:p>
+                      <a:pPr algn="ctr"/>
+                      <a:r>
+                        <a:rPr sz="1100" b="0">
+                          <a:solidFill>
+                            <a:srgbClr val="0F172A"/>
+                          </a:solidFill>
+                          <a:latin typeface="Arial"/>
+                        </a:rPr>
+                        <a:t>так, вручну або моделлю</a:t>
+                      </a:r>
+                    </a:p>
+                  </a:txBody>
+                  <a:tcPr marL="91440" marR="91440" marT="27432" marB="27432" anchor="ctr">
+                    <a:solidFill>
+                      <a:srgbClr val="FFFFFF"/>
+                    </a:solidFill>
+                  </a:tcPr>
+                </a:tc>
+              </a:tr>
+              <a:tr h="402336">
+                <a:tc>
+                  <a:txBody>
+                    <a:bodyPr wrap="square"/>
+                    <a:lstStyle/>
+                    <a:p>
+                      <a:pPr algn="l"/>
+                      <a:r>
+                        <a:rPr sz="1100" b="1">
+                          <a:solidFill>
+                            <a:srgbClr val="0F172A"/>
+                          </a:solidFill>
+                          <a:latin typeface="Arial"/>
+                        </a:rPr>
+                        <a:t>модель керує плазмою в реальному часі</a:t>
+                      </a:r>
+                    </a:p>
+                  </a:txBody>
+                  <a:tcPr marL="91440" marR="91440" marT="27432" marB="27432" anchor="ctr">
+                    <a:solidFill>
+                      <a:srgbClr val="FFFFFF"/>
+                    </a:solidFill>
+                  </a:tcPr>
+                </a:tc>
+                <a:tc>
+                  <a:txBody>
+                    <a:bodyPr wrap="square"/>
+                    <a:lstStyle/>
+                    <a:p>
+                      <a:pPr algn="ctr"/>
+                      <a:r>
+                        <a:rPr sz="1200" b="0">
+                          <a:solidFill>
+                            <a:srgbClr val="0F172A"/>
+                          </a:solidFill>
+                          <a:latin typeface="Arial"/>
+                        </a:rPr>
+                        <a:t>ні</a:t>
+                      </a:r>
+                    </a:p>
+                  </a:txBody>
+                  <a:tcPr marL="91440" marR="91440" marT="27432" marB="27432" anchor="ctr">
+                    <a:solidFill>
+                      <a:srgbClr val="FFFFFF"/>
+                    </a:solidFill>
+                  </a:tcPr>
+                </a:tc>
+                <a:tc>
+                  <a:txBody>
+                    <a:bodyPr wrap="square"/>
+                    <a:lstStyle/>
+                    <a:p>
+                      <a:pPr algn="ctr"/>
+                      <a:r>
+                        <a:rPr sz="1100" b="0">
+                          <a:solidFill>
+                            <a:srgbClr val="0F172A"/>
+                          </a:solidFill>
+                          <a:latin typeface="Arial"/>
+                        </a:rPr>
+                        <a:t>так, fixer кожні 0,25 с</a:t>
+                      </a:r>
+                    </a:p>
+                  </a:txBody>
+                  <a:tcPr marL="91440" marR="91440" marT="27432" marB="27432" anchor="ctr">
+                    <a:solidFill>
+                      <a:srgbClr val="FFFFFF"/>
+                    </a:solidFill>
+                  </a:tcPr>
+                </a:tc>
+              </a:tr>
+              <a:tr h="402336">
+                <a:tc>
+                  <a:txBody>
+                    <a:bodyPr wrap="square"/>
+                    <a:lstStyle/>
+                    <a:p>
+                      <a:pPr algn="l"/>
+                      <a:r>
+                        <a:rPr sz="1100" b="1">
+                          <a:solidFill>
+                            <a:srgbClr val="0F172A"/>
+                          </a:solidFill>
+                          <a:latin typeface="Arial"/>
+                        </a:rPr>
+                        <a:t>«тінь»: та сама плазма без втручань</a:t>
+                      </a:r>
+                    </a:p>
+                  </a:txBody>
+                  <a:tcPr marL="91440" marR="91440" marT="27432" marB="27432" anchor="ctr">
+                    <a:solidFill>
+                      <a:srgbClr val="FFFFFF"/>
+                    </a:solidFill>
+                  </a:tcPr>
+                </a:tc>
+                <a:tc>
+                  <a:txBody>
+                    <a:bodyPr wrap="square"/>
+                    <a:lstStyle/>
+                    <a:p>
+                      <a:pPr algn="ctr"/>
+                      <a:r>
+                        <a:rPr sz="1200" b="0">
+                          <a:solidFill>
+                            <a:srgbClr val="0F172A"/>
+                          </a:solidFill>
+                          <a:latin typeface="Arial"/>
+                        </a:rPr>
+                        <a:t>ні</a:t>
+                      </a:r>
+                    </a:p>
+                  </a:txBody>
+                  <a:tcPr marL="91440" marR="91440" marT="27432" marB="27432" anchor="ctr">
+                    <a:solidFill>
+                      <a:srgbClr val="FFFFFF"/>
+                    </a:solidFill>
+                  </a:tcPr>
+                </a:tc>
+                <a:tc>
+                  <a:txBody>
+                    <a:bodyPr wrap="square"/>
+                    <a:lstStyle/>
+                    <a:p>
+                      <a:pPr algn="ctr"/>
+                      <a:r>
+                        <a:rPr sz="1100" b="0">
+                          <a:solidFill>
+                            <a:srgbClr val="0F172A"/>
+                          </a:solidFill>
+                          <a:latin typeface="Arial"/>
+                        </a:rPr>
+                        <a:t>так, доказ «зірвалася б»</a:t>
+                      </a:r>
+                    </a:p>
+                  </a:txBody>
+                  <a:tcPr marL="91440" marR="91440" marT="27432" marB="27432" anchor="ctr">
+                    <a:solidFill>
+                      <a:srgbClr val="FFFFFF"/>
+                    </a:solidFill>
+                  </a:tcPr>
+                </a:tc>
+              </a:tr>
+              <a:tr h="402336">
+                <a:tc>
+                  <a:txBody>
+                    <a:bodyPr wrap="square"/>
+                    <a:lstStyle/>
+                    <a:p>
+                      <a:pPr algn="l"/>
+                      <a:r>
+                        <a:rPr sz="1100" b="1">
+                          <a:solidFill>
+                            <a:srgbClr val="0F172A"/>
+                          </a:solidFill>
+                          <a:latin typeface="Arial"/>
+                        </a:rPr>
+                        <a:t>причини зриву в інтерфейсі</a:t>
+                      </a:r>
+                    </a:p>
+                  </a:txBody>
+                  <a:tcPr marL="91440" marR="91440" marT="27432" marB="27432" anchor="ctr">
+                    <a:solidFill>
+                      <a:srgbClr val="FFFFFF"/>
+                    </a:solidFill>
+                  </a:tcPr>
+                </a:tc>
+                <a:tc>
+                  <a:txBody>
+                    <a:bodyPr wrap="square"/>
+                    <a:lstStyle/>
+                    <a:p>
+                      <a:pPr algn="ctr"/>
+                      <a:r>
+                        <a:rPr sz="1200" b="0">
+                          <a:solidFill>
+                            <a:srgbClr val="0F172A"/>
+                          </a:solidFill>
+                          <a:latin typeface="Arial"/>
+                        </a:rPr>
+                        <a:t>ні</a:t>
+                      </a:r>
+                    </a:p>
+                  </a:txBody>
+                  <a:tcPr marL="91440" marR="91440" marT="27432" marB="27432" anchor="ctr">
+                    <a:solidFill>
+                      <a:srgbClr val="FFFFFF"/>
+                    </a:solidFill>
+                  </a:tcPr>
+                </a:tc>
+                <a:tc>
+                  <a:txBody>
+                    <a:bodyPr wrap="square"/>
+                    <a:lstStyle/>
+                    <a:p>
+                      <a:pPr algn="ctr"/>
+                      <a:r>
+                        <a:rPr sz="1100" b="0">
+                          <a:solidFill>
+                            <a:srgbClr val="0F172A"/>
+                          </a:solidFill>
+                          <a:latin typeface="Arial"/>
+                        </a:rPr>
+                        <a:t>так, частки ImpactNet</a:t>
+                      </a:r>
+                    </a:p>
+                  </a:txBody>
+                  <a:tcPr marL="91440" marR="91440" marT="27432" marB="27432" anchor="ctr">
+                    <a:solidFill>
+                      <a:srgbClr val="FFFFFF"/>
+                    </a:solidFill>
+                  </a:tcPr>
+                </a:tc>
+              </a:tr>
+              <a:tr h="402336">
+                <a:tc>
+                  <a:txBody>
+                    <a:bodyPr wrap="square"/>
+                    <a:lstStyle/>
+                    <a:p>
+                      <a:pPr algn="l"/>
+                      <a:r>
+                        <a:rPr sz="1100" b="1">
+                          <a:solidFill>
+                            <a:srgbClr val="0F172A"/>
+                          </a:solidFill>
+                          <a:latin typeface="Arial"/>
+                        </a:rPr>
+                        <a:t>шум приладів</a:t>
+                      </a:r>
+                    </a:p>
+                  </a:txBody>
+                  <a:tcPr marL="91440" marR="91440" marT="27432" marB="27432" anchor="ctr">
+                    <a:solidFill>
+                      <a:srgbClr val="FFFFFF"/>
+                    </a:solidFill>
+                  </a:tcPr>
+                </a:tc>
+                <a:tc>
+                  <a:txBody>
+                    <a:bodyPr wrap="square"/>
+                    <a:lstStyle/>
+                    <a:p>
+                      <a:pPr algn="ctr"/>
+                      <a:r>
+                        <a:rPr sz="1200" b="0">
+                          <a:solidFill>
+                            <a:srgbClr val="0F172A"/>
+                          </a:solidFill>
+                          <a:latin typeface="Arial"/>
+                        </a:rPr>
+                        <a:t>так</a:t>
+                      </a:r>
+                    </a:p>
+                  </a:txBody>
+                  <a:tcPr marL="91440" marR="91440" marT="27432" marB="27432" anchor="ctr">
+                    <a:solidFill>
+                      <a:srgbClr val="FFFFFF"/>
+                    </a:solidFill>
+                  </a:tcPr>
+                </a:tc>
+                <a:tc>
+                  <a:txBody>
+                    <a:bodyPr wrap="square"/>
+                    <a:lstStyle/>
+                    <a:p>
+                      <a:pPr algn="ctr"/>
+                      <a:r>
+                        <a:rPr sz="1100" b="0">
+                          <a:solidFill>
+                            <a:srgbClr val="0F172A"/>
+                          </a:solidFill>
+                          <a:latin typeface="Arial"/>
+                        </a:rPr>
+                        <a:t>ні (наступний крок)</a:t>
+                      </a:r>
+                    </a:p>
+                  </a:txBody>
+                  <a:tcPr marL="91440" marR="91440" marT="27432" marB="27432" anchor="ctr">
+                    <a:solidFill>
+                      <a:srgbClr val="FFFFFF"/>
+                    </a:solidFill>
+                  </a:tcPr>
+                </a:tc>
+              </a:tr>
+            </a:tbl>
+          </a:graphicData>
+        </a:graphic>
+      </p:graphicFrame>
+      <p:sp>
+        <p:nvSpPr>
+          <p:cNvPr id="7" name="Rectangle 6"/>
+          <p:cNvSpPr/>
+          <p:nvPr/>
+        </p:nvSpPr>
+        <p:spPr>
+          <a:xfrm>
+            <a:off x="6995160" y="1280160"/>
+            <a:ext cx="4663440" cy="2926080"/>
+          </a:xfrm>
+          <a:prstGeom prst="rect">
+            <a:avLst/>
+          </a:prstGeom>
+          <a:solidFill>
+            <a:srgbClr val="ECFDF5"/>
+          </a:solidFill>
+          <a:ln w="15875">
+            <a:solidFill>
+              <a:srgbClr val="047857"/>
+            </a:solidFill>
+          </a:ln>
+          <a:effectLst/>
+        </p:spPr>
+        <p:style>
+          <a:lnRef idx="1">
+            <a:schemeClr val="accent1"/>
+          </a:lnRef>
+          <a:fillRef idx="3">
+            <a:schemeClr val="accent1"/>
+          </a:fillRef>
+          <a:effectRef idx="2">
+            <a:schemeClr val="accent1"/>
+          </a:effectRef>
+          <a:fontRef idx="minor">
+            <a:schemeClr val="lt1"/>
+          </a:fontRef>
+        </p:style>
+        <p:txBody>
+          <a:bodyPr rtlCol="0" anchor="ctr"/>
+          <a:lstStyle/>
+          <a:p>
+            <a:pPr algn="ctr"/>
+          </a:p>
+        </p:txBody>
+      </p:sp>
+      <p:sp>
+        <p:nvSpPr>
+          <p:cNvPr id="8" name="TextBox 7"/>
+          <p:cNvSpPr txBox="1"/>
+          <p:nvPr/>
+        </p:nvSpPr>
+        <p:spPr>
+          <a:xfrm>
+            <a:off x="7223760" y="1417320"/>
+            <a:ext cx="4251960" cy="3291840"/>
+          </a:xfrm>
+          <a:prstGeom prst="rect">
+            <a:avLst/>
+          </a:prstGeom>
+          <a:noFill/>
+        </p:spPr>
+        <p:txBody>
+          <a:bodyPr wrap="square" anchor="t" lIns="0" rIns="0" tIns="0" bIns="0">
+            <a:spAutoFit/>
+          </a:bodyPr>
+          <a:lstStyle/>
+          <a:p>
+            <a:pPr algn="l">
+              <a:spcAft>
+                <a:spcPts val="800"/>
+              </a:spcAft>
+            </a:pPr>
+            <a:r>
+              <a:rPr sz="1600" b="1" i="0">
+                <a:solidFill>
+                  <a:srgbClr val="047857"/>
+                </a:solidFill>
+                <a:latin typeface="Arial"/>
+              </a:rPr>
+              <a:t>Що покажемо наживо</a:t>
+            </a:r>
+          </a:p>
+          <a:p>
+            <a:pPr algn="l">
+              <a:spcAft>
+                <a:spcPts val="800"/>
+              </a:spcAft>
+            </a:pPr>
+            <a:r>
+              <a:rPr sz="1300" b="0" i="0">
+                <a:solidFill>
+                  <a:srgbClr val="0F172A"/>
+                </a:solidFill>
+                <a:latin typeface="Arial"/>
+              </a:rPr>
+              <a:t>JET → сценарій Density limit → паливо DD, модель v8_fixer</a:t>
+            </a:r>
+          </a:p>
+          <a:p>
+            <a:pPr algn="l">
+              <a:spcAft>
+                <a:spcPts val="600"/>
+              </a:spcAft>
+            </a:pPr>
+            <a:r>
+              <a:rPr sz="1300" b="0" i="0">
+                <a:solidFill>
+                  <a:srgbClr val="0F172A"/>
+                </a:solidFill>
+                <a:latin typeface="Arial"/>
+              </a:rPr>
+              <a:t>Без fixer: розряд зривається на 4–5 с</a:t>
+            </a:r>
+          </a:p>
+          <a:p>
+            <a:pPr algn="l">
+              <a:spcAft>
+                <a:spcPts val="600"/>
+              </a:spcAft>
+            </a:pPr>
+            <a:r>
+              <a:rPr sz="1300" b="1" i="0">
+                <a:solidFill>
+                  <a:srgbClr val="0F172A"/>
+                </a:solidFill>
+                <a:latin typeface="Arial"/>
+              </a:rPr>
+              <a:t>З fixer: ⚠ ПРОГНОЗ ЗРИВУ → FIXER ВНІС ЗМІНИ → ✓ Зрив відвернуто</a:t>
+            </a:r>
+          </a:p>
+          <a:p>
+            <a:pPr algn="l">
+              <a:spcAft>
+                <a:spcPts val="0"/>
+              </a:spcAft>
+            </a:pPr>
+            <a:r>
+              <a:rPr sz="1300" b="0" i="0">
+                <a:solidFill>
+                  <a:srgbClr val="0F172A"/>
+                </a:solidFill>
+                <a:latin typeface="Arial"/>
+              </a:rPr>
+              <a:t>«Тінь» поруч показує, що та сама плазма без fixer зірвалася б</a:t>
+            </a:r>
+          </a:p>
+        </p:txBody>
+      </p:sp>
+      <p:sp>
+        <p:nvSpPr>
+          <p:cNvPr id="9" name="TextBox 8"/>
+          <p:cNvSpPr txBox="1"/>
+          <p:nvPr/>
+        </p:nvSpPr>
+        <p:spPr>
+          <a:xfrm>
+            <a:off x="6995160" y="4434840"/>
+            <a:ext cx="4663440" cy="411480"/>
+          </a:xfrm>
+          <a:prstGeom prst="rect">
+            <a:avLst/>
+          </a:prstGeom>
+          <a:noFill/>
+        </p:spPr>
+        <p:txBody>
+          <a:bodyPr wrap="none" lIns="0" rIns="0" tIns="0" bIns="0">
+            <a:spAutoFit/>
+          </a:bodyPr>
+          <a:lstStyle/>
+          <a:p>
+            <a:r>
+              <a:rPr sz="1400" b="1">
+                <a:solidFill>
+                  <a:srgbClr val="1D4ED8"/>
+                </a:solidFill>
+                <a:latin typeface="Arial"/>
+                <a:hlinkClick r:id="rId3"/>
+              </a:rPr>
+              <a:t>Відкрити симулятор: http://127.0.0.1:9999</a:t>
+            </a:r>
+          </a:p>
+        </p:txBody>
+      </p:sp>
+      <p:sp>
+        <p:nvSpPr>
+          <p:cNvPr id="10" name="TextBox 9"/>
+          <p:cNvSpPr txBox="1"/>
+          <p:nvPr/>
+        </p:nvSpPr>
+        <p:spPr>
+          <a:xfrm>
+            <a:off x="6995160" y="4846320"/>
+            <a:ext cx="4663440" cy="365760"/>
+          </a:xfrm>
+          <a:prstGeom prst="rect">
+            <a:avLst/>
+          </a:prstGeom>
+          <a:noFill/>
+        </p:spPr>
+        <p:txBody>
+          <a:bodyPr wrap="square" anchor="t" lIns="0" rIns="0" tIns="0" bIns="0">
+            <a:spAutoFit/>
+          </a:bodyPr>
+          <a:lstStyle/>
+          <a:p>
+            <a:pPr algn="l">
+              <a:spcAft>
+                <a:spcPts val="0"/>
+              </a:spcAft>
+            </a:pPr>
+            <a:r>
+              <a:rPr sz="1100" b="0" i="0">
+                <a:solidFill>
+                  <a:srgbClr val="475569"/>
+                </a:solidFill>
+                <a:latin typeface="Arial"/>
+              </a:rPr>
+              <a:t>github.com/lurbaby/plasma_simulator</a:t>
+            </a:r>
+          </a:p>
+        </p:txBody>
+      </p:sp>
+      <p:sp>
+        <p:nvSpPr>
+          <p:cNvPr id="11" name="TextBox 10"/>
+          <p:cNvSpPr txBox="1"/>
+          <p:nvPr/>
+        </p:nvSpPr>
+        <p:spPr>
+          <a:xfrm>
+            <a:off x="6995160" y="5623560"/>
+            <a:ext cx="4663440" cy="457200"/>
           </a:xfrm>
           <a:prstGeom prst="rect">
             <a:avLst/>

</xml_diff>